<commit_message>
-working on page: PgTaxa ...
</commit_message>
<xml_diff>
--- a/AlamutB/.appCatalog/Alamut.pptx
+++ b/AlamutB/.appCatalog/Alamut.pptx
@@ -198,7 +198,7 @@
           <a:p>
             <a:fld id="{76AEB20D-1E0E-486A-823D-795E0F1B1A92}" type="datetimeFigureOut">
               <a:rPr lang="en-US" smtClean="0"/>
-              <a:t>8/12/2026</a:t>
+              <a:t>8/19/2026</a:t>
             </a:fld>
             <a:endParaRPr lang="en-US"/>
           </a:p>
@@ -612,7 +612,7 @@
           <a:p>
             <a:fld id="{8A0CD729-867D-477D-ADDA-CA15108676C8}" type="datetimeFigureOut">
               <a:rPr lang="en-US" smtClean="0"/>
-              <a:t>8/12/2026</a:t>
+              <a:t>8/19/2026</a:t>
             </a:fld>
             <a:endParaRPr lang="en-US"/>
           </a:p>
@@ -810,7 +810,7 @@
           <a:p>
             <a:fld id="{8A0CD729-867D-477D-ADDA-CA15108676C8}" type="datetimeFigureOut">
               <a:rPr lang="en-US" smtClean="0"/>
-              <a:t>8/12/2026</a:t>
+              <a:t>8/19/2026</a:t>
             </a:fld>
             <a:endParaRPr lang="en-US"/>
           </a:p>
@@ -1018,7 +1018,7 @@
           <a:p>
             <a:fld id="{8A0CD729-867D-477D-ADDA-CA15108676C8}" type="datetimeFigureOut">
               <a:rPr lang="en-US" smtClean="0"/>
-              <a:t>8/12/2026</a:t>
+              <a:t>8/19/2026</a:t>
             </a:fld>
             <a:endParaRPr lang="en-US"/>
           </a:p>
@@ -1216,7 +1216,7 @@
           <a:p>
             <a:fld id="{8A0CD729-867D-477D-ADDA-CA15108676C8}" type="datetimeFigureOut">
               <a:rPr lang="en-US" smtClean="0"/>
-              <a:t>8/12/2026</a:t>
+              <a:t>8/19/2026</a:t>
             </a:fld>
             <a:endParaRPr lang="en-US"/>
           </a:p>
@@ -1491,7 +1491,7 @@
           <a:p>
             <a:fld id="{8A0CD729-867D-477D-ADDA-CA15108676C8}" type="datetimeFigureOut">
               <a:rPr lang="en-US" smtClean="0"/>
-              <a:t>8/12/2026</a:t>
+              <a:t>8/19/2026</a:t>
             </a:fld>
             <a:endParaRPr lang="en-US"/>
           </a:p>
@@ -1756,7 +1756,7 @@
           <a:p>
             <a:fld id="{8A0CD729-867D-477D-ADDA-CA15108676C8}" type="datetimeFigureOut">
               <a:rPr lang="en-US" smtClean="0"/>
-              <a:t>8/12/2026</a:t>
+              <a:t>8/19/2026</a:t>
             </a:fld>
             <a:endParaRPr lang="en-US"/>
           </a:p>
@@ -2168,7 +2168,7 @@
           <a:p>
             <a:fld id="{8A0CD729-867D-477D-ADDA-CA15108676C8}" type="datetimeFigureOut">
               <a:rPr lang="en-US" smtClean="0"/>
-              <a:t>8/12/2026</a:t>
+              <a:t>8/19/2026</a:t>
             </a:fld>
             <a:endParaRPr lang="en-US"/>
           </a:p>
@@ -2309,7 +2309,7 @@
           <a:p>
             <a:fld id="{8A0CD729-867D-477D-ADDA-CA15108676C8}" type="datetimeFigureOut">
               <a:rPr lang="en-US" smtClean="0"/>
-              <a:t>8/12/2026</a:t>
+              <a:t>8/19/2026</a:t>
             </a:fld>
             <a:endParaRPr lang="en-US"/>
           </a:p>
@@ -2422,7 +2422,7 @@
           <a:p>
             <a:fld id="{8A0CD729-867D-477D-ADDA-CA15108676C8}" type="datetimeFigureOut">
               <a:rPr lang="en-US" smtClean="0"/>
-              <a:t>8/12/2026</a:t>
+              <a:t>8/19/2026</a:t>
             </a:fld>
             <a:endParaRPr lang="en-US"/>
           </a:p>
@@ -2733,7 +2733,7 @@
           <a:p>
             <a:fld id="{8A0CD729-867D-477D-ADDA-CA15108676C8}" type="datetimeFigureOut">
               <a:rPr lang="en-US" smtClean="0"/>
-              <a:t>8/12/2026</a:t>
+              <a:t>8/19/2026</a:t>
             </a:fld>
             <a:endParaRPr lang="en-US"/>
           </a:p>
@@ -3021,7 +3021,7 @@
           <a:p>
             <a:fld id="{8A0CD729-867D-477D-ADDA-CA15108676C8}" type="datetimeFigureOut">
               <a:rPr lang="en-US" smtClean="0"/>
-              <a:t>8/12/2026</a:t>
+              <a:t>8/19/2026</a:t>
             </a:fld>
             <a:endParaRPr lang="en-US"/>
           </a:p>
@@ -3262,7 +3262,7 @@
           <a:p>
             <a:fld id="{8A0CD729-867D-477D-ADDA-CA15108676C8}" type="datetimeFigureOut">
               <a:rPr lang="en-US" smtClean="0"/>
-              <a:t>8/12/2026</a:t>
+              <a:t>8/19/2026</a:t>
             </a:fld>
             <a:endParaRPr lang="en-US"/>
           </a:p>
@@ -6871,7 +6871,7 @@
         <p:spPr bwMode="auto">
           <a:xfrm>
             <a:off x="169682" y="2260157"/>
-            <a:ext cx="1438256" cy="2234821"/>
+            <a:ext cx="1438256" cy="3799085"/>
           </a:xfrm>
           <a:prstGeom prst="roundRect">
             <a:avLst>
@@ -7072,7 +7072,7 @@
                 <a:latin typeface="Segoe UI" panose="020B0502040204020203" pitchFamily="34" charset="0"/>
                 <a:cs typeface="Segoe UI" panose="020B0502040204020203" pitchFamily="34" charset="0"/>
               </a:rPr>
-              <a:t>1: Rtl</a:t>
+              <a:t> 1: Rtl</a:t>
             </a:r>
           </a:p>
           <a:p>
@@ -7087,7 +7087,7 @@
                 <a:latin typeface="Segoe UI" panose="020B0502040204020203" pitchFamily="34" charset="0"/>
                 <a:cs typeface="Segoe UI" panose="020B0502040204020203" pitchFamily="34" charset="0"/>
               </a:rPr>
-              <a:t>2: Bookmarked</a:t>
+              <a:t> 2: Bookmarked</a:t>
             </a:r>
           </a:p>
           <a:p>
@@ -7102,7 +7102,7 @@
                 <a:latin typeface="Segoe UI" panose="020B0502040204020203" pitchFamily="34" charset="0"/>
                 <a:cs typeface="Segoe UI" panose="020B0502040204020203" pitchFamily="34" charset="0"/>
               </a:rPr>
-              <a:t>4: Todo</a:t>
+              <a:t> 4: Todo</a:t>
             </a:r>
           </a:p>
           <a:p>
@@ -7117,7 +7117,7 @@
                 <a:latin typeface="Segoe UI" panose="020B0502040204020203" pitchFamily="34" charset="0"/>
                 <a:cs typeface="Segoe UI" panose="020B0502040204020203" pitchFamily="34" charset="0"/>
               </a:rPr>
-              <a:t>8: Read</a:t>
+              <a:t> 8: Read</a:t>
             </a:r>
           </a:p>
           <a:p>
@@ -7134,6 +7134,225 @@
               </a:rPr>
               <a:t>16: Done</a:t>
             </a:r>
+          </a:p>
+          <a:p>
+            <a:pPr marL="84138">
+              <a:defRPr/>
+            </a:pPr>
+            <a:endParaRPr lang="en-US" sz="800">
+              <a:solidFill>
+                <a:schemeClr val="tx1"/>
+              </a:solidFill>
+              <a:latin typeface="Segoe UI" panose="020B0502040204020203" pitchFamily="34" charset="0"/>
+              <a:cs typeface="Segoe UI" panose="020B0502040204020203" pitchFamily="34" charset="0"/>
+            </a:endParaRPr>
+          </a:p>
+          <a:p>
+            <a:pPr marL="84138">
+              <a:defRPr/>
+            </a:pPr>
+            <a:r>
+              <a:rPr lang="en-US" sz="800" b="1" i="1">
+                <a:solidFill>
+                  <a:schemeClr val="tx1"/>
+                </a:solidFill>
+                <a:latin typeface="Segoe UI" panose="020B0502040204020203" pitchFamily="34" charset="0"/>
+                <a:cs typeface="Segoe UI" panose="020B0502040204020203" pitchFamily="34" charset="0"/>
+              </a:rPr>
+              <a:t>RefTypes:</a:t>
+            </a:r>
+          </a:p>
+          <a:p>
+            <a:pPr marL="84138">
+              <a:defRPr/>
+            </a:pPr>
+            <a:r>
+              <a:rPr lang="en-US" sz="800">
+                <a:solidFill>
+                  <a:schemeClr val="tx1"/>
+                </a:solidFill>
+                <a:latin typeface="Segoe UI" panose="020B0502040204020203" pitchFamily="34" charset="0"/>
+                <a:cs typeface="Segoe UI" panose="020B0502040204020203" pitchFamily="34" charset="0"/>
+              </a:rPr>
+              <a:t> 1:ApgGroups</a:t>
+            </a:r>
+          </a:p>
+          <a:p>
+            <a:pPr marL="84138">
+              <a:defRPr/>
+            </a:pPr>
+            <a:r>
+              <a:rPr lang="en-US" sz="800">
+                <a:solidFill>
+                  <a:schemeClr val="tx1"/>
+                </a:solidFill>
+                <a:latin typeface="Segoe UI" panose="020B0502040204020203" pitchFamily="34" charset="0"/>
+                <a:cs typeface="Segoe UI" panose="020B0502040204020203" pitchFamily="34" charset="0"/>
+              </a:rPr>
+              <a:t> 2:Orders</a:t>
+            </a:r>
+          </a:p>
+          <a:p>
+            <a:pPr marL="84138">
+              <a:defRPr/>
+            </a:pPr>
+            <a:r>
+              <a:rPr lang="en-US" sz="800">
+                <a:solidFill>
+                  <a:schemeClr val="tx1"/>
+                </a:solidFill>
+                <a:latin typeface="Segoe UI" panose="020B0502040204020203" pitchFamily="34" charset="0"/>
+                <a:cs typeface="Segoe UI" panose="020B0502040204020203" pitchFamily="34" charset="0"/>
+              </a:rPr>
+              <a:t> 3:Families</a:t>
+            </a:r>
+          </a:p>
+          <a:p>
+            <a:pPr marL="84138">
+              <a:defRPr/>
+            </a:pPr>
+            <a:r>
+              <a:rPr lang="en-US" sz="800">
+                <a:solidFill>
+                  <a:schemeClr val="tx1"/>
+                </a:solidFill>
+                <a:latin typeface="Segoe UI" panose="020B0502040204020203" pitchFamily="34" charset="0"/>
+                <a:cs typeface="Segoe UI" panose="020B0502040204020203" pitchFamily="34" charset="0"/>
+              </a:rPr>
+              <a:t> 4:Genera</a:t>
+            </a:r>
+          </a:p>
+          <a:p>
+            <a:pPr marL="84138">
+              <a:defRPr/>
+            </a:pPr>
+            <a:r>
+              <a:rPr lang="en-US" sz="800">
+                <a:solidFill>
+                  <a:schemeClr val="tx1"/>
+                </a:solidFill>
+                <a:latin typeface="Segoe UI" panose="020B0502040204020203" pitchFamily="34" charset="0"/>
+                <a:cs typeface="Segoe UI" panose="020B0502040204020203" pitchFamily="34" charset="0"/>
+              </a:rPr>
+              <a:t> 5:Species</a:t>
+            </a:r>
+          </a:p>
+          <a:p>
+            <a:pPr marL="84138">
+              <a:defRPr/>
+            </a:pPr>
+            <a:r>
+              <a:rPr lang="en-US" sz="800">
+                <a:solidFill>
+                  <a:schemeClr val="tx1"/>
+                </a:solidFill>
+                <a:latin typeface="Segoe UI" panose="020B0502040204020203" pitchFamily="34" charset="0"/>
+                <a:cs typeface="Segoe UI" panose="020B0502040204020203" pitchFamily="34" charset="0"/>
+              </a:rPr>
+              <a:t> 6:Datasets(FL)</a:t>
+            </a:r>
+          </a:p>
+          <a:p>
+            <a:pPr marL="84138">
+              <a:defRPr/>
+            </a:pPr>
+            <a:r>
+              <a:rPr lang="en-US" sz="800">
+                <a:solidFill>
+                  <a:schemeClr val="tx1"/>
+                </a:solidFill>
+                <a:latin typeface="Segoe UI" panose="020B0502040204020203" pitchFamily="34" charset="0"/>
+                <a:cs typeface="Segoe UI" panose="020B0502040204020203" pitchFamily="34" charset="0"/>
+              </a:rPr>
+              <a:t> 7:Datasets(CN)</a:t>
+            </a:r>
+          </a:p>
+          <a:p>
+            <a:pPr marL="84138">
+              <a:defRPr/>
+            </a:pPr>
+            <a:r>
+              <a:rPr lang="en-US" sz="800">
+                <a:solidFill>
+                  <a:schemeClr val="tx1"/>
+                </a:solidFill>
+                <a:latin typeface="Segoe UI" panose="020B0502040204020203" pitchFamily="34" charset="0"/>
+                <a:cs typeface="Segoe UI" panose="020B0502040204020203" pitchFamily="34" charset="0"/>
+              </a:rPr>
+              <a:t> 8:Datasets(LM)</a:t>
+            </a:r>
+          </a:p>
+          <a:p>
+            <a:pPr marL="84138">
+              <a:defRPr/>
+            </a:pPr>
+            <a:r>
+              <a:rPr lang="en-US" sz="800">
+                <a:solidFill>
+                  <a:schemeClr val="tx1"/>
+                </a:solidFill>
+                <a:latin typeface="Segoe UI" panose="020B0502040204020203" pitchFamily="34" charset="0"/>
+                <a:cs typeface="Segoe UI" panose="020B0502040204020203" pitchFamily="34" charset="0"/>
+              </a:rPr>
+              <a:t> 9:Stations</a:t>
+            </a:r>
+          </a:p>
+          <a:p>
+            <a:pPr marL="84138">
+              <a:defRPr/>
+            </a:pPr>
+            <a:r>
+              <a:rPr lang="en-US" sz="800">
+                <a:solidFill>
+                  <a:schemeClr val="tx1"/>
+                </a:solidFill>
+                <a:latin typeface="Segoe UI" panose="020B0502040204020203" pitchFamily="34" charset="0"/>
+                <a:cs typeface="Segoe UI" panose="020B0502040204020203" pitchFamily="34" charset="0"/>
+              </a:rPr>
+              <a:t>10:Sets</a:t>
+            </a:r>
+          </a:p>
+          <a:p>
+            <a:pPr marL="84138">
+              <a:defRPr/>
+            </a:pPr>
+            <a:r>
+              <a:rPr lang="en-US" sz="800">
+                <a:solidFill>
+                  <a:schemeClr val="tx1"/>
+                </a:solidFill>
+                <a:latin typeface="Segoe UI" panose="020B0502040204020203" pitchFamily="34" charset="0"/>
+                <a:cs typeface="Segoe UI" panose="020B0502040204020203" pitchFamily="34" charset="0"/>
+              </a:rPr>
+              <a:t>11:SetData</a:t>
+            </a:r>
+          </a:p>
+          <a:p>
+            <a:pPr marL="84138">
+              <a:defRPr/>
+            </a:pPr>
+            <a:r>
+              <a:rPr lang="en-US" sz="800">
+                <a:solidFill>
+                  <a:schemeClr val="tx1"/>
+                </a:solidFill>
+                <a:latin typeface="Segoe UI" panose="020B0502040204020203" pitchFamily="34" charset="0"/>
+                <a:cs typeface="Segoe UI" panose="020B0502040204020203" pitchFamily="34" charset="0"/>
+              </a:rPr>
+              <a:t>12:Users</a:t>
+            </a:r>
+          </a:p>
+          <a:p>
+            <a:pPr marL="84138">
+              <a:defRPr/>
+            </a:pPr>
+            <a:endParaRPr lang="en-US" sz="800">
+              <a:solidFill>
+                <a:schemeClr val="tx1"/>
+              </a:solidFill>
+              <a:latin typeface="Segoe UI" panose="020B0502040204020203" pitchFamily="34" charset="0"/>
+              <a:cs typeface="Segoe UI" panose="020B0502040204020203" pitchFamily="34" charset="0"/>
+            </a:endParaRPr>
           </a:p>
         </p:txBody>
       </p:sp>
@@ -7151,7 +7370,7 @@
         </p:nvSpPr>
         <p:spPr bwMode="auto">
           <a:xfrm>
-            <a:off x="834629" y="4929642"/>
+            <a:off x="1081986" y="5084017"/>
             <a:ext cx="1533975" cy="1044301"/>
           </a:xfrm>
           <a:prstGeom prst="roundRect">
@@ -8217,7 +8436,17 @@
                 <a:latin typeface="Segoe UI" panose="020B0502040204020203" pitchFamily="34" charset="0"/>
                 <a:cs typeface="Segoe UI" panose="020B0502040204020203" pitchFamily="34" charset="0"/>
               </a:rPr>
-              <a:t>DatasetType</a:t>
+              <a:t>DatasetType </a:t>
+            </a:r>
+            <a:r>
+              <a:rPr lang="en-US" sz="800">
+                <a:solidFill>
+                  <a:schemeClr val="tx1"/>
+                </a:solidFill>
+                <a:latin typeface="Segoe UI" panose="020B0502040204020203" pitchFamily="34" charset="0"/>
+                <a:cs typeface="Segoe UI" panose="020B0502040204020203" pitchFamily="34" charset="0"/>
+              </a:rPr>
+              <a:t>{1:FL 2:CN 3:LM 4:ST}</a:t>
             </a:r>
           </a:p>
           <a:p>

</xml_diff>

<commit_message>
- working on Notebooks page
</commit_message>
<xml_diff>
--- a/AlamutB/.appCatalog/Alamut.pptx
+++ b/AlamutB/.appCatalog/Alamut.pptx
@@ -198,7 +198,7 @@
           <a:p>
             <a:fld id="{76AEB20D-1E0E-486A-823D-795E0F1B1A92}" type="datetimeFigureOut">
               <a:rPr lang="en-US" smtClean="0"/>
-              <a:t>8/19/2026</a:t>
+              <a:t>8/20/2026</a:t>
             </a:fld>
             <a:endParaRPr lang="en-US"/>
           </a:p>
@@ -612,7 +612,7 @@
           <a:p>
             <a:fld id="{8A0CD729-867D-477D-ADDA-CA15108676C8}" type="datetimeFigureOut">
               <a:rPr lang="en-US" smtClean="0"/>
-              <a:t>8/19/2026</a:t>
+              <a:t>8/20/2026</a:t>
             </a:fld>
             <a:endParaRPr lang="en-US"/>
           </a:p>
@@ -810,7 +810,7 @@
           <a:p>
             <a:fld id="{8A0CD729-867D-477D-ADDA-CA15108676C8}" type="datetimeFigureOut">
               <a:rPr lang="en-US" smtClean="0"/>
-              <a:t>8/19/2026</a:t>
+              <a:t>8/20/2026</a:t>
             </a:fld>
             <a:endParaRPr lang="en-US"/>
           </a:p>
@@ -1018,7 +1018,7 @@
           <a:p>
             <a:fld id="{8A0CD729-867D-477D-ADDA-CA15108676C8}" type="datetimeFigureOut">
               <a:rPr lang="en-US" smtClean="0"/>
-              <a:t>8/19/2026</a:t>
+              <a:t>8/20/2026</a:t>
             </a:fld>
             <a:endParaRPr lang="en-US"/>
           </a:p>
@@ -1216,7 +1216,7 @@
           <a:p>
             <a:fld id="{8A0CD729-867D-477D-ADDA-CA15108676C8}" type="datetimeFigureOut">
               <a:rPr lang="en-US" smtClean="0"/>
-              <a:t>8/19/2026</a:t>
+              <a:t>8/20/2026</a:t>
             </a:fld>
             <a:endParaRPr lang="en-US"/>
           </a:p>
@@ -1491,7 +1491,7 @@
           <a:p>
             <a:fld id="{8A0CD729-867D-477D-ADDA-CA15108676C8}" type="datetimeFigureOut">
               <a:rPr lang="en-US" smtClean="0"/>
-              <a:t>8/19/2026</a:t>
+              <a:t>8/20/2026</a:t>
             </a:fld>
             <a:endParaRPr lang="en-US"/>
           </a:p>
@@ -1756,7 +1756,7 @@
           <a:p>
             <a:fld id="{8A0CD729-867D-477D-ADDA-CA15108676C8}" type="datetimeFigureOut">
               <a:rPr lang="en-US" smtClean="0"/>
-              <a:t>8/19/2026</a:t>
+              <a:t>8/20/2026</a:t>
             </a:fld>
             <a:endParaRPr lang="en-US"/>
           </a:p>
@@ -2168,7 +2168,7 @@
           <a:p>
             <a:fld id="{8A0CD729-867D-477D-ADDA-CA15108676C8}" type="datetimeFigureOut">
               <a:rPr lang="en-US" smtClean="0"/>
-              <a:t>8/19/2026</a:t>
+              <a:t>8/20/2026</a:t>
             </a:fld>
             <a:endParaRPr lang="en-US"/>
           </a:p>
@@ -2309,7 +2309,7 @@
           <a:p>
             <a:fld id="{8A0CD729-867D-477D-ADDA-CA15108676C8}" type="datetimeFigureOut">
               <a:rPr lang="en-US" smtClean="0"/>
-              <a:t>8/19/2026</a:t>
+              <a:t>8/20/2026</a:t>
             </a:fld>
             <a:endParaRPr lang="en-US"/>
           </a:p>
@@ -2422,7 +2422,7 @@
           <a:p>
             <a:fld id="{8A0CD729-867D-477D-ADDA-CA15108676C8}" type="datetimeFigureOut">
               <a:rPr lang="en-US" smtClean="0"/>
-              <a:t>8/19/2026</a:t>
+              <a:t>8/20/2026</a:t>
             </a:fld>
             <a:endParaRPr lang="en-US"/>
           </a:p>
@@ -2733,7 +2733,7 @@
           <a:p>
             <a:fld id="{8A0CD729-867D-477D-ADDA-CA15108676C8}" type="datetimeFigureOut">
               <a:rPr lang="en-US" smtClean="0"/>
-              <a:t>8/19/2026</a:t>
+              <a:t>8/20/2026</a:t>
             </a:fld>
             <a:endParaRPr lang="en-US"/>
           </a:p>
@@ -3021,7 +3021,7 @@
           <a:p>
             <a:fld id="{8A0CD729-867D-477D-ADDA-CA15108676C8}" type="datetimeFigureOut">
               <a:rPr lang="en-US" smtClean="0"/>
-              <a:t>8/19/2026</a:t>
+              <a:t>8/20/2026</a:t>
             </a:fld>
             <a:endParaRPr lang="en-US"/>
           </a:p>
@@ -3262,7 +3262,7 @@
           <a:p>
             <a:fld id="{8A0CD729-867D-477D-ADDA-CA15108676C8}" type="datetimeFigureOut">
               <a:rPr lang="en-US" smtClean="0"/>
-              <a:t>8/19/2026</a:t>
+              <a:t>8/20/2026</a:t>
             </a:fld>
             <a:endParaRPr lang="en-US"/>
           </a:p>
@@ -3699,8 +3699,8 @@
         </p:nvSpPr>
         <p:spPr>
           <a:xfrm rot="4906371">
-            <a:off x="1098035" y="839580"/>
-            <a:ext cx="5345974" cy="6842123"/>
+            <a:off x="941089" y="645113"/>
+            <a:ext cx="5339144" cy="7304071"/>
           </a:xfrm>
           <a:custGeom>
             <a:avLst/>
@@ -5879,6 +5879,114 @@
               <a:gd name="csY7" fmla="*/ 3578052 h 7029137"/>
               <a:gd name="csX8" fmla="*/ 369988 w 5251399"/>
               <a:gd name="csY8" fmla="*/ 227477 h 7029137"/>
+              <a:gd name="csX0" fmla="*/ 369988 w 5251586"/>
+              <a:gd name="csY0" fmla="*/ 227477 h 7179173"/>
+              <a:gd name="csX1" fmla="*/ 4363942 w 5251586"/>
+              <a:gd name="csY1" fmla="*/ 371209 h 7179173"/>
+              <a:gd name="csX2" fmla="*/ 5250036 w 5251586"/>
+              <a:gd name="csY2" fmla="*/ 941811 h 7179173"/>
+              <a:gd name="csX3" fmla="*/ 4302766 w 5251586"/>
+              <a:gd name="csY3" fmla="*/ 6774460 h 7179173"/>
+              <a:gd name="csX4" fmla="*/ 2448160 w 5251586"/>
+              <a:gd name="csY4" fmla="*/ 6822296 h 7179173"/>
+              <a:gd name="csX5" fmla="*/ 153940 w 5251586"/>
+              <a:gd name="csY5" fmla="*/ 6863513 h 7179173"/>
+              <a:gd name="csX6" fmla="*/ 397928 w 5251586"/>
+              <a:gd name="csY6" fmla="*/ 5524331 h 7179173"/>
+              <a:gd name="csX7" fmla="*/ 578489 w 5251586"/>
+              <a:gd name="csY7" fmla="*/ 3578052 h 7179173"/>
+              <a:gd name="csX8" fmla="*/ 369988 w 5251586"/>
+              <a:gd name="csY8" fmla="*/ 227477 h 7179173"/>
+              <a:gd name="csX0" fmla="*/ 369988 w 5251355"/>
+              <a:gd name="csY0" fmla="*/ 227477 h 7277153"/>
+              <a:gd name="csX1" fmla="*/ 4363942 w 5251355"/>
+              <a:gd name="csY1" fmla="*/ 371209 h 7277153"/>
+              <a:gd name="csX2" fmla="*/ 5250036 w 5251355"/>
+              <a:gd name="csY2" fmla="*/ 941811 h 7277153"/>
+              <a:gd name="csX3" fmla="*/ 4142603 w 5251355"/>
+              <a:gd name="csY3" fmla="*/ 6899646 h 7277153"/>
+              <a:gd name="csX4" fmla="*/ 2448160 w 5251355"/>
+              <a:gd name="csY4" fmla="*/ 6822296 h 7277153"/>
+              <a:gd name="csX5" fmla="*/ 153940 w 5251355"/>
+              <a:gd name="csY5" fmla="*/ 6863513 h 7277153"/>
+              <a:gd name="csX6" fmla="*/ 397928 w 5251355"/>
+              <a:gd name="csY6" fmla="*/ 5524331 h 7277153"/>
+              <a:gd name="csX7" fmla="*/ 578489 w 5251355"/>
+              <a:gd name="csY7" fmla="*/ 3578052 h 7277153"/>
+              <a:gd name="csX8" fmla="*/ 369988 w 5251355"/>
+              <a:gd name="csY8" fmla="*/ 227477 h 7277153"/>
+              <a:gd name="csX0" fmla="*/ 367016 w 5248383"/>
+              <a:gd name="csY0" fmla="*/ 227477 h 7304567"/>
+              <a:gd name="csX1" fmla="*/ 4360970 w 5248383"/>
+              <a:gd name="csY1" fmla="*/ 371209 h 7304567"/>
+              <a:gd name="csX2" fmla="*/ 5247064 w 5248383"/>
+              <a:gd name="csY2" fmla="*/ 941811 h 7304567"/>
+              <a:gd name="csX3" fmla="*/ 4139631 w 5248383"/>
+              <a:gd name="csY3" fmla="*/ 6899646 h 7304567"/>
+              <a:gd name="csX4" fmla="*/ 2405023 w 5248383"/>
+              <a:gd name="csY4" fmla="*/ 6930473 h 7304567"/>
+              <a:gd name="csX5" fmla="*/ 150968 w 5248383"/>
+              <a:gd name="csY5" fmla="*/ 6863513 h 7304567"/>
+              <a:gd name="csX6" fmla="*/ 394956 w 5248383"/>
+              <a:gd name="csY6" fmla="*/ 5524331 h 7304567"/>
+              <a:gd name="csX7" fmla="*/ 575517 w 5248383"/>
+              <a:gd name="csY7" fmla="*/ 3578052 h 7304567"/>
+              <a:gd name="csX8" fmla="*/ 367016 w 5248383"/>
+              <a:gd name="csY8" fmla="*/ 227477 h 7304567"/>
+              <a:gd name="csX0" fmla="*/ 377903 w 5259270"/>
+              <a:gd name="csY0" fmla="*/ 227477 h 7300614"/>
+              <a:gd name="csX1" fmla="*/ 4371857 w 5259270"/>
+              <a:gd name="csY1" fmla="*/ 371209 h 7300614"/>
+              <a:gd name="csX2" fmla="*/ 5257951 w 5259270"/>
+              <a:gd name="csY2" fmla="*/ 941811 h 7300614"/>
+              <a:gd name="csX3" fmla="*/ 4150518 w 5259270"/>
+              <a:gd name="csY3" fmla="*/ 6899646 h 7300614"/>
+              <a:gd name="csX4" fmla="*/ 2415910 w 5259270"/>
+              <a:gd name="csY4" fmla="*/ 6930473 h 7300614"/>
+              <a:gd name="csX5" fmla="*/ 147573 w 5259270"/>
+              <a:gd name="csY5" fmla="*/ 6966817 h 7300614"/>
+              <a:gd name="csX6" fmla="*/ 405843 w 5259270"/>
+              <a:gd name="csY6" fmla="*/ 5524331 h 7300614"/>
+              <a:gd name="csX7" fmla="*/ 586404 w 5259270"/>
+              <a:gd name="csY7" fmla="*/ 3578052 h 7300614"/>
+              <a:gd name="csX8" fmla="*/ 377903 w 5259270"/>
+              <a:gd name="csY8" fmla="*/ 227477 h 7300614"/>
+              <a:gd name="csX0" fmla="*/ 377903 w 5259389"/>
+              <a:gd name="csY0" fmla="*/ 227477 h 7465170"/>
+              <a:gd name="csX1" fmla="*/ 4371857 w 5259389"/>
+              <a:gd name="csY1" fmla="*/ 371209 h 7465170"/>
+              <a:gd name="csX2" fmla="*/ 5257951 w 5259389"/>
+              <a:gd name="csY2" fmla="*/ 941811 h 7465170"/>
+              <a:gd name="csX3" fmla="*/ 4239573 w 5259389"/>
+              <a:gd name="csY3" fmla="*/ 7106459 h 7465170"/>
+              <a:gd name="csX4" fmla="*/ 2415910 w 5259389"/>
+              <a:gd name="csY4" fmla="*/ 6930473 h 7465170"/>
+              <a:gd name="csX5" fmla="*/ 147573 w 5259389"/>
+              <a:gd name="csY5" fmla="*/ 6966817 h 7465170"/>
+              <a:gd name="csX6" fmla="*/ 405843 w 5259389"/>
+              <a:gd name="csY6" fmla="*/ 5524331 h 7465170"/>
+              <a:gd name="csX7" fmla="*/ 586404 w 5259389"/>
+              <a:gd name="csY7" fmla="*/ 3578052 h 7465170"/>
+              <a:gd name="csX8" fmla="*/ 377903 w 5259389"/>
+              <a:gd name="csY8" fmla="*/ 227477 h 7465170"/>
+              <a:gd name="csX0" fmla="*/ 363205 w 5244691"/>
+              <a:gd name="csY0" fmla="*/ 227477 h 7503711"/>
+              <a:gd name="csX1" fmla="*/ 4357159 w 5244691"/>
+              <a:gd name="csY1" fmla="*/ 371209 h 7503711"/>
+              <a:gd name="csX2" fmla="*/ 5243253 w 5244691"/>
+              <a:gd name="csY2" fmla="*/ 941811 h 7503711"/>
+              <a:gd name="csX3" fmla="*/ 4224875 w 5244691"/>
+              <a:gd name="csY3" fmla="*/ 7106459 h 7503711"/>
+              <a:gd name="csX4" fmla="*/ 2202171 w 5244691"/>
+              <a:gd name="csY4" fmla="*/ 7093723 h 7503711"/>
+              <a:gd name="csX5" fmla="*/ 132875 w 5244691"/>
+              <a:gd name="csY5" fmla="*/ 6966817 h 7503711"/>
+              <a:gd name="csX6" fmla="*/ 391145 w 5244691"/>
+              <a:gd name="csY6" fmla="*/ 5524331 h 7503711"/>
+              <a:gd name="csX7" fmla="*/ 571706 w 5244691"/>
+              <a:gd name="csY7" fmla="*/ 3578052 h 7503711"/>
+              <a:gd name="csX8" fmla="*/ 363205 w 5244691"/>
+              <a:gd name="csY8" fmla="*/ 227477 h 7503711"/>
             </a:gdLst>
             <a:ahLst/>
             <a:cxnLst>
@@ -5912,49 +6020,49 @@
             </a:cxnLst>
             <a:rect l="l" t="t" r="r" b="b"/>
             <a:pathLst>
-              <a:path w="5251399" h="7029137">
+              <a:path w="5244691" h="7503711">
                 <a:moveTo>
-                  <a:pt x="369988" y="227477"/>
+                  <a:pt x="363205" y="227477"/>
                 </a:moveTo>
                 <a:cubicBezTo>
-                  <a:pt x="1000897" y="-306997"/>
-                  <a:pt x="3550601" y="252153"/>
-                  <a:pt x="4363942" y="371209"/>
+                  <a:pt x="994114" y="-306997"/>
+                  <a:pt x="3543818" y="252153"/>
+                  <a:pt x="4357159" y="371209"/>
                 </a:cubicBezTo>
                 <a:cubicBezTo>
-                  <a:pt x="5177283" y="490265"/>
-                  <a:pt x="5164004" y="622415"/>
-                  <a:pt x="5250036" y="941811"/>
+                  <a:pt x="5170500" y="490265"/>
+                  <a:pt x="5157221" y="622415"/>
+                  <a:pt x="5243253" y="941811"/>
                 </a:cubicBezTo>
                 <a:cubicBezTo>
-                  <a:pt x="5293586" y="1205617"/>
-                  <a:pt x="4280284" y="6215526"/>
-                  <a:pt x="4177214" y="6588493"/>
+                  <a:pt x="5286803" y="1205617"/>
+                  <a:pt x="4327945" y="6733492"/>
+                  <a:pt x="4224875" y="7106459"/>
                 </a:cubicBezTo>
                 <a:cubicBezTo>
-                  <a:pt x="3735280" y="7478096"/>
-                  <a:pt x="3096883" y="6542178"/>
-                  <a:pt x="2448160" y="6822296"/>
+                  <a:pt x="3782941" y="7996062"/>
+                  <a:pt x="2884171" y="7116997"/>
+                  <a:pt x="2202171" y="7093723"/>
                 </a:cubicBezTo>
                 <a:cubicBezTo>
-                  <a:pt x="1799437" y="7102414"/>
-                  <a:pt x="495645" y="7079840"/>
-                  <a:pt x="153940" y="6863513"/>
+                  <a:pt x="1520171" y="7070449"/>
+                  <a:pt x="434713" y="7228382"/>
+                  <a:pt x="132875" y="6966817"/>
                 </a:cubicBezTo>
                 <a:cubicBezTo>
-                  <a:pt x="-187765" y="6647186"/>
-                  <a:pt x="104874" y="5818557"/>
-                  <a:pt x="397928" y="5524331"/>
+                  <a:pt x="-168963" y="6705252"/>
+                  <a:pt x="98091" y="5818557"/>
+                  <a:pt x="391145" y="5524331"/>
                 </a:cubicBezTo>
                 <a:cubicBezTo>
-                  <a:pt x="602881" y="5034644"/>
-                  <a:pt x="623205" y="4460717"/>
-                  <a:pt x="578489" y="3578052"/>
+                  <a:pt x="596098" y="5034644"/>
+                  <a:pt x="616422" y="4460717"/>
+                  <a:pt x="571706" y="3578052"/>
                 </a:cubicBezTo>
                 <a:cubicBezTo>
-                  <a:pt x="422277" y="2585958"/>
-                  <a:pt x="-260921" y="761951"/>
-                  <a:pt x="369988" y="227477"/>
+                  <a:pt x="415494" y="2585958"/>
+                  <a:pt x="-267704" y="761951"/>
+                  <a:pt x="363205" y="227477"/>
                 </a:cubicBezTo>
                 <a:close/>
               </a:path>
@@ -6017,9 +6125,9 @@
           <p:nvPr/>
         </p:nvSpPr>
         <p:spPr bwMode="auto">
-          <a:xfrm rot="17046999">
-            <a:off x="7240543" y="1330382"/>
-            <a:ext cx="4398995" cy="5763098"/>
+          <a:xfrm rot="15834999">
+            <a:off x="6605165" y="850255"/>
+            <a:ext cx="5342483" cy="5460779"/>
           </a:xfrm>
           <a:custGeom>
             <a:avLst/>
@@ -6384,6 +6492,66 @@
               <a:gd name="csY3" fmla="*/ 7092866 h 7582128"/>
               <a:gd name="csX4" fmla="*/ 481538 w 5000978"/>
               <a:gd name="csY4" fmla="*/ 567495 h 7582128"/>
+              <a:gd name="csX0" fmla="*/ 864022 w 5383462"/>
+              <a:gd name="csY0" fmla="*/ 435073 h 7186175"/>
+              <a:gd name="csX1" fmla="*/ 4921621 w 5383462"/>
+              <a:gd name="csY1" fmla="*/ 1082118 h 7186175"/>
+              <a:gd name="csX2" fmla="*/ 4265961 w 5383462"/>
+              <a:gd name="csY2" fmla="*/ 5764027 h 7186175"/>
+              <a:gd name="csX3" fmla="*/ 270387 w 5383462"/>
+              <a:gd name="csY3" fmla="*/ 6555114 h 7186175"/>
+              <a:gd name="csX4" fmla="*/ 864022 w 5383462"/>
+              <a:gd name="csY4" fmla="*/ 435073 h 7186175"/>
+              <a:gd name="csX0" fmla="*/ 928990 w 5995575"/>
+              <a:gd name="csY0" fmla="*/ 470298 h 7737115"/>
+              <a:gd name="csX1" fmla="*/ 4986589 w 5995575"/>
+              <a:gd name="csY1" fmla="*/ 1117343 h 7737115"/>
+              <a:gd name="csX2" fmla="*/ 5208084 w 5995575"/>
+              <a:gd name="csY2" fmla="*/ 6690835 h 7737115"/>
+              <a:gd name="csX3" fmla="*/ 335355 w 5995575"/>
+              <a:gd name="csY3" fmla="*/ 6590339 h 7737115"/>
+              <a:gd name="csX4" fmla="*/ 928990 w 5995575"/>
+              <a:gd name="csY4" fmla="*/ 470298 h 7737115"/>
+              <a:gd name="csX0" fmla="*/ 644829 w 6221087"/>
+              <a:gd name="csY0" fmla="*/ 577088 h 7467168"/>
+              <a:gd name="csX1" fmla="*/ 5190010 w 6221087"/>
+              <a:gd name="csY1" fmla="*/ 865587 h 7467168"/>
+              <a:gd name="csX2" fmla="*/ 5411505 w 6221087"/>
+              <a:gd name="csY2" fmla="*/ 6439079 h 7467168"/>
+              <a:gd name="csX3" fmla="*/ 538776 w 6221087"/>
+              <a:gd name="csY3" fmla="*/ 6338583 h 7467168"/>
+              <a:gd name="csX4" fmla="*/ 644829 w 6221087"/>
+              <a:gd name="csY4" fmla="*/ 577088 h 7467168"/>
+              <a:gd name="csX0" fmla="*/ 805838 w 6074152"/>
+              <a:gd name="csY0" fmla="*/ 496933 h 7658024"/>
+              <a:gd name="csX1" fmla="*/ 5056506 w 6074152"/>
+              <a:gd name="csY1" fmla="*/ 1043387 h 7658024"/>
+              <a:gd name="csX2" fmla="*/ 5278001 w 6074152"/>
+              <a:gd name="csY2" fmla="*/ 6616879 h 7658024"/>
+              <a:gd name="csX3" fmla="*/ 405272 w 6074152"/>
+              <a:gd name="csY3" fmla="*/ 6516383 h 7658024"/>
+              <a:gd name="csX4" fmla="*/ 805838 w 6074152"/>
+              <a:gd name="csY4" fmla="*/ 496933 h 7658024"/>
+              <a:gd name="csX0" fmla="*/ 787452 w 6055766"/>
+              <a:gd name="csY0" fmla="*/ 496933 h 7743743"/>
+              <a:gd name="csX1" fmla="*/ 5038120 w 6055766"/>
+              <a:gd name="csY1" fmla="*/ 1043387 h 7743743"/>
+              <a:gd name="csX2" fmla="*/ 5259615 w 6055766"/>
+              <a:gd name="csY2" fmla="*/ 6616879 h 7743743"/>
+              <a:gd name="csX3" fmla="*/ 386886 w 6055766"/>
+              <a:gd name="csY3" fmla="*/ 6516383 h 7743743"/>
+              <a:gd name="csX4" fmla="*/ 787452 w 6055766"/>
+              <a:gd name="csY4" fmla="*/ 496933 h 7743743"/>
+              <a:gd name="csX0" fmla="*/ 839520 w 6107834"/>
+              <a:gd name="csY0" fmla="*/ 451596 h 7479185"/>
+              <a:gd name="csX1" fmla="*/ 5090188 w 6107834"/>
+              <a:gd name="csY1" fmla="*/ 998050 h 7479185"/>
+              <a:gd name="csX2" fmla="*/ 5311683 w 6107834"/>
+              <a:gd name="csY2" fmla="*/ 6571542 h 7479185"/>
+              <a:gd name="csX3" fmla="*/ 367608 w 6107834"/>
+              <a:gd name="csY3" fmla="*/ 5850055 h 7479185"/>
+              <a:gd name="csX4" fmla="*/ 839520 w 6107834"/>
+              <a:gd name="csY4" fmla="*/ 451596 h 7479185"/>
             </a:gdLst>
             <a:ahLst/>
             <a:cxnLst>
@@ -6405,29 +6573,29 @@
             </a:cxnLst>
             <a:rect l="l" t="t" r="r" b="b"/>
             <a:pathLst>
-              <a:path w="5000978" h="7582128">
+              <a:path w="6107834" h="7479185">
                 <a:moveTo>
-                  <a:pt x="481538" y="567495"/>
+                  <a:pt x="839520" y="451596"/>
                 </a:moveTo>
                 <a:cubicBezTo>
-                  <a:pt x="1381667" y="-642646"/>
-                  <a:pt x="3972147" y="326381"/>
-                  <a:pt x="4539137" y="1214540"/>
+                  <a:pt x="1626616" y="-357071"/>
+                  <a:pt x="4344828" y="-21941"/>
+                  <a:pt x="5090188" y="998050"/>
                 </a:cubicBezTo>
                 <a:cubicBezTo>
-                  <a:pt x="5106127" y="2102699"/>
-                  <a:pt x="5406879" y="3321431"/>
-                  <a:pt x="3883477" y="5896449"/>
+                  <a:pt x="5835548" y="2018041"/>
+                  <a:pt x="6835085" y="3996524"/>
+                  <a:pt x="5311683" y="6571542"/>
                 </a:cubicBezTo>
                 <a:cubicBezTo>
-                  <a:pt x="2661680" y="7704471"/>
-                  <a:pt x="1250466" y="7981025"/>
-                  <a:pt x="683476" y="7092866"/>
+                  <a:pt x="4089886" y="8379564"/>
+                  <a:pt x="1070986" y="7140168"/>
+                  <a:pt x="367608" y="5850055"/>
                 </a:cubicBezTo>
                 <a:cubicBezTo>
-                  <a:pt x="116486" y="6204707"/>
-                  <a:pt x="-418591" y="1777636"/>
-                  <a:pt x="481538" y="567495"/>
+                  <a:pt x="-335770" y="4559942"/>
+                  <a:pt x="52424" y="1260263"/>
+                  <a:pt x="839520" y="451596"/>
                 </a:cubicBezTo>
                 <a:close/>
               </a:path>
@@ -6491,7 +6659,7 @@
         </p:nvSpPr>
         <p:spPr>
           <a:xfrm rot="7180819">
-            <a:off x="1208703" y="-763277"/>
+            <a:off x="1276439" y="-763277"/>
             <a:ext cx="3175904" cy="3958560"/>
           </a:xfrm>
           <a:custGeom>
@@ -6761,7 +6929,7 @@
         </p:nvSpPr>
         <p:spPr bwMode="auto">
           <a:xfrm>
-            <a:off x="1024114" y="428460"/>
+            <a:off x="1091850" y="428460"/>
             <a:ext cx="1395681" cy="948228"/>
           </a:xfrm>
           <a:prstGeom prst="roundRect">
@@ -6870,8 +7038,8 @@
         </p:nvSpPr>
         <p:spPr bwMode="auto">
           <a:xfrm>
-            <a:off x="169682" y="2260157"/>
-            <a:ext cx="1438256" cy="3799085"/>
+            <a:off x="237418" y="2204171"/>
+            <a:ext cx="1438256" cy="3963361"/>
           </a:xfrm>
           <a:prstGeom prst="roundRect">
             <a:avLst>
@@ -7057,7 +7225,17 @@
                 <a:latin typeface="Segoe UI" panose="020B0502040204020203" pitchFamily="34" charset="0"/>
                 <a:cs typeface="Segoe UI" panose="020B0502040204020203" pitchFamily="34" charset="0"/>
               </a:rPr>
-              <a:t>NoteTags</a:t>
+              <a:t>Note</a:t>
+            </a:r>
+            <a:r>
+              <a:rPr lang="en-US" sz="900">
+                <a:solidFill>
+                  <a:srgbClr val="C00000"/>
+                </a:solidFill>
+                <a:latin typeface="Segoe UI" panose="020B0502040204020203" pitchFamily="34" charset="0"/>
+                <a:cs typeface="Segoe UI" panose="020B0502040204020203" pitchFamily="34" charset="0"/>
+              </a:rPr>
+              <a:t>Tags</a:t>
             </a:r>
           </a:p>
           <a:p>
@@ -7072,7 +7250,7 @@
                 <a:latin typeface="Segoe UI" panose="020B0502040204020203" pitchFamily="34" charset="0"/>
                 <a:cs typeface="Segoe UI" panose="020B0502040204020203" pitchFamily="34" charset="0"/>
               </a:rPr>
-              <a:t> 1: Rtl</a:t>
+              <a:t> 1: IsRtl</a:t>
             </a:r>
           </a:p>
           <a:p>
@@ -7087,7 +7265,7 @@
                 <a:latin typeface="Segoe UI" panose="020B0502040204020203" pitchFamily="34" charset="0"/>
                 <a:cs typeface="Segoe UI" panose="020B0502040204020203" pitchFamily="34" charset="0"/>
               </a:rPr>
-              <a:t> 2: Bookmarked</a:t>
+              <a:t> 2: IsShared</a:t>
             </a:r>
           </a:p>
           <a:p>
@@ -7102,7 +7280,7 @@
                 <a:latin typeface="Segoe UI" panose="020B0502040204020203" pitchFamily="34" charset="0"/>
                 <a:cs typeface="Segoe UI" panose="020B0502040204020203" pitchFamily="34" charset="0"/>
               </a:rPr>
-              <a:t> 4: Todo</a:t>
+              <a:t> 4: IsBookmarked</a:t>
             </a:r>
           </a:p>
           <a:p>
@@ -7117,7 +7295,7 @@
                 <a:latin typeface="Segoe UI" panose="020B0502040204020203" pitchFamily="34" charset="0"/>
                 <a:cs typeface="Segoe UI" panose="020B0502040204020203" pitchFamily="34" charset="0"/>
               </a:rPr>
-              <a:t> 8: Read</a:t>
+              <a:t> 8: IsTodo</a:t>
             </a:r>
           </a:p>
           <a:p>
@@ -7132,7 +7310,22 @@
                 <a:latin typeface="Segoe UI" panose="020B0502040204020203" pitchFamily="34" charset="0"/>
                 <a:cs typeface="Segoe UI" panose="020B0502040204020203" pitchFamily="34" charset="0"/>
               </a:rPr>
-              <a:t>16: Done</a:t>
+              <a:t>16: IsRead</a:t>
+            </a:r>
+          </a:p>
+          <a:p>
+            <a:pPr marL="84138">
+              <a:defRPr/>
+            </a:pPr>
+            <a:r>
+              <a:rPr lang="en-US" sz="800">
+                <a:solidFill>
+                  <a:schemeClr val="tx1"/>
+                </a:solidFill>
+                <a:latin typeface="Segoe UI" panose="020B0502040204020203" pitchFamily="34" charset="0"/>
+                <a:cs typeface="Segoe UI" panose="020B0502040204020203" pitchFamily="34" charset="0"/>
+              </a:rPr>
+              <a:t>32: IsDone</a:t>
             </a:r>
           </a:p>
           <a:p>
@@ -7148,7 +7341,7 @@
             </a:endParaRPr>
           </a:p>
           <a:p>
-            <a:pPr marL="84138">
+            <a:pPr>
               <a:defRPr/>
             </a:pPr>
             <a:r>
@@ -7370,7 +7563,7 @@
         </p:nvSpPr>
         <p:spPr bwMode="auto">
           <a:xfrm>
-            <a:off x="1081986" y="5084017"/>
+            <a:off x="1200524" y="5253353"/>
             <a:ext cx="1533975" cy="1044301"/>
           </a:xfrm>
           <a:prstGeom prst="roundRect">
@@ -7516,7 +7709,7 @@
         </p:nvSpPr>
         <p:spPr bwMode="auto">
           <a:xfrm>
-            <a:off x="2622482" y="216031"/>
+            <a:off x="2690218" y="216031"/>
             <a:ext cx="1395681" cy="948228"/>
           </a:xfrm>
           <a:prstGeom prst="roundRect">
@@ -7632,7 +7825,7 @@
         </p:nvSpPr>
         <p:spPr bwMode="auto">
           <a:xfrm>
-            <a:off x="3184333" y="922742"/>
+            <a:off x="3252069" y="922742"/>
             <a:ext cx="1275139" cy="1163457"/>
           </a:xfrm>
           <a:prstGeom prst="roundRect">
@@ -7763,7 +7956,7 @@
         </p:nvSpPr>
         <p:spPr bwMode="auto">
           <a:xfrm>
-            <a:off x="1317489" y="1234053"/>
+            <a:off x="1385225" y="1234053"/>
             <a:ext cx="1769091" cy="2555899"/>
           </a:xfrm>
           <a:prstGeom prst="roundRect">
@@ -7935,13 +8128,18 @@
                 <a:latin typeface="Segoe UI" panose="020B0502040204020203" pitchFamily="34" charset="0"/>
                 <a:cs typeface="Segoe UI" panose="020B0502040204020203" pitchFamily="34" charset="0"/>
               </a:rPr>
-              <a:t>UserTags</a:t>
-            </a:r>
-          </a:p>
-          <a:p>
-            <a:pPr>
-              <a:defRPr/>
-            </a:pPr>
+              <a:t>User</a:t>
+            </a:r>
+            <a:r>
+              <a:rPr lang="en-US" sz="900">
+                <a:solidFill>
+                  <a:srgbClr val="C00000"/>
+                </a:solidFill>
+                <a:latin typeface="Segoe UI" panose="020B0502040204020203" pitchFamily="34" charset="0"/>
+                <a:cs typeface="Segoe UI" panose="020B0502040204020203" pitchFamily="34" charset="0"/>
+              </a:rPr>
+              <a:t>Tags</a:t>
+            </a:r>
             <a:endParaRPr lang="en-US" sz="900">
               <a:solidFill>
                 <a:schemeClr val="tx1"/>
@@ -8041,8 +8239,8 @@
         </p:nvSpPr>
         <p:spPr bwMode="auto">
           <a:xfrm>
-            <a:off x="2028293" y="3714499"/>
-            <a:ext cx="1625139" cy="2094524"/>
+            <a:off x="2096029" y="3714498"/>
+            <a:ext cx="1625139" cy="2220759"/>
           </a:xfrm>
           <a:prstGeom prst="roundRect">
             <a:avLst>
@@ -8198,22 +8396,44 @@
                 <a:latin typeface="Segoe UI" panose="020B0502040204020203" pitchFamily="34" charset="0"/>
                 <a:cs typeface="Segoe UI" panose="020B0502040204020203" pitchFamily="34" charset="0"/>
               </a:rPr>
-              <a:t>SetTags</a:t>
-            </a:r>
-          </a:p>
-          <a:p>
-            <a:pPr marL="179388">
-              <a:defRPr/>
-            </a:pPr>
-            <a:r>
-              <a:rPr lang="en-US" sz="800" i="1">
-                <a:solidFill>
-                  <a:schemeClr val="tx1"/>
-                </a:solidFill>
-                <a:latin typeface="Segoe UI" panose="020B0502040204020203" pitchFamily="34" charset="0"/>
-                <a:cs typeface="Segoe UI" panose="020B0502040204020203" pitchFamily="34" charset="0"/>
-              </a:rPr>
-              <a:t>types</a:t>
+              <a:t>Set</a:t>
+            </a:r>
+            <a:r>
+              <a:rPr lang="en-US" sz="900">
+                <a:solidFill>
+                  <a:srgbClr val="C00000"/>
+                </a:solidFill>
+                <a:latin typeface="Segoe UI" panose="020B0502040204020203" pitchFamily="34" charset="0"/>
+                <a:cs typeface="Segoe UI" panose="020B0502040204020203" pitchFamily="34" charset="0"/>
+              </a:rPr>
+              <a:t>Tags</a:t>
+            </a:r>
+          </a:p>
+          <a:p>
+            <a:pPr marL="85725">
+              <a:defRPr/>
+            </a:pPr>
+            <a:endParaRPr lang="en-US" sz="900">
+              <a:solidFill>
+                <a:srgbClr val="C00000"/>
+              </a:solidFill>
+              <a:latin typeface="Segoe UI" panose="020B0502040204020203" pitchFamily="34" charset="0"/>
+              <a:cs typeface="Segoe UI" panose="020B0502040204020203" pitchFamily="34" charset="0"/>
+            </a:endParaRPr>
+          </a:p>
+          <a:p>
+            <a:pPr marL="93663">
+              <a:defRPr/>
+            </a:pPr>
+            <a:r>
+              <a:rPr lang="en-US" sz="800" b="1" i="1">
+                <a:solidFill>
+                  <a:schemeClr val="tx1"/>
+                </a:solidFill>
+                <a:latin typeface="Segoe UI" panose="020B0502040204020203" pitchFamily="34" charset="0"/>
+                <a:cs typeface="Segoe UI" panose="020B0502040204020203" pitchFamily="34" charset="0"/>
+              </a:rPr>
+              <a:t>SetTypes</a:t>
             </a:r>
             <a:r>
               <a:rPr lang="en-US" sz="800">
@@ -8317,7 +8537,7 @@
         </p:nvSpPr>
         <p:spPr bwMode="auto">
           <a:xfrm>
-            <a:off x="3010164" y="1944363"/>
+            <a:off x="3077900" y="1944363"/>
             <a:ext cx="2172080" cy="2843039"/>
           </a:xfrm>
           <a:prstGeom prst="roundRect">
@@ -8446,7 +8666,27 @@
                 <a:latin typeface="Segoe UI" panose="020B0502040204020203" pitchFamily="34" charset="0"/>
                 <a:cs typeface="Segoe UI" panose="020B0502040204020203" pitchFamily="34" charset="0"/>
               </a:rPr>
-              <a:t>{1:FL 2:CN 3:LM 4:ST}</a:t>
+              <a:t>{</a:t>
+            </a:r>
+            <a:r>
+              <a:rPr lang="en-US" sz="800">
+                <a:solidFill>
+                  <a:srgbClr val="C00000"/>
+                </a:solidFill>
+                <a:latin typeface="Segoe UI" panose="020B0502040204020203" pitchFamily="34" charset="0"/>
+                <a:cs typeface="Segoe UI" panose="020B0502040204020203" pitchFamily="34" charset="0"/>
+              </a:rPr>
+              <a:t>1:FL 2:CN 3:LM 4:ST</a:t>
+            </a:r>
+            <a:r>
+              <a:rPr lang="en-US" sz="800">
+                <a:solidFill>
+                  <a:schemeClr val="tx1"/>
+                </a:solidFill>
+                <a:latin typeface="Segoe UI" panose="020B0502040204020203" pitchFamily="34" charset="0"/>
+                <a:cs typeface="Segoe UI" panose="020B0502040204020203" pitchFamily="34" charset="0"/>
+              </a:rPr>
+              <a:t>}</a:t>
             </a:r>
           </a:p>
           <a:p>
@@ -8641,7 +8881,17 @@
                 <a:latin typeface="Segoe UI" panose="020B0502040204020203" pitchFamily="34" charset="0"/>
                 <a:cs typeface="Segoe UI" panose="020B0502040204020203" pitchFamily="34" charset="0"/>
               </a:rPr>
-              <a:t>DatasetTags</a:t>
+              <a:t>Dataset</a:t>
+            </a:r>
+            <a:r>
+              <a:rPr lang="en-US" sz="900">
+                <a:solidFill>
+                  <a:srgbClr val="C00000"/>
+                </a:solidFill>
+                <a:latin typeface="Segoe UI" panose="020B0502040204020203" pitchFamily="34" charset="0"/>
+                <a:cs typeface="Segoe UI" panose="020B0502040204020203" pitchFamily="34" charset="0"/>
+              </a:rPr>
+              <a:t>Tags</a:t>
             </a:r>
           </a:p>
         </p:txBody>
@@ -8660,7 +8910,7 @@
         </p:nvSpPr>
         <p:spPr bwMode="auto">
           <a:xfrm>
-            <a:off x="4855520" y="2675240"/>
+            <a:off x="4923256" y="2675240"/>
             <a:ext cx="1821350" cy="1320153"/>
           </a:xfrm>
           <a:prstGeom prst="roundRect">
@@ -8851,7 +9101,7 @@
         </p:nvSpPr>
         <p:spPr bwMode="auto">
           <a:xfrm>
-            <a:off x="4860267" y="4097135"/>
+            <a:off x="4928003" y="4097135"/>
             <a:ext cx="1821351" cy="956800"/>
           </a:xfrm>
           <a:prstGeom prst="roundRect">
@@ -8982,7 +9232,7 @@
         </p:nvSpPr>
         <p:spPr bwMode="auto">
           <a:xfrm>
-            <a:off x="4853691" y="1678316"/>
+            <a:off x="4921427" y="1678316"/>
             <a:ext cx="1747105" cy="871715"/>
           </a:xfrm>
           <a:prstGeom prst="roundRect">
@@ -9128,7 +9378,7 @@
         </p:nvSpPr>
         <p:spPr>
           <a:xfrm>
-            <a:off x="8251847" y="-591923"/>
+            <a:off x="7392551" y="-624829"/>
             <a:ext cx="4113873" cy="2215991"/>
           </a:xfrm>
           <a:prstGeom prst="rect">
@@ -9201,7 +9451,7 @@
         </p:nvSpPr>
         <p:spPr bwMode="auto">
           <a:xfrm>
-            <a:off x="3010164" y="5135864"/>
+            <a:off x="3077900" y="5135864"/>
             <a:ext cx="2144506" cy="1213704"/>
           </a:xfrm>
           <a:prstGeom prst="roundRect">
@@ -9355,7 +9605,7 @@
         </p:nvSpPr>
         <p:spPr bwMode="auto">
           <a:xfrm>
-            <a:off x="4853691" y="5310077"/>
+            <a:off x="4921427" y="5310077"/>
             <a:ext cx="1821350" cy="1140311"/>
           </a:xfrm>
           <a:prstGeom prst="roundRect">
@@ -9528,8 +9778,8 @@
         </p:nvSpPr>
         <p:spPr bwMode="auto">
           <a:xfrm>
-            <a:off x="6492638" y="2335913"/>
-            <a:ext cx="1416106" cy="3287717"/>
+            <a:off x="6560374" y="2204171"/>
+            <a:ext cx="1416106" cy="3419459"/>
           </a:xfrm>
           <a:prstGeom prst="roundRect">
             <a:avLst>
@@ -9836,7 +10086,7 @@
         </p:nvSpPr>
         <p:spPr bwMode="auto">
           <a:xfrm>
-            <a:off x="7539375" y="2743079"/>
+            <a:off x="7607111" y="2743079"/>
             <a:ext cx="1278585" cy="1009790"/>
           </a:xfrm>
           <a:prstGeom prst="roundRect">
@@ -9982,7 +10232,7 @@
         </p:nvSpPr>
         <p:spPr bwMode="auto">
           <a:xfrm>
-            <a:off x="8430527" y="1906672"/>
+            <a:off x="8498263" y="1906672"/>
             <a:ext cx="1233203" cy="1596320"/>
           </a:xfrm>
           <a:prstGeom prst="roundRect">
@@ -10162,7 +10412,17 @@
                 <a:latin typeface="Segoe UI" panose="020B0502040204020203" pitchFamily="34" charset="0"/>
                 <a:cs typeface="Segoe UI" panose="020B0502040204020203" pitchFamily="34" charset="0"/>
               </a:rPr>
-              <a:t>FamilyTags</a:t>
+              <a:t>Family</a:t>
+            </a:r>
+            <a:r>
+              <a:rPr lang="en-US" sz="900">
+                <a:solidFill>
+                  <a:srgbClr val="C00000"/>
+                </a:solidFill>
+                <a:latin typeface="Segoe UI" panose="020B0502040204020203" pitchFamily="34" charset="0"/>
+                <a:cs typeface="Segoe UI" panose="020B0502040204020203" pitchFamily="34" charset="0"/>
+              </a:rPr>
+              <a:t>Tags</a:t>
             </a:r>
           </a:p>
           <a:p>
@@ -10193,7 +10453,7 @@
         </p:nvSpPr>
         <p:spPr bwMode="auto">
           <a:xfrm>
-            <a:off x="9450328" y="1617811"/>
+            <a:off x="9518064" y="1617811"/>
             <a:ext cx="1377673" cy="1364705"/>
           </a:xfrm>
           <a:prstGeom prst="roundRect">
@@ -10354,7 +10614,7 @@
         </p:nvSpPr>
         <p:spPr bwMode="auto">
           <a:xfrm>
-            <a:off x="10404718" y="1271499"/>
+            <a:off x="10472454" y="1271499"/>
             <a:ext cx="1377673" cy="2943148"/>
           </a:xfrm>
           <a:prstGeom prst="roundRect">
@@ -10794,7 +11054,7 @@
         </p:nvSpPr>
         <p:spPr>
           <a:xfrm>
-            <a:off x="7898014" y="4436996"/>
+            <a:off x="7965750" y="4436996"/>
             <a:ext cx="1026285" cy="1338828"/>
           </a:xfrm>
           <a:prstGeom prst="rect">
@@ -10812,13 +11072,13 @@
               <a:buNone/>
             </a:pPr>
             <a:r>
-              <a:rPr lang="en-US" sz="800">
-                <a:latin typeface="Segoe UI" panose="020B0502040204020203" pitchFamily="34" charset="0"/>
-                <a:cs typeface="Segoe UI" panose="020B0502040204020203" pitchFamily="34" charset="0"/>
-              </a:rPr>
-              <a:t>Rank</a:t>
-            </a:r>
-            <a:endParaRPr lang="en-US" sz="800">
+              <a:rPr lang="en-US" sz="800" b="1">
+                <a:latin typeface="Segoe UI" panose="020B0502040204020203" pitchFamily="34" charset="0"/>
+                <a:cs typeface="Segoe UI" panose="020B0502040204020203" pitchFamily="34" charset="0"/>
+              </a:rPr>
+              <a:t>Ranks</a:t>
+            </a:r>
+            <a:endParaRPr lang="en-US" sz="800" b="1">
               <a:effectLst/>
               <a:latin typeface="Cascadia Mono" panose="020B0609020000020004" pitchFamily="49" charset="0"/>
             </a:endParaRPr>
@@ -10947,7 +11207,7 @@
         </p:nvSpPr>
         <p:spPr>
           <a:xfrm>
-            <a:off x="8663279" y="5003712"/>
+            <a:off x="8837531" y="4889662"/>
             <a:ext cx="1026285" cy="969496"/>
           </a:xfrm>
           <a:prstGeom prst="rect">
@@ -10965,13 +11225,13 @@
               <a:buNone/>
             </a:pPr>
             <a:r>
-              <a:rPr lang="en-US" sz="800">
+              <a:rPr lang="en-US" sz="800" b="1">
                 <a:latin typeface="Segoe UI" panose="020B0502040204020203" pitchFamily="34" charset="0"/>
                 <a:cs typeface="Segoe UI" panose="020B0502040204020203" pitchFamily="34" charset="0"/>
               </a:rPr>
               <a:t>NomStatus</a:t>
             </a:r>
-            <a:endParaRPr lang="en-US" sz="800">
+            <a:endParaRPr lang="en-US" sz="800" b="1">
               <a:effectLst/>
               <a:latin typeface="Cascadia Mono" panose="020B0609020000020004" pitchFamily="49" charset="0"/>
             </a:endParaRPr>
@@ -11064,7 +11324,7 @@
         </p:nvSpPr>
         <p:spPr>
           <a:xfrm>
-            <a:off x="9305469" y="5872797"/>
+            <a:off x="9869594" y="5432924"/>
             <a:ext cx="921038" cy="600164"/>
           </a:xfrm>
           <a:prstGeom prst="rect">
@@ -11082,13 +11342,13 @@
               <a:buNone/>
             </a:pPr>
             <a:r>
-              <a:rPr lang="en-US" sz="800">
+              <a:rPr lang="en-US" sz="800" b="1">
                 <a:latin typeface="Segoe UI" panose="020B0502040204020203" pitchFamily="34" charset="0"/>
                 <a:cs typeface="Segoe UI" panose="020B0502040204020203" pitchFamily="34" charset="0"/>
               </a:rPr>
               <a:t>TaxStatus</a:t>
             </a:r>
-            <a:endParaRPr lang="en-US" sz="800">
+            <a:endParaRPr lang="en-US" sz="800" b="1">
               <a:latin typeface="Cascadia Mono" panose="020B0609020000020004" pitchFamily="49" charset="0"/>
             </a:endParaRPr>
           </a:p>

</xml_diff>

<commit_message>
- working on ToDo notes ...
</commit_message>
<xml_diff>
--- a/AlamutB/.appCatalog/Alamut.pptx
+++ b/AlamutB/.appCatalog/Alamut.pptx
@@ -198,7 +198,7 @@
           <a:p>
             <a:fld id="{76AEB20D-1E0E-486A-823D-795E0F1B1A92}" type="datetimeFigureOut">
               <a:rPr lang="en-US" smtClean="0"/>
-              <a:t>8/20/2026</a:t>
+              <a:t>8/21/2026</a:t>
             </a:fld>
             <a:endParaRPr lang="en-US"/>
           </a:p>
@@ -612,7 +612,7 @@
           <a:p>
             <a:fld id="{8A0CD729-867D-477D-ADDA-CA15108676C8}" type="datetimeFigureOut">
               <a:rPr lang="en-US" smtClean="0"/>
-              <a:t>8/20/2026</a:t>
+              <a:t>8/21/2026</a:t>
             </a:fld>
             <a:endParaRPr lang="en-US"/>
           </a:p>
@@ -810,7 +810,7 @@
           <a:p>
             <a:fld id="{8A0CD729-867D-477D-ADDA-CA15108676C8}" type="datetimeFigureOut">
               <a:rPr lang="en-US" smtClean="0"/>
-              <a:t>8/20/2026</a:t>
+              <a:t>8/21/2026</a:t>
             </a:fld>
             <a:endParaRPr lang="en-US"/>
           </a:p>
@@ -1018,7 +1018,7 @@
           <a:p>
             <a:fld id="{8A0CD729-867D-477D-ADDA-CA15108676C8}" type="datetimeFigureOut">
               <a:rPr lang="en-US" smtClean="0"/>
-              <a:t>8/20/2026</a:t>
+              <a:t>8/21/2026</a:t>
             </a:fld>
             <a:endParaRPr lang="en-US"/>
           </a:p>
@@ -1216,7 +1216,7 @@
           <a:p>
             <a:fld id="{8A0CD729-867D-477D-ADDA-CA15108676C8}" type="datetimeFigureOut">
               <a:rPr lang="en-US" smtClean="0"/>
-              <a:t>8/20/2026</a:t>
+              <a:t>8/21/2026</a:t>
             </a:fld>
             <a:endParaRPr lang="en-US"/>
           </a:p>
@@ -1491,7 +1491,7 @@
           <a:p>
             <a:fld id="{8A0CD729-867D-477D-ADDA-CA15108676C8}" type="datetimeFigureOut">
               <a:rPr lang="en-US" smtClean="0"/>
-              <a:t>8/20/2026</a:t>
+              <a:t>8/21/2026</a:t>
             </a:fld>
             <a:endParaRPr lang="en-US"/>
           </a:p>
@@ -1756,7 +1756,7 @@
           <a:p>
             <a:fld id="{8A0CD729-867D-477D-ADDA-CA15108676C8}" type="datetimeFigureOut">
               <a:rPr lang="en-US" smtClean="0"/>
-              <a:t>8/20/2026</a:t>
+              <a:t>8/21/2026</a:t>
             </a:fld>
             <a:endParaRPr lang="en-US"/>
           </a:p>
@@ -2168,7 +2168,7 @@
           <a:p>
             <a:fld id="{8A0CD729-867D-477D-ADDA-CA15108676C8}" type="datetimeFigureOut">
               <a:rPr lang="en-US" smtClean="0"/>
-              <a:t>8/20/2026</a:t>
+              <a:t>8/21/2026</a:t>
             </a:fld>
             <a:endParaRPr lang="en-US"/>
           </a:p>
@@ -2309,7 +2309,7 @@
           <a:p>
             <a:fld id="{8A0CD729-867D-477D-ADDA-CA15108676C8}" type="datetimeFigureOut">
               <a:rPr lang="en-US" smtClean="0"/>
-              <a:t>8/20/2026</a:t>
+              <a:t>8/21/2026</a:t>
             </a:fld>
             <a:endParaRPr lang="en-US"/>
           </a:p>
@@ -2422,7 +2422,7 @@
           <a:p>
             <a:fld id="{8A0CD729-867D-477D-ADDA-CA15108676C8}" type="datetimeFigureOut">
               <a:rPr lang="en-US" smtClean="0"/>
-              <a:t>8/20/2026</a:t>
+              <a:t>8/21/2026</a:t>
             </a:fld>
             <a:endParaRPr lang="en-US"/>
           </a:p>
@@ -2733,7 +2733,7 @@
           <a:p>
             <a:fld id="{8A0CD729-867D-477D-ADDA-CA15108676C8}" type="datetimeFigureOut">
               <a:rPr lang="en-US" smtClean="0"/>
-              <a:t>8/20/2026</a:t>
+              <a:t>8/21/2026</a:t>
             </a:fld>
             <a:endParaRPr lang="en-US"/>
           </a:p>
@@ -3021,7 +3021,7 @@
           <a:p>
             <a:fld id="{8A0CD729-867D-477D-ADDA-CA15108676C8}" type="datetimeFigureOut">
               <a:rPr lang="en-US" smtClean="0"/>
-              <a:t>8/20/2026</a:t>
+              <a:t>8/21/2026</a:t>
             </a:fld>
             <a:endParaRPr lang="en-US"/>
           </a:p>
@@ -3262,7 +3262,7 @@
           <a:p>
             <a:fld id="{8A0CD729-867D-477D-ADDA-CA15108676C8}" type="datetimeFigureOut">
               <a:rPr lang="en-US" smtClean="0"/>
-              <a:t>8/20/2026</a:t>
+              <a:t>8/21/2026</a:t>
             </a:fld>
             <a:endParaRPr lang="en-US"/>
           </a:p>
@@ -7038,8 +7038,8 @@
         </p:nvSpPr>
         <p:spPr bwMode="auto">
           <a:xfrm>
-            <a:off x="237418" y="2204171"/>
-            <a:ext cx="1438256" cy="3963361"/>
+            <a:off x="172101" y="2204171"/>
+            <a:ext cx="1438256" cy="4010017"/>
           </a:xfrm>
           <a:prstGeom prst="roundRect">
             <a:avLst>
@@ -7367,7 +7367,7 @@
                 <a:latin typeface="Segoe UI" panose="020B0502040204020203" pitchFamily="34" charset="0"/>
                 <a:cs typeface="Segoe UI" panose="020B0502040204020203" pitchFamily="34" charset="0"/>
               </a:rPr>
-              <a:t> 1:ApgGroups</a:t>
+              <a:t> 1: ApgGroups</a:t>
             </a:r>
           </a:p>
           <a:p>
@@ -7382,7 +7382,7 @@
                 <a:latin typeface="Segoe UI" panose="020B0502040204020203" pitchFamily="34" charset="0"/>
                 <a:cs typeface="Segoe UI" panose="020B0502040204020203" pitchFamily="34" charset="0"/>
               </a:rPr>
-              <a:t> 2:Orders</a:t>
+              <a:t> 2: Orders</a:t>
             </a:r>
           </a:p>
           <a:p>
@@ -7397,7 +7397,7 @@
                 <a:latin typeface="Segoe UI" panose="020B0502040204020203" pitchFamily="34" charset="0"/>
                 <a:cs typeface="Segoe UI" panose="020B0502040204020203" pitchFamily="34" charset="0"/>
               </a:rPr>
-              <a:t> 3:Families</a:t>
+              <a:t> 3: Families</a:t>
             </a:r>
           </a:p>
           <a:p>
@@ -7412,7 +7412,7 @@
                 <a:latin typeface="Segoe UI" panose="020B0502040204020203" pitchFamily="34" charset="0"/>
                 <a:cs typeface="Segoe UI" panose="020B0502040204020203" pitchFamily="34" charset="0"/>
               </a:rPr>
-              <a:t> 4:Genera</a:t>
+              <a:t> 4: Genera</a:t>
             </a:r>
           </a:p>
           <a:p>
@@ -7427,7 +7427,7 @@
                 <a:latin typeface="Segoe UI" panose="020B0502040204020203" pitchFamily="34" charset="0"/>
                 <a:cs typeface="Segoe UI" panose="020B0502040204020203" pitchFamily="34" charset="0"/>
               </a:rPr>
-              <a:t> 5:Species</a:t>
+              <a:t> 5: Species</a:t>
             </a:r>
           </a:p>
           <a:p>
@@ -7442,7 +7442,7 @@
                 <a:latin typeface="Segoe UI" panose="020B0502040204020203" pitchFamily="34" charset="0"/>
                 <a:cs typeface="Segoe UI" panose="020B0502040204020203" pitchFamily="34" charset="0"/>
               </a:rPr>
-              <a:t> 6:Datasets(FL)</a:t>
+              <a:t> 6: Datasets(FL)</a:t>
             </a:r>
           </a:p>
           <a:p>
@@ -7457,7 +7457,7 @@
                 <a:latin typeface="Segoe UI" panose="020B0502040204020203" pitchFamily="34" charset="0"/>
                 <a:cs typeface="Segoe UI" panose="020B0502040204020203" pitchFamily="34" charset="0"/>
               </a:rPr>
-              <a:t> 7:Datasets(CN)</a:t>
+              <a:t> 7: Datasets(CN)</a:t>
             </a:r>
           </a:p>
           <a:p>
@@ -7472,7 +7472,7 @@
                 <a:latin typeface="Segoe UI" panose="020B0502040204020203" pitchFamily="34" charset="0"/>
                 <a:cs typeface="Segoe UI" panose="020B0502040204020203" pitchFamily="34" charset="0"/>
               </a:rPr>
-              <a:t> 8:Datasets(LM)</a:t>
+              <a:t> 8: Datasets(LM)</a:t>
             </a:r>
           </a:p>
           <a:p>
@@ -7487,7 +7487,7 @@
                 <a:latin typeface="Segoe UI" panose="020B0502040204020203" pitchFamily="34" charset="0"/>
                 <a:cs typeface="Segoe UI" panose="020B0502040204020203" pitchFamily="34" charset="0"/>
               </a:rPr>
-              <a:t> 9:Stations</a:t>
+              <a:t> 9: Stations</a:t>
             </a:r>
           </a:p>
           <a:p>
@@ -7502,7 +7502,7 @@
                 <a:latin typeface="Segoe UI" panose="020B0502040204020203" pitchFamily="34" charset="0"/>
                 <a:cs typeface="Segoe UI" panose="020B0502040204020203" pitchFamily="34" charset="0"/>
               </a:rPr>
-              <a:t>10:Sets</a:t>
+              <a:t>10: Sets</a:t>
             </a:r>
           </a:p>
           <a:p>
@@ -7517,7 +7517,7 @@
                 <a:latin typeface="Segoe UI" panose="020B0502040204020203" pitchFamily="34" charset="0"/>
                 <a:cs typeface="Segoe UI" panose="020B0502040204020203" pitchFamily="34" charset="0"/>
               </a:rPr>
-              <a:t>11:SetData</a:t>
+              <a:t>11: SetData</a:t>
             </a:r>
           </a:p>
           <a:p>
@@ -7532,7 +7532,22 @@
                 <a:latin typeface="Segoe UI" panose="020B0502040204020203" pitchFamily="34" charset="0"/>
                 <a:cs typeface="Segoe UI" panose="020B0502040204020203" pitchFamily="34" charset="0"/>
               </a:rPr>
-              <a:t>12:Users</a:t>
+              <a:t>12: Section</a:t>
+            </a:r>
+          </a:p>
+          <a:p>
+            <a:pPr marL="84138">
+              <a:defRPr/>
+            </a:pPr>
+            <a:r>
+              <a:rPr lang="en-US" sz="800">
+                <a:solidFill>
+                  <a:schemeClr val="tx1"/>
+                </a:solidFill>
+                <a:latin typeface="Segoe UI" panose="020B0502040204020203" pitchFamily="34" charset="0"/>
+                <a:cs typeface="Segoe UI" panose="020B0502040204020203" pitchFamily="34" charset="0"/>
+              </a:rPr>
+              <a:t>13: Users</a:t>
             </a:r>
           </a:p>
           <a:p>
@@ -8160,7 +8175,7 @@
                 <a:latin typeface="Segoe UI" panose="020B0502040204020203" pitchFamily="34" charset="0"/>
                 <a:cs typeface="Segoe UI" panose="020B0502040204020203" pitchFamily="34" charset="0"/>
               </a:rPr>
-              <a:t> 1: Active</a:t>
+              <a:t>    1: Active</a:t>
             </a:r>
           </a:p>
           <a:p>
@@ -8175,7 +8190,7 @@
                 <a:latin typeface="Segoe UI" panose="020B0502040204020203" pitchFamily="34" charset="0"/>
                 <a:cs typeface="Segoe UI" panose="020B0502040204020203" pitchFamily="34" charset="0"/>
               </a:rPr>
-              <a:t> 2: AdminAccount</a:t>
+              <a:t>    2: AdminAccount</a:t>
             </a:r>
           </a:p>
           <a:p>
@@ -8190,7 +8205,7 @@
                 <a:latin typeface="Segoe UI" panose="020B0502040204020203" pitchFamily="34" charset="0"/>
                 <a:cs typeface="Segoe UI" panose="020B0502040204020203" pitchFamily="34" charset="0"/>
               </a:rPr>
-              <a:t> 4: GoldenAccount</a:t>
+              <a:t>    4: GoldAccount</a:t>
             </a:r>
           </a:p>
           <a:p>
@@ -8205,7 +8220,7 @@
                 <a:latin typeface="Segoe UI" panose="020B0502040204020203" pitchFamily="34" charset="0"/>
                 <a:cs typeface="Segoe UI" panose="020B0502040204020203" pitchFamily="34" charset="0"/>
               </a:rPr>
-              <a:t> 8: SilverAccount</a:t>
+              <a:t>    8: SilverAccount</a:t>
             </a:r>
           </a:p>
           <a:p>
@@ -8220,8 +8235,80 @@
                 <a:latin typeface="Segoe UI" panose="020B0502040204020203" pitchFamily="34" charset="0"/>
                 <a:cs typeface="Segoe UI" panose="020B0502040204020203" pitchFamily="34" charset="0"/>
               </a:rPr>
-              <a:t>16: UsePersianCalendar</a:t>
-            </a:r>
+              <a:t>  16: ShowDueNotes</a:t>
+            </a:r>
+          </a:p>
+          <a:p>
+            <a:pPr marL="84138">
+              <a:defRPr/>
+            </a:pPr>
+            <a:r>
+              <a:rPr lang="en-US" sz="800">
+                <a:solidFill>
+                  <a:schemeClr val="tx1"/>
+                </a:solidFill>
+                <a:latin typeface="Segoe UI" panose="020B0502040204020203" pitchFamily="34" charset="0"/>
+                <a:cs typeface="Segoe UI" panose="020B0502040204020203" pitchFamily="34" charset="0"/>
+              </a:rPr>
+              <a:t>  32: DueNotesDays=14  (def=7)</a:t>
+            </a:r>
+          </a:p>
+          <a:p>
+            <a:pPr marL="84138">
+              <a:defRPr/>
+            </a:pPr>
+            <a:r>
+              <a:rPr lang="en-US" sz="800">
+                <a:solidFill>
+                  <a:schemeClr val="tx1"/>
+                </a:solidFill>
+                <a:latin typeface="Segoe UI" panose="020B0502040204020203" pitchFamily="34" charset="0"/>
+                <a:cs typeface="Segoe UI" panose="020B0502040204020203" pitchFamily="34" charset="0"/>
+              </a:rPr>
+              <a:t>  64: -</a:t>
+            </a:r>
+          </a:p>
+          <a:p>
+            <a:pPr marL="84138">
+              <a:defRPr/>
+            </a:pPr>
+            <a:r>
+              <a:rPr lang="en-US" sz="800">
+                <a:solidFill>
+                  <a:schemeClr val="tx1"/>
+                </a:solidFill>
+                <a:latin typeface="Segoe UI" panose="020B0502040204020203" pitchFamily="34" charset="0"/>
+                <a:cs typeface="Segoe UI" panose="020B0502040204020203" pitchFamily="34" charset="0"/>
+              </a:rPr>
+              <a:t>128: -</a:t>
+            </a:r>
+          </a:p>
+          <a:p>
+            <a:pPr marL="84138">
+              <a:defRPr/>
+            </a:pPr>
+            <a:r>
+              <a:rPr lang="en-US" sz="800">
+                <a:solidFill>
+                  <a:schemeClr val="tx1"/>
+                </a:solidFill>
+                <a:latin typeface="Segoe UI" panose="020B0502040204020203" pitchFamily="34" charset="0"/>
+                <a:cs typeface="Segoe UI" panose="020B0502040204020203" pitchFamily="34" charset="0"/>
+              </a:rPr>
+              <a:t>256: CalendarFa</a:t>
+            </a:r>
+          </a:p>
+          <a:p>
+            <a:pPr marL="84138">
+              <a:defRPr/>
+            </a:pPr>
+            <a:endParaRPr lang="en-US" sz="800">
+              <a:solidFill>
+                <a:schemeClr val="tx1"/>
+              </a:solidFill>
+              <a:latin typeface="Segoe UI" panose="020B0502040204020203" pitchFamily="34" charset="0"/>
+              <a:cs typeface="Segoe UI" panose="020B0502040204020203" pitchFamily="34" charset="0"/>
+            </a:endParaRPr>
           </a:p>
         </p:txBody>
       </p:sp>

</xml_diff>

<commit_message>
-component dataset for all 3 pages: LM, CN, LF
</commit_message>
<xml_diff>
--- a/AlamutB/.appCatalog/Alamut.pptx
+++ b/AlamutB/.appCatalog/Alamut.pptx
@@ -198,7 +198,7 @@
           <a:p>
             <a:fld id="{76AEB20D-1E0E-486A-823D-795E0F1B1A92}" type="datetimeFigureOut">
               <a:rPr lang="en-US" smtClean="0"/>
-              <a:t>8/21/2026</a:t>
+              <a:t>8/26/2026</a:t>
             </a:fld>
             <a:endParaRPr lang="en-US"/>
           </a:p>
@@ -612,7 +612,7 @@
           <a:p>
             <a:fld id="{8A0CD729-867D-477D-ADDA-CA15108676C8}" type="datetimeFigureOut">
               <a:rPr lang="en-US" smtClean="0"/>
-              <a:t>8/21/2026</a:t>
+              <a:t>8/26/2026</a:t>
             </a:fld>
             <a:endParaRPr lang="en-US"/>
           </a:p>
@@ -810,7 +810,7 @@
           <a:p>
             <a:fld id="{8A0CD729-867D-477D-ADDA-CA15108676C8}" type="datetimeFigureOut">
               <a:rPr lang="en-US" smtClean="0"/>
-              <a:t>8/21/2026</a:t>
+              <a:t>8/26/2026</a:t>
             </a:fld>
             <a:endParaRPr lang="en-US"/>
           </a:p>
@@ -1018,7 +1018,7 @@
           <a:p>
             <a:fld id="{8A0CD729-867D-477D-ADDA-CA15108676C8}" type="datetimeFigureOut">
               <a:rPr lang="en-US" smtClean="0"/>
-              <a:t>8/21/2026</a:t>
+              <a:t>8/26/2026</a:t>
             </a:fld>
             <a:endParaRPr lang="en-US"/>
           </a:p>
@@ -1216,7 +1216,7 @@
           <a:p>
             <a:fld id="{8A0CD729-867D-477D-ADDA-CA15108676C8}" type="datetimeFigureOut">
               <a:rPr lang="en-US" smtClean="0"/>
-              <a:t>8/21/2026</a:t>
+              <a:t>8/26/2026</a:t>
             </a:fld>
             <a:endParaRPr lang="en-US"/>
           </a:p>
@@ -1491,7 +1491,7 @@
           <a:p>
             <a:fld id="{8A0CD729-867D-477D-ADDA-CA15108676C8}" type="datetimeFigureOut">
               <a:rPr lang="en-US" smtClean="0"/>
-              <a:t>8/21/2026</a:t>
+              <a:t>8/26/2026</a:t>
             </a:fld>
             <a:endParaRPr lang="en-US"/>
           </a:p>
@@ -1756,7 +1756,7 @@
           <a:p>
             <a:fld id="{8A0CD729-867D-477D-ADDA-CA15108676C8}" type="datetimeFigureOut">
               <a:rPr lang="en-US" smtClean="0"/>
-              <a:t>8/21/2026</a:t>
+              <a:t>8/26/2026</a:t>
             </a:fld>
             <a:endParaRPr lang="en-US"/>
           </a:p>
@@ -2168,7 +2168,7 @@
           <a:p>
             <a:fld id="{8A0CD729-867D-477D-ADDA-CA15108676C8}" type="datetimeFigureOut">
               <a:rPr lang="en-US" smtClean="0"/>
-              <a:t>8/21/2026</a:t>
+              <a:t>8/26/2026</a:t>
             </a:fld>
             <a:endParaRPr lang="en-US"/>
           </a:p>
@@ -2309,7 +2309,7 @@
           <a:p>
             <a:fld id="{8A0CD729-867D-477D-ADDA-CA15108676C8}" type="datetimeFigureOut">
               <a:rPr lang="en-US" smtClean="0"/>
-              <a:t>8/21/2026</a:t>
+              <a:t>8/26/2026</a:t>
             </a:fld>
             <a:endParaRPr lang="en-US"/>
           </a:p>
@@ -2422,7 +2422,7 @@
           <a:p>
             <a:fld id="{8A0CD729-867D-477D-ADDA-CA15108676C8}" type="datetimeFigureOut">
               <a:rPr lang="en-US" smtClean="0"/>
-              <a:t>8/21/2026</a:t>
+              <a:t>8/26/2026</a:t>
             </a:fld>
             <a:endParaRPr lang="en-US"/>
           </a:p>
@@ -2733,7 +2733,7 @@
           <a:p>
             <a:fld id="{8A0CD729-867D-477D-ADDA-CA15108676C8}" type="datetimeFigureOut">
               <a:rPr lang="en-US" smtClean="0"/>
-              <a:t>8/21/2026</a:t>
+              <a:t>8/26/2026</a:t>
             </a:fld>
             <a:endParaRPr lang="en-US"/>
           </a:p>
@@ -3021,7 +3021,7 @@
           <a:p>
             <a:fld id="{8A0CD729-867D-477D-ADDA-CA15108676C8}" type="datetimeFigureOut">
               <a:rPr lang="en-US" smtClean="0"/>
-              <a:t>8/21/2026</a:t>
+              <a:t>8/26/2026</a:t>
             </a:fld>
             <a:endParaRPr lang="en-US"/>
           </a:p>
@@ -3262,7 +3262,7 @@
           <a:p>
             <a:fld id="{8A0CD729-867D-477D-ADDA-CA15108676C8}" type="datetimeFigureOut">
               <a:rPr lang="en-US" smtClean="0"/>
-              <a:t>8/21/2026</a:t>
+              <a:t>8/26/2026</a:t>
             </a:fld>
             <a:endParaRPr lang="en-US"/>
           </a:p>
@@ -8326,8 +8326,8 @@
         </p:nvSpPr>
         <p:spPr bwMode="auto">
           <a:xfrm>
-            <a:off x="2096029" y="3714498"/>
-            <a:ext cx="1625139" cy="2220759"/>
+            <a:off x="2096029" y="3714499"/>
+            <a:ext cx="1625139" cy="1909132"/>
           </a:xfrm>
           <a:prstGeom prst="roundRect">
             <a:avLst>
@@ -8545,7 +8545,7 @@
                 <a:latin typeface="Segoe UI" panose="020B0502040204020203" pitchFamily="34" charset="0"/>
                 <a:cs typeface="Segoe UI" panose="020B0502040204020203" pitchFamily="34" charset="0"/>
               </a:rPr>
-              <a:t>1:Flore</a:t>
+              <a:t>1: Floristic</a:t>
             </a:r>
           </a:p>
           <a:p>
@@ -8560,52 +8560,7 @@
                 <a:latin typeface="Segoe UI" panose="020B0502040204020203" pitchFamily="34" charset="0"/>
                 <a:cs typeface="Segoe UI" panose="020B0502040204020203" pitchFamily="34" charset="0"/>
               </a:rPr>
-              <a:t>2:CheckName</a:t>
-            </a:r>
-          </a:p>
-          <a:p>
-            <a:pPr marL="179388">
-              <a:defRPr/>
-            </a:pPr>
-            <a:r>
-              <a:rPr lang="en-US" sz="800">
-                <a:solidFill>
-                  <a:schemeClr val="tx1"/>
-                </a:solidFill>
-                <a:latin typeface="Segoe UI" panose="020B0502040204020203" pitchFamily="34" charset="0"/>
-                <a:cs typeface="Segoe UI" panose="020B0502040204020203" pitchFamily="34" charset="0"/>
-              </a:rPr>
-              <a:t>3:ListMaker</a:t>
-            </a:r>
-          </a:p>
-          <a:p>
-            <a:pPr marL="179388">
-              <a:defRPr/>
-            </a:pPr>
-            <a:r>
-              <a:rPr lang="en-US" sz="800">
-                <a:solidFill>
-                  <a:schemeClr val="tx1"/>
-                </a:solidFill>
-                <a:latin typeface="Segoe UI" panose="020B0502040204020203" pitchFamily="34" charset="0"/>
-                <a:cs typeface="Segoe UI" panose="020B0502040204020203" pitchFamily="34" charset="0"/>
-              </a:rPr>
-              <a:t>10:Climatic</a:t>
-            </a:r>
-          </a:p>
-          <a:p>
-            <a:pPr marL="179388">
-              <a:defRPr/>
-            </a:pPr>
-            <a:r>
-              <a:rPr lang="en-US" sz="800">
-                <a:solidFill>
-                  <a:schemeClr val="tx1"/>
-                </a:solidFill>
-                <a:latin typeface="Segoe UI" panose="020B0502040204020203" pitchFamily="34" charset="0"/>
-                <a:cs typeface="Segoe UI" panose="020B0502040204020203" pitchFamily="34" charset="0"/>
-              </a:rPr>
-              <a:t>11:Climagraph</a:t>
+              <a:t>2: Climatic</a:t>
             </a:r>
           </a:p>
         </p:txBody>
@@ -8624,8 +8579,8 @@
         </p:nvSpPr>
         <p:spPr bwMode="auto">
           <a:xfrm>
-            <a:off x="3077900" y="1944363"/>
-            <a:ext cx="2172080" cy="2843039"/>
+            <a:off x="3077900" y="1868250"/>
+            <a:ext cx="2172080" cy="3128795"/>
           </a:xfrm>
           <a:prstGeom prst="roundRect">
             <a:avLst>
@@ -8979,6 +8934,66 @@
                 <a:cs typeface="Segoe UI" panose="020B0502040204020203" pitchFamily="34" charset="0"/>
               </a:rPr>
               <a:t>Tags</a:t>
+            </a:r>
+          </a:p>
+          <a:p>
+            <a:pPr>
+              <a:defRPr/>
+            </a:pPr>
+            <a:r>
+              <a:rPr lang="en-US" sz="900">
+                <a:solidFill>
+                  <a:schemeClr val="tx1"/>
+                </a:solidFill>
+                <a:latin typeface="Segoe UI" panose="020B0502040204020203" pitchFamily="34" charset="0"/>
+                <a:cs typeface="Segoe UI" panose="020B0502040204020203" pitchFamily="34" charset="0"/>
+              </a:rPr>
+              <a:t>1: </a:t>
+            </a:r>
+          </a:p>
+          <a:p>
+            <a:pPr>
+              <a:defRPr/>
+            </a:pPr>
+            <a:r>
+              <a:rPr lang="en-US" sz="900">
+                <a:solidFill>
+                  <a:schemeClr val="tx1"/>
+                </a:solidFill>
+                <a:latin typeface="Segoe UI" panose="020B0502040204020203" pitchFamily="34" charset="0"/>
+                <a:cs typeface="Segoe UI" panose="020B0502040204020203" pitchFamily="34" charset="0"/>
+              </a:rPr>
+              <a:t>2: </a:t>
+            </a:r>
+          </a:p>
+          <a:p>
+            <a:pPr>
+              <a:defRPr/>
+            </a:pPr>
+            <a:r>
+              <a:rPr lang="en-US" sz="900">
+                <a:solidFill>
+                  <a:schemeClr val="tx1"/>
+                </a:solidFill>
+                <a:latin typeface="Segoe UI" panose="020B0502040204020203" pitchFamily="34" charset="0"/>
+                <a:cs typeface="Segoe UI" panose="020B0502040204020203" pitchFamily="34" charset="0"/>
+              </a:rPr>
+              <a:t>4: </a:t>
+            </a:r>
+          </a:p>
+          <a:p>
+            <a:pPr>
+              <a:defRPr/>
+            </a:pPr>
+            <a:r>
+              <a:rPr lang="en-US" sz="900">
+                <a:solidFill>
+                  <a:schemeClr val="tx1"/>
+                </a:solidFill>
+                <a:latin typeface="Segoe UI" panose="020B0502040204020203" pitchFamily="34" charset="0"/>
+                <a:cs typeface="Segoe UI" panose="020B0502040204020203" pitchFamily="34" charset="0"/>
+              </a:rPr>
+              <a:t>8: </a:t>
             </a:r>
           </a:p>
         </p:txBody>

</xml_diff>

<commit_message>
- pg:  Help, SignUp, ChangePass
</commit_message>
<xml_diff>
--- a/AlamutB/.appCatalog/Alamut.pptx
+++ b/AlamutB/.appCatalog/Alamut.pptx
@@ -5,11 +5,10 @@
     <p:sldMasterId id="2147483648" r:id="rId1"/>
   </p:sldMasterIdLst>
   <p:notesMasterIdLst>
-    <p:notesMasterId r:id="rId4"/>
+    <p:notesMasterId r:id="rId3"/>
   </p:notesMasterIdLst>
   <p:sldIdLst>
     <p:sldId id="259" r:id="rId2"/>
-    <p:sldId id="260" r:id="rId3"/>
   </p:sldIdLst>
   <p:sldSz cx="12192000" cy="6858000"/>
   <p:notesSz cx="6858000" cy="9144000"/>
@@ -198,7 +197,7 @@
           <a:p>
             <a:fld id="{76AEB20D-1E0E-486A-823D-795E0F1B1A92}" type="datetimeFigureOut">
               <a:rPr lang="en-US" smtClean="0"/>
-              <a:t>8/26/2026</a:t>
+              <a:t>8/27/2026</a:t>
             </a:fld>
             <a:endParaRPr lang="en-US"/>
           </a:p>
@@ -612,7 +611,7 @@
           <a:p>
             <a:fld id="{8A0CD729-867D-477D-ADDA-CA15108676C8}" type="datetimeFigureOut">
               <a:rPr lang="en-US" smtClean="0"/>
-              <a:t>8/26/2026</a:t>
+              <a:t>8/27/2026</a:t>
             </a:fld>
             <a:endParaRPr lang="en-US"/>
           </a:p>
@@ -810,7 +809,7 @@
           <a:p>
             <a:fld id="{8A0CD729-867D-477D-ADDA-CA15108676C8}" type="datetimeFigureOut">
               <a:rPr lang="en-US" smtClean="0"/>
-              <a:t>8/26/2026</a:t>
+              <a:t>8/27/2026</a:t>
             </a:fld>
             <a:endParaRPr lang="en-US"/>
           </a:p>
@@ -1018,7 +1017,7 @@
           <a:p>
             <a:fld id="{8A0CD729-867D-477D-ADDA-CA15108676C8}" type="datetimeFigureOut">
               <a:rPr lang="en-US" smtClean="0"/>
-              <a:t>8/26/2026</a:t>
+              <a:t>8/27/2026</a:t>
             </a:fld>
             <a:endParaRPr lang="en-US"/>
           </a:p>
@@ -1216,7 +1215,7 @@
           <a:p>
             <a:fld id="{8A0CD729-867D-477D-ADDA-CA15108676C8}" type="datetimeFigureOut">
               <a:rPr lang="en-US" smtClean="0"/>
-              <a:t>8/26/2026</a:t>
+              <a:t>8/27/2026</a:t>
             </a:fld>
             <a:endParaRPr lang="en-US"/>
           </a:p>
@@ -1491,7 +1490,7 @@
           <a:p>
             <a:fld id="{8A0CD729-867D-477D-ADDA-CA15108676C8}" type="datetimeFigureOut">
               <a:rPr lang="en-US" smtClean="0"/>
-              <a:t>8/26/2026</a:t>
+              <a:t>8/27/2026</a:t>
             </a:fld>
             <a:endParaRPr lang="en-US"/>
           </a:p>
@@ -1756,7 +1755,7 @@
           <a:p>
             <a:fld id="{8A0CD729-867D-477D-ADDA-CA15108676C8}" type="datetimeFigureOut">
               <a:rPr lang="en-US" smtClean="0"/>
-              <a:t>8/26/2026</a:t>
+              <a:t>8/27/2026</a:t>
             </a:fld>
             <a:endParaRPr lang="en-US"/>
           </a:p>
@@ -2168,7 +2167,7 @@
           <a:p>
             <a:fld id="{8A0CD729-867D-477D-ADDA-CA15108676C8}" type="datetimeFigureOut">
               <a:rPr lang="en-US" smtClean="0"/>
-              <a:t>8/26/2026</a:t>
+              <a:t>8/27/2026</a:t>
             </a:fld>
             <a:endParaRPr lang="en-US"/>
           </a:p>
@@ -2309,7 +2308,7 @@
           <a:p>
             <a:fld id="{8A0CD729-867D-477D-ADDA-CA15108676C8}" type="datetimeFigureOut">
               <a:rPr lang="en-US" smtClean="0"/>
-              <a:t>8/26/2026</a:t>
+              <a:t>8/27/2026</a:t>
             </a:fld>
             <a:endParaRPr lang="en-US"/>
           </a:p>
@@ -2422,7 +2421,7 @@
           <a:p>
             <a:fld id="{8A0CD729-867D-477D-ADDA-CA15108676C8}" type="datetimeFigureOut">
               <a:rPr lang="en-US" smtClean="0"/>
-              <a:t>8/26/2026</a:t>
+              <a:t>8/27/2026</a:t>
             </a:fld>
             <a:endParaRPr lang="en-US"/>
           </a:p>
@@ -2733,7 +2732,7 @@
           <a:p>
             <a:fld id="{8A0CD729-867D-477D-ADDA-CA15108676C8}" type="datetimeFigureOut">
               <a:rPr lang="en-US" smtClean="0"/>
-              <a:t>8/26/2026</a:t>
+              <a:t>8/27/2026</a:t>
             </a:fld>
             <a:endParaRPr lang="en-US"/>
           </a:p>
@@ -3021,7 +3020,7 @@
           <a:p>
             <a:fld id="{8A0CD729-867D-477D-ADDA-CA15108676C8}" type="datetimeFigureOut">
               <a:rPr lang="en-US" smtClean="0"/>
-              <a:t>8/26/2026</a:t>
+              <a:t>8/27/2026</a:t>
             </a:fld>
             <a:endParaRPr lang="en-US"/>
           </a:p>
@@ -3262,7 +3261,7 @@
           <a:p>
             <a:fld id="{8A0CD729-867D-477D-ADDA-CA15108676C8}" type="datetimeFigureOut">
               <a:rPr lang="en-US" smtClean="0"/>
-              <a:t>8/26/2026</a:t>
+              <a:t>8/27/2026</a:t>
             </a:fld>
             <a:endParaRPr lang="en-US"/>
           </a:p>
@@ -8235,7 +8234,7 @@
                 <a:latin typeface="Segoe UI" panose="020B0502040204020203" pitchFamily="34" charset="0"/>
                 <a:cs typeface="Segoe UI" panose="020B0502040204020203" pitchFamily="34" charset="0"/>
               </a:rPr>
-              <a:t>  16: ShowDueNotes</a:t>
+              <a:t>  16: RemindDueNotes</a:t>
             </a:r>
           </a:p>
           <a:p>
@@ -8250,7 +8249,7 @@
                 <a:latin typeface="Segoe UI" panose="020B0502040204020203" pitchFamily="34" charset="0"/>
                 <a:cs typeface="Segoe UI" panose="020B0502040204020203" pitchFamily="34" charset="0"/>
               </a:rPr>
-              <a:t>  32: DueNotesDays=14  (def=7)</a:t>
+              <a:t>  32: DueNotesDays=14  (def: 7)</a:t>
             </a:r>
           </a:p>
           <a:p>
@@ -8265,7 +8264,7 @@
                 <a:latin typeface="Segoe UI" panose="020B0502040204020203" pitchFamily="34" charset="0"/>
                 <a:cs typeface="Segoe UI" panose="020B0502040204020203" pitchFamily="34" charset="0"/>
               </a:rPr>
-              <a:t>  64: -</a:t>
+              <a:t>  64: CanChangeNickname</a:t>
             </a:r>
           </a:p>
           <a:p>
@@ -8280,7 +8279,7 @@
                 <a:latin typeface="Segoe UI" panose="020B0502040204020203" pitchFamily="34" charset="0"/>
                 <a:cs typeface="Segoe UI" panose="020B0502040204020203" pitchFamily="34" charset="0"/>
               </a:rPr>
-              <a:t>128: -</a:t>
+              <a:t>128: OnExpire: Inactive</a:t>
             </a:r>
           </a:p>
           <a:p>
@@ -8295,7 +8294,7 @@
                 <a:latin typeface="Segoe UI" panose="020B0502040204020203" pitchFamily="34" charset="0"/>
                 <a:cs typeface="Segoe UI" panose="020B0502040204020203" pitchFamily="34" charset="0"/>
               </a:rPr>
-              <a:t>256: CalendarFa</a:t>
+              <a:t>256: UseFaCalendar</a:t>
             </a:r>
           </a:p>
           <a:p>
@@ -11493,74 +11492,6 @@
     <p:extLst>
       <p:ext uri="{BB962C8B-B14F-4D97-AF65-F5344CB8AC3E}">
         <p14:creationId xmlns:p14="http://schemas.microsoft.com/office/powerpoint/2010/main" val="230367927"/>
-      </p:ext>
-    </p:extLst>
-  </p:cSld>
-  <p:clrMapOvr>
-    <a:masterClrMapping/>
-  </p:clrMapOvr>
-</p:sld>
-</file>
-
-<file path=ppt/slides/slide2.xml><?xml version="1.0" encoding="utf-8"?>
-<p:sld xmlns:a="http://schemas.openxmlformats.org/drawingml/2006/main" xmlns:r="http://schemas.openxmlformats.org/officeDocument/2006/relationships" xmlns:p="http://schemas.openxmlformats.org/presentationml/2006/main">
-  <p:cSld>
-    <p:bg>
-      <p:bgPr>
-        <a:solidFill>
-          <a:schemeClr val="bg1"/>
-        </a:solidFill>
-        <a:effectLst/>
-      </p:bgPr>
-    </p:bg>
-    <p:spTree>
-      <p:nvGrpSpPr>
-        <p:cNvPr id="1" name=""/>
-        <p:cNvGrpSpPr/>
-        <p:nvPr/>
-      </p:nvGrpSpPr>
-      <p:grpSpPr>
-        <a:xfrm>
-          <a:off x="0" y="0"/>
-          <a:ext cx="0" cy="0"/>
-          <a:chOff x="0" y="0"/>
-          <a:chExt cx="0" cy="0"/>
-        </a:xfrm>
-      </p:grpSpPr>
-      <p:pic>
-        <p:nvPicPr>
-          <p:cNvPr id="6" name="Picture 5">
-            <a:extLst>
-              <a:ext uri="{FF2B5EF4-FFF2-40B4-BE49-F238E27FC236}">
-                <a16:creationId xmlns:a16="http://schemas.microsoft.com/office/drawing/2014/main" id="{1930F4FE-ED81-10D7-02B4-BBE900585588}"/>
-              </a:ext>
-            </a:extLst>
-          </p:cNvPr>
-          <p:cNvPicPr>
-            <a:picLocks noChangeAspect="1"/>
-          </p:cNvPicPr>
-          <p:nvPr/>
-        </p:nvPicPr>
-        <p:blipFill>
-          <a:blip r:embed="rId2"/>
-          <a:stretch>
-            <a:fillRect/>
-          </a:stretch>
-        </p:blipFill>
-        <p:spPr>
-          <a:xfrm>
-            <a:off x="3352250" y="643466"/>
-            <a:ext cx="5487500" cy="5571067"/>
-          </a:xfrm>
-          <a:prstGeom prst="rect">
-            <a:avLst/>
-          </a:prstGeom>
-        </p:spPr>
-      </p:pic>
-    </p:spTree>
-    <p:extLst>
-      <p:ext uri="{BB962C8B-B14F-4D97-AF65-F5344CB8AC3E}">
-        <p14:creationId xmlns:p14="http://schemas.microsoft.com/office/powerpoint/2010/main" val="560371075"/>
       </p:ext>
     </p:extLst>
   </p:cSld>

</xml_diff>

<commit_message>
- DatasetData 3 types LM, CN, FL combined into DatasetData. -DatasetDataST -> StationData
_sp (s) corrected
BE, Interface. API , FE , page codes all corrected
</commit_message>
<xml_diff>
--- a/AlamutB/.appCatalog/Alamut.pptx
+++ b/AlamutB/.appCatalog/Alamut.pptx
@@ -197,7 +197,7 @@
           <a:p>
             <a:fld id="{76AEB20D-1E0E-486A-823D-795E0F1B1A92}" type="datetimeFigureOut">
               <a:rPr lang="en-US" smtClean="0"/>
-              <a:t>8/27/2026</a:t>
+              <a:t>8/30/2026</a:t>
             </a:fld>
             <a:endParaRPr lang="en-US"/>
           </a:p>
@@ -611,7 +611,7 @@
           <a:p>
             <a:fld id="{8A0CD729-867D-477D-ADDA-CA15108676C8}" type="datetimeFigureOut">
               <a:rPr lang="en-US" smtClean="0"/>
-              <a:t>8/27/2026</a:t>
+              <a:t>8/30/2026</a:t>
             </a:fld>
             <a:endParaRPr lang="en-US"/>
           </a:p>
@@ -809,7 +809,7 @@
           <a:p>
             <a:fld id="{8A0CD729-867D-477D-ADDA-CA15108676C8}" type="datetimeFigureOut">
               <a:rPr lang="en-US" smtClean="0"/>
-              <a:t>8/27/2026</a:t>
+              <a:t>8/30/2026</a:t>
             </a:fld>
             <a:endParaRPr lang="en-US"/>
           </a:p>
@@ -1017,7 +1017,7 @@
           <a:p>
             <a:fld id="{8A0CD729-867D-477D-ADDA-CA15108676C8}" type="datetimeFigureOut">
               <a:rPr lang="en-US" smtClean="0"/>
-              <a:t>8/27/2026</a:t>
+              <a:t>8/30/2026</a:t>
             </a:fld>
             <a:endParaRPr lang="en-US"/>
           </a:p>
@@ -1215,7 +1215,7 @@
           <a:p>
             <a:fld id="{8A0CD729-867D-477D-ADDA-CA15108676C8}" type="datetimeFigureOut">
               <a:rPr lang="en-US" smtClean="0"/>
-              <a:t>8/27/2026</a:t>
+              <a:t>8/30/2026</a:t>
             </a:fld>
             <a:endParaRPr lang="en-US"/>
           </a:p>
@@ -1490,7 +1490,7 @@
           <a:p>
             <a:fld id="{8A0CD729-867D-477D-ADDA-CA15108676C8}" type="datetimeFigureOut">
               <a:rPr lang="en-US" smtClean="0"/>
-              <a:t>8/27/2026</a:t>
+              <a:t>8/30/2026</a:t>
             </a:fld>
             <a:endParaRPr lang="en-US"/>
           </a:p>
@@ -1755,7 +1755,7 @@
           <a:p>
             <a:fld id="{8A0CD729-867D-477D-ADDA-CA15108676C8}" type="datetimeFigureOut">
               <a:rPr lang="en-US" smtClean="0"/>
-              <a:t>8/27/2026</a:t>
+              <a:t>8/30/2026</a:t>
             </a:fld>
             <a:endParaRPr lang="en-US"/>
           </a:p>
@@ -2167,7 +2167,7 @@
           <a:p>
             <a:fld id="{8A0CD729-867D-477D-ADDA-CA15108676C8}" type="datetimeFigureOut">
               <a:rPr lang="en-US" smtClean="0"/>
-              <a:t>8/27/2026</a:t>
+              <a:t>8/30/2026</a:t>
             </a:fld>
             <a:endParaRPr lang="en-US"/>
           </a:p>
@@ -2308,7 +2308,7 @@
           <a:p>
             <a:fld id="{8A0CD729-867D-477D-ADDA-CA15108676C8}" type="datetimeFigureOut">
               <a:rPr lang="en-US" smtClean="0"/>
-              <a:t>8/27/2026</a:t>
+              <a:t>8/30/2026</a:t>
             </a:fld>
             <a:endParaRPr lang="en-US"/>
           </a:p>
@@ -2421,7 +2421,7 @@
           <a:p>
             <a:fld id="{8A0CD729-867D-477D-ADDA-CA15108676C8}" type="datetimeFigureOut">
               <a:rPr lang="en-US" smtClean="0"/>
-              <a:t>8/27/2026</a:t>
+              <a:t>8/30/2026</a:t>
             </a:fld>
             <a:endParaRPr lang="en-US"/>
           </a:p>
@@ -2732,7 +2732,7 @@
           <a:p>
             <a:fld id="{8A0CD729-867D-477D-ADDA-CA15108676C8}" type="datetimeFigureOut">
               <a:rPr lang="en-US" smtClean="0"/>
-              <a:t>8/27/2026</a:t>
+              <a:t>8/30/2026</a:t>
             </a:fld>
             <a:endParaRPr lang="en-US"/>
           </a:p>
@@ -3020,7 +3020,7 @@
           <a:p>
             <a:fld id="{8A0CD729-867D-477D-ADDA-CA15108676C8}" type="datetimeFigureOut">
               <a:rPr lang="en-US" smtClean="0"/>
-              <a:t>8/27/2026</a:t>
+              <a:t>8/30/2026</a:t>
             </a:fld>
             <a:endParaRPr lang="en-US"/>
           </a:p>
@@ -3261,7 +3261,7 @@
           <a:p>
             <a:fld id="{8A0CD729-867D-477D-ADDA-CA15108676C8}" type="datetimeFigureOut">
               <a:rPr lang="en-US" smtClean="0"/>
-              <a:t>8/27/2026</a:t>
+              <a:t>8/30/2026</a:t>
             </a:fld>
             <a:endParaRPr lang="en-US"/>
           </a:p>
@@ -8579,7 +8579,7 @@
         <p:spPr bwMode="auto">
           <a:xfrm>
             <a:off x="3077900" y="1868250"/>
-            <a:ext cx="2172080" cy="3128795"/>
+            <a:ext cx="2172080" cy="2975213"/>
           </a:xfrm>
           <a:prstGeom prst="roundRect">
             <a:avLst>
@@ -8980,21 +8980,6 @@
               <a:t>4: </a:t>
             </a:r>
           </a:p>
-          <a:p>
-            <a:pPr>
-              <a:defRPr/>
-            </a:pPr>
-            <a:r>
-              <a:rPr lang="en-US" sz="900">
-                <a:solidFill>
-                  <a:schemeClr val="tx1"/>
-                </a:solidFill>
-                <a:latin typeface="Segoe UI" panose="020B0502040204020203" pitchFamily="34" charset="0"/>
-                <a:cs typeface="Segoe UI" panose="020B0502040204020203" pitchFamily="34" charset="0"/>
-              </a:rPr>
-              <a:t>8: </a:t>
-            </a:r>
-          </a:p>
         </p:txBody>
       </p:sp>
       <p:sp>
@@ -9011,8 +8996,8 @@
         </p:nvSpPr>
         <p:spPr bwMode="auto">
           <a:xfrm>
-            <a:off x="4923256" y="2675240"/>
-            <a:ext cx="1821350" cy="1320153"/>
+            <a:off x="5065258" y="2738268"/>
+            <a:ext cx="1679348" cy="1909132"/>
           </a:xfrm>
           <a:prstGeom prst="roundRect">
             <a:avLst>
@@ -9061,7 +9046,7 @@
                 <a:latin typeface="Segoe UI" panose="020B0502040204020203" pitchFamily="34" charset="0"/>
                 <a:cs typeface="Segoe UI" panose="020B0502040204020203" pitchFamily="34" charset="0"/>
               </a:rPr>
-              <a:t>DatasetDataCN</a:t>
+              <a:t>DatasetData</a:t>
             </a:r>
             <a:endParaRPr sz="1600" b="1">
               <a:solidFill>
@@ -9086,7 +9071,7 @@
                 <a:latin typeface="Segoe UI" panose="020B0502040204020203" pitchFamily="34" charset="0"/>
                 <a:cs typeface="Segoe UI" panose="020B0502040204020203" pitchFamily="34" charset="0"/>
               </a:rPr>
-              <a:t>DatasetDataCNId</a:t>
+              <a:t>DatasetDataId</a:t>
             </a:r>
             <a:endParaRPr lang="en-US" sz="900">
               <a:solidFill>
@@ -9123,6 +9108,36 @@
                 <a:latin typeface="Segoe UI" panose="020B0502040204020203" pitchFamily="34" charset="0"/>
                 <a:cs typeface="Segoe UI" panose="020B0502040204020203" pitchFamily="34" charset="0"/>
               </a:rPr>
+              <a:t>SpeciesId</a:t>
+            </a:r>
+          </a:p>
+          <a:p>
+            <a:pPr>
+              <a:defRPr/>
+            </a:pPr>
+            <a:r>
+              <a:rPr lang="en-US" sz="900">
+                <a:solidFill>
+                  <a:schemeClr val="tx1"/>
+                </a:solidFill>
+                <a:latin typeface="Segoe UI" panose="020B0502040204020203" pitchFamily="34" charset="0"/>
+                <a:cs typeface="Segoe UI" panose="020B0502040204020203" pitchFamily="34" charset="0"/>
+              </a:rPr>
+              <a:t>Infraspecific</a:t>
+            </a:r>
+          </a:p>
+          <a:p>
+            <a:pPr>
+              <a:defRPr/>
+            </a:pPr>
+            <a:r>
+              <a:rPr lang="en-US" sz="900">
+                <a:solidFill>
+                  <a:schemeClr val="tx1"/>
+                </a:solidFill>
+                <a:latin typeface="Segoe UI" panose="020B0502040204020203" pitchFamily="34" charset="0"/>
+                <a:cs typeface="Segoe UI" panose="020B0502040204020203" pitchFamily="34" charset="0"/>
+              </a:rPr>
               <a:t>LineString</a:t>
             </a:r>
           </a:p>
@@ -9154,313 +9169,6 @@
                 <a:cs typeface="Segoe UI" panose="020B0502040204020203" pitchFamily="34" charset="0"/>
               </a:rPr>
               <a:t>ParsedEpithet</a:t>
-            </a:r>
-          </a:p>
-          <a:p>
-            <a:pPr>
-              <a:defRPr/>
-            </a:pPr>
-            <a:r>
-              <a:rPr lang="en-US" sz="900">
-                <a:solidFill>
-                  <a:schemeClr val="tx1"/>
-                </a:solidFill>
-                <a:latin typeface="Segoe UI" panose="020B0502040204020203" pitchFamily="34" charset="0"/>
-                <a:cs typeface="Segoe UI" panose="020B0502040204020203" pitchFamily="34" charset="0"/>
-              </a:rPr>
-              <a:t>SpeciesId</a:t>
-            </a:r>
-          </a:p>
-          <a:p>
-            <a:pPr>
-              <a:defRPr/>
-            </a:pPr>
-            <a:r>
-              <a:rPr lang="en-US" sz="900">
-                <a:solidFill>
-                  <a:schemeClr val="tx1"/>
-                </a:solidFill>
-                <a:latin typeface="Segoe UI" panose="020B0502040204020203" pitchFamily="34" charset="0"/>
-                <a:cs typeface="Segoe UI" panose="020B0502040204020203" pitchFamily="34" charset="0"/>
-              </a:rPr>
-              <a:t>Infraspecific</a:t>
-            </a:r>
-          </a:p>
-        </p:txBody>
-      </p:sp>
-      <p:sp>
-        <p:nvSpPr>
-          <p:cNvPr id="47" name="Rectangle: Rounded Corners 45">
-            <a:extLst>
-              <a:ext uri="{FF2B5EF4-FFF2-40B4-BE49-F238E27FC236}">
-                <a16:creationId xmlns:a16="http://schemas.microsoft.com/office/drawing/2014/main" id="{7B375414-8750-DD39-909D-63A7A32B31A5}"/>
-              </a:ext>
-            </a:extLst>
-          </p:cNvPr>
-          <p:cNvSpPr/>
-          <p:nvPr/>
-        </p:nvSpPr>
-        <p:spPr bwMode="auto">
-          <a:xfrm>
-            <a:off x="4928003" y="4097135"/>
-            <a:ext cx="1821351" cy="956800"/>
-          </a:xfrm>
-          <a:prstGeom prst="roundRect">
-            <a:avLst>
-              <a:gd name="adj" fmla="val 3991"/>
-            </a:avLst>
-          </a:prstGeom>
-          <a:solidFill>
-            <a:schemeClr val="bg1"/>
-          </a:solidFill>
-          <a:ln w="12700">
-            <a:solidFill>
-              <a:schemeClr val="tx1"/>
-            </a:solidFill>
-          </a:ln>
-          <a:effectLst/>
-        </p:spPr>
-        <p:style>
-          <a:lnRef idx="0">
-            <a:schemeClr val="accent4"/>
-          </a:lnRef>
-          <a:fillRef idx="3">
-            <a:schemeClr val="accent4"/>
-          </a:fillRef>
-          <a:effectRef idx="3">
-            <a:schemeClr val="accent4"/>
-          </a:effectRef>
-          <a:fontRef idx="minor">
-            <a:schemeClr val="lt1"/>
-          </a:fontRef>
-        </p:style>
-        <p:txBody>
-          <a:bodyPr rtlCol="1" anchor="t"/>
-          <a:lstStyle/>
-          <a:p>
-            <a:pPr>
-              <a:defRPr/>
-            </a:pPr>
-            <a:r>
-              <a:rPr lang="en-US" sz="1600" b="1">
-                <a:solidFill>
-                  <a:schemeClr val="bg1"/>
-                </a:solidFill>
-                <a:highlight>
-                  <a:srgbClr val="800080"/>
-                </a:highlight>
-                <a:latin typeface="Segoe UI" panose="020B0502040204020203" pitchFamily="34" charset="0"/>
-                <a:cs typeface="Segoe UI" panose="020B0502040204020203" pitchFamily="34" charset="0"/>
-              </a:rPr>
-              <a:t>DatasetDataLM</a:t>
-            </a:r>
-            <a:endParaRPr sz="1600" b="1">
-              <a:solidFill>
-                <a:schemeClr val="bg1"/>
-              </a:solidFill>
-              <a:highlight>
-                <a:srgbClr val="800080"/>
-              </a:highlight>
-              <a:latin typeface="Segoe UI" panose="020B0502040204020203" pitchFamily="34" charset="0"/>
-              <a:cs typeface="Segoe UI" panose="020B0502040204020203" pitchFamily="34" charset="0"/>
-            </a:endParaRPr>
-          </a:p>
-          <a:p>
-            <a:pPr>
-              <a:defRPr/>
-            </a:pPr>
-            <a:r>
-              <a:rPr lang="en-US" sz="900" i="1">
-                <a:solidFill>
-                  <a:schemeClr val="accent5"/>
-                </a:solidFill>
-                <a:latin typeface="Segoe UI" panose="020B0502040204020203" pitchFamily="34" charset="0"/>
-                <a:cs typeface="Segoe UI" panose="020B0502040204020203" pitchFamily="34" charset="0"/>
-              </a:rPr>
-              <a:t>DatasetDataLMId</a:t>
-            </a:r>
-            <a:endParaRPr lang="en-US" sz="900">
-              <a:solidFill>
-                <a:schemeClr val="tx1"/>
-              </a:solidFill>
-              <a:latin typeface="Segoe UI" panose="020B0502040204020203" pitchFamily="34" charset="0"/>
-              <a:cs typeface="Segoe UI" panose="020B0502040204020203" pitchFamily="34" charset="0"/>
-            </a:endParaRPr>
-          </a:p>
-          <a:p>
-            <a:pPr>
-              <a:defRPr/>
-            </a:pPr>
-            <a:r>
-              <a:rPr lang="en-US" sz="900">
-                <a:solidFill>
-                  <a:schemeClr val="tx1"/>
-                </a:solidFill>
-                <a:latin typeface="Segoe UI" panose="020B0502040204020203" pitchFamily="34" charset="0"/>
-                <a:cs typeface="Segoe UI" panose="020B0502040204020203" pitchFamily="34" charset="0"/>
-              </a:rPr>
-              <a:t>DatasetId</a:t>
-            </a:r>
-          </a:p>
-          <a:p>
-            <a:pPr>
-              <a:defRPr/>
-            </a:pPr>
-            <a:r>
-              <a:rPr lang="en-US" sz="900">
-                <a:solidFill>
-                  <a:schemeClr val="tx1"/>
-                </a:solidFill>
-                <a:latin typeface="Segoe UI" panose="020B0502040204020203" pitchFamily="34" charset="0"/>
-                <a:cs typeface="Segoe UI" panose="020B0502040204020203" pitchFamily="34" charset="0"/>
-              </a:rPr>
-              <a:t>SpeciesId</a:t>
-            </a:r>
-          </a:p>
-        </p:txBody>
-      </p:sp>
-      <p:sp>
-        <p:nvSpPr>
-          <p:cNvPr id="39" name="Rectangle: Rounded Corners 45">
-            <a:extLst>
-              <a:ext uri="{FF2B5EF4-FFF2-40B4-BE49-F238E27FC236}">
-                <a16:creationId xmlns:a16="http://schemas.microsoft.com/office/drawing/2014/main" id="{49951EDA-2E8F-EE6B-9731-1CC1E82FEF61}"/>
-              </a:ext>
-            </a:extLst>
-          </p:cNvPr>
-          <p:cNvSpPr/>
-          <p:nvPr/>
-        </p:nvSpPr>
-        <p:spPr bwMode="auto">
-          <a:xfrm>
-            <a:off x="4921427" y="1678316"/>
-            <a:ext cx="1747105" cy="871715"/>
-          </a:xfrm>
-          <a:prstGeom prst="roundRect">
-            <a:avLst>
-              <a:gd name="adj" fmla="val 3991"/>
-            </a:avLst>
-          </a:prstGeom>
-          <a:solidFill>
-            <a:schemeClr val="bg1"/>
-          </a:solidFill>
-          <a:ln w="12700">
-            <a:solidFill>
-              <a:schemeClr val="tx1"/>
-            </a:solidFill>
-          </a:ln>
-          <a:effectLst/>
-        </p:spPr>
-        <p:style>
-          <a:lnRef idx="0">
-            <a:schemeClr val="accent4"/>
-          </a:lnRef>
-          <a:fillRef idx="3">
-            <a:schemeClr val="accent4"/>
-          </a:fillRef>
-          <a:effectRef idx="3">
-            <a:schemeClr val="accent4"/>
-          </a:effectRef>
-          <a:fontRef idx="minor">
-            <a:schemeClr val="lt1"/>
-          </a:fontRef>
-        </p:style>
-        <p:txBody>
-          <a:bodyPr rtlCol="1" anchor="t"/>
-          <a:lstStyle/>
-          <a:p>
-            <a:pPr>
-              <a:defRPr/>
-            </a:pPr>
-            <a:r>
-              <a:rPr lang="en-US" sz="1600" b="1">
-                <a:solidFill>
-                  <a:schemeClr val="bg1"/>
-                </a:solidFill>
-                <a:highlight>
-                  <a:srgbClr val="800080"/>
-                </a:highlight>
-                <a:latin typeface="Segoe UI" panose="020B0502040204020203" pitchFamily="34" charset="0"/>
-                <a:cs typeface="Segoe UI" panose="020B0502040204020203" pitchFamily="34" charset="0"/>
-              </a:rPr>
-              <a:t>DatasetDataFL</a:t>
-            </a:r>
-            <a:endParaRPr sz="1600" b="1">
-              <a:solidFill>
-                <a:schemeClr val="bg1"/>
-              </a:solidFill>
-              <a:highlight>
-                <a:srgbClr val="800080"/>
-              </a:highlight>
-              <a:latin typeface="Segoe UI" panose="020B0502040204020203" pitchFamily="34" charset="0"/>
-              <a:cs typeface="Segoe UI" panose="020B0502040204020203" pitchFamily="34" charset="0"/>
-            </a:endParaRPr>
-          </a:p>
-          <a:p>
-            <a:pPr>
-              <a:defRPr/>
-            </a:pPr>
-            <a:r>
-              <a:rPr lang="en-US" sz="900" i="1">
-                <a:solidFill>
-                  <a:schemeClr val="accent5"/>
-                </a:solidFill>
-                <a:latin typeface="Segoe UI" panose="020B0502040204020203" pitchFamily="34" charset="0"/>
-                <a:cs typeface="Segoe UI" panose="020B0502040204020203" pitchFamily="34" charset="0"/>
-              </a:rPr>
-              <a:t>DatasetDataFLId</a:t>
-            </a:r>
-            <a:endParaRPr lang="en-US" sz="900">
-              <a:solidFill>
-                <a:schemeClr val="tx1"/>
-              </a:solidFill>
-              <a:latin typeface="Segoe UI" panose="020B0502040204020203" pitchFamily="34" charset="0"/>
-              <a:cs typeface="Segoe UI" panose="020B0502040204020203" pitchFamily="34" charset="0"/>
-            </a:endParaRPr>
-          </a:p>
-          <a:p>
-            <a:pPr>
-              <a:defRPr/>
-            </a:pPr>
-            <a:r>
-              <a:rPr lang="en-US" sz="900">
-                <a:solidFill>
-                  <a:schemeClr val="tx1"/>
-                </a:solidFill>
-                <a:latin typeface="Segoe UI" panose="020B0502040204020203" pitchFamily="34" charset="0"/>
-                <a:cs typeface="Segoe UI" panose="020B0502040204020203" pitchFamily="34" charset="0"/>
-              </a:rPr>
-              <a:t>DatasetId</a:t>
-            </a:r>
-          </a:p>
-          <a:p>
-            <a:pPr>
-              <a:defRPr/>
-            </a:pPr>
-            <a:r>
-              <a:rPr lang="en-US" sz="900">
-                <a:solidFill>
-                  <a:schemeClr val="tx1"/>
-                </a:solidFill>
-                <a:latin typeface="Segoe UI" panose="020B0502040204020203" pitchFamily="34" charset="0"/>
-                <a:cs typeface="Segoe UI" panose="020B0502040204020203" pitchFamily="34" charset="0"/>
-              </a:rPr>
-              <a:t>SpeciesId</a:t>
-            </a:r>
-          </a:p>
-          <a:p>
-            <a:pPr>
-              <a:defRPr/>
-            </a:pPr>
-            <a:r>
-              <a:rPr lang="en-US" sz="900">
-                <a:solidFill>
-                  <a:schemeClr val="tx1"/>
-                </a:solidFill>
-                <a:latin typeface="Segoe UI" panose="020B0502040204020203" pitchFamily="34" charset="0"/>
-                <a:cs typeface="Segoe UI" panose="020B0502040204020203" pitchFamily="34" charset="0"/>
-              </a:rPr>
-              <a:t>Infraspecific</a:t>
             </a:r>
           </a:p>
         </p:txBody>
@@ -9706,8 +9414,8 @@
         </p:nvSpPr>
         <p:spPr bwMode="auto">
           <a:xfrm>
-            <a:off x="4921427" y="5310077"/>
-            <a:ext cx="1821350" cy="1140311"/>
+            <a:off x="5065258" y="5283555"/>
+            <a:ext cx="1679348" cy="1210093"/>
           </a:xfrm>
           <a:prstGeom prst="roundRect">
             <a:avLst>
@@ -9756,7 +9464,7 @@
                 <a:latin typeface="Segoe UI" panose="020B0502040204020203" pitchFamily="34" charset="0"/>
                 <a:cs typeface="Segoe UI" panose="020B0502040204020203" pitchFamily="34" charset="0"/>
               </a:rPr>
-              <a:t>DatasetDataST</a:t>
+              <a:t>StationData</a:t>
             </a:r>
             <a:endParaRPr sz="1600" b="1">
               <a:solidFill>
@@ -9781,7 +9489,7 @@
                 <a:latin typeface="Segoe UI" panose="020B0502040204020203" pitchFamily="34" charset="0"/>
                 <a:cs typeface="Segoe UI" panose="020B0502040204020203" pitchFamily="34" charset="0"/>
               </a:rPr>
-              <a:t>DatasetDataSTId</a:t>
+              <a:t>StationDataId</a:t>
             </a:r>
             <a:endParaRPr lang="en-US" sz="900">
               <a:solidFill>
@@ -9833,7 +9541,27 @@
                 <a:latin typeface="Segoe UI" panose="020B0502040204020203" pitchFamily="34" charset="0"/>
                 <a:cs typeface="Segoe UI" panose="020B0502040204020203" pitchFamily="34" charset="0"/>
               </a:rPr>
-              <a:t>DataType {T/P}</a:t>
+              <a:t>DataType {</a:t>
+            </a:r>
+            <a:r>
+              <a:rPr lang="en-US" sz="900">
+                <a:solidFill>
+                  <a:srgbClr val="FF0000"/>
+                </a:solidFill>
+                <a:latin typeface="Segoe UI" panose="020B0502040204020203" pitchFamily="34" charset="0"/>
+                <a:cs typeface="Segoe UI" panose="020B0502040204020203" pitchFamily="34" charset="0"/>
+              </a:rPr>
+              <a:t>T/P</a:t>
+            </a:r>
+            <a:r>
+              <a:rPr lang="en-US" sz="900">
+                <a:solidFill>
+                  <a:schemeClr val="tx1"/>
+                </a:solidFill>
+                <a:latin typeface="Segoe UI" panose="020B0502040204020203" pitchFamily="34" charset="0"/>
+                <a:cs typeface="Segoe UI" panose="020B0502040204020203" pitchFamily="34" charset="0"/>
+              </a:rPr>
+              <a:t>}</a:t>
             </a:r>
           </a:p>
           <a:p>

</xml_diff>

<commit_message>
- corrections needed after combining 3 tables of DatasetData (LM, CN, FL) - corrections for delete item from dataset in ListMaker -search icons of Filters in each page/component moved to left of textInput.
</commit_message>
<xml_diff>
--- a/AlamutB/.appCatalog/Alamut.pptx
+++ b/AlamutB/.appCatalog/Alamut.pptx
@@ -5,10 +5,11 @@
     <p:sldMasterId id="2147483648" r:id="rId1"/>
   </p:sldMasterIdLst>
   <p:notesMasterIdLst>
-    <p:notesMasterId r:id="rId3"/>
+    <p:notesMasterId r:id="rId4"/>
   </p:notesMasterIdLst>
   <p:sldIdLst>
     <p:sldId id="259" r:id="rId2"/>
+    <p:sldId id="260" r:id="rId3"/>
   </p:sldIdLst>
   <p:sldSz cx="12192000" cy="6858000"/>
   <p:notesSz cx="6858000" cy="9144000"/>
@@ -3686,10 +3687,10 @@
       </p:grpSpPr>
       <p:sp>
         <p:nvSpPr>
-          <p:cNvPr id="11" name="Oval 10">
+          <p:cNvPr id="2" name="Oval 1">
             <a:extLst>
               <a:ext uri="{FF2B5EF4-FFF2-40B4-BE49-F238E27FC236}">
-                <a16:creationId xmlns:a16="http://schemas.microsoft.com/office/drawing/2014/main" id="{A2537CC6-003A-316F-5529-57D6B0DEC272}"/>
+                <a16:creationId xmlns:a16="http://schemas.microsoft.com/office/drawing/2014/main" id="{593362CC-2ACB-B0F9-54CE-223C0497C830}"/>
               </a:ext>
             </a:extLst>
           </p:cNvPr>
@@ -3697,2381 +3698,15 @@
           <p:nvPr/>
         </p:nvSpPr>
         <p:spPr>
-          <a:xfrm rot="4906371">
-            <a:off x="941089" y="645113"/>
-            <a:ext cx="5339144" cy="7304071"/>
+          <a:xfrm>
+            <a:off x="6218818" y="846826"/>
+            <a:ext cx="5718777" cy="5139178"/>
           </a:xfrm>
-          <a:custGeom>
+          <a:prstGeom prst="ellipse">
             <a:avLst/>
-            <a:gdLst>
-              <a:gd name="csX0" fmla="*/ 0 w 5693503"/>
-              <a:gd name="csY0" fmla="*/ 3460376 h 6920752"/>
-              <a:gd name="csX1" fmla="*/ 2846752 w 5693503"/>
-              <a:gd name="csY1" fmla="*/ 0 h 6920752"/>
-              <a:gd name="csX2" fmla="*/ 5693504 w 5693503"/>
-              <a:gd name="csY2" fmla="*/ 3460376 h 6920752"/>
-              <a:gd name="csX3" fmla="*/ 2846752 w 5693503"/>
-              <a:gd name="csY3" fmla="*/ 6920752 h 6920752"/>
-              <a:gd name="csX4" fmla="*/ 0 w 5693503"/>
-              <a:gd name="csY4" fmla="*/ 3460376 h 6920752"/>
-              <a:gd name="csX0" fmla="*/ 0 w 5838383"/>
-              <a:gd name="csY0" fmla="*/ 3460376 h 7043980"/>
-              <a:gd name="csX1" fmla="*/ 2846752 w 5838383"/>
-              <a:gd name="csY1" fmla="*/ 0 h 7043980"/>
-              <a:gd name="csX2" fmla="*/ 5693504 w 5838383"/>
-              <a:gd name="csY2" fmla="*/ 3460376 h 7043980"/>
-              <a:gd name="csX3" fmla="*/ 5259296 w 5838383"/>
-              <a:gd name="csY3" fmla="*/ 6006352 h 7043980"/>
-              <a:gd name="csX4" fmla="*/ 2846752 w 5838383"/>
-              <a:gd name="csY4" fmla="*/ 6920752 h 7043980"/>
-              <a:gd name="csX5" fmla="*/ 0 w 5838383"/>
-              <a:gd name="csY5" fmla="*/ 3460376 h 7043980"/>
-              <a:gd name="csX0" fmla="*/ 0 w 5729583"/>
-              <a:gd name="csY0" fmla="*/ 3577624 h 7161228"/>
-              <a:gd name="csX1" fmla="*/ 2846752 w 5729583"/>
-              <a:gd name="csY1" fmla="*/ 117248 h 7161228"/>
-              <a:gd name="csX2" fmla="*/ 5402731 w 5729583"/>
-              <a:gd name="csY2" fmla="*/ 1067506 h 7161228"/>
-              <a:gd name="csX3" fmla="*/ 5693504 w 5729583"/>
-              <a:gd name="csY3" fmla="*/ 3577624 h 7161228"/>
-              <a:gd name="csX4" fmla="*/ 5259296 w 5729583"/>
-              <a:gd name="csY4" fmla="*/ 6123600 h 7161228"/>
-              <a:gd name="csX5" fmla="*/ 2846752 w 5729583"/>
-              <a:gd name="csY5" fmla="*/ 7038000 h 7161228"/>
-              <a:gd name="csX6" fmla="*/ 0 w 5729583"/>
-              <a:gd name="csY6" fmla="*/ 3577624 h 7161228"/>
-              <a:gd name="csX0" fmla="*/ 28786 w 5758369"/>
-              <a:gd name="csY0" fmla="*/ 3577624 h 6996553"/>
-              <a:gd name="csX1" fmla="*/ 2875538 w 5758369"/>
-              <a:gd name="csY1" fmla="*/ 117248 h 6996553"/>
-              <a:gd name="csX2" fmla="*/ 5431517 w 5758369"/>
-              <a:gd name="csY2" fmla="*/ 1067506 h 6996553"/>
-              <a:gd name="csX3" fmla="*/ 5722290 w 5758369"/>
-              <a:gd name="csY3" fmla="*/ 3577624 h 6996553"/>
-              <a:gd name="csX4" fmla="*/ 5288082 w 5758369"/>
-              <a:gd name="csY4" fmla="*/ 6123600 h 6996553"/>
-              <a:gd name="csX5" fmla="*/ 1638409 w 5758369"/>
-              <a:gd name="csY5" fmla="*/ 6849741 h 6996553"/>
-              <a:gd name="csX6" fmla="*/ 28786 w 5758369"/>
-              <a:gd name="csY6" fmla="*/ 3577624 h 6996553"/>
-              <a:gd name="csX0" fmla="*/ 55635 w 5112865"/>
-              <a:gd name="csY0" fmla="*/ 841492 h 7132142"/>
-              <a:gd name="csX1" fmla="*/ 2230034 w 5112865"/>
-              <a:gd name="csY1" fmla="*/ 61563 h 7132142"/>
-              <a:gd name="csX2" fmla="*/ 4786013 w 5112865"/>
-              <a:gd name="csY2" fmla="*/ 1011821 h 7132142"/>
-              <a:gd name="csX3" fmla="*/ 5076786 w 5112865"/>
-              <a:gd name="csY3" fmla="*/ 3521939 h 7132142"/>
-              <a:gd name="csX4" fmla="*/ 4642578 w 5112865"/>
-              <a:gd name="csY4" fmla="*/ 6067915 h 7132142"/>
-              <a:gd name="csX5" fmla="*/ 992905 w 5112865"/>
-              <a:gd name="csY5" fmla="*/ 6794056 h 7132142"/>
-              <a:gd name="csX6" fmla="*/ 55635 w 5112865"/>
-              <a:gd name="csY6" fmla="*/ 841492 h 7132142"/>
-              <a:gd name="csX0" fmla="*/ 6699 w 5063929"/>
-              <a:gd name="csY0" fmla="*/ 782841 h 6858084"/>
-              <a:gd name="csX1" fmla="*/ 2181098 w 5063929"/>
-              <a:gd name="csY1" fmla="*/ 2912 h 6858084"/>
-              <a:gd name="csX2" fmla="*/ 4737077 w 5063929"/>
-              <a:gd name="csY2" fmla="*/ 953170 h 6858084"/>
-              <a:gd name="csX3" fmla="*/ 5027850 w 5063929"/>
-              <a:gd name="csY3" fmla="*/ 3463288 h 6858084"/>
-              <a:gd name="csX4" fmla="*/ 4593642 w 5063929"/>
-              <a:gd name="csY4" fmla="*/ 6009264 h 6858084"/>
-              <a:gd name="csX5" fmla="*/ 943969 w 5063929"/>
-              <a:gd name="csY5" fmla="*/ 6735405 h 6858084"/>
-              <a:gd name="csX6" fmla="*/ 1482885 w 5063929"/>
-              <a:gd name="csY6" fmla="*/ 3812911 h 6858084"/>
-              <a:gd name="csX7" fmla="*/ 6699 w 5063929"/>
-              <a:gd name="csY7" fmla="*/ 782841 h 6858084"/>
-              <a:gd name="csX0" fmla="*/ 57080 w 5114310"/>
-              <a:gd name="csY0" fmla="*/ 782662 h 6864060"/>
-              <a:gd name="csX1" fmla="*/ 2231479 w 5114310"/>
-              <a:gd name="csY1" fmla="*/ 2733 h 6864060"/>
-              <a:gd name="csX2" fmla="*/ 4787458 w 5114310"/>
-              <a:gd name="csY2" fmla="*/ 952991 h 6864060"/>
-              <a:gd name="csX3" fmla="*/ 5078231 w 5114310"/>
-              <a:gd name="csY3" fmla="*/ 3463109 h 6864060"/>
-              <a:gd name="csX4" fmla="*/ 4644023 w 5114310"/>
-              <a:gd name="csY4" fmla="*/ 6009085 h 6864060"/>
-              <a:gd name="csX5" fmla="*/ 994350 w 5114310"/>
-              <a:gd name="csY5" fmla="*/ 6735226 h 6864060"/>
-              <a:gd name="csX6" fmla="*/ 663690 w 5114310"/>
-              <a:gd name="csY6" fmla="*/ 3723085 h 6864060"/>
-              <a:gd name="csX7" fmla="*/ 57080 w 5114310"/>
-              <a:gd name="csY7" fmla="*/ 782662 h 6864060"/>
-              <a:gd name="csX0" fmla="*/ 57080 w 5114310"/>
-              <a:gd name="csY0" fmla="*/ 782662 h 6981921"/>
-              <a:gd name="csX1" fmla="*/ 2231479 w 5114310"/>
-              <a:gd name="csY1" fmla="*/ 2733 h 6981921"/>
-              <a:gd name="csX2" fmla="*/ 4787458 w 5114310"/>
-              <a:gd name="csY2" fmla="*/ 952991 h 6981921"/>
-              <a:gd name="csX3" fmla="*/ 5078231 w 5114310"/>
-              <a:gd name="csY3" fmla="*/ 3463109 h 6981921"/>
-              <a:gd name="csX4" fmla="*/ 4644023 w 5114310"/>
-              <a:gd name="csY4" fmla="*/ 6009085 h 6981921"/>
-              <a:gd name="csX5" fmla="*/ 877809 w 5114310"/>
-              <a:gd name="csY5" fmla="*/ 6869696 h 6981921"/>
-              <a:gd name="csX6" fmla="*/ 663690 w 5114310"/>
-              <a:gd name="csY6" fmla="*/ 3723085 h 6981921"/>
-              <a:gd name="csX7" fmla="*/ 57080 w 5114310"/>
-              <a:gd name="csY7" fmla="*/ 782662 h 6981921"/>
-              <a:gd name="csX0" fmla="*/ 67720 w 4981512"/>
-              <a:gd name="csY0" fmla="*/ 690350 h 6988221"/>
-              <a:gd name="csX1" fmla="*/ 2098681 w 4981512"/>
-              <a:gd name="csY1" fmla="*/ 9033 h 6988221"/>
-              <a:gd name="csX2" fmla="*/ 4654660 w 4981512"/>
-              <a:gd name="csY2" fmla="*/ 959291 h 6988221"/>
-              <a:gd name="csX3" fmla="*/ 4945433 w 4981512"/>
-              <a:gd name="csY3" fmla="*/ 3469409 h 6988221"/>
-              <a:gd name="csX4" fmla="*/ 4511225 w 4981512"/>
-              <a:gd name="csY4" fmla="*/ 6015385 h 6988221"/>
-              <a:gd name="csX5" fmla="*/ 745011 w 4981512"/>
-              <a:gd name="csY5" fmla="*/ 6875996 h 6988221"/>
-              <a:gd name="csX6" fmla="*/ 530892 w 4981512"/>
-              <a:gd name="csY6" fmla="*/ 3729385 h 6988221"/>
-              <a:gd name="csX7" fmla="*/ 67720 w 4981512"/>
-              <a:gd name="csY7" fmla="*/ 690350 h 6988221"/>
-              <a:gd name="csX0" fmla="*/ 67720 w 4981512"/>
-              <a:gd name="csY0" fmla="*/ 688641 h 6986512"/>
-              <a:gd name="csX1" fmla="*/ 2098681 w 4981512"/>
-              <a:gd name="csY1" fmla="*/ 7324 h 6986512"/>
-              <a:gd name="csX2" fmla="*/ 4708451 w 4981512"/>
-              <a:gd name="csY2" fmla="*/ 921723 h 6986512"/>
-              <a:gd name="csX3" fmla="*/ 4945433 w 4981512"/>
-              <a:gd name="csY3" fmla="*/ 3467700 h 6986512"/>
-              <a:gd name="csX4" fmla="*/ 4511225 w 4981512"/>
-              <a:gd name="csY4" fmla="*/ 6013676 h 6986512"/>
-              <a:gd name="csX5" fmla="*/ 745011 w 4981512"/>
-              <a:gd name="csY5" fmla="*/ 6874287 h 6986512"/>
-              <a:gd name="csX6" fmla="*/ 530892 w 4981512"/>
-              <a:gd name="csY6" fmla="*/ 3727676 h 6986512"/>
-              <a:gd name="csX7" fmla="*/ 67720 w 4981512"/>
-              <a:gd name="csY7" fmla="*/ 688641 h 6986512"/>
-              <a:gd name="csX0" fmla="*/ 67720 w 4998396"/>
-              <a:gd name="csY0" fmla="*/ 688641 h 6984967"/>
-              <a:gd name="csX1" fmla="*/ 2098681 w 4998396"/>
-              <a:gd name="csY1" fmla="*/ 7324 h 6984967"/>
-              <a:gd name="csX2" fmla="*/ 4708451 w 4998396"/>
-              <a:gd name="csY2" fmla="*/ 921723 h 6984967"/>
-              <a:gd name="csX3" fmla="*/ 4945433 w 4998396"/>
-              <a:gd name="csY3" fmla="*/ 3467700 h 6984967"/>
-              <a:gd name="csX4" fmla="*/ 4591908 w 4998396"/>
-              <a:gd name="csY4" fmla="*/ 6004711 h 6984967"/>
-              <a:gd name="csX5" fmla="*/ 745011 w 4998396"/>
-              <a:gd name="csY5" fmla="*/ 6874287 h 6984967"/>
-              <a:gd name="csX6" fmla="*/ 530892 w 4998396"/>
-              <a:gd name="csY6" fmla="*/ 3727676 h 6984967"/>
-              <a:gd name="csX7" fmla="*/ 67720 w 4998396"/>
-              <a:gd name="csY7" fmla="*/ 688641 h 6984967"/>
-              <a:gd name="csX0" fmla="*/ 67720 w 5054723"/>
-              <a:gd name="csY0" fmla="*/ 688641 h 6984967"/>
-              <a:gd name="csX1" fmla="*/ 2098681 w 5054723"/>
-              <a:gd name="csY1" fmla="*/ 7324 h 6984967"/>
-              <a:gd name="csX2" fmla="*/ 4708451 w 5054723"/>
-              <a:gd name="csY2" fmla="*/ 921723 h 6984967"/>
-              <a:gd name="csX3" fmla="*/ 5017154 w 5054723"/>
-              <a:gd name="csY3" fmla="*/ 3503559 h 6984967"/>
-              <a:gd name="csX4" fmla="*/ 4591908 w 5054723"/>
-              <a:gd name="csY4" fmla="*/ 6004711 h 6984967"/>
-              <a:gd name="csX5" fmla="*/ 745011 w 5054723"/>
-              <a:gd name="csY5" fmla="*/ 6874287 h 6984967"/>
-              <a:gd name="csX6" fmla="*/ 530892 w 5054723"/>
-              <a:gd name="csY6" fmla="*/ 3727676 h 6984967"/>
-              <a:gd name="csX7" fmla="*/ 67720 w 5054723"/>
-              <a:gd name="csY7" fmla="*/ 688641 h 6984967"/>
-              <a:gd name="csX0" fmla="*/ 67720 w 5069050"/>
-              <a:gd name="csY0" fmla="*/ 688641 h 6984967"/>
-              <a:gd name="csX1" fmla="*/ 2098681 w 5069050"/>
-              <a:gd name="csY1" fmla="*/ 7324 h 6984967"/>
-              <a:gd name="csX2" fmla="*/ 4708451 w 5069050"/>
-              <a:gd name="csY2" fmla="*/ 921723 h 6984967"/>
-              <a:gd name="csX3" fmla="*/ 5017154 w 5069050"/>
-              <a:gd name="csY3" fmla="*/ 3503559 h 6984967"/>
-              <a:gd name="csX4" fmla="*/ 4591908 w 5069050"/>
-              <a:gd name="csY4" fmla="*/ 6004711 h 6984967"/>
-              <a:gd name="csX5" fmla="*/ 745011 w 5069050"/>
-              <a:gd name="csY5" fmla="*/ 6874287 h 6984967"/>
-              <a:gd name="csX6" fmla="*/ 530892 w 5069050"/>
-              <a:gd name="csY6" fmla="*/ 3727676 h 6984967"/>
-              <a:gd name="csX7" fmla="*/ 67720 w 5069050"/>
-              <a:gd name="csY7" fmla="*/ 688641 h 6984967"/>
-              <a:gd name="csX0" fmla="*/ 67720 w 5069050"/>
-              <a:gd name="csY0" fmla="*/ 688641 h 6984967"/>
-              <a:gd name="csX1" fmla="*/ 2098681 w 5069050"/>
-              <a:gd name="csY1" fmla="*/ 7324 h 6984967"/>
-              <a:gd name="csX2" fmla="*/ 4708451 w 5069050"/>
-              <a:gd name="csY2" fmla="*/ 921723 h 6984967"/>
-              <a:gd name="csX3" fmla="*/ 5017154 w 5069050"/>
-              <a:gd name="csY3" fmla="*/ 3503559 h 6984967"/>
-              <a:gd name="csX4" fmla="*/ 4591908 w 5069050"/>
-              <a:gd name="csY4" fmla="*/ 6004711 h 6984967"/>
-              <a:gd name="csX5" fmla="*/ 745011 w 5069050"/>
-              <a:gd name="csY5" fmla="*/ 6874287 h 6984967"/>
-              <a:gd name="csX6" fmla="*/ 530892 w 5069050"/>
-              <a:gd name="csY6" fmla="*/ 3727676 h 6984967"/>
-              <a:gd name="csX7" fmla="*/ 67720 w 5069050"/>
-              <a:gd name="csY7" fmla="*/ 688641 h 6984967"/>
-              <a:gd name="csX0" fmla="*/ 67720 w 5049680"/>
-              <a:gd name="csY0" fmla="*/ 688641 h 6984967"/>
-              <a:gd name="csX1" fmla="*/ 2098681 w 5049680"/>
-              <a:gd name="csY1" fmla="*/ 7324 h 6984967"/>
-              <a:gd name="csX2" fmla="*/ 4708451 w 5049680"/>
-              <a:gd name="csY2" fmla="*/ 921723 h 6984967"/>
-              <a:gd name="csX3" fmla="*/ 5017154 w 5049680"/>
-              <a:gd name="csY3" fmla="*/ 3503559 h 6984967"/>
-              <a:gd name="csX4" fmla="*/ 4591908 w 5049680"/>
-              <a:gd name="csY4" fmla="*/ 6004711 h 6984967"/>
-              <a:gd name="csX5" fmla="*/ 745011 w 5049680"/>
-              <a:gd name="csY5" fmla="*/ 6874287 h 6984967"/>
-              <a:gd name="csX6" fmla="*/ 530892 w 5049680"/>
-              <a:gd name="csY6" fmla="*/ 3727676 h 6984967"/>
-              <a:gd name="csX7" fmla="*/ 67720 w 5049680"/>
-              <a:gd name="csY7" fmla="*/ 688641 h 6984967"/>
-              <a:gd name="csX0" fmla="*/ 67720 w 5053733"/>
-              <a:gd name="csY0" fmla="*/ 688641 h 6984967"/>
-              <a:gd name="csX1" fmla="*/ 2098681 w 5053733"/>
-              <a:gd name="csY1" fmla="*/ 7324 h 6984967"/>
-              <a:gd name="csX2" fmla="*/ 4708451 w 5053733"/>
-              <a:gd name="csY2" fmla="*/ 921723 h 6984967"/>
-              <a:gd name="csX3" fmla="*/ 4591908 w 5053733"/>
-              <a:gd name="csY3" fmla="*/ 6004711 h 6984967"/>
-              <a:gd name="csX4" fmla="*/ 745011 w 5053733"/>
-              <a:gd name="csY4" fmla="*/ 6874287 h 6984967"/>
-              <a:gd name="csX5" fmla="*/ 530892 w 5053733"/>
-              <a:gd name="csY5" fmla="*/ 3727676 h 6984967"/>
-              <a:gd name="csX6" fmla="*/ 67720 w 5053733"/>
-              <a:gd name="csY6" fmla="*/ 688641 h 6984967"/>
-              <a:gd name="csX0" fmla="*/ 58817 w 5161371"/>
-              <a:gd name="csY0" fmla="*/ 610325 h 6996298"/>
-              <a:gd name="csX1" fmla="*/ 2206319 w 5161371"/>
-              <a:gd name="csY1" fmla="*/ 18655 h 6996298"/>
-              <a:gd name="csX2" fmla="*/ 4816089 w 5161371"/>
-              <a:gd name="csY2" fmla="*/ 933054 h 6996298"/>
-              <a:gd name="csX3" fmla="*/ 4699546 w 5161371"/>
-              <a:gd name="csY3" fmla="*/ 6016042 h 6996298"/>
-              <a:gd name="csX4" fmla="*/ 852649 w 5161371"/>
-              <a:gd name="csY4" fmla="*/ 6885618 h 6996298"/>
-              <a:gd name="csX5" fmla="*/ 638530 w 5161371"/>
-              <a:gd name="csY5" fmla="*/ 3739007 h 6996298"/>
-              <a:gd name="csX6" fmla="*/ 58817 w 5161371"/>
-              <a:gd name="csY6" fmla="*/ 610325 h 6996298"/>
-              <a:gd name="csX0" fmla="*/ 55441 w 5211781"/>
-              <a:gd name="csY0" fmla="*/ 713475 h 6982907"/>
-              <a:gd name="csX1" fmla="*/ 2256729 w 5211781"/>
-              <a:gd name="csY1" fmla="*/ 5264 h 6982907"/>
-              <a:gd name="csX2" fmla="*/ 4866499 w 5211781"/>
-              <a:gd name="csY2" fmla="*/ 919663 h 6982907"/>
-              <a:gd name="csX3" fmla="*/ 4749956 w 5211781"/>
-              <a:gd name="csY3" fmla="*/ 6002651 h 6982907"/>
-              <a:gd name="csX4" fmla="*/ 903059 w 5211781"/>
-              <a:gd name="csY4" fmla="*/ 6872227 h 6982907"/>
-              <a:gd name="csX5" fmla="*/ 688940 w 5211781"/>
-              <a:gd name="csY5" fmla="*/ 3725616 h 6982907"/>
-              <a:gd name="csX6" fmla="*/ 55441 w 5211781"/>
-              <a:gd name="csY6" fmla="*/ 713475 h 6982907"/>
-              <a:gd name="csX0" fmla="*/ 45279 w 5201619"/>
-              <a:gd name="csY0" fmla="*/ 713475 h 6982907"/>
-              <a:gd name="csX1" fmla="*/ 2246567 w 5201619"/>
-              <a:gd name="csY1" fmla="*/ 5264 h 6982907"/>
-              <a:gd name="csX2" fmla="*/ 4856337 w 5201619"/>
-              <a:gd name="csY2" fmla="*/ 919663 h 6982907"/>
-              <a:gd name="csX3" fmla="*/ 4739794 w 5201619"/>
-              <a:gd name="csY3" fmla="*/ 6002651 h 6982907"/>
-              <a:gd name="csX4" fmla="*/ 892897 w 5201619"/>
-              <a:gd name="csY4" fmla="*/ 6872227 h 6982907"/>
-              <a:gd name="csX5" fmla="*/ 777390 w 5201619"/>
-              <a:gd name="csY5" fmla="*/ 3725616 h 6982907"/>
-              <a:gd name="csX6" fmla="*/ 45279 w 5201619"/>
-              <a:gd name="csY6" fmla="*/ 713475 h 6982907"/>
-              <a:gd name="csX0" fmla="*/ 45279 w 5201619"/>
-              <a:gd name="csY0" fmla="*/ 713475 h 6998952"/>
-              <a:gd name="csX1" fmla="*/ 2246567 w 5201619"/>
-              <a:gd name="csY1" fmla="*/ 5264 h 6998952"/>
-              <a:gd name="csX2" fmla="*/ 4856337 w 5201619"/>
-              <a:gd name="csY2" fmla="*/ 919663 h 6998952"/>
-              <a:gd name="csX3" fmla="*/ 4739794 w 5201619"/>
-              <a:gd name="csY3" fmla="*/ 6002651 h 6998952"/>
-              <a:gd name="csX4" fmla="*/ 883932 w 5201619"/>
-              <a:gd name="csY4" fmla="*/ 6890156 h 6998952"/>
-              <a:gd name="csX5" fmla="*/ 777390 w 5201619"/>
-              <a:gd name="csY5" fmla="*/ 3725616 h 6998952"/>
-              <a:gd name="csX6" fmla="*/ 45279 w 5201619"/>
-              <a:gd name="csY6" fmla="*/ 713475 h 6998952"/>
-              <a:gd name="csX0" fmla="*/ 45279 w 5143878"/>
-              <a:gd name="csY0" fmla="*/ 713475 h 6982323"/>
-              <a:gd name="csX1" fmla="*/ 2246567 w 5143878"/>
-              <a:gd name="csY1" fmla="*/ 5264 h 6982323"/>
-              <a:gd name="csX2" fmla="*/ 4856337 w 5143878"/>
-              <a:gd name="csY2" fmla="*/ 919663 h 6982323"/>
-              <a:gd name="csX3" fmla="*/ 4614291 w 5143878"/>
-              <a:gd name="csY3" fmla="*/ 5895075 h 6982323"/>
-              <a:gd name="csX4" fmla="*/ 883932 w 5143878"/>
-              <a:gd name="csY4" fmla="*/ 6890156 h 6982323"/>
-              <a:gd name="csX5" fmla="*/ 777390 w 5143878"/>
-              <a:gd name="csY5" fmla="*/ 3725616 h 6982323"/>
-              <a:gd name="csX6" fmla="*/ 45279 w 5143878"/>
-              <a:gd name="csY6" fmla="*/ 713475 h 6982323"/>
-              <a:gd name="csX0" fmla="*/ 45279 w 5089704"/>
-              <a:gd name="csY0" fmla="*/ 765801 h 7034649"/>
-              <a:gd name="csX1" fmla="*/ 2246567 w 5089704"/>
-              <a:gd name="csY1" fmla="*/ 57590 h 7034649"/>
-              <a:gd name="csX2" fmla="*/ 4757728 w 5089704"/>
-              <a:gd name="csY2" fmla="*/ 720977 h 7034649"/>
-              <a:gd name="csX3" fmla="*/ 4614291 w 5089704"/>
-              <a:gd name="csY3" fmla="*/ 5947401 h 7034649"/>
-              <a:gd name="csX4" fmla="*/ 883932 w 5089704"/>
-              <a:gd name="csY4" fmla="*/ 6942482 h 7034649"/>
-              <a:gd name="csX5" fmla="*/ 777390 w 5089704"/>
-              <a:gd name="csY5" fmla="*/ 3777942 h 7034649"/>
-              <a:gd name="csX6" fmla="*/ 45279 w 5089704"/>
-              <a:gd name="csY6" fmla="*/ 765801 h 7034649"/>
-              <a:gd name="csX0" fmla="*/ 45279 w 4971054"/>
-              <a:gd name="csY0" fmla="*/ 765801 h 7020453"/>
-              <a:gd name="csX1" fmla="*/ 2246567 w 4971054"/>
-              <a:gd name="csY1" fmla="*/ 57590 h 7020453"/>
-              <a:gd name="csX2" fmla="*/ 4757728 w 4971054"/>
-              <a:gd name="csY2" fmla="*/ 720977 h 7020453"/>
-              <a:gd name="csX3" fmla="*/ 4300529 w 4971054"/>
-              <a:gd name="csY3" fmla="*/ 5839825 h 7020453"/>
-              <a:gd name="csX4" fmla="*/ 883932 w 4971054"/>
-              <a:gd name="csY4" fmla="*/ 6942482 h 7020453"/>
-              <a:gd name="csX5" fmla="*/ 777390 w 4971054"/>
-              <a:gd name="csY5" fmla="*/ 3777942 h 7020453"/>
-              <a:gd name="csX6" fmla="*/ 45279 w 4971054"/>
-              <a:gd name="csY6" fmla="*/ 765801 h 7020453"/>
-              <a:gd name="csX0" fmla="*/ 45279 w 4971054"/>
-              <a:gd name="csY0" fmla="*/ 765801 h 7044407"/>
-              <a:gd name="csX1" fmla="*/ 2246567 w 4971054"/>
-              <a:gd name="csY1" fmla="*/ 57590 h 7044407"/>
-              <a:gd name="csX2" fmla="*/ 4757728 w 4971054"/>
-              <a:gd name="csY2" fmla="*/ 720977 h 7044407"/>
-              <a:gd name="csX3" fmla="*/ 4300529 w 4971054"/>
-              <a:gd name="csY3" fmla="*/ 5839825 h 7044407"/>
-              <a:gd name="csX4" fmla="*/ 883932 w 4971054"/>
-              <a:gd name="csY4" fmla="*/ 6942482 h 7044407"/>
-              <a:gd name="csX5" fmla="*/ 777390 w 4971054"/>
-              <a:gd name="csY5" fmla="*/ 3777942 h 7044407"/>
-              <a:gd name="csX6" fmla="*/ 45279 w 4971054"/>
-              <a:gd name="csY6" fmla="*/ 765801 h 7044407"/>
-              <a:gd name="csX0" fmla="*/ 45279 w 5076557"/>
-              <a:gd name="csY0" fmla="*/ 765801 h 7044407"/>
-              <a:gd name="csX1" fmla="*/ 2246567 w 5076557"/>
-              <a:gd name="csY1" fmla="*/ 57590 h 7044407"/>
-              <a:gd name="csX2" fmla="*/ 4757728 w 5076557"/>
-              <a:gd name="csY2" fmla="*/ 720977 h 7044407"/>
-              <a:gd name="csX3" fmla="*/ 4300529 w 5076557"/>
-              <a:gd name="csY3" fmla="*/ 5839825 h 7044407"/>
-              <a:gd name="csX4" fmla="*/ 883932 w 5076557"/>
-              <a:gd name="csY4" fmla="*/ 6942482 h 7044407"/>
-              <a:gd name="csX5" fmla="*/ 777390 w 5076557"/>
-              <a:gd name="csY5" fmla="*/ 3777942 h 7044407"/>
-              <a:gd name="csX6" fmla="*/ 45279 w 5076557"/>
-              <a:gd name="csY6" fmla="*/ 765801 h 7044407"/>
-              <a:gd name="csX0" fmla="*/ 45279 w 5298120"/>
-              <a:gd name="csY0" fmla="*/ 758918 h 7037524"/>
-              <a:gd name="csX1" fmla="*/ 2246567 w 5298120"/>
-              <a:gd name="csY1" fmla="*/ 50707 h 7037524"/>
-              <a:gd name="csX2" fmla="*/ 5089422 w 5298120"/>
-              <a:gd name="csY2" fmla="*/ 1771929 h 7037524"/>
-              <a:gd name="csX3" fmla="*/ 4300529 w 5298120"/>
-              <a:gd name="csY3" fmla="*/ 5832942 h 7037524"/>
-              <a:gd name="csX4" fmla="*/ 883932 w 5298120"/>
-              <a:gd name="csY4" fmla="*/ 6935599 h 7037524"/>
-              <a:gd name="csX5" fmla="*/ 777390 w 5298120"/>
-              <a:gd name="csY5" fmla="*/ 3771059 h 7037524"/>
-              <a:gd name="csX6" fmla="*/ 45279 w 5298120"/>
-              <a:gd name="csY6" fmla="*/ 758918 h 7037524"/>
-              <a:gd name="csX0" fmla="*/ 45279 w 5170673"/>
-              <a:gd name="csY0" fmla="*/ 758918 h 7037524"/>
-              <a:gd name="csX1" fmla="*/ 2246567 w 5170673"/>
-              <a:gd name="csY1" fmla="*/ 50707 h 7037524"/>
-              <a:gd name="csX2" fmla="*/ 5089422 w 5170673"/>
-              <a:gd name="csY2" fmla="*/ 1771929 h 7037524"/>
-              <a:gd name="csX3" fmla="*/ 4300529 w 5170673"/>
-              <a:gd name="csY3" fmla="*/ 5832942 h 7037524"/>
-              <a:gd name="csX4" fmla="*/ 883932 w 5170673"/>
-              <a:gd name="csY4" fmla="*/ 6935599 h 7037524"/>
-              <a:gd name="csX5" fmla="*/ 777390 w 5170673"/>
-              <a:gd name="csY5" fmla="*/ 3771059 h 7037524"/>
-              <a:gd name="csX6" fmla="*/ 45279 w 5170673"/>
-              <a:gd name="csY6" fmla="*/ 758918 h 7037524"/>
-              <a:gd name="csX0" fmla="*/ 99784 w 5225178"/>
-              <a:gd name="csY0" fmla="*/ 556845 h 6835451"/>
-              <a:gd name="csX1" fmla="*/ 3305119 w 5225178"/>
-              <a:gd name="csY1" fmla="*/ 81717 h 6835451"/>
-              <a:gd name="csX2" fmla="*/ 5143927 w 5225178"/>
-              <a:gd name="csY2" fmla="*/ 1569856 h 6835451"/>
-              <a:gd name="csX3" fmla="*/ 4355034 w 5225178"/>
-              <a:gd name="csY3" fmla="*/ 5630869 h 6835451"/>
-              <a:gd name="csX4" fmla="*/ 938437 w 5225178"/>
-              <a:gd name="csY4" fmla="*/ 6733526 h 6835451"/>
-              <a:gd name="csX5" fmla="*/ 831895 w 5225178"/>
-              <a:gd name="csY5" fmla="*/ 3568986 h 6835451"/>
-              <a:gd name="csX6" fmla="*/ 99784 w 5225178"/>
-              <a:gd name="csY6" fmla="*/ 556845 h 6835451"/>
-              <a:gd name="csX0" fmla="*/ 99784 w 5216847"/>
-              <a:gd name="csY0" fmla="*/ 556845 h 6874906"/>
-              <a:gd name="csX1" fmla="*/ 3305119 w 5216847"/>
-              <a:gd name="csY1" fmla="*/ 81717 h 6874906"/>
-              <a:gd name="csX2" fmla="*/ 5143927 w 5216847"/>
-              <a:gd name="csY2" fmla="*/ 1569856 h 6874906"/>
-              <a:gd name="csX3" fmla="*/ 4319178 w 5216847"/>
-              <a:gd name="csY3" fmla="*/ 5828093 h 6874906"/>
-              <a:gd name="csX4" fmla="*/ 938437 w 5216847"/>
-              <a:gd name="csY4" fmla="*/ 6733526 h 6874906"/>
-              <a:gd name="csX5" fmla="*/ 831895 w 5216847"/>
-              <a:gd name="csY5" fmla="*/ 3568986 h 6874906"/>
-              <a:gd name="csX6" fmla="*/ 99784 w 5216847"/>
-              <a:gd name="csY6" fmla="*/ 556845 h 6874906"/>
-              <a:gd name="csX0" fmla="*/ 99784 w 5216847"/>
-              <a:gd name="csY0" fmla="*/ 556845 h 6709641"/>
-              <a:gd name="csX1" fmla="*/ 3305119 w 5216847"/>
-              <a:gd name="csY1" fmla="*/ 81717 h 6709641"/>
-              <a:gd name="csX2" fmla="*/ 5143927 w 5216847"/>
-              <a:gd name="csY2" fmla="*/ 1569856 h 6709641"/>
-              <a:gd name="csX3" fmla="*/ 4319178 w 5216847"/>
-              <a:gd name="csY3" fmla="*/ 5828093 h 6709641"/>
-              <a:gd name="csX4" fmla="*/ 1028084 w 5216847"/>
-              <a:gd name="csY4" fmla="*/ 6527337 h 6709641"/>
-              <a:gd name="csX5" fmla="*/ 831895 w 5216847"/>
-              <a:gd name="csY5" fmla="*/ 3568986 h 6709641"/>
-              <a:gd name="csX6" fmla="*/ 99784 w 5216847"/>
-              <a:gd name="csY6" fmla="*/ 556845 h 6709641"/>
-              <a:gd name="csX0" fmla="*/ 99784 w 5216847"/>
-              <a:gd name="csY0" fmla="*/ 556845 h 6777303"/>
-              <a:gd name="csX1" fmla="*/ 3305119 w 5216847"/>
-              <a:gd name="csY1" fmla="*/ 81717 h 6777303"/>
-              <a:gd name="csX2" fmla="*/ 5143927 w 5216847"/>
-              <a:gd name="csY2" fmla="*/ 1569856 h 6777303"/>
-              <a:gd name="csX3" fmla="*/ 4319178 w 5216847"/>
-              <a:gd name="csY3" fmla="*/ 5828093 h 6777303"/>
-              <a:gd name="csX4" fmla="*/ 1028084 w 5216847"/>
-              <a:gd name="csY4" fmla="*/ 6527337 h 6777303"/>
-              <a:gd name="csX5" fmla="*/ 831895 w 5216847"/>
-              <a:gd name="csY5" fmla="*/ 3568986 h 6777303"/>
-              <a:gd name="csX6" fmla="*/ 99784 w 5216847"/>
-              <a:gd name="csY6" fmla="*/ 556845 h 6777303"/>
-              <a:gd name="csX0" fmla="*/ 99784 w 5244782"/>
-              <a:gd name="csY0" fmla="*/ 556845 h 6706837"/>
-              <a:gd name="csX1" fmla="*/ 3305119 w 5244782"/>
-              <a:gd name="csY1" fmla="*/ 81717 h 6706837"/>
-              <a:gd name="csX2" fmla="*/ 5143927 w 5244782"/>
-              <a:gd name="csY2" fmla="*/ 1569856 h 6706837"/>
-              <a:gd name="csX3" fmla="*/ 4426754 w 5244782"/>
-              <a:gd name="csY3" fmla="*/ 5819128 h 6706837"/>
-              <a:gd name="csX4" fmla="*/ 1028084 w 5244782"/>
-              <a:gd name="csY4" fmla="*/ 6527337 h 6706837"/>
-              <a:gd name="csX5" fmla="*/ 831895 w 5244782"/>
-              <a:gd name="csY5" fmla="*/ 3568986 h 6706837"/>
-              <a:gd name="csX6" fmla="*/ 99784 w 5244782"/>
-              <a:gd name="csY6" fmla="*/ 556845 h 6706837"/>
-              <a:gd name="csX0" fmla="*/ 116725 w 5073461"/>
-              <a:gd name="csY0" fmla="*/ 405540 h 6815508"/>
-              <a:gd name="csX1" fmla="*/ 3133798 w 5073461"/>
-              <a:gd name="csY1" fmla="*/ 190388 h 6815508"/>
-              <a:gd name="csX2" fmla="*/ 4972606 w 5073461"/>
-              <a:gd name="csY2" fmla="*/ 1678527 h 6815508"/>
-              <a:gd name="csX3" fmla="*/ 4255433 w 5073461"/>
-              <a:gd name="csY3" fmla="*/ 5927799 h 6815508"/>
-              <a:gd name="csX4" fmla="*/ 856763 w 5073461"/>
-              <a:gd name="csY4" fmla="*/ 6636008 h 6815508"/>
-              <a:gd name="csX5" fmla="*/ 660574 w 5073461"/>
-              <a:gd name="csY5" fmla="*/ 3677657 h 6815508"/>
-              <a:gd name="csX6" fmla="*/ 116725 w 5073461"/>
-              <a:gd name="csY6" fmla="*/ 405540 h 6815508"/>
-              <a:gd name="csX0" fmla="*/ 153544 w 5110280"/>
-              <a:gd name="csY0" fmla="*/ 404467 h 6815760"/>
-              <a:gd name="csX1" fmla="*/ 3170617 w 5110280"/>
-              <a:gd name="csY1" fmla="*/ 189315 h 6815760"/>
-              <a:gd name="csX2" fmla="*/ 5009425 w 5110280"/>
-              <a:gd name="csY2" fmla="*/ 1677454 h 6815760"/>
-              <a:gd name="csX3" fmla="*/ 4292252 w 5110280"/>
-              <a:gd name="csY3" fmla="*/ 5926726 h 6815760"/>
-              <a:gd name="csX4" fmla="*/ 893582 w 5110280"/>
-              <a:gd name="csY4" fmla="*/ 6634935 h 6815760"/>
-              <a:gd name="csX5" fmla="*/ 509134 w 5110280"/>
-              <a:gd name="csY5" fmla="*/ 3658654 h 6815760"/>
-              <a:gd name="csX6" fmla="*/ 153544 w 5110280"/>
-              <a:gd name="csY6" fmla="*/ 404467 h 6815760"/>
-              <a:gd name="csX0" fmla="*/ 109977 w 5454962"/>
-              <a:gd name="csY0" fmla="*/ 583573 h 6696995"/>
-              <a:gd name="csX1" fmla="*/ 3515299 w 5454962"/>
-              <a:gd name="csY1" fmla="*/ 70550 h 6696995"/>
-              <a:gd name="csX2" fmla="*/ 5354107 w 5454962"/>
-              <a:gd name="csY2" fmla="*/ 1558689 h 6696995"/>
-              <a:gd name="csX3" fmla="*/ 4636934 w 5454962"/>
-              <a:gd name="csY3" fmla="*/ 5807961 h 6696995"/>
-              <a:gd name="csX4" fmla="*/ 1238264 w 5454962"/>
-              <a:gd name="csY4" fmla="*/ 6516170 h 6696995"/>
-              <a:gd name="csX5" fmla="*/ 853816 w 5454962"/>
-              <a:gd name="csY5" fmla="*/ 3539889 h 6696995"/>
-              <a:gd name="csX6" fmla="*/ 109977 w 5454962"/>
-              <a:gd name="csY6" fmla="*/ 583573 h 6696995"/>
-              <a:gd name="csX0" fmla="*/ 116776 w 5461761"/>
-              <a:gd name="csY0" fmla="*/ 663718 h 6777140"/>
-              <a:gd name="csX1" fmla="*/ 3522098 w 5461761"/>
-              <a:gd name="csY1" fmla="*/ 150695 h 6777140"/>
-              <a:gd name="csX2" fmla="*/ 5360906 w 5461761"/>
-              <a:gd name="csY2" fmla="*/ 1638834 h 6777140"/>
-              <a:gd name="csX3" fmla="*/ 4643733 w 5461761"/>
-              <a:gd name="csY3" fmla="*/ 5888106 h 6777140"/>
-              <a:gd name="csX4" fmla="*/ 1245063 w 5461761"/>
-              <a:gd name="csY4" fmla="*/ 6596315 h 6777140"/>
-              <a:gd name="csX5" fmla="*/ 860615 w 5461761"/>
-              <a:gd name="csY5" fmla="*/ 3620034 h 6777140"/>
-              <a:gd name="csX6" fmla="*/ 116776 w 5461761"/>
-              <a:gd name="csY6" fmla="*/ 663718 h 6777140"/>
-              <a:gd name="csX0" fmla="*/ 116776 w 5461761"/>
-              <a:gd name="csY0" fmla="*/ 663718 h 6891737"/>
-              <a:gd name="csX1" fmla="*/ 3522098 w 5461761"/>
-              <a:gd name="csY1" fmla="*/ 150695 h 6891737"/>
-              <a:gd name="csX2" fmla="*/ 5360906 w 5461761"/>
-              <a:gd name="csY2" fmla="*/ 1638834 h 6891737"/>
-              <a:gd name="csX3" fmla="*/ 4643733 w 5461761"/>
-              <a:gd name="csY3" fmla="*/ 5888106 h 6891737"/>
-              <a:gd name="csX4" fmla="*/ 1112490 w 5461761"/>
-              <a:gd name="csY4" fmla="*/ 6740738 h 6891737"/>
-              <a:gd name="csX5" fmla="*/ 860615 w 5461761"/>
-              <a:gd name="csY5" fmla="*/ 3620034 h 6891737"/>
-              <a:gd name="csX6" fmla="*/ 116776 w 5461761"/>
-              <a:gd name="csY6" fmla="*/ 663718 h 6891737"/>
-              <a:gd name="csX0" fmla="*/ 116776 w 5461761"/>
-              <a:gd name="csY0" fmla="*/ 663718 h 6985955"/>
-              <a:gd name="csX1" fmla="*/ 3522098 w 5461761"/>
-              <a:gd name="csY1" fmla="*/ 150695 h 6985955"/>
-              <a:gd name="csX2" fmla="*/ 5360906 w 5461761"/>
-              <a:gd name="csY2" fmla="*/ 1638834 h 6985955"/>
-              <a:gd name="csX3" fmla="*/ 4643733 w 5461761"/>
-              <a:gd name="csY3" fmla="*/ 5888106 h 6985955"/>
-              <a:gd name="csX4" fmla="*/ 1112490 w 5461761"/>
-              <a:gd name="csY4" fmla="*/ 6740738 h 6985955"/>
-              <a:gd name="csX5" fmla="*/ 860615 w 5461761"/>
-              <a:gd name="csY5" fmla="*/ 3620034 h 6985955"/>
-              <a:gd name="csX6" fmla="*/ 116776 w 5461761"/>
-              <a:gd name="csY6" fmla="*/ 663718 h 6985955"/>
-              <a:gd name="csX0" fmla="*/ 116776 w 5593010"/>
-              <a:gd name="csY0" fmla="*/ 663718 h 6878706"/>
-              <a:gd name="csX1" fmla="*/ 3522098 w 5593010"/>
-              <a:gd name="csY1" fmla="*/ 150695 h 6878706"/>
-              <a:gd name="csX2" fmla="*/ 5360906 w 5593010"/>
-              <a:gd name="csY2" fmla="*/ 1638834 h 6878706"/>
-              <a:gd name="csX3" fmla="*/ 4956229 w 5593010"/>
-              <a:gd name="csY3" fmla="*/ 5833948 h 6878706"/>
-              <a:gd name="csX4" fmla="*/ 1112490 w 5593010"/>
-              <a:gd name="csY4" fmla="*/ 6740738 h 6878706"/>
-              <a:gd name="csX5" fmla="*/ 860615 w 5593010"/>
-              <a:gd name="csY5" fmla="*/ 3620034 h 6878706"/>
-              <a:gd name="csX6" fmla="*/ 116776 w 5593010"/>
-              <a:gd name="csY6" fmla="*/ 663718 h 6878706"/>
-              <a:gd name="csX0" fmla="*/ 116776 w 5593010"/>
-              <a:gd name="csY0" fmla="*/ 663718 h 6884037"/>
-              <a:gd name="csX1" fmla="*/ 3522098 w 5593010"/>
-              <a:gd name="csY1" fmla="*/ 150695 h 6884037"/>
-              <a:gd name="csX2" fmla="*/ 5360906 w 5593010"/>
-              <a:gd name="csY2" fmla="*/ 1638834 h 6884037"/>
-              <a:gd name="csX3" fmla="*/ 4956229 w 5593010"/>
-              <a:gd name="csY3" fmla="*/ 5833948 h 6884037"/>
-              <a:gd name="csX4" fmla="*/ 1112490 w 5593010"/>
-              <a:gd name="csY4" fmla="*/ 6740738 h 6884037"/>
-              <a:gd name="csX5" fmla="*/ 860615 w 5593010"/>
-              <a:gd name="csY5" fmla="*/ 3620034 h 6884037"/>
-              <a:gd name="csX6" fmla="*/ 116776 w 5593010"/>
-              <a:gd name="csY6" fmla="*/ 663718 h 6884037"/>
-              <a:gd name="csX0" fmla="*/ 116776 w 5430174"/>
-              <a:gd name="csY0" fmla="*/ 663718 h 6884037"/>
-              <a:gd name="csX1" fmla="*/ 3522098 w 5430174"/>
-              <a:gd name="csY1" fmla="*/ 150695 h 6884037"/>
-              <a:gd name="csX2" fmla="*/ 5360906 w 5430174"/>
-              <a:gd name="csY2" fmla="*/ 1638834 h 6884037"/>
-              <a:gd name="csX3" fmla="*/ 4956229 w 5430174"/>
-              <a:gd name="csY3" fmla="*/ 5833948 h 6884037"/>
-              <a:gd name="csX4" fmla="*/ 1112490 w 5430174"/>
-              <a:gd name="csY4" fmla="*/ 6740738 h 6884037"/>
-              <a:gd name="csX5" fmla="*/ 860615 w 5430174"/>
-              <a:gd name="csY5" fmla="*/ 3620034 h 6884037"/>
-              <a:gd name="csX6" fmla="*/ 116776 w 5430174"/>
-              <a:gd name="csY6" fmla="*/ 663718 h 6884037"/>
-              <a:gd name="csX0" fmla="*/ 116776 w 5596248"/>
-              <a:gd name="csY0" fmla="*/ 663718 h 6849503"/>
-              <a:gd name="csX1" fmla="*/ 3522098 w 5596248"/>
-              <a:gd name="csY1" fmla="*/ 150695 h 6849503"/>
-              <a:gd name="csX2" fmla="*/ 5360906 w 5596248"/>
-              <a:gd name="csY2" fmla="*/ 1638834 h 6849503"/>
-              <a:gd name="csX3" fmla="*/ 5316072 w 5596248"/>
-              <a:gd name="csY3" fmla="*/ 5671473 h 6849503"/>
-              <a:gd name="csX4" fmla="*/ 1112490 w 5596248"/>
-              <a:gd name="csY4" fmla="*/ 6740738 h 6849503"/>
-              <a:gd name="csX5" fmla="*/ 860615 w 5596248"/>
-              <a:gd name="csY5" fmla="*/ 3620034 h 6849503"/>
-              <a:gd name="csX6" fmla="*/ 116776 w 5596248"/>
-              <a:gd name="csY6" fmla="*/ 663718 h 6849503"/>
-              <a:gd name="csX0" fmla="*/ 116776 w 5596248"/>
-              <a:gd name="csY0" fmla="*/ 663718 h 6902241"/>
-              <a:gd name="csX1" fmla="*/ 3522098 w 5596248"/>
-              <a:gd name="csY1" fmla="*/ 150695 h 6902241"/>
-              <a:gd name="csX2" fmla="*/ 5360906 w 5596248"/>
-              <a:gd name="csY2" fmla="*/ 1638834 h 6902241"/>
-              <a:gd name="csX3" fmla="*/ 5316072 w 5596248"/>
-              <a:gd name="csY3" fmla="*/ 5671473 h 6902241"/>
-              <a:gd name="csX4" fmla="*/ 1112490 w 5596248"/>
-              <a:gd name="csY4" fmla="*/ 6740738 h 6902241"/>
-              <a:gd name="csX5" fmla="*/ 860615 w 5596248"/>
-              <a:gd name="csY5" fmla="*/ 3620034 h 6902241"/>
-              <a:gd name="csX6" fmla="*/ 116776 w 5596248"/>
-              <a:gd name="csY6" fmla="*/ 663718 h 6902241"/>
-              <a:gd name="csX0" fmla="*/ 137004 w 5616476"/>
-              <a:gd name="csY0" fmla="*/ 576037 h 6814560"/>
-              <a:gd name="csX1" fmla="*/ 3987398 w 5616476"/>
-              <a:gd name="csY1" fmla="*/ 72041 h 6814560"/>
-              <a:gd name="csX2" fmla="*/ 5381134 w 5616476"/>
-              <a:gd name="csY2" fmla="*/ 1551153 h 6814560"/>
-              <a:gd name="csX3" fmla="*/ 5336300 w 5616476"/>
-              <a:gd name="csY3" fmla="*/ 5583792 h 6814560"/>
-              <a:gd name="csX4" fmla="*/ 1132718 w 5616476"/>
-              <a:gd name="csY4" fmla="*/ 6653057 h 6814560"/>
-              <a:gd name="csX5" fmla="*/ 880843 w 5616476"/>
-              <a:gd name="csY5" fmla="*/ 3532353 h 6814560"/>
-              <a:gd name="csX6" fmla="*/ 137004 w 5616476"/>
-              <a:gd name="csY6" fmla="*/ 576037 h 6814560"/>
-              <a:gd name="csX0" fmla="*/ 137004 w 5732526"/>
-              <a:gd name="csY0" fmla="*/ 557687 h 6796210"/>
-              <a:gd name="csX1" fmla="*/ 3987398 w 5732526"/>
-              <a:gd name="csY1" fmla="*/ 53691 h 6796210"/>
-              <a:gd name="csX2" fmla="*/ 5627346 w 5732526"/>
-              <a:gd name="csY2" fmla="*/ 1280063 h 6796210"/>
-              <a:gd name="csX3" fmla="*/ 5336300 w 5732526"/>
-              <a:gd name="csY3" fmla="*/ 5565442 h 6796210"/>
-              <a:gd name="csX4" fmla="*/ 1132718 w 5732526"/>
-              <a:gd name="csY4" fmla="*/ 6634707 h 6796210"/>
-              <a:gd name="csX5" fmla="*/ 880843 w 5732526"/>
-              <a:gd name="csY5" fmla="*/ 3514003 h 6796210"/>
-              <a:gd name="csX6" fmla="*/ 137004 w 5732526"/>
-              <a:gd name="csY6" fmla="*/ 557687 h 6796210"/>
-              <a:gd name="csX0" fmla="*/ 164218 w 5759740"/>
-              <a:gd name="csY0" fmla="*/ 563773 h 6787061"/>
-              <a:gd name="csX1" fmla="*/ 4014612 w 5759740"/>
-              <a:gd name="csY1" fmla="*/ 59777 h 6787061"/>
-              <a:gd name="csX2" fmla="*/ 5654560 w 5759740"/>
-              <a:gd name="csY2" fmla="*/ 1286149 h 6787061"/>
-              <a:gd name="csX3" fmla="*/ 5363514 w 5759740"/>
-              <a:gd name="csY3" fmla="*/ 5571528 h 6787061"/>
-              <a:gd name="csX4" fmla="*/ 1159932 w 5759740"/>
-              <a:gd name="csY4" fmla="*/ 6640793 h 6787061"/>
-              <a:gd name="csX5" fmla="*/ 747076 w 5759740"/>
-              <a:gd name="csY5" fmla="*/ 3727696 h 6787061"/>
-              <a:gd name="csX6" fmla="*/ 164218 w 5759740"/>
-              <a:gd name="csY6" fmla="*/ 563773 h 6787061"/>
-              <a:gd name="csX0" fmla="*/ 138471 w 5733993"/>
-              <a:gd name="csY0" fmla="*/ 563494 h 6787446"/>
-              <a:gd name="csX1" fmla="*/ 3988865 w 5733993"/>
-              <a:gd name="csY1" fmla="*/ 59498 h 6787446"/>
-              <a:gd name="csX2" fmla="*/ 5628813 w 5733993"/>
-              <a:gd name="csY2" fmla="*/ 1285870 h 6787446"/>
-              <a:gd name="csX3" fmla="*/ 5337767 w 5733993"/>
-              <a:gd name="csY3" fmla="*/ 5571249 h 6787446"/>
-              <a:gd name="csX4" fmla="*/ 1134185 w 5733993"/>
-              <a:gd name="csY4" fmla="*/ 6640514 h 6787446"/>
-              <a:gd name="csX5" fmla="*/ 872842 w 5733993"/>
-              <a:gd name="csY5" fmla="*/ 3718391 h 6787446"/>
-              <a:gd name="csX6" fmla="*/ 138471 w 5733993"/>
-              <a:gd name="csY6" fmla="*/ 563494 h 6787446"/>
-              <a:gd name="csX0" fmla="*/ 138471 w 5733993"/>
-              <a:gd name="csY0" fmla="*/ 563494 h 6852869"/>
-              <a:gd name="csX1" fmla="*/ 3988865 w 5733993"/>
-              <a:gd name="csY1" fmla="*/ 59498 h 6852869"/>
-              <a:gd name="csX2" fmla="*/ 5628813 w 5733993"/>
-              <a:gd name="csY2" fmla="*/ 1285870 h 6852869"/>
-              <a:gd name="csX3" fmla="*/ 5337767 w 5733993"/>
-              <a:gd name="csY3" fmla="*/ 5571249 h 6852869"/>
-              <a:gd name="csX4" fmla="*/ 1191003 w 5733993"/>
-              <a:gd name="csY4" fmla="*/ 6721752 h 6852869"/>
-              <a:gd name="csX5" fmla="*/ 872842 w 5733993"/>
-              <a:gd name="csY5" fmla="*/ 3718391 h 6852869"/>
-              <a:gd name="csX6" fmla="*/ 138471 w 5733993"/>
-              <a:gd name="csY6" fmla="*/ 563494 h 6852869"/>
-              <a:gd name="csX0" fmla="*/ 302492 w 5074241"/>
-              <a:gd name="csY0" fmla="*/ 373611 h 7015156"/>
-              <a:gd name="csX1" fmla="*/ 3329113 w 5074241"/>
-              <a:gd name="csY1" fmla="*/ 221785 h 7015156"/>
-              <a:gd name="csX2" fmla="*/ 4969061 w 5074241"/>
-              <a:gd name="csY2" fmla="*/ 1448157 h 7015156"/>
-              <a:gd name="csX3" fmla="*/ 4678015 w 5074241"/>
-              <a:gd name="csY3" fmla="*/ 5733536 h 7015156"/>
-              <a:gd name="csX4" fmla="*/ 531251 w 5074241"/>
-              <a:gd name="csY4" fmla="*/ 6884039 h 7015156"/>
-              <a:gd name="csX5" fmla="*/ 213090 w 5074241"/>
-              <a:gd name="csY5" fmla="*/ 3880678 h 7015156"/>
-              <a:gd name="csX6" fmla="*/ 302492 w 5074241"/>
-              <a:gd name="csY6" fmla="*/ 373611 h 7015156"/>
-              <a:gd name="csX0" fmla="*/ 195674 w 4967423"/>
-              <a:gd name="csY0" fmla="*/ 373986 h 7015128"/>
-              <a:gd name="csX1" fmla="*/ 3222295 w 4967423"/>
-              <a:gd name="csY1" fmla="*/ 222160 h 7015128"/>
-              <a:gd name="csX2" fmla="*/ 4862243 w 4967423"/>
-              <a:gd name="csY2" fmla="*/ 1448532 h 7015128"/>
-              <a:gd name="csX3" fmla="*/ 4571197 w 4967423"/>
-              <a:gd name="csY3" fmla="*/ 5733911 h 7015128"/>
-              <a:gd name="csX4" fmla="*/ 424433 w 4967423"/>
-              <a:gd name="csY4" fmla="*/ 6884414 h 7015128"/>
-              <a:gd name="csX5" fmla="*/ 390208 w 4967423"/>
-              <a:gd name="csY5" fmla="*/ 3886654 h 7015128"/>
-              <a:gd name="csX6" fmla="*/ 195674 w 4967423"/>
-              <a:gd name="csY6" fmla="*/ 373986 h 7015128"/>
-              <a:gd name="csX0" fmla="*/ 192259 w 4964008"/>
-              <a:gd name="csY0" fmla="*/ 284746 h 6925888"/>
-              <a:gd name="csX1" fmla="*/ 3172467 w 4964008"/>
-              <a:gd name="csY1" fmla="*/ 335807 h 6925888"/>
-              <a:gd name="csX2" fmla="*/ 4858828 w 4964008"/>
-              <a:gd name="csY2" fmla="*/ 1359292 h 6925888"/>
-              <a:gd name="csX3" fmla="*/ 4567782 w 4964008"/>
-              <a:gd name="csY3" fmla="*/ 5644671 h 6925888"/>
-              <a:gd name="csX4" fmla="*/ 421018 w 4964008"/>
-              <a:gd name="csY4" fmla="*/ 6795174 h 6925888"/>
-              <a:gd name="csX5" fmla="*/ 386793 w 4964008"/>
-              <a:gd name="csY5" fmla="*/ 3797414 h 6925888"/>
-              <a:gd name="csX6" fmla="*/ 192259 w 4964008"/>
-              <a:gd name="csY6" fmla="*/ 284746 h 6925888"/>
-              <a:gd name="csX0" fmla="*/ 192259 w 5064538"/>
-              <a:gd name="csY0" fmla="*/ 281800 h 6922942"/>
-              <a:gd name="csX1" fmla="*/ 3172467 w 5064538"/>
-              <a:gd name="csY1" fmla="*/ 332861 h 6922942"/>
-              <a:gd name="csX2" fmla="*/ 5002162 w 5064538"/>
-              <a:gd name="csY2" fmla="*/ 1286385 h 6922942"/>
-              <a:gd name="csX3" fmla="*/ 4567782 w 5064538"/>
-              <a:gd name="csY3" fmla="*/ 5641725 h 6922942"/>
-              <a:gd name="csX4" fmla="*/ 421018 w 5064538"/>
-              <a:gd name="csY4" fmla="*/ 6792228 h 6922942"/>
-              <a:gd name="csX5" fmla="*/ 386793 w 5064538"/>
-              <a:gd name="csY5" fmla="*/ 3794468 h 6922942"/>
-              <a:gd name="csX6" fmla="*/ 192259 w 5064538"/>
-              <a:gd name="csY6" fmla="*/ 281800 h 6922942"/>
-              <a:gd name="csX0" fmla="*/ 192259 w 5032433"/>
-              <a:gd name="csY0" fmla="*/ 281800 h 6835614"/>
-              <a:gd name="csX1" fmla="*/ 3172467 w 5032433"/>
-              <a:gd name="csY1" fmla="*/ 332861 h 6835614"/>
-              <a:gd name="csX2" fmla="*/ 5002162 w 5032433"/>
-              <a:gd name="csY2" fmla="*/ 1286385 h 6835614"/>
-              <a:gd name="csX3" fmla="*/ 4313357 w 5032433"/>
-              <a:gd name="csY3" fmla="*/ 5111522 h 6835614"/>
-              <a:gd name="csX4" fmla="*/ 421018 w 5032433"/>
-              <a:gd name="csY4" fmla="*/ 6792228 h 6835614"/>
-              <a:gd name="csX5" fmla="*/ 386793 w 5032433"/>
-              <a:gd name="csY5" fmla="*/ 3794468 h 6835614"/>
-              <a:gd name="csX6" fmla="*/ 192259 w 5032433"/>
-              <a:gd name="csY6" fmla="*/ 281800 h 6835614"/>
-              <a:gd name="csX0" fmla="*/ 192259 w 5032433"/>
-              <a:gd name="csY0" fmla="*/ 281800 h 7054382"/>
-              <a:gd name="csX1" fmla="*/ 3172467 w 5032433"/>
-              <a:gd name="csY1" fmla="*/ 332861 h 7054382"/>
-              <a:gd name="csX2" fmla="*/ 5002162 w 5032433"/>
-              <a:gd name="csY2" fmla="*/ 1286385 h 7054382"/>
-              <a:gd name="csX3" fmla="*/ 4313357 w 5032433"/>
-              <a:gd name="csY3" fmla="*/ 5111522 h 7054382"/>
-              <a:gd name="csX4" fmla="*/ 2445058 w 5032433"/>
-              <a:gd name="csY4" fmla="*/ 6710969 h 7054382"/>
-              <a:gd name="csX5" fmla="*/ 421018 w 5032433"/>
-              <a:gd name="csY5" fmla="*/ 6792228 h 7054382"/>
-              <a:gd name="csX6" fmla="*/ 386793 w 5032433"/>
-              <a:gd name="csY6" fmla="*/ 3794468 h 7054382"/>
-              <a:gd name="csX7" fmla="*/ 192259 w 5032433"/>
-              <a:gd name="csY7" fmla="*/ 281800 h 7054382"/>
-              <a:gd name="csX0" fmla="*/ 192259 w 5032433"/>
-              <a:gd name="csY0" fmla="*/ 281800 h 6956996"/>
-              <a:gd name="csX1" fmla="*/ 3172467 w 5032433"/>
-              <a:gd name="csY1" fmla="*/ 332861 h 6956996"/>
-              <a:gd name="csX2" fmla="*/ 5002162 w 5032433"/>
-              <a:gd name="csY2" fmla="*/ 1286385 h 6956996"/>
-              <a:gd name="csX3" fmla="*/ 4313357 w 5032433"/>
-              <a:gd name="csY3" fmla="*/ 5111522 h 6956996"/>
-              <a:gd name="csX4" fmla="*/ 2445058 w 5032433"/>
-              <a:gd name="csY4" fmla="*/ 6710969 h 6956996"/>
-              <a:gd name="csX5" fmla="*/ 666626 w 5032433"/>
-              <a:gd name="csY5" fmla="*/ 6627983 h 6956996"/>
-              <a:gd name="csX6" fmla="*/ 386793 w 5032433"/>
-              <a:gd name="csY6" fmla="*/ 3794468 h 6956996"/>
-              <a:gd name="csX7" fmla="*/ 192259 w 5032433"/>
-              <a:gd name="csY7" fmla="*/ 281800 h 6956996"/>
-              <a:gd name="csX0" fmla="*/ 192259 w 5032433"/>
-              <a:gd name="csY0" fmla="*/ 281800 h 6866647"/>
-              <a:gd name="csX1" fmla="*/ 3172467 w 5032433"/>
-              <a:gd name="csY1" fmla="*/ 332861 h 6866647"/>
-              <a:gd name="csX2" fmla="*/ 5002162 w 5032433"/>
-              <a:gd name="csY2" fmla="*/ 1286385 h 6866647"/>
-              <a:gd name="csX3" fmla="*/ 4313357 w 5032433"/>
-              <a:gd name="csY3" fmla="*/ 5111522 h 6866647"/>
-              <a:gd name="csX4" fmla="*/ 2445058 w 5032433"/>
-              <a:gd name="csY4" fmla="*/ 6710969 h 6866647"/>
-              <a:gd name="csX5" fmla="*/ 666626 w 5032433"/>
-              <a:gd name="csY5" fmla="*/ 6627983 h 6866647"/>
-              <a:gd name="csX6" fmla="*/ 52400 w 5032433"/>
-              <a:gd name="csY6" fmla="*/ 5380499 h 6866647"/>
-              <a:gd name="csX7" fmla="*/ 386793 w 5032433"/>
-              <a:gd name="csY7" fmla="*/ 3794468 h 6866647"/>
-              <a:gd name="csX8" fmla="*/ 192259 w 5032433"/>
-              <a:gd name="csY8" fmla="*/ 281800 h 6866647"/>
-              <a:gd name="csX0" fmla="*/ 192259 w 5032433"/>
-              <a:gd name="csY0" fmla="*/ 281800 h 6869630"/>
-              <a:gd name="csX1" fmla="*/ 3172467 w 5032433"/>
-              <a:gd name="csY1" fmla="*/ 332861 h 6869630"/>
-              <a:gd name="csX2" fmla="*/ 5002162 w 5032433"/>
-              <a:gd name="csY2" fmla="*/ 1286385 h 6869630"/>
-              <a:gd name="csX3" fmla="*/ 4313357 w 5032433"/>
-              <a:gd name="csY3" fmla="*/ 5111522 h 6869630"/>
-              <a:gd name="csX4" fmla="*/ 2445058 w 5032433"/>
-              <a:gd name="csY4" fmla="*/ 6710969 h 6869630"/>
-              <a:gd name="csX5" fmla="*/ 416291 w 5032433"/>
-              <a:gd name="csY5" fmla="*/ 6636484 h 6869630"/>
-              <a:gd name="csX6" fmla="*/ 52400 w 5032433"/>
-              <a:gd name="csY6" fmla="*/ 5380499 h 6869630"/>
-              <a:gd name="csX7" fmla="*/ 386793 w 5032433"/>
-              <a:gd name="csY7" fmla="*/ 3794468 h 6869630"/>
-              <a:gd name="csX8" fmla="*/ 192259 w 5032433"/>
-              <a:gd name="csY8" fmla="*/ 281800 h 6869630"/>
-              <a:gd name="csX0" fmla="*/ 192420 w 5032594"/>
-              <a:gd name="csY0" fmla="*/ 224784 h 6812614"/>
-              <a:gd name="csX1" fmla="*/ 3174832 w 5032594"/>
-              <a:gd name="csY1" fmla="*/ 449457 h 6812614"/>
-              <a:gd name="csX2" fmla="*/ 5002323 w 5032594"/>
-              <a:gd name="csY2" fmla="*/ 1229369 h 6812614"/>
-              <a:gd name="csX3" fmla="*/ 4313518 w 5032594"/>
-              <a:gd name="csY3" fmla="*/ 5054506 h 6812614"/>
-              <a:gd name="csX4" fmla="*/ 2445219 w 5032594"/>
-              <a:gd name="csY4" fmla="*/ 6653953 h 6812614"/>
-              <a:gd name="csX5" fmla="*/ 416452 w 5032594"/>
-              <a:gd name="csY5" fmla="*/ 6579468 h 6812614"/>
-              <a:gd name="csX6" fmla="*/ 52561 w 5032594"/>
-              <a:gd name="csY6" fmla="*/ 5323483 h 6812614"/>
-              <a:gd name="csX7" fmla="*/ 386954 w 5032594"/>
-              <a:gd name="csY7" fmla="*/ 3737452 h 6812614"/>
-              <a:gd name="csX8" fmla="*/ 192420 w 5032594"/>
-              <a:gd name="csY8" fmla="*/ 224784 h 6812614"/>
-              <a:gd name="csX0" fmla="*/ 192420 w 5122055"/>
-              <a:gd name="csY0" fmla="*/ 221538 h 6809368"/>
-              <a:gd name="csX1" fmla="*/ 3174832 w 5122055"/>
-              <a:gd name="csY1" fmla="*/ 446211 h 6809368"/>
-              <a:gd name="csX2" fmla="*/ 5097146 w 5122055"/>
-              <a:gd name="csY2" fmla="*/ 1121611 h 6809368"/>
-              <a:gd name="csX3" fmla="*/ 4313518 w 5122055"/>
-              <a:gd name="csY3" fmla="*/ 5051260 h 6809368"/>
-              <a:gd name="csX4" fmla="*/ 2445219 w 5122055"/>
-              <a:gd name="csY4" fmla="*/ 6650707 h 6809368"/>
-              <a:gd name="csX5" fmla="*/ 416452 w 5122055"/>
-              <a:gd name="csY5" fmla="*/ 6576222 h 6809368"/>
-              <a:gd name="csX6" fmla="*/ 52561 w 5122055"/>
-              <a:gd name="csY6" fmla="*/ 5320237 h 6809368"/>
-              <a:gd name="csX7" fmla="*/ 386954 w 5122055"/>
-              <a:gd name="csY7" fmla="*/ 3734206 h 6809368"/>
-              <a:gd name="csX8" fmla="*/ 192420 w 5122055"/>
-              <a:gd name="csY8" fmla="*/ 221538 h 6809368"/>
-              <a:gd name="csX0" fmla="*/ 208519 w 5138154"/>
-              <a:gd name="csY0" fmla="*/ 156038 h 6743868"/>
-              <a:gd name="csX1" fmla="*/ 3409657 w 5138154"/>
-              <a:gd name="csY1" fmla="*/ 659374 h 6743868"/>
-              <a:gd name="csX2" fmla="*/ 5113245 w 5138154"/>
-              <a:gd name="csY2" fmla="*/ 1056111 h 6743868"/>
-              <a:gd name="csX3" fmla="*/ 4329617 w 5138154"/>
-              <a:gd name="csY3" fmla="*/ 4985760 h 6743868"/>
-              <a:gd name="csX4" fmla="*/ 2461318 w 5138154"/>
-              <a:gd name="csY4" fmla="*/ 6585207 h 6743868"/>
-              <a:gd name="csX5" fmla="*/ 432551 w 5138154"/>
-              <a:gd name="csY5" fmla="*/ 6510722 h 6743868"/>
-              <a:gd name="csX6" fmla="*/ 68660 w 5138154"/>
-              <a:gd name="csY6" fmla="*/ 5254737 h 6743868"/>
-              <a:gd name="csX7" fmla="*/ 403053 w 5138154"/>
-              <a:gd name="csY7" fmla="*/ 3668706 h 6743868"/>
-              <a:gd name="csX8" fmla="*/ 208519 w 5138154"/>
-              <a:gd name="csY8" fmla="*/ 156038 h 6743868"/>
-              <a:gd name="csX0" fmla="*/ 208519 w 5323796"/>
-              <a:gd name="csY0" fmla="*/ 149464 h 6737294"/>
-              <a:gd name="csX1" fmla="*/ 3409657 w 5323796"/>
-              <a:gd name="csY1" fmla="*/ 652800 h 6737294"/>
-              <a:gd name="csX2" fmla="*/ 5305618 w 5323796"/>
-              <a:gd name="csY2" fmla="*/ 694995 h 6737294"/>
-              <a:gd name="csX3" fmla="*/ 4329617 w 5323796"/>
-              <a:gd name="csY3" fmla="*/ 4979186 h 6737294"/>
-              <a:gd name="csX4" fmla="*/ 2461318 w 5323796"/>
-              <a:gd name="csY4" fmla="*/ 6578633 h 6737294"/>
-              <a:gd name="csX5" fmla="*/ 432551 w 5323796"/>
-              <a:gd name="csY5" fmla="*/ 6504148 h 6737294"/>
-              <a:gd name="csX6" fmla="*/ 68660 w 5323796"/>
-              <a:gd name="csY6" fmla="*/ 5248163 h 6737294"/>
-              <a:gd name="csX7" fmla="*/ 403053 w 5323796"/>
-              <a:gd name="csY7" fmla="*/ 3662132 h 6737294"/>
-              <a:gd name="csX8" fmla="*/ 208519 w 5323796"/>
-              <a:gd name="csY8" fmla="*/ 149464 h 6737294"/>
-              <a:gd name="csX0" fmla="*/ 223302 w 5275890"/>
-              <a:gd name="csY0" fmla="*/ 127867 h 6970895"/>
-              <a:gd name="csX1" fmla="*/ 3361751 w 5275890"/>
-              <a:gd name="csY1" fmla="*/ 886401 h 6970895"/>
-              <a:gd name="csX2" fmla="*/ 5257712 w 5275890"/>
-              <a:gd name="csY2" fmla="*/ 928596 h 6970895"/>
-              <a:gd name="csX3" fmla="*/ 4281711 w 5275890"/>
-              <a:gd name="csY3" fmla="*/ 5212787 h 6970895"/>
-              <a:gd name="csX4" fmla="*/ 2413412 w 5275890"/>
-              <a:gd name="csY4" fmla="*/ 6812234 h 6970895"/>
-              <a:gd name="csX5" fmla="*/ 384645 w 5275890"/>
-              <a:gd name="csY5" fmla="*/ 6737749 h 6970895"/>
-              <a:gd name="csX6" fmla="*/ 20754 w 5275890"/>
-              <a:gd name="csY6" fmla="*/ 5481764 h 6970895"/>
-              <a:gd name="csX7" fmla="*/ 355147 w 5275890"/>
-              <a:gd name="csY7" fmla="*/ 3895733 h 6970895"/>
-              <a:gd name="csX8" fmla="*/ 223302 w 5275890"/>
-              <a:gd name="csY8" fmla="*/ 127867 h 6970895"/>
-              <a:gd name="csX0" fmla="*/ 208185 w 5260773"/>
-              <a:gd name="csY0" fmla="*/ 47640 h 6890668"/>
-              <a:gd name="csX1" fmla="*/ 3346634 w 5260773"/>
-              <a:gd name="csY1" fmla="*/ 806174 h 6890668"/>
-              <a:gd name="csX2" fmla="*/ 5242595 w 5260773"/>
-              <a:gd name="csY2" fmla="*/ 848369 h 6890668"/>
-              <a:gd name="csX3" fmla="*/ 4266594 w 5260773"/>
-              <a:gd name="csY3" fmla="*/ 5132560 h 6890668"/>
-              <a:gd name="csX4" fmla="*/ 2398295 w 5260773"/>
-              <a:gd name="csY4" fmla="*/ 6732007 h 6890668"/>
-              <a:gd name="csX5" fmla="*/ 369528 w 5260773"/>
-              <a:gd name="csY5" fmla="*/ 6657522 h 6890668"/>
-              <a:gd name="csX6" fmla="*/ 5637 w 5260773"/>
-              <a:gd name="csY6" fmla="*/ 5401537 h 6890668"/>
-              <a:gd name="csX7" fmla="*/ 340030 w 5260773"/>
-              <a:gd name="csY7" fmla="*/ 3815506 h 6890668"/>
-              <a:gd name="csX8" fmla="*/ 208185 w 5260773"/>
-              <a:gd name="csY8" fmla="*/ 47640 h 6890668"/>
-              <a:gd name="csX0" fmla="*/ 206125 w 5258713"/>
-              <a:gd name="csY0" fmla="*/ 53095 h 6896123"/>
-              <a:gd name="csX1" fmla="*/ 3344574 w 5258713"/>
-              <a:gd name="csY1" fmla="*/ 811629 h 6896123"/>
-              <a:gd name="csX2" fmla="*/ 5240535 w 5258713"/>
-              <a:gd name="csY2" fmla="*/ 853824 h 6896123"/>
-              <a:gd name="csX3" fmla="*/ 4264534 w 5258713"/>
-              <a:gd name="csY3" fmla="*/ 5138015 h 6896123"/>
-              <a:gd name="csX4" fmla="*/ 2396235 w 5258713"/>
-              <a:gd name="csY4" fmla="*/ 6737462 h 6896123"/>
-              <a:gd name="csX5" fmla="*/ 367468 w 5258713"/>
-              <a:gd name="csY5" fmla="*/ 6662977 h 6896123"/>
-              <a:gd name="csX6" fmla="*/ 3577 w 5258713"/>
-              <a:gd name="csY6" fmla="*/ 5406992 h 6896123"/>
-              <a:gd name="csX7" fmla="*/ 337970 w 5258713"/>
-              <a:gd name="csY7" fmla="*/ 3820961 h 6896123"/>
-              <a:gd name="csX8" fmla="*/ 206125 w 5258713"/>
-              <a:gd name="csY8" fmla="*/ 53095 h 6896123"/>
-              <a:gd name="csX0" fmla="*/ 206125 w 5258713"/>
-              <a:gd name="csY0" fmla="*/ 82499 h 6925527"/>
-              <a:gd name="csX1" fmla="*/ 3344574 w 5258713"/>
-              <a:gd name="csY1" fmla="*/ 841033 h 6925527"/>
-              <a:gd name="csX2" fmla="*/ 5240535 w 5258713"/>
-              <a:gd name="csY2" fmla="*/ 883228 h 6925527"/>
-              <a:gd name="csX3" fmla="*/ 4264534 w 5258713"/>
-              <a:gd name="csY3" fmla="*/ 5167419 h 6925527"/>
-              <a:gd name="csX4" fmla="*/ 2396235 w 5258713"/>
-              <a:gd name="csY4" fmla="*/ 6766866 h 6925527"/>
-              <a:gd name="csX5" fmla="*/ 367468 w 5258713"/>
-              <a:gd name="csY5" fmla="*/ 6692381 h 6925527"/>
-              <a:gd name="csX6" fmla="*/ 3577 w 5258713"/>
-              <a:gd name="csY6" fmla="*/ 5436396 h 6925527"/>
-              <a:gd name="csX7" fmla="*/ 337970 w 5258713"/>
-              <a:gd name="csY7" fmla="*/ 3850365 h 6925527"/>
-              <a:gd name="csX8" fmla="*/ 206125 w 5258713"/>
-              <a:gd name="csY8" fmla="*/ 82499 h 6925527"/>
-              <a:gd name="csX0" fmla="*/ 204893 w 5257481"/>
-              <a:gd name="csY0" fmla="*/ 113063 h 6956091"/>
-              <a:gd name="csX1" fmla="*/ 3343342 w 5257481"/>
-              <a:gd name="csY1" fmla="*/ 871597 h 6956091"/>
-              <a:gd name="csX2" fmla="*/ 5239303 w 5257481"/>
-              <a:gd name="csY2" fmla="*/ 913792 h 6956091"/>
-              <a:gd name="csX3" fmla="*/ 4263302 w 5257481"/>
-              <a:gd name="csY3" fmla="*/ 5197983 h 6956091"/>
-              <a:gd name="csX4" fmla="*/ 2395003 w 5257481"/>
-              <a:gd name="csY4" fmla="*/ 6797430 h 6956091"/>
-              <a:gd name="csX5" fmla="*/ 366236 w 5257481"/>
-              <a:gd name="csY5" fmla="*/ 6722945 h 6956091"/>
-              <a:gd name="csX6" fmla="*/ 2345 w 5257481"/>
-              <a:gd name="csY6" fmla="*/ 5466960 h 6956091"/>
-              <a:gd name="csX7" fmla="*/ 576258 w 5257481"/>
-              <a:gd name="csY7" fmla="*/ 3633698 h 6956091"/>
-              <a:gd name="csX8" fmla="*/ 204893 w 5257481"/>
-              <a:gd name="csY8" fmla="*/ 113063 h 6956091"/>
-              <a:gd name="csX0" fmla="*/ 324311 w 5376899"/>
-              <a:gd name="csY0" fmla="*/ 113063 h 6956359"/>
-              <a:gd name="csX1" fmla="*/ 3462760 w 5376899"/>
-              <a:gd name="csY1" fmla="*/ 871597 h 6956359"/>
-              <a:gd name="csX2" fmla="*/ 5358721 w 5376899"/>
-              <a:gd name="csY2" fmla="*/ 913792 h 6956359"/>
-              <a:gd name="csX3" fmla="*/ 4382720 w 5376899"/>
-              <a:gd name="csY3" fmla="*/ 5197983 h 6956359"/>
-              <a:gd name="csX4" fmla="*/ 2514421 w 5376899"/>
-              <a:gd name="csY4" fmla="*/ 6797430 h 6956359"/>
-              <a:gd name="csX5" fmla="*/ 183027 w 5376899"/>
-              <a:gd name="csY5" fmla="*/ 6723696 h 6956359"/>
-              <a:gd name="csX6" fmla="*/ 121763 w 5376899"/>
-              <a:gd name="csY6" fmla="*/ 5466960 h 6956359"/>
-              <a:gd name="csX7" fmla="*/ 695676 w 5376899"/>
-              <a:gd name="csY7" fmla="*/ 3633698 h 6956359"/>
-              <a:gd name="csX8" fmla="*/ 324311 w 5376899"/>
-              <a:gd name="csY8" fmla="*/ 113063 h 6956359"/>
-              <a:gd name="csX0" fmla="*/ 270878 w 5323466"/>
-              <a:gd name="csY0" fmla="*/ 113063 h 6955478"/>
-              <a:gd name="csX1" fmla="*/ 3409327 w 5323466"/>
-              <a:gd name="csY1" fmla="*/ 871597 h 6955478"/>
-              <a:gd name="csX2" fmla="*/ 5305288 w 5323466"/>
-              <a:gd name="csY2" fmla="*/ 913792 h 6955478"/>
-              <a:gd name="csX3" fmla="*/ 4329287 w 5323466"/>
-              <a:gd name="csY3" fmla="*/ 5197983 h 6955478"/>
-              <a:gd name="csX4" fmla="*/ 2460988 w 5323466"/>
-              <a:gd name="csY4" fmla="*/ 6797430 h 6955478"/>
-              <a:gd name="csX5" fmla="*/ 129594 w 5323466"/>
-              <a:gd name="csY5" fmla="*/ 6723696 h 6955478"/>
-              <a:gd name="csX6" fmla="*/ 252615 w 5323466"/>
-              <a:gd name="csY6" fmla="*/ 5485152 h 6955478"/>
-              <a:gd name="csX7" fmla="*/ 642243 w 5323466"/>
-              <a:gd name="csY7" fmla="*/ 3633698 h 6955478"/>
-              <a:gd name="csX8" fmla="*/ 270878 w 5323466"/>
-              <a:gd name="csY8" fmla="*/ 113063 h 6955478"/>
-              <a:gd name="csX0" fmla="*/ 270878 w 5323466"/>
-              <a:gd name="csY0" fmla="*/ 113063 h 6955478"/>
-              <a:gd name="csX1" fmla="*/ 3409327 w 5323466"/>
-              <a:gd name="csY1" fmla="*/ 871597 h 6955478"/>
-              <a:gd name="csX2" fmla="*/ 5305288 w 5323466"/>
-              <a:gd name="csY2" fmla="*/ 913792 h 6955478"/>
-              <a:gd name="csX3" fmla="*/ 4329287 w 5323466"/>
-              <a:gd name="csY3" fmla="*/ 5197983 h 6955478"/>
-              <a:gd name="csX4" fmla="*/ 2460988 w 5323466"/>
-              <a:gd name="csY4" fmla="*/ 6797430 h 6955478"/>
-              <a:gd name="csX5" fmla="*/ 129594 w 5323466"/>
-              <a:gd name="csY5" fmla="*/ 6723696 h 6955478"/>
-              <a:gd name="csX6" fmla="*/ 252615 w 5323466"/>
-              <a:gd name="csY6" fmla="*/ 5485152 h 6955478"/>
-              <a:gd name="csX7" fmla="*/ 642243 w 5323466"/>
-              <a:gd name="csY7" fmla="*/ 3633698 h 6955478"/>
-              <a:gd name="csX8" fmla="*/ 270878 w 5323466"/>
-              <a:gd name="csY8" fmla="*/ 113063 h 6955478"/>
-              <a:gd name="csX0" fmla="*/ 315612 w 5368200"/>
-              <a:gd name="csY0" fmla="*/ 113063 h 6955478"/>
-              <a:gd name="csX1" fmla="*/ 3454061 w 5368200"/>
-              <a:gd name="csY1" fmla="*/ 871597 h 6955478"/>
-              <a:gd name="csX2" fmla="*/ 5350022 w 5368200"/>
-              <a:gd name="csY2" fmla="*/ 913792 h 6955478"/>
-              <a:gd name="csX3" fmla="*/ 4374021 w 5368200"/>
-              <a:gd name="csY3" fmla="*/ 5197983 h 6955478"/>
-              <a:gd name="csX4" fmla="*/ 2505722 w 5368200"/>
-              <a:gd name="csY4" fmla="*/ 6797430 h 6955478"/>
-              <a:gd name="csX5" fmla="*/ 174328 w 5368200"/>
-              <a:gd name="csY5" fmla="*/ 6723696 h 6955478"/>
-              <a:gd name="csX6" fmla="*/ 297349 w 5368200"/>
-              <a:gd name="csY6" fmla="*/ 5485152 h 6955478"/>
-              <a:gd name="csX7" fmla="*/ 686977 w 5368200"/>
-              <a:gd name="csY7" fmla="*/ 3633698 h 6955478"/>
-              <a:gd name="csX8" fmla="*/ 315612 w 5368200"/>
-              <a:gd name="csY8" fmla="*/ 113063 h 6955478"/>
-              <a:gd name="csX0" fmla="*/ 301873 w 5354461"/>
-              <a:gd name="csY0" fmla="*/ 113063 h 6955478"/>
-              <a:gd name="csX1" fmla="*/ 3440322 w 5354461"/>
-              <a:gd name="csY1" fmla="*/ 871597 h 6955478"/>
-              <a:gd name="csX2" fmla="*/ 5336283 w 5354461"/>
-              <a:gd name="csY2" fmla="*/ 913792 h 6955478"/>
-              <a:gd name="csX3" fmla="*/ 4360282 w 5354461"/>
-              <a:gd name="csY3" fmla="*/ 5197983 h 6955478"/>
-              <a:gd name="csX4" fmla="*/ 2491983 w 5354461"/>
-              <a:gd name="csY4" fmla="*/ 6797430 h 6955478"/>
-              <a:gd name="csX5" fmla="*/ 160589 w 5354461"/>
-              <a:gd name="csY5" fmla="*/ 6723696 h 6955478"/>
-              <a:gd name="csX6" fmla="*/ 283610 w 5354461"/>
-              <a:gd name="csY6" fmla="*/ 5485152 h 6955478"/>
-              <a:gd name="csX7" fmla="*/ 673238 w 5354461"/>
-              <a:gd name="csY7" fmla="*/ 3633698 h 6955478"/>
-              <a:gd name="csX8" fmla="*/ 301873 w 5354461"/>
-              <a:gd name="csY8" fmla="*/ 113063 h 6955478"/>
-              <a:gd name="csX0" fmla="*/ 261384 w 5313972"/>
-              <a:gd name="csY0" fmla="*/ 113063 h 6949250"/>
-              <a:gd name="csX1" fmla="*/ 3399833 w 5313972"/>
-              <a:gd name="csY1" fmla="*/ 871597 h 6949250"/>
-              <a:gd name="csX2" fmla="*/ 5295794 w 5313972"/>
-              <a:gd name="csY2" fmla="*/ 913792 h 6949250"/>
-              <a:gd name="csX3" fmla="*/ 4319793 w 5313972"/>
-              <a:gd name="csY3" fmla="*/ 5197983 h 6949250"/>
-              <a:gd name="csX4" fmla="*/ 2451494 w 5313972"/>
-              <a:gd name="csY4" fmla="*/ 6797430 h 6949250"/>
-              <a:gd name="csX5" fmla="*/ 120100 w 5313972"/>
-              <a:gd name="csY5" fmla="*/ 6723696 h 6949250"/>
-              <a:gd name="csX6" fmla="*/ 393593 w 5313972"/>
-              <a:gd name="csY6" fmla="*/ 5616897 h 6949250"/>
-              <a:gd name="csX7" fmla="*/ 632749 w 5313972"/>
-              <a:gd name="csY7" fmla="*/ 3633698 h 6949250"/>
-              <a:gd name="csX8" fmla="*/ 261384 w 5313972"/>
-              <a:gd name="csY8" fmla="*/ 113063 h 6949250"/>
-              <a:gd name="csX0" fmla="*/ 288908 w 5341496"/>
-              <a:gd name="csY0" fmla="*/ 113063 h 6949250"/>
-              <a:gd name="csX1" fmla="*/ 3427357 w 5341496"/>
-              <a:gd name="csY1" fmla="*/ 871597 h 6949250"/>
-              <a:gd name="csX2" fmla="*/ 5323318 w 5341496"/>
-              <a:gd name="csY2" fmla="*/ 913792 h 6949250"/>
-              <a:gd name="csX3" fmla="*/ 4347317 w 5341496"/>
-              <a:gd name="csY3" fmla="*/ 5197983 h 6949250"/>
-              <a:gd name="csX4" fmla="*/ 2479018 w 5341496"/>
-              <a:gd name="csY4" fmla="*/ 6797430 h 6949250"/>
-              <a:gd name="csX5" fmla="*/ 147624 w 5341496"/>
-              <a:gd name="csY5" fmla="*/ 6723696 h 6949250"/>
-              <a:gd name="csX6" fmla="*/ 421117 w 5341496"/>
-              <a:gd name="csY6" fmla="*/ 5616897 h 6949250"/>
-              <a:gd name="csX7" fmla="*/ 660273 w 5341496"/>
-              <a:gd name="csY7" fmla="*/ 3633698 h 6949250"/>
-              <a:gd name="csX8" fmla="*/ 288908 w 5341496"/>
-              <a:gd name="csY8" fmla="*/ 113063 h 6949250"/>
-              <a:gd name="csX0" fmla="*/ 309076 w 5361664"/>
-              <a:gd name="csY0" fmla="*/ 113063 h 6954856"/>
-              <a:gd name="csX1" fmla="*/ 3447525 w 5361664"/>
-              <a:gd name="csY1" fmla="*/ 871597 h 6954856"/>
-              <a:gd name="csX2" fmla="*/ 5343486 w 5361664"/>
-              <a:gd name="csY2" fmla="*/ 913792 h 6954856"/>
-              <a:gd name="csX3" fmla="*/ 4367485 w 5361664"/>
-              <a:gd name="csY3" fmla="*/ 5197983 h 6954856"/>
-              <a:gd name="csX4" fmla="*/ 2499186 w 5361664"/>
-              <a:gd name="csY4" fmla="*/ 6797430 h 6954856"/>
-              <a:gd name="csX5" fmla="*/ 167792 w 5361664"/>
-              <a:gd name="csY5" fmla="*/ 6723696 h 6954856"/>
-              <a:gd name="csX6" fmla="*/ 377968 w 5361664"/>
-              <a:gd name="csY6" fmla="*/ 5498068 h 6954856"/>
-              <a:gd name="csX7" fmla="*/ 680441 w 5361664"/>
-              <a:gd name="csY7" fmla="*/ 3633698 h 6954856"/>
-              <a:gd name="csX8" fmla="*/ 309076 w 5361664"/>
-              <a:gd name="csY8" fmla="*/ 113063 h 6954856"/>
-              <a:gd name="csX0" fmla="*/ 319793 w 5372381"/>
-              <a:gd name="csY0" fmla="*/ 113063 h 6867048"/>
-              <a:gd name="csX1" fmla="*/ 3458242 w 5372381"/>
-              <a:gd name="csY1" fmla="*/ 871597 h 6867048"/>
-              <a:gd name="csX2" fmla="*/ 5354203 w 5372381"/>
-              <a:gd name="csY2" fmla="*/ 913792 h 6867048"/>
-              <a:gd name="csX3" fmla="*/ 4378202 w 5372381"/>
-              <a:gd name="csY3" fmla="*/ 5197983 h 6867048"/>
-              <a:gd name="csX4" fmla="*/ 2654602 w 5372381"/>
-              <a:gd name="csY4" fmla="*/ 6654710 h 6867048"/>
-              <a:gd name="csX5" fmla="*/ 178509 w 5372381"/>
-              <a:gd name="csY5" fmla="*/ 6723696 h 6867048"/>
-              <a:gd name="csX6" fmla="*/ 388685 w 5372381"/>
-              <a:gd name="csY6" fmla="*/ 5498068 h 6867048"/>
-              <a:gd name="csX7" fmla="*/ 691158 w 5372381"/>
-              <a:gd name="csY7" fmla="*/ 3633698 h 6867048"/>
-              <a:gd name="csX8" fmla="*/ 319793 w 5372381"/>
-              <a:gd name="csY8" fmla="*/ 113063 h 6867048"/>
-              <a:gd name="csX0" fmla="*/ 319793 w 5369217"/>
-              <a:gd name="csY0" fmla="*/ 113063 h 6867048"/>
-              <a:gd name="csX1" fmla="*/ 3458242 w 5369217"/>
-              <a:gd name="csY1" fmla="*/ 871597 h 6867048"/>
-              <a:gd name="csX2" fmla="*/ 5354203 w 5369217"/>
-              <a:gd name="csY2" fmla="*/ 913792 h 6867048"/>
-              <a:gd name="csX3" fmla="*/ 4230766 w 5369217"/>
-              <a:gd name="csY3" fmla="*/ 6243205 h 6867048"/>
-              <a:gd name="csX4" fmla="*/ 2654602 w 5369217"/>
-              <a:gd name="csY4" fmla="*/ 6654710 h 6867048"/>
-              <a:gd name="csX5" fmla="*/ 178509 w 5369217"/>
-              <a:gd name="csY5" fmla="*/ 6723696 h 6867048"/>
-              <a:gd name="csX6" fmla="*/ 388685 w 5369217"/>
-              <a:gd name="csY6" fmla="*/ 5498068 h 6867048"/>
-              <a:gd name="csX7" fmla="*/ 691158 w 5369217"/>
-              <a:gd name="csY7" fmla="*/ 3633698 h 6867048"/>
-              <a:gd name="csX8" fmla="*/ 319793 w 5369217"/>
-              <a:gd name="csY8" fmla="*/ 113063 h 6867048"/>
-              <a:gd name="csX0" fmla="*/ 319793 w 5363347"/>
-              <a:gd name="csY0" fmla="*/ 113063 h 6867048"/>
-              <a:gd name="csX1" fmla="*/ 3458242 w 5363347"/>
-              <a:gd name="csY1" fmla="*/ 871597 h 6867048"/>
-              <a:gd name="csX2" fmla="*/ 5354203 w 5363347"/>
-              <a:gd name="csY2" fmla="*/ 913792 h 6867048"/>
-              <a:gd name="csX3" fmla="*/ 4230766 w 5363347"/>
-              <a:gd name="csY3" fmla="*/ 6243205 h 6867048"/>
-              <a:gd name="csX4" fmla="*/ 2654602 w 5363347"/>
-              <a:gd name="csY4" fmla="*/ 6654710 h 6867048"/>
-              <a:gd name="csX5" fmla="*/ 178509 w 5363347"/>
-              <a:gd name="csY5" fmla="*/ 6723696 h 6867048"/>
-              <a:gd name="csX6" fmla="*/ 388685 w 5363347"/>
-              <a:gd name="csY6" fmla="*/ 5498068 h 6867048"/>
-              <a:gd name="csX7" fmla="*/ 691158 w 5363347"/>
-              <a:gd name="csY7" fmla="*/ 3633698 h 6867048"/>
-              <a:gd name="csX8" fmla="*/ 319793 w 5363347"/>
-              <a:gd name="csY8" fmla="*/ 113063 h 6867048"/>
-              <a:gd name="csX0" fmla="*/ 319793 w 5365508"/>
-              <a:gd name="csY0" fmla="*/ 113063 h 6867048"/>
-              <a:gd name="csX1" fmla="*/ 3458242 w 5365508"/>
-              <a:gd name="csY1" fmla="*/ 871597 h 6867048"/>
-              <a:gd name="csX2" fmla="*/ 5354203 w 5365508"/>
-              <a:gd name="csY2" fmla="*/ 913792 h 6867048"/>
-              <a:gd name="csX3" fmla="*/ 4230766 w 5365508"/>
-              <a:gd name="csY3" fmla="*/ 6243205 h 6867048"/>
-              <a:gd name="csX4" fmla="*/ 2654602 w 5365508"/>
-              <a:gd name="csY4" fmla="*/ 6654710 h 6867048"/>
-              <a:gd name="csX5" fmla="*/ 178509 w 5365508"/>
-              <a:gd name="csY5" fmla="*/ 6723696 h 6867048"/>
-              <a:gd name="csX6" fmla="*/ 388685 w 5365508"/>
-              <a:gd name="csY6" fmla="*/ 5498068 h 6867048"/>
-              <a:gd name="csX7" fmla="*/ 691158 w 5365508"/>
-              <a:gd name="csY7" fmla="*/ 3633698 h 6867048"/>
-              <a:gd name="csX8" fmla="*/ 319793 w 5365508"/>
-              <a:gd name="csY8" fmla="*/ 113063 h 6867048"/>
-              <a:gd name="csX0" fmla="*/ 319793 w 5365508"/>
-              <a:gd name="csY0" fmla="*/ 113063 h 6867048"/>
-              <a:gd name="csX1" fmla="*/ 3458242 w 5365508"/>
-              <a:gd name="csY1" fmla="*/ 871597 h 6867048"/>
-              <a:gd name="csX2" fmla="*/ 5354203 w 5365508"/>
-              <a:gd name="csY2" fmla="*/ 913792 h 6867048"/>
-              <a:gd name="csX3" fmla="*/ 4230766 w 5365508"/>
-              <a:gd name="csY3" fmla="*/ 6243205 h 6867048"/>
-              <a:gd name="csX4" fmla="*/ 2654602 w 5365508"/>
-              <a:gd name="csY4" fmla="*/ 6654710 h 6867048"/>
-              <a:gd name="csX5" fmla="*/ 178509 w 5365508"/>
-              <a:gd name="csY5" fmla="*/ 6723696 h 6867048"/>
-              <a:gd name="csX6" fmla="*/ 388685 w 5365508"/>
-              <a:gd name="csY6" fmla="*/ 5498068 h 6867048"/>
-              <a:gd name="csX7" fmla="*/ 691158 w 5365508"/>
-              <a:gd name="csY7" fmla="*/ 3633698 h 6867048"/>
-              <a:gd name="csX8" fmla="*/ 319793 w 5365508"/>
-              <a:gd name="csY8" fmla="*/ 113063 h 6867048"/>
-              <a:gd name="csX0" fmla="*/ 319793 w 5364340"/>
-              <a:gd name="csY0" fmla="*/ 113063 h 6867048"/>
-              <a:gd name="csX1" fmla="*/ 3458242 w 5364340"/>
-              <a:gd name="csY1" fmla="*/ 871597 h 6867048"/>
-              <a:gd name="csX2" fmla="*/ 5354203 w 5364340"/>
-              <a:gd name="csY2" fmla="*/ 913792 h 6867048"/>
-              <a:gd name="csX3" fmla="*/ 4103602 w 5364340"/>
-              <a:gd name="csY3" fmla="*/ 6324683 h 6867048"/>
-              <a:gd name="csX4" fmla="*/ 2654602 w 5364340"/>
-              <a:gd name="csY4" fmla="*/ 6654710 h 6867048"/>
-              <a:gd name="csX5" fmla="*/ 178509 w 5364340"/>
-              <a:gd name="csY5" fmla="*/ 6723696 h 6867048"/>
-              <a:gd name="csX6" fmla="*/ 388685 w 5364340"/>
-              <a:gd name="csY6" fmla="*/ 5498068 h 6867048"/>
-              <a:gd name="csX7" fmla="*/ 691158 w 5364340"/>
-              <a:gd name="csY7" fmla="*/ 3633698 h 6867048"/>
-              <a:gd name="csX8" fmla="*/ 319793 w 5364340"/>
-              <a:gd name="csY8" fmla="*/ 113063 h 6867048"/>
-              <a:gd name="csX0" fmla="*/ 319793 w 5367467"/>
-              <a:gd name="csY0" fmla="*/ 113063 h 6867048"/>
-              <a:gd name="csX1" fmla="*/ 3458242 w 5367467"/>
-              <a:gd name="csY1" fmla="*/ 871597 h 6867048"/>
-              <a:gd name="csX2" fmla="*/ 5354203 w 5367467"/>
-              <a:gd name="csY2" fmla="*/ 913792 h 6867048"/>
-              <a:gd name="csX3" fmla="*/ 4103602 w 5367467"/>
-              <a:gd name="csY3" fmla="*/ 6324683 h 6867048"/>
-              <a:gd name="csX4" fmla="*/ 2654602 w 5367467"/>
-              <a:gd name="csY4" fmla="*/ 6654710 h 6867048"/>
-              <a:gd name="csX5" fmla="*/ 178509 w 5367467"/>
-              <a:gd name="csY5" fmla="*/ 6723696 h 6867048"/>
-              <a:gd name="csX6" fmla="*/ 388685 w 5367467"/>
-              <a:gd name="csY6" fmla="*/ 5498068 h 6867048"/>
-              <a:gd name="csX7" fmla="*/ 691158 w 5367467"/>
-              <a:gd name="csY7" fmla="*/ 3633698 h 6867048"/>
-              <a:gd name="csX8" fmla="*/ 319793 w 5367467"/>
-              <a:gd name="csY8" fmla="*/ 113063 h 6867048"/>
-              <a:gd name="csX0" fmla="*/ 319793 w 5371352"/>
-              <a:gd name="csY0" fmla="*/ 113063 h 6934412"/>
-              <a:gd name="csX1" fmla="*/ 3458242 w 5371352"/>
-              <a:gd name="csY1" fmla="*/ 871597 h 6934412"/>
-              <a:gd name="csX2" fmla="*/ 5354203 w 5371352"/>
-              <a:gd name="csY2" fmla="*/ 913792 h 6934412"/>
-              <a:gd name="csX3" fmla="*/ 4320017 w 5371352"/>
-              <a:gd name="csY3" fmla="*/ 6493560 h 6934412"/>
-              <a:gd name="csX4" fmla="*/ 2654602 w 5371352"/>
-              <a:gd name="csY4" fmla="*/ 6654710 h 6934412"/>
-              <a:gd name="csX5" fmla="*/ 178509 w 5371352"/>
-              <a:gd name="csY5" fmla="*/ 6723696 h 6934412"/>
-              <a:gd name="csX6" fmla="*/ 388685 w 5371352"/>
-              <a:gd name="csY6" fmla="*/ 5498068 h 6934412"/>
-              <a:gd name="csX7" fmla="*/ 691158 w 5371352"/>
-              <a:gd name="csY7" fmla="*/ 3633698 h 6934412"/>
-              <a:gd name="csX8" fmla="*/ 319793 w 5371352"/>
-              <a:gd name="csY8" fmla="*/ 113063 h 6934412"/>
-              <a:gd name="csX0" fmla="*/ 319793 w 5368122"/>
-              <a:gd name="csY0" fmla="*/ 113063 h 6934412"/>
-              <a:gd name="csX1" fmla="*/ 3458242 w 5368122"/>
-              <a:gd name="csY1" fmla="*/ 871597 h 6934412"/>
-              <a:gd name="csX2" fmla="*/ 5354203 w 5368122"/>
-              <a:gd name="csY2" fmla="*/ 913792 h 6934412"/>
-              <a:gd name="csX3" fmla="*/ 4320017 w 5368122"/>
-              <a:gd name="csY3" fmla="*/ 6493560 h 6934412"/>
-              <a:gd name="csX4" fmla="*/ 2654602 w 5368122"/>
-              <a:gd name="csY4" fmla="*/ 6654710 h 6934412"/>
-              <a:gd name="csX5" fmla="*/ 178509 w 5368122"/>
-              <a:gd name="csY5" fmla="*/ 6723696 h 6934412"/>
-              <a:gd name="csX6" fmla="*/ 388685 w 5368122"/>
-              <a:gd name="csY6" fmla="*/ 5498068 h 6934412"/>
-              <a:gd name="csX7" fmla="*/ 691158 w 5368122"/>
-              <a:gd name="csY7" fmla="*/ 3633698 h 6934412"/>
-              <a:gd name="csX8" fmla="*/ 319793 w 5368122"/>
-              <a:gd name="csY8" fmla="*/ 113063 h 6934412"/>
-              <a:gd name="csX0" fmla="*/ 319793 w 5445135"/>
-              <a:gd name="csY0" fmla="*/ 115631 h 6936980"/>
-              <a:gd name="csX1" fmla="*/ 3458242 w 5445135"/>
-              <a:gd name="csY1" fmla="*/ 874165 h 6936980"/>
-              <a:gd name="csX2" fmla="*/ 5432326 w 5445135"/>
-              <a:gd name="csY2" fmla="*/ 1119464 h 6936980"/>
-              <a:gd name="csX3" fmla="*/ 4320017 w 5445135"/>
-              <a:gd name="csY3" fmla="*/ 6496128 h 6936980"/>
-              <a:gd name="csX4" fmla="*/ 2654602 w 5445135"/>
-              <a:gd name="csY4" fmla="*/ 6657278 h 6936980"/>
-              <a:gd name="csX5" fmla="*/ 178509 w 5445135"/>
-              <a:gd name="csY5" fmla="*/ 6726264 h 6936980"/>
-              <a:gd name="csX6" fmla="*/ 388685 w 5445135"/>
-              <a:gd name="csY6" fmla="*/ 5500636 h 6936980"/>
-              <a:gd name="csX7" fmla="*/ 691158 w 5445135"/>
-              <a:gd name="csY7" fmla="*/ 3636266 h 6936980"/>
-              <a:gd name="csX8" fmla="*/ 319793 w 5445135"/>
-              <a:gd name="csY8" fmla="*/ 115631 h 6936980"/>
-              <a:gd name="csX0" fmla="*/ 319793 w 5445135"/>
-              <a:gd name="csY0" fmla="*/ 115631 h 6936980"/>
-              <a:gd name="csX1" fmla="*/ 3458242 w 5445135"/>
-              <a:gd name="csY1" fmla="*/ 874165 h 6936980"/>
-              <a:gd name="csX2" fmla="*/ 5432326 w 5445135"/>
-              <a:gd name="csY2" fmla="*/ 1119464 h 6936980"/>
-              <a:gd name="csX3" fmla="*/ 4320017 w 5445135"/>
-              <a:gd name="csY3" fmla="*/ 6496128 h 6936980"/>
-              <a:gd name="csX4" fmla="*/ 2654602 w 5445135"/>
-              <a:gd name="csY4" fmla="*/ 6657278 h 6936980"/>
-              <a:gd name="csX5" fmla="*/ 178509 w 5445135"/>
-              <a:gd name="csY5" fmla="*/ 6726264 h 6936980"/>
-              <a:gd name="csX6" fmla="*/ 388685 w 5445135"/>
-              <a:gd name="csY6" fmla="*/ 5500636 h 6936980"/>
-              <a:gd name="csX7" fmla="*/ 691158 w 5445135"/>
-              <a:gd name="csY7" fmla="*/ 3636266 h 6936980"/>
-              <a:gd name="csX8" fmla="*/ 319793 w 5445135"/>
-              <a:gd name="csY8" fmla="*/ 115631 h 6936980"/>
-              <a:gd name="csX0" fmla="*/ 319793 w 5445135"/>
-              <a:gd name="csY0" fmla="*/ 96247 h 6917596"/>
-              <a:gd name="csX1" fmla="*/ 3472942 w 5445135"/>
-              <a:gd name="csY1" fmla="*/ 1002885 h 6917596"/>
-              <a:gd name="csX2" fmla="*/ 5432326 w 5445135"/>
-              <a:gd name="csY2" fmla="*/ 1100080 h 6917596"/>
-              <a:gd name="csX3" fmla="*/ 4320017 w 5445135"/>
-              <a:gd name="csY3" fmla="*/ 6476744 h 6917596"/>
-              <a:gd name="csX4" fmla="*/ 2654602 w 5445135"/>
-              <a:gd name="csY4" fmla="*/ 6637894 h 6917596"/>
-              <a:gd name="csX5" fmla="*/ 178509 w 5445135"/>
-              <a:gd name="csY5" fmla="*/ 6706880 h 6917596"/>
-              <a:gd name="csX6" fmla="*/ 388685 w 5445135"/>
-              <a:gd name="csY6" fmla="*/ 5481252 h 6917596"/>
-              <a:gd name="csX7" fmla="*/ 691158 w 5445135"/>
-              <a:gd name="csY7" fmla="*/ 3616882 h 6917596"/>
-              <a:gd name="csX8" fmla="*/ 319793 w 5445135"/>
-              <a:gd name="csY8" fmla="*/ 96247 h 6917596"/>
-              <a:gd name="csX0" fmla="*/ 319793 w 5472506"/>
-              <a:gd name="csY0" fmla="*/ 94297 h 6915646"/>
-              <a:gd name="csX1" fmla="*/ 3472942 w 5472506"/>
-              <a:gd name="csY1" fmla="*/ 1000935 h 6915646"/>
-              <a:gd name="csX2" fmla="*/ 5460049 w 5472506"/>
-              <a:gd name="csY2" fmla="*/ 901594 h 6915646"/>
-              <a:gd name="csX3" fmla="*/ 4320017 w 5472506"/>
-              <a:gd name="csY3" fmla="*/ 6474794 h 6915646"/>
-              <a:gd name="csX4" fmla="*/ 2654602 w 5472506"/>
-              <a:gd name="csY4" fmla="*/ 6635944 h 6915646"/>
-              <a:gd name="csX5" fmla="*/ 178509 w 5472506"/>
-              <a:gd name="csY5" fmla="*/ 6704930 h 6915646"/>
-              <a:gd name="csX6" fmla="*/ 388685 w 5472506"/>
-              <a:gd name="csY6" fmla="*/ 5479302 h 6915646"/>
-              <a:gd name="csX7" fmla="*/ 691158 w 5472506"/>
-              <a:gd name="csY7" fmla="*/ 3614932 h 6915646"/>
-              <a:gd name="csX8" fmla="*/ 319793 w 5472506"/>
-              <a:gd name="csY8" fmla="*/ 94297 h 6915646"/>
-              <a:gd name="csX0" fmla="*/ 319793 w 5460049"/>
-              <a:gd name="csY0" fmla="*/ 94297 h 6915646"/>
-              <a:gd name="csX1" fmla="*/ 3472942 w 5460049"/>
-              <a:gd name="csY1" fmla="*/ 1000935 h 6915646"/>
-              <a:gd name="csX2" fmla="*/ 5460049 w 5460049"/>
-              <a:gd name="csY2" fmla="*/ 901594 h 6915646"/>
-              <a:gd name="csX3" fmla="*/ 4320017 w 5460049"/>
-              <a:gd name="csY3" fmla="*/ 6474794 h 6915646"/>
-              <a:gd name="csX4" fmla="*/ 2654602 w 5460049"/>
-              <a:gd name="csY4" fmla="*/ 6635944 h 6915646"/>
-              <a:gd name="csX5" fmla="*/ 178509 w 5460049"/>
-              <a:gd name="csY5" fmla="*/ 6704930 h 6915646"/>
-              <a:gd name="csX6" fmla="*/ 388685 w 5460049"/>
-              <a:gd name="csY6" fmla="*/ 5479302 h 6915646"/>
-              <a:gd name="csX7" fmla="*/ 691158 w 5460049"/>
-              <a:gd name="csY7" fmla="*/ 3614932 h 6915646"/>
-              <a:gd name="csX8" fmla="*/ 319793 w 5460049"/>
-              <a:gd name="csY8" fmla="*/ 94297 h 6915646"/>
-              <a:gd name="csX0" fmla="*/ 319793 w 5460049"/>
-              <a:gd name="csY0" fmla="*/ 94297 h 6849372"/>
-              <a:gd name="csX1" fmla="*/ 3472942 w 5460049"/>
-              <a:gd name="csY1" fmla="*/ 1000935 h 6849372"/>
-              <a:gd name="csX2" fmla="*/ 5460049 w 5460049"/>
-              <a:gd name="csY2" fmla="*/ 901594 h 6849372"/>
-              <a:gd name="csX3" fmla="*/ 4332619 w 5460049"/>
-              <a:gd name="csY3" fmla="*/ 6385459 h 6849372"/>
-              <a:gd name="csX4" fmla="*/ 2654602 w 5460049"/>
-              <a:gd name="csY4" fmla="*/ 6635944 h 6849372"/>
-              <a:gd name="csX5" fmla="*/ 178509 w 5460049"/>
-              <a:gd name="csY5" fmla="*/ 6704930 h 6849372"/>
-              <a:gd name="csX6" fmla="*/ 388685 w 5460049"/>
-              <a:gd name="csY6" fmla="*/ 5479302 h 6849372"/>
-              <a:gd name="csX7" fmla="*/ 691158 w 5460049"/>
-              <a:gd name="csY7" fmla="*/ 3614932 h 6849372"/>
-              <a:gd name="csX8" fmla="*/ 319793 w 5460049"/>
-              <a:gd name="csY8" fmla="*/ 94297 h 6849372"/>
-              <a:gd name="csX0" fmla="*/ 319793 w 5460049"/>
-              <a:gd name="csY0" fmla="*/ 94297 h 6920530"/>
-              <a:gd name="csX1" fmla="*/ 3472942 w 5460049"/>
-              <a:gd name="csY1" fmla="*/ 1000935 h 6920530"/>
-              <a:gd name="csX2" fmla="*/ 5460049 w 5460049"/>
-              <a:gd name="csY2" fmla="*/ 901594 h 6920530"/>
-              <a:gd name="csX3" fmla="*/ 4363595 w 5460049"/>
-              <a:gd name="csY3" fmla="*/ 6481254 h 6920530"/>
-              <a:gd name="csX4" fmla="*/ 2654602 w 5460049"/>
-              <a:gd name="csY4" fmla="*/ 6635944 h 6920530"/>
-              <a:gd name="csX5" fmla="*/ 178509 w 5460049"/>
-              <a:gd name="csY5" fmla="*/ 6704930 h 6920530"/>
-              <a:gd name="csX6" fmla="*/ 388685 w 5460049"/>
-              <a:gd name="csY6" fmla="*/ 5479302 h 6920530"/>
-              <a:gd name="csX7" fmla="*/ 691158 w 5460049"/>
-              <a:gd name="csY7" fmla="*/ 3614932 h 6920530"/>
-              <a:gd name="csX8" fmla="*/ 319793 w 5460049"/>
-              <a:gd name="csY8" fmla="*/ 94297 h 6920530"/>
-              <a:gd name="csX0" fmla="*/ 319793 w 5460049"/>
-              <a:gd name="csY0" fmla="*/ 94297 h 7170026"/>
-              <a:gd name="csX1" fmla="*/ 3472942 w 5460049"/>
-              <a:gd name="csY1" fmla="*/ 1000935 h 7170026"/>
-              <a:gd name="csX2" fmla="*/ 5460049 w 5460049"/>
-              <a:gd name="csY2" fmla="*/ 901594 h 7170026"/>
-              <a:gd name="csX3" fmla="*/ 4363595 w 5460049"/>
-              <a:gd name="csY3" fmla="*/ 6481254 h 7170026"/>
-              <a:gd name="csX4" fmla="*/ 2654602 w 5460049"/>
-              <a:gd name="csY4" fmla="*/ 6635944 h 7170026"/>
-              <a:gd name="csX5" fmla="*/ 178509 w 5460049"/>
-              <a:gd name="csY5" fmla="*/ 6704930 h 7170026"/>
-              <a:gd name="csX6" fmla="*/ 388685 w 5460049"/>
-              <a:gd name="csY6" fmla="*/ 5479302 h 7170026"/>
-              <a:gd name="csX7" fmla="*/ 691158 w 5460049"/>
-              <a:gd name="csY7" fmla="*/ 3614932 h 7170026"/>
-              <a:gd name="csX8" fmla="*/ 319793 w 5460049"/>
-              <a:gd name="csY8" fmla="*/ 94297 h 7170026"/>
-              <a:gd name="csX0" fmla="*/ 319793 w 5460049"/>
-              <a:gd name="csY0" fmla="*/ 94297 h 7170026"/>
-              <a:gd name="csX1" fmla="*/ 3472942 w 5460049"/>
-              <a:gd name="csY1" fmla="*/ 1000935 h 7170026"/>
-              <a:gd name="csX2" fmla="*/ 5460049 w 5460049"/>
-              <a:gd name="csY2" fmla="*/ 901594 h 7170026"/>
-              <a:gd name="csX3" fmla="*/ 4363595 w 5460049"/>
-              <a:gd name="csY3" fmla="*/ 6481254 h 7170026"/>
-              <a:gd name="csX4" fmla="*/ 2654602 w 5460049"/>
-              <a:gd name="csY4" fmla="*/ 6635944 h 7170026"/>
-              <a:gd name="csX5" fmla="*/ 178509 w 5460049"/>
-              <a:gd name="csY5" fmla="*/ 6704930 h 7170026"/>
-              <a:gd name="csX6" fmla="*/ 388685 w 5460049"/>
-              <a:gd name="csY6" fmla="*/ 5479302 h 7170026"/>
-              <a:gd name="csX7" fmla="*/ 691158 w 5460049"/>
-              <a:gd name="csY7" fmla="*/ 3614932 h 7170026"/>
-              <a:gd name="csX8" fmla="*/ 319793 w 5460049"/>
-              <a:gd name="csY8" fmla="*/ 94297 h 7170026"/>
-              <a:gd name="csX0" fmla="*/ 319793 w 5460049"/>
-              <a:gd name="csY0" fmla="*/ 94297 h 7170026"/>
-              <a:gd name="csX1" fmla="*/ 3472942 w 5460049"/>
-              <a:gd name="csY1" fmla="*/ 1000935 h 7170026"/>
-              <a:gd name="csX2" fmla="*/ 5460049 w 5460049"/>
-              <a:gd name="csY2" fmla="*/ 901594 h 7170026"/>
-              <a:gd name="csX3" fmla="*/ 4363595 w 5460049"/>
-              <a:gd name="csY3" fmla="*/ 6481254 h 7170026"/>
-              <a:gd name="csX4" fmla="*/ 2654602 w 5460049"/>
-              <a:gd name="csY4" fmla="*/ 6635944 h 7170026"/>
-              <a:gd name="csX5" fmla="*/ 178509 w 5460049"/>
-              <a:gd name="csY5" fmla="*/ 6704930 h 7170026"/>
-              <a:gd name="csX6" fmla="*/ 388685 w 5460049"/>
-              <a:gd name="csY6" fmla="*/ 5479302 h 7170026"/>
-              <a:gd name="csX7" fmla="*/ 691158 w 5460049"/>
-              <a:gd name="csY7" fmla="*/ 3614932 h 7170026"/>
-              <a:gd name="csX8" fmla="*/ 319793 w 5460049"/>
-              <a:gd name="csY8" fmla="*/ 94297 h 7170026"/>
-              <a:gd name="csX0" fmla="*/ 319793 w 5545839"/>
-              <a:gd name="csY0" fmla="*/ 95137 h 7170866"/>
-              <a:gd name="csX1" fmla="*/ 3472942 w 5545839"/>
-              <a:gd name="csY1" fmla="*/ 1001775 h 7170866"/>
-              <a:gd name="csX2" fmla="*/ 5545839 w 5545839"/>
-              <a:gd name="csY2" fmla="*/ 988111 h 7170866"/>
-              <a:gd name="csX3" fmla="*/ 4363595 w 5545839"/>
-              <a:gd name="csY3" fmla="*/ 6482094 h 7170866"/>
-              <a:gd name="csX4" fmla="*/ 2654602 w 5545839"/>
-              <a:gd name="csY4" fmla="*/ 6636784 h 7170866"/>
-              <a:gd name="csX5" fmla="*/ 178509 w 5545839"/>
-              <a:gd name="csY5" fmla="*/ 6705770 h 7170866"/>
-              <a:gd name="csX6" fmla="*/ 388685 w 5545839"/>
-              <a:gd name="csY6" fmla="*/ 5480142 h 7170866"/>
-              <a:gd name="csX7" fmla="*/ 691158 w 5545839"/>
-              <a:gd name="csY7" fmla="*/ 3615772 h 7170866"/>
-              <a:gd name="csX8" fmla="*/ 319793 w 5545839"/>
-              <a:gd name="csY8" fmla="*/ 95137 h 7170866"/>
-              <a:gd name="csX0" fmla="*/ 319793 w 5545839"/>
-              <a:gd name="csY0" fmla="*/ 110143 h 7185872"/>
-              <a:gd name="csX1" fmla="*/ 3534162 w 5545839"/>
-              <a:gd name="csY1" fmla="*/ 898171 h 7185872"/>
-              <a:gd name="csX2" fmla="*/ 5545839 w 5545839"/>
-              <a:gd name="csY2" fmla="*/ 1003117 h 7185872"/>
-              <a:gd name="csX3" fmla="*/ 4363595 w 5545839"/>
-              <a:gd name="csY3" fmla="*/ 6497100 h 7185872"/>
-              <a:gd name="csX4" fmla="*/ 2654602 w 5545839"/>
-              <a:gd name="csY4" fmla="*/ 6651790 h 7185872"/>
-              <a:gd name="csX5" fmla="*/ 178509 w 5545839"/>
-              <a:gd name="csY5" fmla="*/ 6720776 h 7185872"/>
-              <a:gd name="csX6" fmla="*/ 388685 w 5545839"/>
-              <a:gd name="csY6" fmla="*/ 5495148 h 7185872"/>
-              <a:gd name="csX7" fmla="*/ 691158 w 5545839"/>
-              <a:gd name="csY7" fmla="*/ 3630778 h 7185872"/>
-              <a:gd name="csX8" fmla="*/ 319793 w 5545839"/>
-              <a:gd name="csY8" fmla="*/ 110143 h 7185872"/>
-              <a:gd name="csX0" fmla="*/ 319793 w 5545839"/>
-              <a:gd name="csY0" fmla="*/ 110143 h 6892510"/>
-              <a:gd name="csX1" fmla="*/ 3534162 w 5545839"/>
-              <a:gd name="csY1" fmla="*/ 898171 h 6892510"/>
-              <a:gd name="csX2" fmla="*/ 5545839 w 5545839"/>
-              <a:gd name="csY2" fmla="*/ 1003117 h 6892510"/>
-              <a:gd name="csX3" fmla="*/ 4363595 w 5545839"/>
-              <a:gd name="csY3" fmla="*/ 6497100 h 6892510"/>
-              <a:gd name="csX4" fmla="*/ 2654602 w 5545839"/>
-              <a:gd name="csY4" fmla="*/ 6651790 h 6892510"/>
-              <a:gd name="csX5" fmla="*/ 178509 w 5545839"/>
-              <a:gd name="csY5" fmla="*/ 6720776 h 6892510"/>
-              <a:gd name="csX6" fmla="*/ 388685 w 5545839"/>
-              <a:gd name="csY6" fmla="*/ 5495148 h 6892510"/>
-              <a:gd name="csX7" fmla="*/ 691158 w 5545839"/>
-              <a:gd name="csY7" fmla="*/ 3630778 h 6892510"/>
-              <a:gd name="csX8" fmla="*/ 319793 w 5545839"/>
-              <a:gd name="csY8" fmla="*/ 110143 h 6892510"/>
-              <a:gd name="csX0" fmla="*/ 308922 w 5534968"/>
-              <a:gd name="csY0" fmla="*/ 110143 h 6870931"/>
-              <a:gd name="csX1" fmla="*/ 3523291 w 5534968"/>
-              <a:gd name="csY1" fmla="*/ 898171 h 6870931"/>
-              <a:gd name="csX2" fmla="*/ 5534968 w 5534968"/>
-              <a:gd name="csY2" fmla="*/ 1003117 h 6870931"/>
-              <a:gd name="csX3" fmla="*/ 4352724 w 5534968"/>
-              <a:gd name="csY3" fmla="*/ 6497100 h 6870931"/>
-              <a:gd name="csX4" fmla="*/ 2496933 w 5534968"/>
-              <a:gd name="csY4" fmla="*/ 6557073 h 6870931"/>
-              <a:gd name="csX5" fmla="*/ 167638 w 5534968"/>
-              <a:gd name="csY5" fmla="*/ 6720776 h 6870931"/>
-              <a:gd name="csX6" fmla="*/ 377814 w 5534968"/>
-              <a:gd name="csY6" fmla="*/ 5495148 h 6870931"/>
-              <a:gd name="csX7" fmla="*/ 680287 w 5534968"/>
-              <a:gd name="csY7" fmla="*/ 3630778 h 6870931"/>
-              <a:gd name="csX8" fmla="*/ 308922 w 5534968"/>
-              <a:gd name="csY8" fmla="*/ 110143 h 6870931"/>
-              <a:gd name="csX0" fmla="*/ 243903 w 5469949"/>
-              <a:gd name="csY0" fmla="*/ 110143 h 6891646"/>
-              <a:gd name="csX1" fmla="*/ 3458272 w 5469949"/>
-              <a:gd name="csY1" fmla="*/ 898171 h 6891646"/>
-              <a:gd name="csX2" fmla="*/ 5469949 w 5469949"/>
-              <a:gd name="csY2" fmla="*/ 1003117 h 6891646"/>
-              <a:gd name="csX3" fmla="*/ 4287705 w 5469949"/>
-              <a:gd name="csY3" fmla="*/ 6497100 h 6891646"/>
-              <a:gd name="csX4" fmla="*/ 2431914 w 5469949"/>
-              <a:gd name="csY4" fmla="*/ 6557073 h 6891646"/>
-              <a:gd name="csX5" fmla="*/ 195863 w 5469949"/>
-              <a:gd name="csY5" fmla="*/ 6816678 h 6891646"/>
-              <a:gd name="csX6" fmla="*/ 312795 w 5469949"/>
-              <a:gd name="csY6" fmla="*/ 5495148 h 6891646"/>
-              <a:gd name="csX7" fmla="*/ 615268 w 5469949"/>
-              <a:gd name="csY7" fmla="*/ 3630778 h 6891646"/>
-              <a:gd name="csX8" fmla="*/ 243903 w 5469949"/>
-              <a:gd name="csY8" fmla="*/ 110143 h 6891646"/>
-              <a:gd name="csX0" fmla="*/ 334133 w 5560179"/>
-              <a:gd name="csY0" fmla="*/ 110143 h 6905799"/>
-              <a:gd name="csX1" fmla="*/ 3548502 w 5560179"/>
-              <a:gd name="csY1" fmla="*/ 898171 h 6905799"/>
-              <a:gd name="csX2" fmla="*/ 5560179 w 5560179"/>
-              <a:gd name="csY2" fmla="*/ 1003117 h 6905799"/>
-              <a:gd name="csX3" fmla="*/ 4377935 w 5560179"/>
-              <a:gd name="csY3" fmla="*/ 6497100 h 6905799"/>
-              <a:gd name="csX4" fmla="*/ 2522144 w 5560179"/>
-              <a:gd name="csY4" fmla="*/ 6557073 h 6905799"/>
-              <a:gd name="csX5" fmla="*/ 159037 w 5560179"/>
-              <a:gd name="csY5" fmla="*/ 6834330 h 6905799"/>
-              <a:gd name="csX6" fmla="*/ 403025 w 5560179"/>
-              <a:gd name="csY6" fmla="*/ 5495148 h 6905799"/>
-              <a:gd name="csX7" fmla="*/ 705498 w 5560179"/>
-              <a:gd name="csY7" fmla="*/ 3630778 h 6905799"/>
-              <a:gd name="csX8" fmla="*/ 334133 w 5560179"/>
-              <a:gd name="csY8" fmla="*/ 110143 h 6905799"/>
-              <a:gd name="csX0" fmla="*/ 331538 w 5557584"/>
-              <a:gd name="csY0" fmla="*/ 110143 h 6946015"/>
-              <a:gd name="csX1" fmla="*/ 3545907 w 5557584"/>
-              <a:gd name="csY1" fmla="*/ 898171 h 6946015"/>
-              <a:gd name="csX2" fmla="*/ 5557584 w 5557584"/>
-              <a:gd name="csY2" fmla="*/ 1003117 h 6946015"/>
-              <a:gd name="csX3" fmla="*/ 4375340 w 5557584"/>
-              <a:gd name="csY3" fmla="*/ 6497100 h 6946015"/>
-              <a:gd name="csX4" fmla="*/ 2484475 w 5557584"/>
-              <a:gd name="csY4" fmla="*/ 6679560 h 6946015"/>
-              <a:gd name="csX5" fmla="*/ 156442 w 5557584"/>
-              <a:gd name="csY5" fmla="*/ 6834330 h 6946015"/>
-              <a:gd name="csX6" fmla="*/ 400430 w 5557584"/>
-              <a:gd name="csY6" fmla="*/ 5495148 h 6946015"/>
-              <a:gd name="csX7" fmla="*/ 702903 w 5557584"/>
-              <a:gd name="csY7" fmla="*/ 3630778 h 6946015"/>
-              <a:gd name="csX8" fmla="*/ 331538 w 5557584"/>
-              <a:gd name="csY8" fmla="*/ 110143 h 6946015"/>
-              <a:gd name="csX0" fmla="*/ 331538 w 5557584"/>
-              <a:gd name="csY0" fmla="*/ 110143 h 6946015"/>
-              <a:gd name="csX1" fmla="*/ 3545907 w 5557584"/>
-              <a:gd name="csY1" fmla="*/ 898171 h 6946015"/>
-              <a:gd name="csX2" fmla="*/ 5557584 w 5557584"/>
-              <a:gd name="csY2" fmla="*/ 1003117 h 6946015"/>
-              <a:gd name="csX3" fmla="*/ 4358121 w 5557584"/>
-              <a:gd name="csY3" fmla="*/ 6366865 h 6946015"/>
-              <a:gd name="csX4" fmla="*/ 2484475 w 5557584"/>
-              <a:gd name="csY4" fmla="*/ 6679560 h 6946015"/>
-              <a:gd name="csX5" fmla="*/ 156442 w 5557584"/>
-              <a:gd name="csY5" fmla="*/ 6834330 h 6946015"/>
-              <a:gd name="csX6" fmla="*/ 400430 w 5557584"/>
-              <a:gd name="csY6" fmla="*/ 5495148 h 6946015"/>
-              <a:gd name="csX7" fmla="*/ 702903 w 5557584"/>
-              <a:gd name="csY7" fmla="*/ 3630778 h 6946015"/>
-              <a:gd name="csX8" fmla="*/ 331538 w 5557584"/>
-              <a:gd name="csY8" fmla="*/ 110143 h 6946015"/>
-              <a:gd name="csX0" fmla="*/ 331538 w 5557584"/>
-              <a:gd name="csY0" fmla="*/ 110143 h 6946015"/>
-              <a:gd name="csX1" fmla="*/ 3545907 w 5557584"/>
-              <a:gd name="csY1" fmla="*/ 898171 h 6946015"/>
-              <a:gd name="csX2" fmla="*/ 5557584 w 5557584"/>
-              <a:gd name="csY2" fmla="*/ 1003117 h 6946015"/>
-              <a:gd name="csX3" fmla="*/ 4358121 w 5557584"/>
-              <a:gd name="csY3" fmla="*/ 6366865 h 6946015"/>
-              <a:gd name="csX4" fmla="*/ 2484475 w 5557584"/>
-              <a:gd name="csY4" fmla="*/ 6679560 h 6946015"/>
-              <a:gd name="csX5" fmla="*/ 156442 w 5557584"/>
-              <a:gd name="csY5" fmla="*/ 6834330 h 6946015"/>
-              <a:gd name="csX6" fmla="*/ 400430 w 5557584"/>
-              <a:gd name="csY6" fmla="*/ 5495148 h 6946015"/>
-              <a:gd name="csX7" fmla="*/ 702903 w 5557584"/>
-              <a:gd name="csY7" fmla="*/ 3630778 h 6946015"/>
-              <a:gd name="csX8" fmla="*/ 331538 w 5557584"/>
-              <a:gd name="csY8" fmla="*/ 110143 h 6946015"/>
-              <a:gd name="csX0" fmla="*/ 331538 w 5557584"/>
-              <a:gd name="csY0" fmla="*/ 110143 h 6946015"/>
-              <a:gd name="csX1" fmla="*/ 3545907 w 5557584"/>
-              <a:gd name="csY1" fmla="*/ 898171 h 6946015"/>
-              <a:gd name="csX2" fmla="*/ 5557584 w 5557584"/>
-              <a:gd name="csY2" fmla="*/ 1003117 h 6946015"/>
-              <a:gd name="csX3" fmla="*/ 4358121 w 5557584"/>
-              <a:gd name="csY3" fmla="*/ 6366865 h 6946015"/>
-              <a:gd name="csX4" fmla="*/ 2484475 w 5557584"/>
-              <a:gd name="csY4" fmla="*/ 6679560 h 6946015"/>
-              <a:gd name="csX5" fmla="*/ 156442 w 5557584"/>
-              <a:gd name="csY5" fmla="*/ 6834330 h 6946015"/>
-              <a:gd name="csX6" fmla="*/ 400430 w 5557584"/>
-              <a:gd name="csY6" fmla="*/ 5495148 h 6946015"/>
-              <a:gd name="csX7" fmla="*/ 702903 w 5557584"/>
-              <a:gd name="csY7" fmla="*/ 3630778 h 6946015"/>
-              <a:gd name="csX8" fmla="*/ 331538 w 5557584"/>
-              <a:gd name="csY8" fmla="*/ 110143 h 6946015"/>
-              <a:gd name="csX0" fmla="*/ 331538 w 5557584"/>
-              <a:gd name="csY0" fmla="*/ 110143 h 6946015"/>
-              <a:gd name="csX1" fmla="*/ 3545907 w 5557584"/>
-              <a:gd name="csY1" fmla="*/ 898171 h 6946015"/>
-              <a:gd name="csX2" fmla="*/ 5557584 w 5557584"/>
-              <a:gd name="csY2" fmla="*/ 1003117 h 6946015"/>
-              <a:gd name="csX3" fmla="*/ 4179716 w 5557584"/>
-              <a:gd name="csY3" fmla="*/ 6559310 h 6946015"/>
-              <a:gd name="csX4" fmla="*/ 2484475 w 5557584"/>
-              <a:gd name="csY4" fmla="*/ 6679560 h 6946015"/>
-              <a:gd name="csX5" fmla="*/ 156442 w 5557584"/>
-              <a:gd name="csY5" fmla="*/ 6834330 h 6946015"/>
-              <a:gd name="csX6" fmla="*/ 400430 w 5557584"/>
-              <a:gd name="csY6" fmla="*/ 5495148 h 6946015"/>
-              <a:gd name="csX7" fmla="*/ 702903 w 5557584"/>
-              <a:gd name="csY7" fmla="*/ 3630778 h 6946015"/>
-              <a:gd name="csX8" fmla="*/ 331538 w 5557584"/>
-              <a:gd name="csY8" fmla="*/ 110143 h 6946015"/>
-              <a:gd name="csX0" fmla="*/ 331538 w 5557584"/>
-              <a:gd name="csY0" fmla="*/ 110143 h 6946015"/>
-              <a:gd name="csX1" fmla="*/ 3545907 w 5557584"/>
-              <a:gd name="csY1" fmla="*/ 898171 h 6946015"/>
-              <a:gd name="csX2" fmla="*/ 5557584 w 5557584"/>
-              <a:gd name="csY2" fmla="*/ 1003117 h 6946015"/>
-              <a:gd name="csX3" fmla="*/ 4179716 w 5557584"/>
-              <a:gd name="csY3" fmla="*/ 6559310 h 6946015"/>
-              <a:gd name="csX4" fmla="*/ 2484475 w 5557584"/>
-              <a:gd name="csY4" fmla="*/ 6679560 h 6946015"/>
-              <a:gd name="csX5" fmla="*/ 156442 w 5557584"/>
-              <a:gd name="csY5" fmla="*/ 6834330 h 6946015"/>
-              <a:gd name="csX6" fmla="*/ 400430 w 5557584"/>
-              <a:gd name="csY6" fmla="*/ 5495148 h 6946015"/>
-              <a:gd name="csX7" fmla="*/ 702903 w 5557584"/>
-              <a:gd name="csY7" fmla="*/ 3630778 h 6946015"/>
-              <a:gd name="csX8" fmla="*/ 331538 w 5557584"/>
-              <a:gd name="csY8" fmla="*/ 110143 h 6946015"/>
-              <a:gd name="csX0" fmla="*/ 329036 w 5555082"/>
-              <a:gd name="csY0" fmla="*/ 110143 h 6999954"/>
-              <a:gd name="csX1" fmla="*/ 3543405 w 5555082"/>
-              <a:gd name="csY1" fmla="*/ 898171 h 6999954"/>
-              <a:gd name="csX2" fmla="*/ 5555082 w 5555082"/>
-              <a:gd name="csY2" fmla="*/ 1003117 h 6999954"/>
-              <a:gd name="csX3" fmla="*/ 4177214 w 5555082"/>
-              <a:gd name="csY3" fmla="*/ 6559310 h 6999954"/>
-              <a:gd name="csX4" fmla="*/ 2448160 w 5555082"/>
-              <a:gd name="csY4" fmla="*/ 6793113 h 6999954"/>
-              <a:gd name="csX5" fmla="*/ 153940 w 5555082"/>
-              <a:gd name="csY5" fmla="*/ 6834330 h 6999954"/>
-              <a:gd name="csX6" fmla="*/ 397928 w 5555082"/>
-              <a:gd name="csY6" fmla="*/ 5495148 h 6999954"/>
-              <a:gd name="csX7" fmla="*/ 700401 w 5555082"/>
-              <a:gd name="csY7" fmla="*/ 3630778 h 6999954"/>
-              <a:gd name="csX8" fmla="*/ 329036 w 5555082"/>
-              <a:gd name="csY8" fmla="*/ 110143 h 6999954"/>
-              <a:gd name="csX0" fmla="*/ 369988 w 5555082"/>
-              <a:gd name="csY0" fmla="*/ 116194 h 6917854"/>
-              <a:gd name="csX1" fmla="*/ 3543405 w 5555082"/>
-              <a:gd name="csY1" fmla="*/ 816071 h 6917854"/>
-              <a:gd name="csX2" fmla="*/ 5555082 w 5555082"/>
-              <a:gd name="csY2" fmla="*/ 921017 h 6917854"/>
-              <a:gd name="csX3" fmla="*/ 4177214 w 5555082"/>
-              <a:gd name="csY3" fmla="*/ 6477210 h 6917854"/>
-              <a:gd name="csX4" fmla="*/ 2448160 w 5555082"/>
-              <a:gd name="csY4" fmla="*/ 6711013 h 6917854"/>
-              <a:gd name="csX5" fmla="*/ 153940 w 5555082"/>
-              <a:gd name="csY5" fmla="*/ 6752230 h 6917854"/>
-              <a:gd name="csX6" fmla="*/ 397928 w 5555082"/>
-              <a:gd name="csY6" fmla="*/ 5413048 h 6917854"/>
-              <a:gd name="csX7" fmla="*/ 700401 w 5555082"/>
-              <a:gd name="csY7" fmla="*/ 3548678 h 6917854"/>
-              <a:gd name="csX8" fmla="*/ 369988 w 5555082"/>
-              <a:gd name="csY8" fmla="*/ 116194 h 6917854"/>
-              <a:gd name="csX0" fmla="*/ 369988 w 5555082"/>
-              <a:gd name="csY0" fmla="*/ 111253 h 6912913"/>
-              <a:gd name="csX1" fmla="*/ 3543405 w 5555082"/>
-              <a:gd name="csY1" fmla="*/ 811130 h 6912913"/>
-              <a:gd name="csX2" fmla="*/ 5555082 w 5555082"/>
-              <a:gd name="csY2" fmla="*/ 916076 h 6912913"/>
-              <a:gd name="csX3" fmla="*/ 4177214 w 5555082"/>
-              <a:gd name="csY3" fmla="*/ 6472269 h 6912913"/>
-              <a:gd name="csX4" fmla="*/ 2448160 w 5555082"/>
-              <a:gd name="csY4" fmla="*/ 6706072 h 6912913"/>
-              <a:gd name="csX5" fmla="*/ 153940 w 5555082"/>
-              <a:gd name="csY5" fmla="*/ 6747289 h 6912913"/>
-              <a:gd name="csX6" fmla="*/ 397928 w 5555082"/>
-              <a:gd name="csY6" fmla="*/ 5408107 h 6912913"/>
-              <a:gd name="csX7" fmla="*/ 578489 w 5555082"/>
-              <a:gd name="csY7" fmla="*/ 3461828 h 6912913"/>
-              <a:gd name="csX8" fmla="*/ 369988 w 5555082"/>
-              <a:gd name="csY8" fmla="*/ 111253 h 6912913"/>
-              <a:gd name="csX0" fmla="*/ 369988 w 5555082"/>
-              <a:gd name="csY0" fmla="*/ 130966 h 6932626"/>
-              <a:gd name="csX1" fmla="*/ 3552332 w 5555082"/>
-              <a:gd name="csY1" fmla="*/ 704483 h 6932626"/>
-              <a:gd name="csX2" fmla="*/ 5555082 w 5555082"/>
-              <a:gd name="csY2" fmla="*/ 935789 h 6932626"/>
-              <a:gd name="csX3" fmla="*/ 4177214 w 5555082"/>
-              <a:gd name="csY3" fmla="*/ 6491982 h 6932626"/>
-              <a:gd name="csX4" fmla="*/ 2448160 w 5555082"/>
-              <a:gd name="csY4" fmla="*/ 6725785 h 6932626"/>
-              <a:gd name="csX5" fmla="*/ 153940 w 5555082"/>
-              <a:gd name="csY5" fmla="*/ 6767002 h 6932626"/>
-              <a:gd name="csX6" fmla="*/ 397928 w 5555082"/>
-              <a:gd name="csY6" fmla="*/ 5427820 h 6932626"/>
-              <a:gd name="csX7" fmla="*/ 578489 w 5555082"/>
-              <a:gd name="csY7" fmla="*/ 3481541 h 6932626"/>
-              <a:gd name="csX8" fmla="*/ 369988 w 5555082"/>
-              <a:gd name="csY8" fmla="*/ 130966 h 6932626"/>
-              <a:gd name="csX0" fmla="*/ 369988 w 5478952"/>
-              <a:gd name="csY0" fmla="*/ 132570 h 6934230"/>
-              <a:gd name="csX1" fmla="*/ 3552332 w 5478952"/>
-              <a:gd name="csY1" fmla="*/ 706087 h 6934230"/>
-              <a:gd name="csX2" fmla="*/ 5478952 w 5478952"/>
-              <a:gd name="csY2" fmla="*/ 1035553 h 6934230"/>
-              <a:gd name="csX3" fmla="*/ 4177214 w 5478952"/>
-              <a:gd name="csY3" fmla="*/ 6493586 h 6934230"/>
-              <a:gd name="csX4" fmla="*/ 2448160 w 5478952"/>
-              <a:gd name="csY4" fmla="*/ 6727389 h 6934230"/>
-              <a:gd name="csX5" fmla="*/ 153940 w 5478952"/>
-              <a:gd name="csY5" fmla="*/ 6768606 h 6934230"/>
-              <a:gd name="csX6" fmla="*/ 397928 w 5478952"/>
-              <a:gd name="csY6" fmla="*/ 5429424 h 6934230"/>
-              <a:gd name="csX7" fmla="*/ 578489 w 5478952"/>
-              <a:gd name="csY7" fmla="*/ 3483145 h 6934230"/>
-              <a:gd name="csX8" fmla="*/ 369988 w 5478952"/>
-              <a:gd name="csY8" fmla="*/ 132570 h 6934230"/>
-              <a:gd name="csX0" fmla="*/ 369988 w 5478952"/>
-              <a:gd name="csY0" fmla="*/ 159142 h 6960802"/>
-              <a:gd name="csX1" fmla="*/ 3652193 w 5478952"/>
-              <a:gd name="csY1" fmla="*/ 592414 h 6960802"/>
-              <a:gd name="csX2" fmla="*/ 5478952 w 5478952"/>
-              <a:gd name="csY2" fmla="*/ 1062125 h 6960802"/>
-              <a:gd name="csX3" fmla="*/ 4177214 w 5478952"/>
-              <a:gd name="csY3" fmla="*/ 6520158 h 6960802"/>
-              <a:gd name="csX4" fmla="*/ 2448160 w 5478952"/>
-              <a:gd name="csY4" fmla="*/ 6753961 h 6960802"/>
-              <a:gd name="csX5" fmla="*/ 153940 w 5478952"/>
-              <a:gd name="csY5" fmla="*/ 6795178 h 6960802"/>
-              <a:gd name="csX6" fmla="*/ 397928 w 5478952"/>
-              <a:gd name="csY6" fmla="*/ 5455996 h 6960802"/>
-              <a:gd name="csX7" fmla="*/ 578489 w 5478952"/>
-              <a:gd name="csY7" fmla="*/ 3509717 h 6960802"/>
-              <a:gd name="csX8" fmla="*/ 369988 w 5478952"/>
-              <a:gd name="csY8" fmla="*/ 159142 h 6960802"/>
-              <a:gd name="csX0" fmla="*/ 369988 w 5564640"/>
-              <a:gd name="csY0" fmla="*/ 147155 h 6948815"/>
-              <a:gd name="csX1" fmla="*/ 3652193 w 5564640"/>
-              <a:gd name="csY1" fmla="*/ 580427 h 6948815"/>
-              <a:gd name="csX2" fmla="*/ 5564640 w 5564640"/>
-              <a:gd name="csY2" fmla="*/ 442659 h 6948815"/>
-              <a:gd name="csX3" fmla="*/ 4177214 w 5564640"/>
-              <a:gd name="csY3" fmla="*/ 6508171 h 6948815"/>
-              <a:gd name="csX4" fmla="*/ 2448160 w 5564640"/>
-              <a:gd name="csY4" fmla="*/ 6741974 h 6948815"/>
-              <a:gd name="csX5" fmla="*/ 153940 w 5564640"/>
-              <a:gd name="csY5" fmla="*/ 6783191 h 6948815"/>
-              <a:gd name="csX6" fmla="*/ 397928 w 5564640"/>
-              <a:gd name="csY6" fmla="*/ 5444009 h 6948815"/>
-              <a:gd name="csX7" fmla="*/ 578489 w 5564640"/>
-              <a:gd name="csY7" fmla="*/ 3497730 h 6948815"/>
-              <a:gd name="csX8" fmla="*/ 369988 w 5564640"/>
-              <a:gd name="csY8" fmla="*/ 147155 h 6948815"/>
-              <a:gd name="csX0" fmla="*/ 369988 w 5564640"/>
-              <a:gd name="csY0" fmla="*/ 186331 h 6987991"/>
-              <a:gd name="csX1" fmla="*/ 3870626 w 5564640"/>
-              <a:gd name="csY1" fmla="*/ 435852 h 6987991"/>
-              <a:gd name="csX2" fmla="*/ 5564640 w 5564640"/>
-              <a:gd name="csY2" fmla="*/ 481835 h 6987991"/>
-              <a:gd name="csX3" fmla="*/ 4177214 w 5564640"/>
-              <a:gd name="csY3" fmla="*/ 6547347 h 6987991"/>
-              <a:gd name="csX4" fmla="*/ 2448160 w 5564640"/>
-              <a:gd name="csY4" fmla="*/ 6781150 h 6987991"/>
-              <a:gd name="csX5" fmla="*/ 153940 w 5564640"/>
-              <a:gd name="csY5" fmla="*/ 6822367 h 6987991"/>
-              <a:gd name="csX6" fmla="*/ 397928 w 5564640"/>
-              <a:gd name="csY6" fmla="*/ 5483185 h 6987991"/>
-              <a:gd name="csX7" fmla="*/ 578489 w 5564640"/>
-              <a:gd name="csY7" fmla="*/ 3536906 h 6987991"/>
-              <a:gd name="csX8" fmla="*/ 369988 w 5564640"/>
-              <a:gd name="csY8" fmla="*/ 186331 h 6987991"/>
-              <a:gd name="csX0" fmla="*/ 369988 w 5643837"/>
-              <a:gd name="csY0" fmla="*/ 635372 h 7437032"/>
-              <a:gd name="csX1" fmla="*/ 3870626 w 5643837"/>
-              <a:gd name="csY1" fmla="*/ 884893 h 7437032"/>
-              <a:gd name="csX2" fmla="*/ 5643837 w 5643837"/>
-              <a:gd name="csY2" fmla="*/ 369418 h 7437032"/>
-              <a:gd name="csX3" fmla="*/ 4177214 w 5643837"/>
-              <a:gd name="csY3" fmla="*/ 6996388 h 7437032"/>
-              <a:gd name="csX4" fmla="*/ 2448160 w 5643837"/>
-              <a:gd name="csY4" fmla="*/ 7230191 h 7437032"/>
-              <a:gd name="csX5" fmla="*/ 153940 w 5643837"/>
-              <a:gd name="csY5" fmla="*/ 7271408 h 7437032"/>
-              <a:gd name="csX6" fmla="*/ 397928 w 5643837"/>
-              <a:gd name="csY6" fmla="*/ 5932226 h 7437032"/>
-              <a:gd name="csX7" fmla="*/ 578489 w 5643837"/>
-              <a:gd name="csY7" fmla="*/ 3985947 h 7437032"/>
-              <a:gd name="csX8" fmla="*/ 369988 w 5643837"/>
-              <a:gd name="csY8" fmla="*/ 635372 h 7437032"/>
-              <a:gd name="csX0" fmla="*/ 369988 w 5643837"/>
-              <a:gd name="csY0" fmla="*/ 674792 h 7476452"/>
-              <a:gd name="csX1" fmla="*/ 4103232 w 5643837"/>
-              <a:gd name="csY1" fmla="*/ 705076 h 7476452"/>
-              <a:gd name="csX2" fmla="*/ 5643837 w 5643837"/>
-              <a:gd name="csY2" fmla="*/ 408838 h 7476452"/>
-              <a:gd name="csX3" fmla="*/ 4177214 w 5643837"/>
-              <a:gd name="csY3" fmla="*/ 7035808 h 7476452"/>
-              <a:gd name="csX4" fmla="*/ 2448160 w 5643837"/>
-              <a:gd name="csY4" fmla="*/ 7269611 h 7476452"/>
-              <a:gd name="csX5" fmla="*/ 153940 w 5643837"/>
-              <a:gd name="csY5" fmla="*/ 7310828 h 7476452"/>
-              <a:gd name="csX6" fmla="*/ 397928 w 5643837"/>
-              <a:gd name="csY6" fmla="*/ 5971646 h 7476452"/>
-              <a:gd name="csX7" fmla="*/ 578489 w 5643837"/>
-              <a:gd name="csY7" fmla="*/ 4025367 h 7476452"/>
-              <a:gd name="csX8" fmla="*/ 369988 w 5643837"/>
-              <a:gd name="csY8" fmla="*/ 674792 h 7476452"/>
-              <a:gd name="csX0" fmla="*/ 369988 w 5643837"/>
-              <a:gd name="csY0" fmla="*/ 725406 h 7527066"/>
-              <a:gd name="csX1" fmla="*/ 4103232 w 5643837"/>
-              <a:gd name="csY1" fmla="*/ 755690 h 7527066"/>
-              <a:gd name="csX2" fmla="*/ 5643837 w 5643837"/>
-              <a:gd name="csY2" fmla="*/ 459452 h 7527066"/>
-              <a:gd name="csX3" fmla="*/ 4177214 w 5643837"/>
-              <a:gd name="csY3" fmla="*/ 7086422 h 7527066"/>
-              <a:gd name="csX4" fmla="*/ 2448160 w 5643837"/>
-              <a:gd name="csY4" fmla="*/ 7320225 h 7527066"/>
-              <a:gd name="csX5" fmla="*/ 153940 w 5643837"/>
-              <a:gd name="csY5" fmla="*/ 7361442 h 7527066"/>
-              <a:gd name="csX6" fmla="*/ 397928 w 5643837"/>
-              <a:gd name="csY6" fmla="*/ 6022260 h 7527066"/>
-              <a:gd name="csX7" fmla="*/ 578489 w 5643837"/>
-              <a:gd name="csY7" fmla="*/ 4075981 h 7527066"/>
-              <a:gd name="csX8" fmla="*/ 369988 w 5643837"/>
-              <a:gd name="csY8" fmla="*/ 725406 h 7527066"/>
-              <a:gd name="csX0" fmla="*/ 369988 w 5643837"/>
-              <a:gd name="csY0" fmla="*/ 745998 h 7547658"/>
-              <a:gd name="csX1" fmla="*/ 4188053 w 5643837"/>
-              <a:gd name="csY1" fmla="*/ 694886 h 7547658"/>
-              <a:gd name="csX2" fmla="*/ 5643837 w 5643837"/>
-              <a:gd name="csY2" fmla="*/ 480044 h 7547658"/>
-              <a:gd name="csX3" fmla="*/ 4177214 w 5643837"/>
-              <a:gd name="csY3" fmla="*/ 7107014 h 7547658"/>
-              <a:gd name="csX4" fmla="*/ 2448160 w 5643837"/>
-              <a:gd name="csY4" fmla="*/ 7340817 h 7547658"/>
-              <a:gd name="csX5" fmla="*/ 153940 w 5643837"/>
-              <a:gd name="csY5" fmla="*/ 7382034 h 7547658"/>
-              <a:gd name="csX6" fmla="*/ 397928 w 5643837"/>
-              <a:gd name="csY6" fmla="*/ 6042852 h 7547658"/>
-              <a:gd name="csX7" fmla="*/ 578489 w 5643837"/>
-              <a:gd name="csY7" fmla="*/ 4096573 h 7547658"/>
-              <a:gd name="csX8" fmla="*/ 369988 w 5643837"/>
-              <a:gd name="csY8" fmla="*/ 745998 h 7547658"/>
-              <a:gd name="csX0" fmla="*/ 369988 w 5643837"/>
-              <a:gd name="csY0" fmla="*/ 707232 h 7508892"/>
-              <a:gd name="csX1" fmla="*/ 4183941 w 5643837"/>
-              <a:gd name="csY1" fmla="*/ 815255 h 7508892"/>
-              <a:gd name="csX2" fmla="*/ 5643837 w 5643837"/>
-              <a:gd name="csY2" fmla="*/ 441278 h 7508892"/>
-              <a:gd name="csX3" fmla="*/ 4177214 w 5643837"/>
-              <a:gd name="csY3" fmla="*/ 7068248 h 7508892"/>
-              <a:gd name="csX4" fmla="*/ 2448160 w 5643837"/>
-              <a:gd name="csY4" fmla="*/ 7302051 h 7508892"/>
-              <a:gd name="csX5" fmla="*/ 153940 w 5643837"/>
-              <a:gd name="csY5" fmla="*/ 7343268 h 7508892"/>
-              <a:gd name="csX6" fmla="*/ 397928 w 5643837"/>
-              <a:gd name="csY6" fmla="*/ 6004086 h 7508892"/>
-              <a:gd name="csX7" fmla="*/ 578489 w 5643837"/>
-              <a:gd name="csY7" fmla="*/ 4057807 h 7508892"/>
-              <a:gd name="csX8" fmla="*/ 369988 w 5643837"/>
-              <a:gd name="csY8" fmla="*/ 707232 h 7508892"/>
-              <a:gd name="csX0" fmla="*/ 369988 w 5643837"/>
-              <a:gd name="csY0" fmla="*/ 693143 h 7494803"/>
-              <a:gd name="csX1" fmla="*/ 4183941 w 5643837"/>
-              <a:gd name="csY1" fmla="*/ 801166 h 7494803"/>
-              <a:gd name="csX2" fmla="*/ 5643837 w 5643837"/>
-              <a:gd name="csY2" fmla="*/ 427189 h 7494803"/>
-              <a:gd name="csX3" fmla="*/ 4177214 w 5643837"/>
-              <a:gd name="csY3" fmla="*/ 7054159 h 7494803"/>
-              <a:gd name="csX4" fmla="*/ 2448160 w 5643837"/>
-              <a:gd name="csY4" fmla="*/ 7287962 h 7494803"/>
-              <a:gd name="csX5" fmla="*/ 153940 w 5643837"/>
-              <a:gd name="csY5" fmla="*/ 7329179 h 7494803"/>
-              <a:gd name="csX6" fmla="*/ 397928 w 5643837"/>
-              <a:gd name="csY6" fmla="*/ 5989997 h 7494803"/>
-              <a:gd name="csX7" fmla="*/ 578489 w 5643837"/>
-              <a:gd name="csY7" fmla="*/ 4043718 h 7494803"/>
-              <a:gd name="csX8" fmla="*/ 369988 w 5643837"/>
-              <a:gd name="csY8" fmla="*/ 693143 h 7494803"/>
-              <a:gd name="csX0" fmla="*/ 369988 w 5439083"/>
-              <a:gd name="csY0" fmla="*/ 231175 h 7032835"/>
-              <a:gd name="csX1" fmla="*/ 4183941 w 5439083"/>
-              <a:gd name="csY1" fmla="*/ 339198 h 7032835"/>
-              <a:gd name="csX2" fmla="*/ 5439083 w 5439083"/>
-              <a:gd name="csY2" fmla="*/ 729669 h 7032835"/>
-              <a:gd name="csX3" fmla="*/ 4177214 w 5439083"/>
-              <a:gd name="csY3" fmla="*/ 6592191 h 7032835"/>
-              <a:gd name="csX4" fmla="*/ 2448160 w 5439083"/>
-              <a:gd name="csY4" fmla="*/ 6825994 h 7032835"/>
-              <a:gd name="csX5" fmla="*/ 153940 w 5439083"/>
-              <a:gd name="csY5" fmla="*/ 6867211 h 7032835"/>
-              <a:gd name="csX6" fmla="*/ 397928 w 5439083"/>
-              <a:gd name="csY6" fmla="*/ 5528029 h 7032835"/>
-              <a:gd name="csX7" fmla="*/ 578489 w 5439083"/>
-              <a:gd name="csY7" fmla="*/ 3581750 h 7032835"/>
-              <a:gd name="csX8" fmla="*/ 369988 w 5439083"/>
-              <a:gd name="csY8" fmla="*/ 231175 h 7032835"/>
-              <a:gd name="csX0" fmla="*/ 369988 w 5439083"/>
-              <a:gd name="csY0" fmla="*/ 231175 h 7032835"/>
-              <a:gd name="csX1" fmla="*/ 4183941 w 5439083"/>
-              <a:gd name="csY1" fmla="*/ 339198 h 7032835"/>
-              <a:gd name="csX2" fmla="*/ 5439083 w 5439083"/>
-              <a:gd name="csY2" fmla="*/ 729669 h 7032835"/>
-              <a:gd name="csX3" fmla="*/ 4177214 w 5439083"/>
-              <a:gd name="csY3" fmla="*/ 6592191 h 7032835"/>
-              <a:gd name="csX4" fmla="*/ 2448160 w 5439083"/>
-              <a:gd name="csY4" fmla="*/ 6825994 h 7032835"/>
-              <a:gd name="csX5" fmla="*/ 153940 w 5439083"/>
-              <a:gd name="csY5" fmla="*/ 6867211 h 7032835"/>
-              <a:gd name="csX6" fmla="*/ 397928 w 5439083"/>
-              <a:gd name="csY6" fmla="*/ 5528029 h 7032835"/>
-              <a:gd name="csX7" fmla="*/ 578489 w 5439083"/>
-              <a:gd name="csY7" fmla="*/ 3581750 h 7032835"/>
-              <a:gd name="csX8" fmla="*/ 369988 w 5439083"/>
-              <a:gd name="csY8" fmla="*/ 231175 h 7032835"/>
-              <a:gd name="csX0" fmla="*/ 369988 w 5439275"/>
-              <a:gd name="csY0" fmla="*/ 231175 h 7032835"/>
-              <a:gd name="csX1" fmla="*/ 4183941 w 5439275"/>
-              <a:gd name="csY1" fmla="*/ 339198 h 7032835"/>
-              <a:gd name="csX2" fmla="*/ 5439083 w 5439275"/>
-              <a:gd name="csY2" fmla="*/ 729669 h 7032835"/>
-              <a:gd name="csX3" fmla="*/ 4177214 w 5439275"/>
-              <a:gd name="csY3" fmla="*/ 6592191 h 7032835"/>
-              <a:gd name="csX4" fmla="*/ 2448160 w 5439275"/>
-              <a:gd name="csY4" fmla="*/ 6825994 h 7032835"/>
-              <a:gd name="csX5" fmla="*/ 153940 w 5439275"/>
-              <a:gd name="csY5" fmla="*/ 6867211 h 7032835"/>
-              <a:gd name="csX6" fmla="*/ 397928 w 5439275"/>
-              <a:gd name="csY6" fmla="*/ 5528029 h 7032835"/>
-              <a:gd name="csX7" fmla="*/ 578489 w 5439275"/>
-              <a:gd name="csY7" fmla="*/ 3581750 h 7032835"/>
-              <a:gd name="csX8" fmla="*/ 369988 w 5439275"/>
-              <a:gd name="csY8" fmla="*/ 231175 h 7032835"/>
-              <a:gd name="csX0" fmla="*/ 369988 w 5345705"/>
-              <a:gd name="csY0" fmla="*/ 228260 h 7029920"/>
-              <a:gd name="csX1" fmla="*/ 4183941 w 5345705"/>
-              <a:gd name="csY1" fmla="*/ 336283 h 7029920"/>
-              <a:gd name="csX2" fmla="*/ 5345497 w 5345705"/>
-              <a:gd name="csY2" fmla="*/ 640630 h 7029920"/>
-              <a:gd name="csX3" fmla="*/ 4177214 w 5345705"/>
-              <a:gd name="csY3" fmla="*/ 6589276 h 7029920"/>
-              <a:gd name="csX4" fmla="*/ 2448160 w 5345705"/>
-              <a:gd name="csY4" fmla="*/ 6823079 h 7029920"/>
-              <a:gd name="csX5" fmla="*/ 153940 w 5345705"/>
-              <a:gd name="csY5" fmla="*/ 6864296 h 7029920"/>
-              <a:gd name="csX6" fmla="*/ 397928 w 5345705"/>
-              <a:gd name="csY6" fmla="*/ 5525114 h 7029920"/>
-              <a:gd name="csX7" fmla="*/ 578489 w 5345705"/>
-              <a:gd name="csY7" fmla="*/ 3578835 h 7029920"/>
-              <a:gd name="csX8" fmla="*/ 369988 w 5345705"/>
-              <a:gd name="csY8" fmla="*/ 228260 h 7029920"/>
-              <a:gd name="csX0" fmla="*/ 369988 w 5358243"/>
-              <a:gd name="csY0" fmla="*/ 228260 h 7029920"/>
-              <a:gd name="csX1" fmla="*/ 4183941 w 5358243"/>
-              <a:gd name="csY1" fmla="*/ 336283 h 7029920"/>
-              <a:gd name="csX2" fmla="*/ 5345497 w 5358243"/>
-              <a:gd name="csY2" fmla="*/ 640630 h 7029920"/>
-              <a:gd name="csX3" fmla="*/ 4177214 w 5358243"/>
-              <a:gd name="csY3" fmla="*/ 6589276 h 7029920"/>
-              <a:gd name="csX4" fmla="*/ 2448160 w 5358243"/>
-              <a:gd name="csY4" fmla="*/ 6823079 h 7029920"/>
-              <a:gd name="csX5" fmla="*/ 153940 w 5358243"/>
-              <a:gd name="csY5" fmla="*/ 6864296 h 7029920"/>
-              <a:gd name="csX6" fmla="*/ 397928 w 5358243"/>
-              <a:gd name="csY6" fmla="*/ 5525114 h 7029920"/>
-              <a:gd name="csX7" fmla="*/ 578489 w 5358243"/>
-              <a:gd name="csY7" fmla="*/ 3578835 h 7029920"/>
-              <a:gd name="csX8" fmla="*/ 369988 w 5358243"/>
-              <a:gd name="csY8" fmla="*/ 228260 h 7029920"/>
-              <a:gd name="csX0" fmla="*/ 369988 w 5358243"/>
-              <a:gd name="csY0" fmla="*/ 228260 h 7029920"/>
-              <a:gd name="csX1" fmla="*/ 4183941 w 5358243"/>
-              <a:gd name="csY1" fmla="*/ 336283 h 7029920"/>
-              <a:gd name="csX2" fmla="*/ 5345497 w 5358243"/>
-              <a:gd name="csY2" fmla="*/ 640630 h 7029920"/>
-              <a:gd name="csX3" fmla="*/ 4177214 w 5358243"/>
-              <a:gd name="csY3" fmla="*/ 6589276 h 7029920"/>
-              <a:gd name="csX4" fmla="*/ 2448160 w 5358243"/>
-              <a:gd name="csY4" fmla="*/ 6823079 h 7029920"/>
-              <a:gd name="csX5" fmla="*/ 153940 w 5358243"/>
-              <a:gd name="csY5" fmla="*/ 6864296 h 7029920"/>
-              <a:gd name="csX6" fmla="*/ 397928 w 5358243"/>
-              <a:gd name="csY6" fmla="*/ 5525114 h 7029920"/>
-              <a:gd name="csX7" fmla="*/ 578489 w 5358243"/>
-              <a:gd name="csY7" fmla="*/ 3578835 h 7029920"/>
-              <a:gd name="csX8" fmla="*/ 369988 w 5358243"/>
-              <a:gd name="csY8" fmla="*/ 228260 h 7029920"/>
-              <a:gd name="csX0" fmla="*/ 369988 w 5352167"/>
-              <a:gd name="csY0" fmla="*/ 228260 h 7029920"/>
-              <a:gd name="csX1" fmla="*/ 4183941 w 5352167"/>
-              <a:gd name="csY1" fmla="*/ 336283 h 7029920"/>
-              <a:gd name="csX2" fmla="*/ 5345497 w 5352167"/>
-              <a:gd name="csY2" fmla="*/ 640630 h 7029920"/>
-              <a:gd name="csX3" fmla="*/ 4177214 w 5352167"/>
-              <a:gd name="csY3" fmla="*/ 6589276 h 7029920"/>
-              <a:gd name="csX4" fmla="*/ 2448160 w 5352167"/>
-              <a:gd name="csY4" fmla="*/ 6823079 h 7029920"/>
-              <a:gd name="csX5" fmla="*/ 153940 w 5352167"/>
-              <a:gd name="csY5" fmla="*/ 6864296 h 7029920"/>
-              <a:gd name="csX6" fmla="*/ 397928 w 5352167"/>
-              <a:gd name="csY6" fmla="*/ 5525114 h 7029920"/>
-              <a:gd name="csX7" fmla="*/ 578489 w 5352167"/>
-              <a:gd name="csY7" fmla="*/ 3578835 h 7029920"/>
-              <a:gd name="csX8" fmla="*/ 369988 w 5352167"/>
-              <a:gd name="csY8" fmla="*/ 228260 h 7029920"/>
-              <a:gd name="csX0" fmla="*/ 369988 w 5300672"/>
-              <a:gd name="csY0" fmla="*/ 228003 h 7029663"/>
-              <a:gd name="csX1" fmla="*/ 4183941 w 5300672"/>
-              <a:gd name="csY1" fmla="*/ 336026 h 7029663"/>
-              <a:gd name="csX2" fmla="*/ 5293712 w 5300672"/>
-              <a:gd name="csY2" fmla="*/ 632699 h 7029663"/>
-              <a:gd name="csX3" fmla="*/ 4177214 w 5300672"/>
-              <a:gd name="csY3" fmla="*/ 6589019 h 7029663"/>
-              <a:gd name="csX4" fmla="*/ 2448160 w 5300672"/>
-              <a:gd name="csY4" fmla="*/ 6822822 h 7029663"/>
-              <a:gd name="csX5" fmla="*/ 153940 w 5300672"/>
-              <a:gd name="csY5" fmla="*/ 6864039 h 7029663"/>
-              <a:gd name="csX6" fmla="*/ 397928 w 5300672"/>
-              <a:gd name="csY6" fmla="*/ 5524857 h 7029663"/>
-              <a:gd name="csX7" fmla="*/ 578489 w 5300672"/>
-              <a:gd name="csY7" fmla="*/ 3578578 h 7029663"/>
-              <a:gd name="csX8" fmla="*/ 369988 w 5300672"/>
-              <a:gd name="csY8" fmla="*/ 228003 h 7029663"/>
-              <a:gd name="csX0" fmla="*/ 369988 w 5300672"/>
-              <a:gd name="csY0" fmla="*/ 217406 h 7019066"/>
-              <a:gd name="csX1" fmla="*/ 4363942 w 5300672"/>
-              <a:gd name="csY1" fmla="*/ 361138 h 7019066"/>
-              <a:gd name="csX2" fmla="*/ 5293712 w 5300672"/>
-              <a:gd name="csY2" fmla="*/ 622102 h 7019066"/>
-              <a:gd name="csX3" fmla="*/ 4177214 w 5300672"/>
-              <a:gd name="csY3" fmla="*/ 6578422 h 7019066"/>
-              <a:gd name="csX4" fmla="*/ 2448160 w 5300672"/>
-              <a:gd name="csY4" fmla="*/ 6812225 h 7019066"/>
-              <a:gd name="csX5" fmla="*/ 153940 w 5300672"/>
-              <a:gd name="csY5" fmla="*/ 6853442 h 7019066"/>
-              <a:gd name="csX6" fmla="*/ 397928 w 5300672"/>
-              <a:gd name="csY6" fmla="*/ 5514260 h 7019066"/>
-              <a:gd name="csX7" fmla="*/ 578489 w 5300672"/>
-              <a:gd name="csY7" fmla="*/ 3567981 h 7019066"/>
-              <a:gd name="csX8" fmla="*/ 369988 w 5300672"/>
-              <a:gd name="csY8" fmla="*/ 217406 h 7019066"/>
-              <a:gd name="csX0" fmla="*/ 369988 w 5300672"/>
-              <a:gd name="csY0" fmla="*/ 214248 h 7015908"/>
-              <a:gd name="csX1" fmla="*/ 4363942 w 5300672"/>
-              <a:gd name="csY1" fmla="*/ 357980 h 7015908"/>
-              <a:gd name="csX2" fmla="*/ 5293712 w 5300672"/>
-              <a:gd name="csY2" fmla="*/ 618944 h 7015908"/>
-              <a:gd name="csX3" fmla="*/ 4177214 w 5300672"/>
-              <a:gd name="csY3" fmla="*/ 6575264 h 7015908"/>
-              <a:gd name="csX4" fmla="*/ 2448160 w 5300672"/>
-              <a:gd name="csY4" fmla="*/ 6809067 h 7015908"/>
-              <a:gd name="csX5" fmla="*/ 153940 w 5300672"/>
-              <a:gd name="csY5" fmla="*/ 6850284 h 7015908"/>
-              <a:gd name="csX6" fmla="*/ 397928 w 5300672"/>
-              <a:gd name="csY6" fmla="*/ 5511102 h 7015908"/>
-              <a:gd name="csX7" fmla="*/ 578489 w 5300672"/>
-              <a:gd name="csY7" fmla="*/ 3564823 h 7015908"/>
-              <a:gd name="csX8" fmla="*/ 369988 w 5300672"/>
-              <a:gd name="csY8" fmla="*/ 214248 h 7015908"/>
-              <a:gd name="csX0" fmla="*/ 369988 w 5257260"/>
-              <a:gd name="csY0" fmla="*/ 227477 h 7029137"/>
-              <a:gd name="csX1" fmla="*/ 4363942 w 5257260"/>
-              <a:gd name="csY1" fmla="*/ 371209 h 7029137"/>
-              <a:gd name="csX2" fmla="*/ 5250036 w 5257260"/>
-              <a:gd name="csY2" fmla="*/ 941811 h 7029137"/>
-              <a:gd name="csX3" fmla="*/ 4177214 w 5257260"/>
-              <a:gd name="csY3" fmla="*/ 6588493 h 7029137"/>
-              <a:gd name="csX4" fmla="*/ 2448160 w 5257260"/>
-              <a:gd name="csY4" fmla="*/ 6822296 h 7029137"/>
-              <a:gd name="csX5" fmla="*/ 153940 w 5257260"/>
-              <a:gd name="csY5" fmla="*/ 6863513 h 7029137"/>
-              <a:gd name="csX6" fmla="*/ 397928 w 5257260"/>
-              <a:gd name="csY6" fmla="*/ 5524331 h 7029137"/>
-              <a:gd name="csX7" fmla="*/ 578489 w 5257260"/>
-              <a:gd name="csY7" fmla="*/ 3578052 h 7029137"/>
-              <a:gd name="csX8" fmla="*/ 369988 w 5257260"/>
-              <a:gd name="csY8" fmla="*/ 227477 h 7029137"/>
-              <a:gd name="csX0" fmla="*/ 369988 w 5257260"/>
-              <a:gd name="csY0" fmla="*/ 227477 h 7029137"/>
-              <a:gd name="csX1" fmla="*/ 4363942 w 5257260"/>
-              <a:gd name="csY1" fmla="*/ 371209 h 7029137"/>
-              <a:gd name="csX2" fmla="*/ 5250036 w 5257260"/>
-              <a:gd name="csY2" fmla="*/ 941811 h 7029137"/>
-              <a:gd name="csX3" fmla="*/ 4177214 w 5257260"/>
-              <a:gd name="csY3" fmla="*/ 6588493 h 7029137"/>
-              <a:gd name="csX4" fmla="*/ 2448160 w 5257260"/>
-              <a:gd name="csY4" fmla="*/ 6822296 h 7029137"/>
-              <a:gd name="csX5" fmla="*/ 153940 w 5257260"/>
-              <a:gd name="csY5" fmla="*/ 6863513 h 7029137"/>
-              <a:gd name="csX6" fmla="*/ 397928 w 5257260"/>
-              <a:gd name="csY6" fmla="*/ 5524331 h 7029137"/>
-              <a:gd name="csX7" fmla="*/ 578489 w 5257260"/>
-              <a:gd name="csY7" fmla="*/ 3578052 h 7029137"/>
-              <a:gd name="csX8" fmla="*/ 369988 w 5257260"/>
-              <a:gd name="csY8" fmla="*/ 227477 h 7029137"/>
-              <a:gd name="csX0" fmla="*/ 369988 w 5251399"/>
-              <a:gd name="csY0" fmla="*/ 227477 h 7029137"/>
-              <a:gd name="csX1" fmla="*/ 4363942 w 5251399"/>
-              <a:gd name="csY1" fmla="*/ 371209 h 7029137"/>
-              <a:gd name="csX2" fmla="*/ 5250036 w 5251399"/>
-              <a:gd name="csY2" fmla="*/ 941811 h 7029137"/>
-              <a:gd name="csX3" fmla="*/ 4177214 w 5251399"/>
-              <a:gd name="csY3" fmla="*/ 6588493 h 7029137"/>
-              <a:gd name="csX4" fmla="*/ 2448160 w 5251399"/>
-              <a:gd name="csY4" fmla="*/ 6822296 h 7029137"/>
-              <a:gd name="csX5" fmla="*/ 153940 w 5251399"/>
-              <a:gd name="csY5" fmla="*/ 6863513 h 7029137"/>
-              <a:gd name="csX6" fmla="*/ 397928 w 5251399"/>
-              <a:gd name="csY6" fmla="*/ 5524331 h 7029137"/>
-              <a:gd name="csX7" fmla="*/ 578489 w 5251399"/>
-              <a:gd name="csY7" fmla="*/ 3578052 h 7029137"/>
-              <a:gd name="csX8" fmla="*/ 369988 w 5251399"/>
-              <a:gd name="csY8" fmla="*/ 227477 h 7029137"/>
-              <a:gd name="csX0" fmla="*/ 369988 w 5251586"/>
-              <a:gd name="csY0" fmla="*/ 227477 h 7179173"/>
-              <a:gd name="csX1" fmla="*/ 4363942 w 5251586"/>
-              <a:gd name="csY1" fmla="*/ 371209 h 7179173"/>
-              <a:gd name="csX2" fmla="*/ 5250036 w 5251586"/>
-              <a:gd name="csY2" fmla="*/ 941811 h 7179173"/>
-              <a:gd name="csX3" fmla="*/ 4302766 w 5251586"/>
-              <a:gd name="csY3" fmla="*/ 6774460 h 7179173"/>
-              <a:gd name="csX4" fmla="*/ 2448160 w 5251586"/>
-              <a:gd name="csY4" fmla="*/ 6822296 h 7179173"/>
-              <a:gd name="csX5" fmla="*/ 153940 w 5251586"/>
-              <a:gd name="csY5" fmla="*/ 6863513 h 7179173"/>
-              <a:gd name="csX6" fmla="*/ 397928 w 5251586"/>
-              <a:gd name="csY6" fmla="*/ 5524331 h 7179173"/>
-              <a:gd name="csX7" fmla="*/ 578489 w 5251586"/>
-              <a:gd name="csY7" fmla="*/ 3578052 h 7179173"/>
-              <a:gd name="csX8" fmla="*/ 369988 w 5251586"/>
-              <a:gd name="csY8" fmla="*/ 227477 h 7179173"/>
-              <a:gd name="csX0" fmla="*/ 369988 w 5251355"/>
-              <a:gd name="csY0" fmla="*/ 227477 h 7277153"/>
-              <a:gd name="csX1" fmla="*/ 4363942 w 5251355"/>
-              <a:gd name="csY1" fmla="*/ 371209 h 7277153"/>
-              <a:gd name="csX2" fmla="*/ 5250036 w 5251355"/>
-              <a:gd name="csY2" fmla="*/ 941811 h 7277153"/>
-              <a:gd name="csX3" fmla="*/ 4142603 w 5251355"/>
-              <a:gd name="csY3" fmla="*/ 6899646 h 7277153"/>
-              <a:gd name="csX4" fmla="*/ 2448160 w 5251355"/>
-              <a:gd name="csY4" fmla="*/ 6822296 h 7277153"/>
-              <a:gd name="csX5" fmla="*/ 153940 w 5251355"/>
-              <a:gd name="csY5" fmla="*/ 6863513 h 7277153"/>
-              <a:gd name="csX6" fmla="*/ 397928 w 5251355"/>
-              <a:gd name="csY6" fmla="*/ 5524331 h 7277153"/>
-              <a:gd name="csX7" fmla="*/ 578489 w 5251355"/>
-              <a:gd name="csY7" fmla="*/ 3578052 h 7277153"/>
-              <a:gd name="csX8" fmla="*/ 369988 w 5251355"/>
-              <a:gd name="csY8" fmla="*/ 227477 h 7277153"/>
-              <a:gd name="csX0" fmla="*/ 367016 w 5248383"/>
-              <a:gd name="csY0" fmla="*/ 227477 h 7304567"/>
-              <a:gd name="csX1" fmla="*/ 4360970 w 5248383"/>
-              <a:gd name="csY1" fmla="*/ 371209 h 7304567"/>
-              <a:gd name="csX2" fmla="*/ 5247064 w 5248383"/>
-              <a:gd name="csY2" fmla="*/ 941811 h 7304567"/>
-              <a:gd name="csX3" fmla="*/ 4139631 w 5248383"/>
-              <a:gd name="csY3" fmla="*/ 6899646 h 7304567"/>
-              <a:gd name="csX4" fmla="*/ 2405023 w 5248383"/>
-              <a:gd name="csY4" fmla="*/ 6930473 h 7304567"/>
-              <a:gd name="csX5" fmla="*/ 150968 w 5248383"/>
-              <a:gd name="csY5" fmla="*/ 6863513 h 7304567"/>
-              <a:gd name="csX6" fmla="*/ 394956 w 5248383"/>
-              <a:gd name="csY6" fmla="*/ 5524331 h 7304567"/>
-              <a:gd name="csX7" fmla="*/ 575517 w 5248383"/>
-              <a:gd name="csY7" fmla="*/ 3578052 h 7304567"/>
-              <a:gd name="csX8" fmla="*/ 367016 w 5248383"/>
-              <a:gd name="csY8" fmla="*/ 227477 h 7304567"/>
-              <a:gd name="csX0" fmla="*/ 377903 w 5259270"/>
-              <a:gd name="csY0" fmla="*/ 227477 h 7300614"/>
-              <a:gd name="csX1" fmla="*/ 4371857 w 5259270"/>
-              <a:gd name="csY1" fmla="*/ 371209 h 7300614"/>
-              <a:gd name="csX2" fmla="*/ 5257951 w 5259270"/>
-              <a:gd name="csY2" fmla="*/ 941811 h 7300614"/>
-              <a:gd name="csX3" fmla="*/ 4150518 w 5259270"/>
-              <a:gd name="csY3" fmla="*/ 6899646 h 7300614"/>
-              <a:gd name="csX4" fmla="*/ 2415910 w 5259270"/>
-              <a:gd name="csY4" fmla="*/ 6930473 h 7300614"/>
-              <a:gd name="csX5" fmla="*/ 147573 w 5259270"/>
-              <a:gd name="csY5" fmla="*/ 6966817 h 7300614"/>
-              <a:gd name="csX6" fmla="*/ 405843 w 5259270"/>
-              <a:gd name="csY6" fmla="*/ 5524331 h 7300614"/>
-              <a:gd name="csX7" fmla="*/ 586404 w 5259270"/>
-              <a:gd name="csY7" fmla="*/ 3578052 h 7300614"/>
-              <a:gd name="csX8" fmla="*/ 377903 w 5259270"/>
-              <a:gd name="csY8" fmla="*/ 227477 h 7300614"/>
-              <a:gd name="csX0" fmla="*/ 377903 w 5259389"/>
-              <a:gd name="csY0" fmla="*/ 227477 h 7465170"/>
-              <a:gd name="csX1" fmla="*/ 4371857 w 5259389"/>
-              <a:gd name="csY1" fmla="*/ 371209 h 7465170"/>
-              <a:gd name="csX2" fmla="*/ 5257951 w 5259389"/>
-              <a:gd name="csY2" fmla="*/ 941811 h 7465170"/>
-              <a:gd name="csX3" fmla="*/ 4239573 w 5259389"/>
-              <a:gd name="csY3" fmla="*/ 7106459 h 7465170"/>
-              <a:gd name="csX4" fmla="*/ 2415910 w 5259389"/>
-              <a:gd name="csY4" fmla="*/ 6930473 h 7465170"/>
-              <a:gd name="csX5" fmla="*/ 147573 w 5259389"/>
-              <a:gd name="csY5" fmla="*/ 6966817 h 7465170"/>
-              <a:gd name="csX6" fmla="*/ 405843 w 5259389"/>
-              <a:gd name="csY6" fmla="*/ 5524331 h 7465170"/>
-              <a:gd name="csX7" fmla="*/ 586404 w 5259389"/>
-              <a:gd name="csY7" fmla="*/ 3578052 h 7465170"/>
-              <a:gd name="csX8" fmla="*/ 377903 w 5259389"/>
-              <a:gd name="csY8" fmla="*/ 227477 h 7465170"/>
-              <a:gd name="csX0" fmla="*/ 363205 w 5244691"/>
-              <a:gd name="csY0" fmla="*/ 227477 h 7503711"/>
-              <a:gd name="csX1" fmla="*/ 4357159 w 5244691"/>
-              <a:gd name="csY1" fmla="*/ 371209 h 7503711"/>
-              <a:gd name="csX2" fmla="*/ 5243253 w 5244691"/>
-              <a:gd name="csY2" fmla="*/ 941811 h 7503711"/>
-              <a:gd name="csX3" fmla="*/ 4224875 w 5244691"/>
-              <a:gd name="csY3" fmla="*/ 7106459 h 7503711"/>
-              <a:gd name="csX4" fmla="*/ 2202171 w 5244691"/>
-              <a:gd name="csY4" fmla="*/ 7093723 h 7503711"/>
-              <a:gd name="csX5" fmla="*/ 132875 w 5244691"/>
-              <a:gd name="csY5" fmla="*/ 6966817 h 7503711"/>
-              <a:gd name="csX6" fmla="*/ 391145 w 5244691"/>
-              <a:gd name="csY6" fmla="*/ 5524331 h 7503711"/>
-              <a:gd name="csX7" fmla="*/ 571706 w 5244691"/>
-              <a:gd name="csY7" fmla="*/ 3578052 h 7503711"/>
-              <a:gd name="csX8" fmla="*/ 363205 w 5244691"/>
-              <a:gd name="csY8" fmla="*/ 227477 h 7503711"/>
-            </a:gdLst>
-            <a:ahLst/>
-            <a:cxnLst>
-              <a:cxn ang="0">
-                <a:pos x="csX0" y="csY0"/>
-              </a:cxn>
-              <a:cxn ang="0">
-                <a:pos x="csX1" y="csY1"/>
-              </a:cxn>
-              <a:cxn ang="0">
-                <a:pos x="csX2" y="csY2"/>
-              </a:cxn>
-              <a:cxn ang="0">
-                <a:pos x="csX3" y="csY3"/>
-              </a:cxn>
-              <a:cxn ang="0">
-                <a:pos x="csX4" y="csY4"/>
-              </a:cxn>
-              <a:cxn ang="0">
-                <a:pos x="csX5" y="csY5"/>
-              </a:cxn>
-              <a:cxn ang="0">
-                <a:pos x="csX6" y="csY6"/>
-              </a:cxn>
-              <a:cxn ang="0">
-                <a:pos x="csX7" y="csY7"/>
-              </a:cxn>
-              <a:cxn ang="0">
-                <a:pos x="csX8" y="csY8"/>
-              </a:cxn>
-            </a:cxnLst>
-            <a:rect l="l" t="t" r="r" b="b"/>
-            <a:pathLst>
-              <a:path w="5244691" h="7503711">
-                <a:moveTo>
-                  <a:pt x="363205" y="227477"/>
-                </a:moveTo>
-                <a:cubicBezTo>
-                  <a:pt x="994114" y="-306997"/>
-                  <a:pt x="3543818" y="252153"/>
-                  <a:pt x="4357159" y="371209"/>
-                </a:cubicBezTo>
-                <a:cubicBezTo>
-                  <a:pt x="5170500" y="490265"/>
-                  <a:pt x="5157221" y="622415"/>
-                  <a:pt x="5243253" y="941811"/>
-                </a:cubicBezTo>
-                <a:cubicBezTo>
-                  <a:pt x="5286803" y="1205617"/>
-                  <a:pt x="4327945" y="6733492"/>
-                  <a:pt x="4224875" y="7106459"/>
-                </a:cubicBezTo>
-                <a:cubicBezTo>
-                  <a:pt x="3782941" y="7996062"/>
-                  <a:pt x="2884171" y="7116997"/>
-                  <a:pt x="2202171" y="7093723"/>
-                </a:cubicBezTo>
-                <a:cubicBezTo>
-                  <a:pt x="1520171" y="7070449"/>
-                  <a:pt x="434713" y="7228382"/>
-                  <a:pt x="132875" y="6966817"/>
-                </a:cubicBezTo>
-                <a:cubicBezTo>
-                  <a:pt x="-168963" y="6705252"/>
-                  <a:pt x="98091" y="5818557"/>
-                  <a:pt x="391145" y="5524331"/>
-                </a:cubicBezTo>
-                <a:cubicBezTo>
-                  <a:pt x="596098" y="5034644"/>
-                  <a:pt x="616422" y="4460717"/>
-                  <a:pt x="571706" y="3578052"/>
-                </a:cubicBezTo>
-                <a:cubicBezTo>
-                  <a:pt x="415494" y="2585958"/>
-                  <a:pt x="-267704" y="761951"/>
-                  <a:pt x="363205" y="227477"/>
-                </a:cubicBezTo>
-                <a:close/>
-              </a:path>
-            </a:pathLst>
-          </a:custGeom>
+          </a:prstGeom>
           <a:solidFill>
-            <a:schemeClr val="accent5">
-              <a:lumMod val="20000"/>
-              <a:lumOff val="80000"/>
-            </a:schemeClr>
+            <a:srgbClr val="E4F6DE"/>
           </a:solidFill>
           <a:ln w="28575">
             <a:noFill/>
@@ -6113,498 +3748,26 @@
       </p:sp>
       <p:sp>
         <p:nvSpPr>
-          <p:cNvPr id="57" name="Oval 29">
+          <p:cNvPr id="10" name="Oval 9">
             <a:extLst>
               <a:ext uri="{FF2B5EF4-FFF2-40B4-BE49-F238E27FC236}">
-                <a16:creationId xmlns:a16="http://schemas.microsoft.com/office/drawing/2014/main" id="{52C673DC-6075-A1DB-A17D-97DDDC88F6C6}"/>
+                <a16:creationId xmlns:a16="http://schemas.microsoft.com/office/drawing/2014/main" id="{60E99BB7-6ADD-2CA6-D412-260DD9E0B6F7}"/>
               </a:ext>
             </a:extLst>
           </p:cNvPr>
           <p:cNvSpPr/>
           <p:nvPr/>
         </p:nvSpPr>
-        <p:spPr bwMode="auto">
-          <a:xfrm rot="15834999">
-            <a:off x="6605165" y="850255"/>
-            <a:ext cx="5342483" cy="5460779"/>
+        <p:spPr>
+          <a:xfrm rot="20926109">
+            <a:off x="421202" y="945579"/>
+            <a:ext cx="6369193" cy="5883392"/>
           </a:xfrm>
-          <a:custGeom>
+          <a:prstGeom prst="ellipse">
             <a:avLst/>
-            <a:gdLst>
-              <a:gd name="csX0" fmla="*/ 0 w 5678600"/>
-              <a:gd name="csY0" fmla="*/ 3658973 h 7317945"/>
-              <a:gd name="csX1" fmla="*/ 2839300 w 5678600"/>
-              <a:gd name="csY1" fmla="*/ 0 h 7317945"/>
-              <a:gd name="csX2" fmla="*/ 5678600 w 5678600"/>
-              <a:gd name="csY2" fmla="*/ 3658973 h 7317945"/>
-              <a:gd name="csX3" fmla="*/ 2839300 w 5678600"/>
-              <a:gd name="csY3" fmla="*/ 7317946 h 7317945"/>
-              <a:gd name="csX4" fmla="*/ 0 w 5678600"/>
-              <a:gd name="csY4" fmla="*/ 3658973 h 7317945"/>
-              <a:gd name="csX0" fmla="*/ 0 w 5127434"/>
-              <a:gd name="csY0" fmla="*/ 3659351 h 7318665"/>
-              <a:gd name="csX1" fmla="*/ 2839300 w 5127434"/>
-              <a:gd name="csY1" fmla="*/ 378 h 7318665"/>
-              <a:gd name="csX2" fmla="*/ 5127434 w 5127434"/>
-              <a:gd name="csY2" fmla="*/ 3492962 h 7318665"/>
-              <a:gd name="csX3" fmla="*/ 2839300 w 5127434"/>
-              <a:gd name="csY3" fmla="*/ 7318324 h 7318665"/>
-              <a:gd name="csX4" fmla="*/ 0 w 5127434"/>
-              <a:gd name="csY4" fmla="*/ 3659351 h 7318665"/>
-              <a:gd name="csX0" fmla="*/ 0 w 5637665"/>
-              <a:gd name="csY0" fmla="*/ 3659309 h 7318623"/>
-              <a:gd name="csX1" fmla="*/ 2839300 w 5637665"/>
-              <a:gd name="csY1" fmla="*/ 336 h 7318623"/>
-              <a:gd name="csX2" fmla="*/ 5127434 w 5637665"/>
-              <a:gd name="csY2" fmla="*/ 3492920 h 7318623"/>
-              <a:gd name="csX3" fmla="*/ 2839300 w 5637665"/>
-              <a:gd name="csY3" fmla="*/ 7318282 h 7318623"/>
-              <a:gd name="csX4" fmla="*/ 0 w 5637665"/>
-              <a:gd name="csY4" fmla="*/ 3659309 h 7318623"/>
-              <a:gd name="csX0" fmla="*/ 0 w 5637665"/>
-              <a:gd name="csY0" fmla="*/ 3659309 h 7318623"/>
-              <a:gd name="csX1" fmla="*/ 2839300 w 5637665"/>
-              <a:gd name="csY1" fmla="*/ 336 h 7318623"/>
-              <a:gd name="csX2" fmla="*/ 5127434 w 5637665"/>
-              <a:gd name="csY2" fmla="*/ 3492920 h 7318623"/>
-              <a:gd name="csX3" fmla="*/ 2839300 w 5637665"/>
-              <a:gd name="csY3" fmla="*/ 7318282 h 7318623"/>
-              <a:gd name="csX4" fmla="*/ 0 w 5637665"/>
-              <a:gd name="csY4" fmla="*/ 3659309 h 7318623"/>
-              <a:gd name="csX0" fmla="*/ 0 w 5556500"/>
-              <a:gd name="csY0" fmla="*/ 3659563 h 7318877"/>
-              <a:gd name="csX1" fmla="*/ 2839300 w 5556500"/>
-              <a:gd name="csY1" fmla="*/ 590 h 7318877"/>
-              <a:gd name="csX2" fmla="*/ 5127434 w 5556500"/>
-              <a:gd name="csY2" fmla="*/ 3493174 h 7318877"/>
-              <a:gd name="csX3" fmla="*/ 2839300 w 5556500"/>
-              <a:gd name="csY3" fmla="*/ 7318536 h 7318877"/>
-              <a:gd name="csX4" fmla="*/ 0 w 5556500"/>
-              <a:gd name="csY4" fmla="*/ 3659563 h 7318877"/>
-              <a:gd name="csX0" fmla="*/ 43 w 5563315"/>
-              <a:gd name="csY0" fmla="*/ 3308805 h 6968004"/>
-              <a:gd name="csX1" fmla="*/ 2903994 w 5563315"/>
-              <a:gd name="csY1" fmla="*/ 913 h 6968004"/>
-              <a:gd name="csX2" fmla="*/ 5127477 w 5563315"/>
-              <a:gd name="csY2" fmla="*/ 3142416 h 6968004"/>
-              <a:gd name="csX3" fmla="*/ 2839343 w 5563315"/>
-              <a:gd name="csY3" fmla="*/ 6967778 h 6968004"/>
-              <a:gd name="csX4" fmla="*/ 43 w 5563315"/>
-              <a:gd name="csY4" fmla="*/ 3308805 h 6968004"/>
-              <a:gd name="csX0" fmla="*/ 60 w 4894157"/>
-              <a:gd name="csY0" fmla="*/ 1630203 h 7043433"/>
-              <a:gd name="csX1" fmla="*/ 2245373 w 4894157"/>
-              <a:gd name="csY1" fmla="*/ 55990 h 7043433"/>
-              <a:gd name="csX2" fmla="*/ 4468856 w 4894157"/>
-              <a:gd name="csY2" fmla="*/ 3197493 h 7043433"/>
-              <a:gd name="csX3" fmla="*/ 2180722 w 4894157"/>
-              <a:gd name="csY3" fmla="*/ 7022855 h 7043433"/>
-              <a:gd name="csX4" fmla="*/ 60 w 4894157"/>
-              <a:gd name="csY4" fmla="*/ 1630203 h 7043433"/>
-              <a:gd name="csX0" fmla="*/ 120413 w 5014510"/>
-              <a:gd name="csY0" fmla="*/ 1631920 h 7230796"/>
-              <a:gd name="csX1" fmla="*/ 2365726 w 5014510"/>
-              <a:gd name="csY1" fmla="*/ 57707 h 7230796"/>
-              <a:gd name="csX2" fmla="*/ 4589209 w 5014510"/>
-              <a:gd name="csY2" fmla="*/ 3199210 h 7230796"/>
-              <a:gd name="csX3" fmla="*/ 760880 w 5014510"/>
-              <a:gd name="csY3" fmla="*/ 7211640 h 7230796"/>
-              <a:gd name="csX4" fmla="*/ 120413 w 5014510"/>
-              <a:gd name="csY4" fmla="*/ 1631920 h 7230796"/>
-              <a:gd name="csX0" fmla="*/ 346956 w 5241053"/>
-              <a:gd name="csY0" fmla="*/ 1631920 h 7259305"/>
-              <a:gd name="csX1" fmla="*/ 2592269 w 5241053"/>
-              <a:gd name="csY1" fmla="*/ 57707 h 7259305"/>
-              <a:gd name="csX2" fmla="*/ 4815752 w 5241053"/>
-              <a:gd name="csY2" fmla="*/ 3199210 h 7259305"/>
-              <a:gd name="csX3" fmla="*/ 987423 w 5241053"/>
-              <a:gd name="csY3" fmla="*/ 7211640 h 7259305"/>
-              <a:gd name="csX4" fmla="*/ 346956 w 5241053"/>
-              <a:gd name="csY4" fmla="*/ 1631920 h 7259305"/>
-              <a:gd name="csX0" fmla="*/ 349977 w 5248987"/>
-              <a:gd name="csY0" fmla="*/ 1677593 h 7304978"/>
-              <a:gd name="csX1" fmla="*/ 2643077 w 5248987"/>
-              <a:gd name="csY1" fmla="*/ 55378 h 7304978"/>
-              <a:gd name="csX2" fmla="*/ 4818773 w 5248987"/>
-              <a:gd name="csY2" fmla="*/ 3244883 h 7304978"/>
-              <a:gd name="csX3" fmla="*/ 990444 w 5248987"/>
-              <a:gd name="csY3" fmla="*/ 7257313 h 7304978"/>
-              <a:gd name="csX4" fmla="*/ 349977 w 5248987"/>
-              <a:gd name="csY4" fmla="*/ 1677593 h 7304978"/>
-              <a:gd name="csX0" fmla="*/ 349977 w 5236960"/>
-              <a:gd name="csY0" fmla="*/ 1627449 h 7254834"/>
-              <a:gd name="csX1" fmla="*/ 2643077 w 5236960"/>
-              <a:gd name="csY1" fmla="*/ 5234 h 7254834"/>
-              <a:gd name="csX2" fmla="*/ 4818773 w 5236960"/>
-              <a:gd name="csY2" fmla="*/ 3194739 h 7254834"/>
-              <a:gd name="csX3" fmla="*/ 990444 w 5236960"/>
-              <a:gd name="csY3" fmla="*/ 7207169 h 7254834"/>
-              <a:gd name="csX4" fmla="*/ 349977 w 5236960"/>
-              <a:gd name="csY4" fmla="*/ 1627449 h 7254834"/>
-              <a:gd name="csX0" fmla="*/ 119626 w 5043533"/>
-              <a:gd name="csY0" fmla="*/ 1463253 h 7315371"/>
-              <a:gd name="csX1" fmla="*/ 2437231 w 5043533"/>
-              <a:gd name="csY1" fmla="*/ 88439 h 7315371"/>
-              <a:gd name="csX2" fmla="*/ 4612927 w 5043533"/>
-              <a:gd name="csY2" fmla="*/ 3277944 h 7315371"/>
-              <a:gd name="csX3" fmla="*/ 784598 w 5043533"/>
-              <a:gd name="csY3" fmla="*/ 7290374 h 7315371"/>
-              <a:gd name="csX4" fmla="*/ 119626 w 5043533"/>
-              <a:gd name="csY4" fmla="*/ 1463253 h 7315371"/>
-              <a:gd name="csX0" fmla="*/ 105918 w 5029825"/>
-              <a:gd name="csY0" fmla="*/ 1443927 h 7296045"/>
-              <a:gd name="csX1" fmla="*/ 2423523 w 5029825"/>
-              <a:gd name="csY1" fmla="*/ 69113 h 7296045"/>
-              <a:gd name="csX2" fmla="*/ 4599219 w 5029825"/>
-              <a:gd name="csY2" fmla="*/ 3258618 h 7296045"/>
-              <a:gd name="csX3" fmla="*/ 770890 w 5029825"/>
-              <a:gd name="csY3" fmla="*/ 7271048 h 7296045"/>
-              <a:gd name="csX4" fmla="*/ 105918 w 5029825"/>
-              <a:gd name="csY4" fmla="*/ 1443927 h 7296045"/>
-              <a:gd name="csX0" fmla="*/ 183921 w 5107828"/>
-              <a:gd name="csY0" fmla="*/ 1443927 h 7398576"/>
-              <a:gd name="csX1" fmla="*/ 2501526 w 5107828"/>
-              <a:gd name="csY1" fmla="*/ 69113 h 7398576"/>
-              <a:gd name="csX2" fmla="*/ 4677222 w 5107828"/>
-              <a:gd name="csY2" fmla="*/ 3258618 h 7398576"/>
-              <a:gd name="csX3" fmla="*/ 848893 w 5107828"/>
-              <a:gd name="csY3" fmla="*/ 7271048 h 7398576"/>
-              <a:gd name="csX4" fmla="*/ 183921 w 5107828"/>
-              <a:gd name="csY4" fmla="*/ 1443927 h 7398576"/>
-              <a:gd name="csX0" fmla="*/ 395880 w 5319787"/>
-              <a:gd name="csY0" fmla="*/ 1458340 h 7091336"/>
-              <a:gd name="csX1" fmla="*/ 2713485 w 5319787"/>
-              <a:gd name="csY1" fmla="*/ 83526 h 7091336"/>
-              <a:gd name="csX2" fmla="*/ 4889181 w 5319787"/>
-              <a:gd name="csY2" fmla="*/ 3273031 h 7091336"/>
-              <a:gd name="csX3" fmla="*/ 676940 w 5319787"/>
-              <a:gd name="csY3" fmla="*/ 6951063 h 7091336"/>
-              <a:gd name="csX4" fmla="*/ 395880 w 5319787"/>
-              <a:gd name="csY4" fmla="*/ 1458340 h 7091336"/>
-              <a:gd name="csX0" fmla="*/ 260637 w 5041744"/>
-              <a:gd name="csY0" fmla="*/ 1484778 h 7026385"/>
-              <a:gd name="csX1" fmla="*/ 2578242 w 5041744"/>
-              <a:gd name="csY1" fmla="*/ 109964 h 7026385"/>
-              <a:gd name="csX2" fmla="*/ 4596837 w 5041744"/>
-              <a:gd name="csY2" fmla="*/ 3720161 h 7026385"/>
-              <a:gd name="csX3" fmla="*/ 541697 w 5041744"/>
-              <a:gd name="csY3" fmla="*/ 6977501 h 7026385"/>
-              <a:gd name="csX4" fmla="*/ 260637 w 5041744"/>
-              <a:gd name="csY4" fmla="*/ 1484778 h 7026385"/>
-              <a:gd name="csX0" fmla="*/ 316639 w 5210603"/>
-              <a:gd name="csY0" fmla="*/ 1435776 h 6977383"/>
-              <a:gd name="csX1" fmla="*/ 3451192 w 5210603"/>
-              <a:gd name="csY1" fmla="*/ 114895 h 6977383"/>
-              <a:gd name="csX2" fmla="*/ 4652839 w 5210603"/>
-              <a:gd name="csY2" fmla="*/ 3671159 h 6977383"/>
-              <a:gd name="csX3" fmla="*/ 597699 w 5210603"/>
-              <a:gd name="csY3" fmla="*/ 6928499 h 6977383"/>
-              <a:gd name="csX4" fmla="*/ 316639 w 5210603"/>
-              <a:gd name="csY4" fmla="*/ 1435776 h 6977383"/>
-              <a:gd name="csX0" fmla="*/ 316640 w 5242461"/>
-              <a:gd name="csY0" fmla="*/ 1321869 h 6863476"/>
-              <a:gd name="csX1" fmla="*/ 3451193 w 5242461"/>
-              <a:gd name="csY1" fmla="*/ 988 h 6863476"/>
-              <a:gd name="csX2" fmla="*/ 4652840 w 5242461"/>
-              <a:gd name="csY2" fmla="*/ 3557252 h 6863476"/>
-              <a:gd name="csX3" fmla="*/ 597700 w 5242461"/>
-              <a:gd name="csY3" fmla="*/ 6814592 h 6863476"/>
-              <a:gd name="csX4" fmla="*/ 316640 w 5242461"/>
-              <a:gd name="csY4" fmla="*/ 1321869 h 6863476"/>
-              <a:gd name="csX0" fmla="*/ 182355 w 5667392"/>
-              <a:gd name="csY0" fmla="*/ 1079957 h 7114685"/>
-              <a:gd name="csX1" fmla="*/ 3892959 w 5667392"/>
-              <a:gd name="csY1" fmla="*/ 233704 h 7114685"/>
-              <a:gd name="csX2" fmla="*/ 5094606 w 5667392"/>
-              <a:gd name="csY2" fmla="*/ 3789968 h 7114685"/>
-              <a:gd name="csX3" fmla="*/ 1039466 w 5667392"/>
-              <a:gd name="csY3" fmla="*/ 7047308 h 7114685"/>
-              <a:gd name="csX4" fmla="*/ 182355 w 5667392"/>
-              <a:gd name="csY4" fmla="*/ 1079957 h 7114685"/>
-              <a:gd name="csX0" fmla="*/ 222668 w 5471196"/>
-              <a:gd name="csY0" fmla="*/ 1101670 h 7102718"/>
-              <a:gd name="csX1" fmla="*/ 3702848 w 5471196"/>
-              <a:gd name="csY1" fmla="*/ 223057 h 7102718"/>
-              <a:gd name="csX2" fmla="*/ 4904495 w 5471196"/>
-              <a:gd name="csY2" fmla="*/ 3779321 h 7102718"/>
-              <a:gd name="csX3" fmla="*/ 849355 w 5471196"/>
-              <a:gd name="csY3" fmla="*/ 7036661 h 7102718"/>
-              <a:gd name="csX4" fmla="*/ 222668 w 5471196"/>
-              <a:gd name="csY4" fmla="*/ 1101670 h 7102718"/>
-              <a:gd name="csX0" fmla="*/ 394952 w 5643480"/>
-              <a:gd name="csY0" fmla="*/ 1101670 h 7108047"/>
-              <a:gd name="csX1" fmla="*/ 3875132 w 5643480"/>
-              <a:gd name="csY1" fmla="*/ 223057 h 7108047"/>
-              <a:gd name="csX2" fmla="*/ 5076779 w 5643480"/>
-              <a:gd name="csY2" fmla="*/ 3779321 h 7108047"/>
-              <a:gd name="csX3" fmla="*/ 1021639 w 5643480"/>
-              <a:gd name="csY3" fmla="*/ 7036661 h 7108047"/>
-              <a:gd name="csX4" fmla="*/ 394952 w 5643480"/>
-              <a:gd name="csY4" fmla="*/ 1101670 h 7108047"/>
-              <a:gd name="csX0" fmla="*/ 217195 w 5331008"/>
-              <a:gd name="csY0" fmla="*/ 1175903 h 7285675"/>
-              <a:gd name="csX1" fmla="*/ 3697375 w 5331008"/>
-              <a:gd name="csY1" fmla="*/ 297290 h 7285675"/>
-              <a:gd name="csX2" fmla="*/ 4739322 w 5331008"/>
-              <a:gd name="csY2" fmla="*/ 4856073 h 7285675"/>
-              <a:gd name="csX3" fmla="*/ 843882 w 5331008"/>
-              <a:gd name="csY3" fmla="*/ 7110894 h 7285675"/>
-              <a:gd name="csX4" fmla="*/ 217195 w 5331008"/>
-              <a:gd name="csY4" fmla="*/ 1175903 h 7285675"/>
-              <a:gd name="csX0" fmla="*/ 264404 w 5528947"/>
-              <a:gd name="csY0" fmla="*/ 1167451 h 7277223"/>
-              <a:gd name="csX1" fmla="*/ 4383389 w 5528947"/>
-              <a:gd name="csY1" fmla="*/ 299619 h 7277223"/>
-              <a:gd name="csX2" fmla="*/ 4786531 w 5528947"/>
-              <a:gd name="csY2" fmla="*/ 4847621 h 7277223"/>
-              <a:gd name="csX3" fmla="*/ 891091 w 5528947"/>
-              <a:gd name="csY3" fmla="*/ 7102442 h 7277223"/>
-              <a:gd name="csX4" fmla="*/ 264404 w 5528947"/>
-              <a:gd name="csY4" fmla="*/ 1167451 h 7277223"/>
-              <a:gd name="csX0" fmla="*/ 666933 w 5931477"/>
-              <a:gd name="csY0" fmla="*/ 1167451 h 7349905"/>
-              <a:gd name="csX1" fmla="*/ 4785918 w 5931477"/>
-              <a:gd name="csY1" fmla="*/ 299619 h 7349905"/>
-              <a:gd name="csX2" fmla="*/ 5189060 w 5931477"/>
-              <a:gd name="csY2" fmla="*/ 4847621 h 7349905"/>
-              <a:gd name="csX3" fmla="*/ 1293620 w 5931477"/>
-              <a:gd name="csY3" fmla="*/ 7102442 h 7349905"/>
-              <a:gd name="csX4" fmla="*/ 666933 w 5931477"/>
-              <a:gd name="csY4" fmla="*/ 1167451 h 7349905"/>
-              <a:gd name="csX0" fmla="*/ 661874 w 5902731"/>
-              <a:gd name="csY0" fmla="*/ 832907 h 7015361"/>
-              <a:gd name="csX1" fmla="*/ 4696614 w 5902731"/>
-              <a:gd name="csY1" fmla="*/ 433384 h 7015361"/>
-              <a:gd name="csX2" fmla="*/ 5184001 w 5902731"/>
-              <a:gd name="csY2" fmla="*/ 4513077 h 7015361"/>
-              <a:gd name="csX3" fmla="*/ 1288561 w 5902731"/>
-              <a:gd name="csY3" fmla="*/ 6767898 h 7015361"/>
-              <a:gd name="csX4" fmla="*/ 661874 w 5902731"/>
-              <a:gd name="csY4" fmla="*/ 832907 h 7015361"/>
-              <a:gd name="csX0" fmla="*/ 661874 w 5963556"/>
-              <a:gd name="csY0" fmla="*/ 802174 h 6984628"/>
-              <a:gd name="csX1" fmla="*/ 4696614 w 5963556"/>
-              <a:gd name="csY1" fmla="*/ 402651 h 6984628"/>
-              <a:gd name="csX2" fmla="*/ 5184001 w 5963556"/>
-              <a:gd name="csY2" fmla="*/ 4482344 h 6984628"/>
-              <a:gd name="csX3" fmla="*/ 1288561 w 5963556"/>
-              <a:gd name="csY3" fmla="*/ 6737165 h 6984628"/>
-              <a:gd name="csX4" fmla="*/ 661874 w 5963556"/>
-              <a:gd name="csY4" fmla="*/ 802174 h 6984628"/>
-              <a:gd name="csX0" fmla="*/ 679365 w 5981047"/>
-              <a:gd name="csY0" fmla="*/ 1068233 h 7250687"/>
-              <a:gd name="csX1" fmla="*/ 4714105 w 5981047"/>
-              <a:gd name="csY1" fmla="*/ 668710 h 7250687"/>
-              <a:gd name="csX2" fmla="*/ 5201492 w 5981047"/>
-              <a:gd name="csY2" fmla="*/ 4748403 h 7250687"/>
-              <a:gd name="csX3" fmla="*/ 1306052 w 5981047"/>
-              <a:gd name="csY3" fmla="*/ 7003224 h 7250687"/>
-              <a:gd name="csX4" fmla="*/ 679365 w 5981047"/>
-              <a:gd name="csY4" fmla="*/ 1068233 h 7250687"/>
-              <a:gd name="csX0" fmla="*/ 660877 w 5957462"/>
-              <a:gd name="csY0" fmla="*/ 861777 h 7044231"/>
-              <a:gd name="csX1" fmla="*/ 4678983 w 5957462"/>
-              <a:gd name="csY1" fmla="*/ 369411 h 7044231"/>
-              <a:gd name="csX2" fmla="*/ 5183004 w 5957462"/>
-              <a:gd name="csY2" fmla="*/ 4541947 h 7044231"/>
-              <a:gd name="csX3" fmla="*/ 1287564 w 5957462"/>
-              <a:gd name="csY3" fmla="*/ 6796768 h 7044231"/>
-              <a:gd name="csX4" fmla="*/ 660877 w 5957462"/>
-              <a:gd name="csY4" fmla="*/ 861777 h 7044231"/>
-              <a:gd name="csX0" fmla="*/ 660876 w 6004790"/>
-              <a:gd name="csY0" fmla="*/ 1085878 h 7268332"/>
-              <a:gd name="csX1" fmla="*/ 4678982 w 6004790"/>
-              <a:gd name="csY1" fmla="*/ 593512 h 7268332"/>
-              <a:gd name="csX2" fmla="*/ 5183003 w 6004790"/>
-              <a:gd name="csY2" fmla="*/ 4766048 h 7268332"/>
-              <a:gd name="csX3" fmla="*/ 1287563 w 6004790"/>
-              <a:gd name="csY3" fmla="*/ 7020869 h 7268332"/>
-              <a:gd name="csX4" fmla="*/ 660876 w 6004790"/>
-              <a:gd name="csY4" fmla="*/ 1085878 h 7268332"/>
-              <a:gd name="csX0" fmla="*/ 688934 w 6211322"/>
-              <a:gd name="csY0" fmla="*/ 736712 h 6919166"/>
-              <a:gd name="csX1" fmla="*/ 5171282 w 6211322"/>
-              <a:gd name="csY1" fmla="*/ 793377 h 6919166"/>
-              <a:gd name="csX2" fmla="*/ 5211061 w 6211322"/>
-              <a:gd name="csY2" fmla="*/ 4416882 h 6919166"/>
-              <a:gd name="csX3" fmla="*/ 1315621 w 6211322"/>
-              <a:gd name="csY3" fmla="*/ 6671703 h 6919166"/>
-              <a:gd name="csX4" fmla="*/ 688934 w 6211322"/>
-              <a:gd name="csY4" fmla="*/ 736712 h 6919166"/>
-              <a:gd name="csX0" fmla="*/ 269364 w 5254351"/>
-              <a:gd name="csY0" fmla="*/ 624383 h 6910924"/>
-              <a:gd name="csX1" fmla="*/ 4751712 w 5254351"/>
-              <a:gd name="csY1" fmla="*/ 681048 h 6910924"/>
-              <a:gd name="csX2" fmla="*/ 4120238 w 5254351"/>
-              <a:gd name="csY2" fmla="*/ 5084716 h 6910924"/>
-              <a:gd name="csX3" fmla="*/ 896051 w 5254351"/>
-              <a:gd name="csY3" fmla="*/ 6559374 h 6910924"/>
-              <a:gd name="csX4" fmla="*/ 269364 w 5254351"/>
-              <a:gd name="csY4" fmla="*/ 624383 h 6910924"/>
-              <a:gd name="csX0" fmla="*/ 382980 w 5367966"/>
-              <a:gd name="csY0" fmla="*/ 719818 h 7006359"/>
-              <a:gd name="csX1" fmla="*/ 4865328 w 5367966"/>
-              <a:gd name="csY1" fmla="*/ 776483 h 7006359"/>
-              <a:gd name="csX2" fmla="*/ 4233854 w 5367966"/>
-              <a:gd name="csY2" fmla="*/ 5180151 h 7006359"/>
-              <a:gd name="csX3" fmla="*/ 1009667 w 5367966"/>
-              <a:gd name="csY3" fmla="*/ 6654809 h 7006359"/>
-              <a:gd name="csX4" fmla="*/ 382980 w 5367966"/>
-              <a:gd name="csY4" fmla="*/ 719818 h 7006359"/>
-              <a:gd name="csX0" fmla="*/ 482648 w 5014320"/>
-              <a:gd name="csY0" fmla="*/ 557175 h 7477700"/>
-              <a:gd name="csX1" fmla="*/ 4540247 w 5014320"/>
-              <a:gd name="csY1" fmla="*/ 1204220 h 7477700"/>
-              <a:gd name="csX2" fmla="*/ 3908773 w 5014320"/>
-              <a:gd name="csY2" fmla="*/ 5607888 h 7477700"/>
-              <a:gd name="csX3" fmla="*/ 684586 w 5014320"/>
-              <a:gd name="csY3" fmla="*/ 7082546 h 7477700"/>
-              <a:gd name="csX4" fmla="*/ 482648 w 5014320"/>
-              <a:gd name="csY4" fmla="*/ 557175 h 7477700"/>
-              <a:gd name="csX0" fmla="*/ 844350 w 5376022"/>
-              <a:gd name="csY0" fmla="*/ 557176 h 7758830"/>
-              <a:gd name="csX1" fmla="*/ 4901949 w 5376022"/>
-              <a:gd name="csY1" fmla="*/ 1204221 h 7758830"/>
-              <a:gd name="csX2" fmla="*/ 4270475 w 5376022"/>
-              <a:gd name="csY2" fmla="*/ 5607889 h 7758830"/>
-              <a:gd name="csX3" fmla="*/ 1046288 w 5376022"/>
-              <a:gd name="csY3" fmla="*/ 7082547 h 7758830"/>
-              <a:gd name="csX4" fmla="*/ 844350 w 5376022"/>
-              <a:gd name="csY4" fmla="*/ 557176 h 7758830"/>
-              <a:gd name="csX0" fmla="*/ 863849 w 5395521"/>
-              <a:gd name="csY0" fmla="*/ 557176 h 7382180"/>
-              <a:gd name="csX1" fmla="*/ 4921448 w 5395521"/>
-              <a:gd name="csY1" fmla="*/ 1204221 h 7382180"/>
-              <a:gd name="csX2" fmla="*/ 4289974 w 5395521"/>
-              <a:gd name="csY2" fmla="*/ 5607889 h 7382180"/>
-              <a:gd name="csX3" fmla="*/ 1065787 w 5395521"/>
-              <a:gd name="csY3" fmla="*/ 7082547 h 7382180"/>
-              <a:gd name="csX4" fmla="*/ 863849 w 5395521"/>
-              <a:gd name="csY4" fmla="*/ 557176 h 7382180"/>
-              <a:gd name="csX0" fmla="*/ 481538 w 5000978"/>
-              <a:gd name="csY0" fmla="*/ 567495 h 7582128"/>
-              <a:gd name="csX1" fmla="*/ 4539137 w 5000978"/>
-              <a:gd name="csY1" fmla="*/ 1214540 h 7582128"/>
-              <a:gd name="csX2" fmla="*/ 3883477 w 5000978"/>
-              <a:gd name="csY2" fmla="*/ 5896449 h 7582128"/>
-              <a:gd name="csX3" fmla="*/ 683476 w 5000978"/>
-              <a:gd name="csY3" fmla="*/ 7092866 h 7582128"/>
-              <a:gd name="csX4" fmla="*/ 481538 w 5000978"/>
-              <a:gd name="csY4" fmla="*/ 567495 h 7582128"/>
-              <a:gd name="csX0" fmla="*/ 864022 w 5383462"/>
-              <a:gd name="csY0" fmla="*/ 435073 h 7186175"/>
-              <a:gd name="csX1" fmla="*/ 4921621 w 5383462"/>
-              <a:gd name="csY1" fmla="*/ 1082118 h 7186175"/>
-              <a:gd name="csX2" fmla="*/ 4265961 w 5383462"/>
-              <a:gd name="csY2" fmla="*/ 5764027 h 7186175"/>
-              <a:gd name="csX3" fmla="*/ 270387 w 5383462"/>
-              <a:gd name="csY3" fmla="*/ 6555114 h 7186175"/>
-              <a:gd name="csX4" fmla="*/ 864022 w 5383462"/>
-              <a:gd name="csY4" fmla="*/ 435073 h 7186175"/>
-              <a:gd name="csX0" fmla="*/ 928990 w 5995575"/>
-              <a:gd name="csY0" fmla="*/ 470298 h 7737115"/>
-              <a:gd name="csX1" fmla="*/ 4986589 w 5995575"/>
-              <a:gd name="csY1" fmla="*/ 1117343 h 7737115"/>
-              <a:gd name="csX2" fmla="*/ 5208084 w 5995575"/>
-              <a:gd name="csY2" fmla="*/ 6690835 h 7737115"/>
-              <a:gd name="csX3" fmla="*/ 335355 w 5995575"/>
-              <a:gd name="csY3" fmla="*/ 6590339 h 7737115"/>
-              <a:gd name="csX4" fmla="*/ 928990 w 5995575"/>
-              <a:gd name="csY4" fmla="*/ 470298 h 7737115"/>
-              <a:gd name="csX0" fmla="*/ 644829 w 6221087"/>
-              <a:gd name="csY0" fmla="*/ 577088 h 7467168"/>
-              <a:gd name="csX1" fmla="*/ 5190010 w 6221087"/>
-              <a:gd name="csY1" fmla="*/ 865587 h 7467168"/>
-              <a:gd name="csX2" fmla="*/ 5411505 w 6221087"/>
-              <a:gd name="csY2" fmla="*/ 6439079 h 7467168"/>
-              <a:gd name="csX3" fmla="*/ 538776 w 6221087"/>
-              <a:gd name="csY3" fmla="*/ 6338583 h 7467168"/>
-              <a:gd name="csX4" fmla="*/ 644829 w 6221087"/>
-              <a:gd name="csY4" fmla="*/ 577088 h 7467168"/>
-              <a:gd name="csX0" fmla="*/ 805838 w 6074152"/>
-              <a:gd name="csY0" fmla="*/ 496933 h 7658024"/>
-              <a:gd name="csX1" fmla="*/ 5056506 w 6074152"/>
-              <a:gd name="csY1" fmla="*/ 1043387 h 7658024"/>
-              <a:gd name="csX2" fmla="*/ 5278001 w 6074152"/>
-              <a:gd name="csY2" fmla="*/ 6616879 h 7658024"/>
-              <a:gd name="csX3" fmla="*/ 405272 w 6074152"/>
-              <a:gd name="csY3" fmla="*/ 6516383 h 7658024"/>
-              <a:gd name="csX4" fmla="*/ 805838 w 6074152"/>
-              <a:gd name="csY4" fmla="*/ 496933 h 7658024"/>
-              <a:gd name="csX0" fmla="*/ 787452 w 6055766"/>
-              <a:gd name="csY0" fmla="*/ 496933 h 7743743"/>
-              <a:gd name="csX1" fmla="*/ 5038120 w 6055766"/>
-              <a:gd name="csY1" fmla="*/ 1043387 h 7743743"/>
-              <a:gd name="csX2" fmla="*/ 5259615 w 6055766"/>
-              <a:gd name="csY2" fmla="*/ 6616879 h 7743743"/>
-              <a:gd name="csX3" fmla="*/ 386886 w 6055766"/>
-              <a:gd name="csY3" fmla="*/ 6516383 h 7743743"/>
-              <a:gd name="csX4" fmla="*/ 787452 w 6055766"/>
-              <a:gd name="csY4" fmla="*/ 496933 h 7743743"/>
-              <a:gd name="csX0" fmla="*/ 839520 w 6107834"/>
-              <a:gd name="csY0" fmla="*/ 451596 h 7479185"/>
-              <a:gd name="csX1" fmla="*/ 5090188 w 6107834"/>
-              <a:gd name="csY1" fmla="*/ 998050 h 7479185"/>
-              <a:gd name="csX2" fmla="*/ 5311683 w 6107834"/>
-              <a:gd name="csY2" fmla="*/ 6571542 h 7479185"/>
-              <a:gd name="csX3" fmla="*/ 367608 w 6107834"/>
-              <a:gd name="csY3" fmla="*/ 5850055 h 7479185"/>
-              <a:gd name="csX4" fmla="*/ 839520 w 6107834"/>
-              <a:gd name="csY4" fmla="*/ 451596 h 7479185"/>
-            </a:gdLst>
-            <a:ahLst/>
-            <a:cxnLst>
-              <a:cxn ang="0">
-                <a:pos x="csX0" y="csY0"/>
-              </a:cxn>
-              <a:cxn ang="0">
-                <a:pos x="csX1" y="csY1"/>
-              </a:cxn>
-              <a:cxn ang="0">
-                <a:pos x="csX2" y="csY2"/>
-              </a:cxn>
-              <a:cxn ang="0">
-                <a:pos x="csX3" y="csY3"/>
-              </a:cxn>
-              <a:cxn ang="0">
-                <a:pos x="csX4" y="csY4"/>
-              </a:cxn>
-            </a:cxnLst>
-            <a:rect l="l" t="t" r="r" b="b"/>
-            <a:pathLst>
-              <a:path w="6107834" h="7479185">
-                <a:moveTo>
-                  <a:pt x="839520" y="451596"/>
-                </a:moveTo>
-                <a:cubicBezTo>
-                  <a:pt x="1626616" y="-357071"/>
-                  <a:pt x="4344828" y="-21941"/>
-                  <a:pt x="5090188" y="998050"/>
-                </a:cubicBezTo>
-                <a:cubicBezTo>
-                  <a:pt x="5835548" y="2018041"/>
-                  <a:pt x="6835085" y="3996524"/>
-                  <a:pt x="5311683" y="6571542"/>
-                </a:cubicBezTo>
-                <a:cubicBezTo>
-                  <a:pt x="4089886" y="8379564"/>
-                  <a:pt x="1070986" y="7140168"/>
-                  <a:pt x="367608" y="5850055"/>
-                </a:cubicBezTo>
-                <a:cubicBezTo>
-                  <a:pt x="-335770" y="4559942"/>
-                  <a:pt x="52424" y="1260263"/>
-                  <a:pt x="839520" y="451596"/>
-                </a:cubicBezTo>
-                <a:close/>
-              </a:path>
-            </a:pathLst>
-          </a:custGeom>
+          </a:prstGeom>
           <a:solidFill>
-            <a:schemeClr val="accent6">
-              <a:lumMod val="20000"/>
-              <a:lumOff val="80000"/>
-            </a:schemeClr>
+            <a:srgbClr val="F8E4F6"/>
           </a:solidFill>
           <a:ln w="28575">
             <a:noFill/>
@@ -6646,10 +3809,10 @@
       </p:sp>
       <p:sp>
         <p:nvSpPr>
-          <p:cNvPr id="62" name="Oval 61">
+          <p:cNvPr id="13" name="Oval 12">
             <a:extLst>
               <a:ext uri="{FF2B5EF4-FFF2-40B4-BE49-F238E27FC236}">
-                <a16:creationId xmlns:a16="http://schemas.microsoft.com/office/drawing/2014/main" id="{AA5C58BE-DA79-94EF-9F3F-3C6A0D645BD5}"/>
+                <a16:creationId xmlns:a16="http://schemas.microsoft.com/office/drawing/2014/main" id="{AA6DBB74-DE79-BF08-F03B-1001FB83B862}"/>
               </a:ext>
             </a:extLst>
           </p:cNvPr>
@@ -6657,224 +3820,15 @@
           <p:nvPr/>
         </p:nvSpPr>
         <p:spPr>
-          <a:xfrm rot="7180819">
-            <a:off x="1276439" y="-763277"/>
-            <a:ext cx="3175904" cy="3958560"/>
+          <a:xfrm rot="20705849">
+            <a:off x="1144751" y="63945"/>
+            <a:ext cx="3972129" cy="3030464"/>
           </a:xfrm>
-          <a:custGeom>
+          <a:prstGeom prst="ellipse">
             <a:avLst/>
-            <a:gdLst>
-              <a:gd name="csX0" fmla="*/ 0 w 2990221"/>
-              <a:gd name="csY0" fmla="*/ 1909024 h 3818047"/>
-              <a:gd name="csX1" fmla="*/ 1495111 w 2990221"/>
-              <a:gd name="csY1" fmla="*/ 0 h 3818047"/>
-              <a:gd name="csX2" fmla="*/ 2990222 w 2990221"/>
-              <a:gd name="csY2" fmla="*/ 1909024 h 3818047"/>
-              <a:gd name="csX3" fmla="*/ 1495111 w 2990221"/>
-              <a:gd name="csY3" fmla="*/ 3818048 h 3818047"/>
-              <a:gd name="csX4" fmla="*/ 0 w 2990221"/>
-              <a:gd name="csY4" fmla="*/ 1909024 h 3818047"/>
-              <a:gd name="csX0" fmla="*/ 31520 w 3021742"/>
-              <a:gd name="csY0" fmla="*/ 1909024 h 3852823"/>
-              <a:gd name="csX1" fmla="*/ 1526631 w 3021742"/>
-              <a:gd name="csY1" fmla="*/ 0 h 3852823"/>
-              <a:gd name="csX2" fmla="*/ 3021742 w 3021742"/>
-              <a:gd name="csY2" fmla="*/ 1909024 h 3852823"/>
-              <a:gd name="csX3" fmla="*/ 1526631 w 3021742"/>
-              <a:gd name="csY3" fmla="*/ 3818048 h 3852823"/>
-              <a:gd name="csX4" fmla="*/ 588086 w 3021742"/>
-              <a:gd name="csY4" fmla="*/ 3051425 h 3852823"/>
-              <a:gd name="csX5" fmla="*/ 31520 w 3021742"/>
-              <a:gd name="csY5" fmla="*/ 1909024 h 3852823"/>
-              <a:gd name="csX0" fmla="*/ 42163 w 3032385"/>
-              <a:gd name="csY0" fmla="*/ 1909024 h 3852823"/>
-              <a:gd name="csX1" fmla="*/ 1537274 w 3032385"/>
-              <a:gd name="csY1" fmla="*/ 0 h 3852823"/>
-              <a:gd name="csX2" fmla="*/ 3032385 w 3032385"/>
-              <a:gd name="csY2" fmla="*/ 1909024 h 3852823"/>
-              <a:gd name="csX3" fmla="*/ 1537274 w 3032385"/>
-              <a:gd name="csY3" fmla="*/ 3818048 h 3852823"/>
-              <a:gd name="csX4" fmla="*/ 598729 w 3032385"/>
-              <a:gd name="csY4" fmla="*/ 3051425 h 3852823"/>
-              <a:gd name="csX5" fmla="*/ 42163 w 3032385"/>
-              <a:gd name="csY5" fmla="*/ 1909024 h 3852823"/>
-              <a:gd name="csX0" fmla="*/ 42163 w 3032385"/>
-              <a:gd name="csY0" fmla="*/ 1909024 h 3869423"/>
-              <a:gd name="csX1" fmla="*/ 1537274 w 3032385"/>
-              <a:gd name="csY1" fmla="*/ 0 h 3869423"/>
-              <a:gd name="csX2" fmla="*/ 3032385 w 3032385"/>
-              <a:gd name="csY2" fmla="*/ 1909024 h 3869423"/>
-              <a:gd name="csX3" fmla="*/ 1537274 w 3032385"/>
-              <a:gd name="csY3" fmla="*/ 3818048 h 3869423"/>
-              <a:gd name="csX4" fmla="*/ 598729 w 3032385"/>
-              <a:gd name="csY4" fmla="*/ 3051425 h 3869423"/>
-              <a:gd name="csX5" fmla="*/ 42163 w 3032385"/>
-              <a:gd name="csY5" fmla="*/ 1909024 h 3869423"/>
-              <a:gd name="csX0" fmla="*/ 42163 w 3054534"/>
-              <a:gd name="csY0" fmla="*/ 1909024 h 3837295"/>
-              <a:gd name="csX1" fmla="*/ 1537274 w 3054534"/>
-              <a:gd name="csY1" fmla="*/ 0 h 3837295"/>
-              <a:gd name="csX2" fmla="*/ 3032385 w 3054534"/>
-              <a:gd name="csY2" fmla="*/ 1909024 h 3837295"/>
-              <a:gd name="csX3" fmla="*/ 2491896 w 3054534"/>
-              <a:gd name="csY3" fmla="*/ 3458304 h 3837295"/>
-              <a:gd name="csX4" fmla="*/ 1537274 w 3054534"/>
-              <a:gd name="csY4" fmla="*/ 3818048 h 3837295"/>
-              <a:gd name="csX5" fmla="*/ 598729 w 3054534"/>
-              <a:gd name="csY5" fmla="*/ 3051425 h 3837295"/>
-              <a:gd name="csX6" fmla="*/ 42163 w 3054534"/>
-              <a:gd name="csY6" fmla="*/ 1909024 h 3837295"/>
-              <a:gd name="csX0" fmla="*/ 42163 w 3054534"/>
-              <a:gd name="csY0" fmla="*/ 1909024 h 4062413"/>
-              <a:gd name="csX1" fmla="*/ 1537274 w 3054534"/>
-              <a:gd name="csY1" fmla="*/ 0 h 4062413"/>
-              <a:gd name="csX2" fmla="*/ 3032385 w 3054534"/>
-              <a:gd name="csY2" fmla="*/ 1909024 h 4062413"/>
-              <a:gd name="csX3" fmla="*/ 2491896 w 3054534"/>
-              <a:gd name="csY3" fmla="*/ 3458304 h 4062413"/>
-              <a:gd name="csX4" fmla="*/ 1558136 w 3054534"/>
-              <a:gd name="csY4" fmla="*/ 4053801 h 4062413"/>
-              <a:gd name="csX5" fmla="*/ 598729 w 3054534"/>
-              <a:gd name="csY5" fmla="*/ 3051425 h 4062413"/>
-              <a:gd name="csX6" fmla="*/ 42163 w 3054534"/>
-              <a:gd name="csY6" fmla="*/ 1909024 h 4062413"/>
-              <a:gd name="csX0" fmla="*/ 37535 w 3049906"/>
-              <a:gd name="csY0" fmla="*/ 1909024 h 4067997"/>
-              <a:gd name="csX1" fmla="*/ 1532646 w 3049906"/>
-              <a:gd name="csY1" fmla="*/ 0 h 4067997"/>
-              <a:gd name="csX2" fmla="*/ 3027757 w 3049906"/>
-              <a:gd name="csY2" fmla="*/ 1909024 h 4067997"/>
-              <a:gd name="csX3" fmla="*/ 2487268 w 3049906"/>
-              <a:gd name="csY3" fmla="*/ 3458304 h 4067997"/>
-              <a:gd name="csX4" fmla="*/ 1553508 w 3049906"/>
-              <a:gd name="csY4" fmla="*/ 4053801 h 4067997"/>
-              <a:gd name="csX5" fmla="*/ 626508 w 3049906"/>
-              <a:gd name="csY5" fmla="*/ 2909133 h 4067997"/>
-              <a:gd name="csX6" fmla="*/ 37535 w 3049906"/>
-              <a:gd name="csY6" fmla="*/ 1909024 h 4067997"/>
-              <a:gd name="csX0" fmla="*/ 21715 w 3379154"/>
-              <a:gd name="csY0" fmla="*/ 1258724 h 4077464"/>
-              <a:gd name="csX1" fmla="*/ 1861894 w 3379154"/>
-              <a:gd name="csY1" fmla="*/ 9467 h 4077464"/>
-              <a:gd name="csX2" fmla="*/ 3357005 w 3379154"/>
-              <a:gd name="csY2" fmla="*/ 1918491 h 4077464"/>
-              <a:gd name="csX3" fmla="*/ 2816516 w 3379154"/>
-              <a:gd name="csY3" fmla="*/ 3467771 h 4077464"/>
-              <a:gd name="csX4" fmla="*/ 1882756 w 3379154"/>
-              <a:gd name="csY4" fmla="*/ 4063268 h 4077464"/>
-              <a:gd name="csX5" fmla="*/ 955756 w 3379154"/>
-              <a:gd name="csY5" fmla="*/ 2918600 h 4077464"/>
-              <a:gd name="csX6" fmla="*/ 21715 w 3379154"/>
-              <a:gd name="csY6" fmla="*/ 1258724 h 4077464"/>
-              <a:gd name="csX0" fmla="*/ 21715 w 3174715"/>
-              <a:gd name="csY0" fmla="*/ 1255557 h 4074297"/>
-              <a:gd name="csX1" fmla="*/ 1861894 w 3174715"/>
-              <a:gd name="csY1" fmla="*/ 6300 h 4074297"/>
-              <a:gd name="csX2" fmla="*/ 3136991 w 3174715"/>
-              <a:gd name="csY2" fmla="*/ 1782755 h 4074297"/>
-              <a:gd name="csX3" fmla="*/ 2816516 w 3174715"/>
-              <a:gd name="csY3" fmla="*/ 3464604 h 4074297"/>
-              <a:gd name="csX4" fmla="*/ 1882756 w 3174715"/>
-              <a:gd name="csY4" fmla="*/ 4060101 h 4074297"/>
-              <a:gd name="csX5" fmla="*/ 955756 w 3174715"/>
-              <a:gd name="csY5" fmla="*/ 2915433 h 4074297"/>
-              <a:gd name="csX6" fmla="*/ 21715 w 3174715"/>
-              <a:gd name="csY6" fmla="*/ 1255557 h 4074297"/>
-              <a:gd name="csX0" fmla="*/ 21005 w 3174005"/>
-              <a:gd name="csY0" fmla="*/ 1142876 h 3961616"/>
-              <a:gd name="csX1" fmla="*/ 1843266 w 3174005"/>
-              <a:gd name="csY1" fmla="*/ 7016 h 3961616"/>
-              <a:gd name="csX2" fmla="*/ 3136281 w 3174005"/>
-              <a:gd name="csY2" fmla="*/ 1670074 h 3961616"/>
-              <a:gd name="csX3" fmla="*/ 2815806 w 3174005"/>
-              <a:gd name="csY3" fmla="*/ 3351923 h 3961616"/>
-              <a:gd name="csX4" fmla="*/ 1882046 w 3174005"/>
-              <a:gd name="csY4" fmla="*/ 3947420 h 3961616"/>
-              <a:gd name="csX5" fmla="*/ 955046 w 3174005"/>
-              <a:gd name="csY5" fmla="*/ 2802752 h 3961616"/>
-              <a:gd name="csX6" fmla="*/ 21005 w 3174005"/>
-              <a:gd name="csY6" fmla="*/ 1142876 h 3961616"/>
-              <a:gd name="csX0" fmla="*/ 22904 w 3175904"/>
-              <a:gd name="csY0" fmla="*/ 1142984 h 3958560"/>
-              <a:gd name="csX1" fmla="*/ 1845165 w 3175904"/>
-              <a:gd name="csY1" fmla="*/ 7124 h 3958560"/>
-              <a:gd name="csX2" fmla="*/ 3138180 w 3175904"/>
-              <a:gd name="csY2" fmla="*/ 1670182 h 3958560"/>
-              <a:gd name="csX3" fmla="*/ 2817705 w 3175904"/>
-              <a:gd name="csY3" fmla="*/ 3352031 h 3958560"/>
-              <a:gd name="csX4" fmla="*/ 1883945 w 3175904"/>
-              <a:gd name="csY4" fmla="*/ 3947528 h 3958560"/>
-              <a:gd name="csX5" fmla="*/ 929060 w 3175904"/>
-              <a:gd name="csY5" fmla="*/ 2880663 h 3958560"/>
-              <a:gd name="csX6" fmla="*/ 22904 w 3175904"/>
-              <a:gd name="csY6" fmla="*/ 1142984 h 3958560"/>
-            </a:gdLst>
-            <a:ahLst/>
-            <a:cxnLst>
-              <a:cxn ang="0">
-                <a:pos x="csX0" y="csY0"/>
-              </a:cxn>
-              <a:cxn ang="0">
-                <a:pos x="csX1" y="csY1"/>
-              </a:cxn>
-              <a:cxn ang="0">
-                <a:pos x="csX2" y="csY2"/>
-              </a:cxn>
-              <a:cxn ang="0">
-                <a:pos x="csX3" y="csY3"/>
-              </a:cxn>
-              <a:cxn ang="0">
-                <a:pos x="csX4" y="csY4"/>
-              </a:cxn>
-              <a:cxn ang="0">
-                <a:pos x="csX5" y="csY5"/>
-              </a:cxn>
-              <a:cxn ang="0">
-                <a:pos x="csX6" y="csY6"/>
-              </a:cxn>
-            </a:cxnLst>
-            <a:rect l="l" t="t" r="r" b="b"/>
-            <a:pathLst>
-              <a:path w="3175904" h="3958560">
-                <a:moveTo>
-                  <a:pt x="22904" y="1142984"/>
-                </a:moveTo>
-                <a:cubicBezTo>
-                  <a:pt x="175588" y="664061"/>
-                  <a:pt x="1325952" y="-80742"/>
-                  <a:pt x="1845165" y="7124"/>
-                </a:cubicBezTo>
-                <a:cubicBezTo>
-                  <a:pt x="2364378" y="94990"/>
-                  <a:pt x="3015745" y="1115893"/>
-                  <a:pt x="3138180" y="1670182"/>
-                </a:cubicBezTo>
-                <a:cubicBezTo>
-                  <a:pt x="3260615" y="2224471"/>
-                  <a:pt x="3066890" y="3033860"/>
-                  <a:pt x="2817705" y="3352031"/>
-                </a:cubicBezTo>
-                <a:cubicBezTo>
-                  <a:pt x="2568520" y="3670202"/>
-                  <a:pt x="2198719" y="4026089"/>
-                  <a:pt x="1883945" y="3947528"/>
-                </a:cubicBezTo>
-                <a:cubicBezTo>
-                  <a:pt x="1569171" y="3868967"/>
-                  <a:pt x="1390307" y="3480392"/>
-                  <a:pt x="929060" y="2880663"/>
-                </a:cubicBezTo>
-                <a:cubicBezTo>
-                  <a:pt x="515633" y="2274316"/>
-                  <a:pt x="-129780" y="1621907"/>
-                  <a:pt x="22904" y="1142984"/>
-                </a:cubicBezTo>
-                <a:close/>
-              </a:path>
-            </a:pathLst>
-          </a:custGeom>
+          </a:prstGeom>
           <a:solidFill>
-            <a:schemeClr val="bg2"/>
+            <a:srgbClr val="F0F0F0"/>
           </a:solidFill>
           <a:ln w="28575">
             <a:noFill/>
@@ -6928,7 +3882,7 @@
         </p:nvSpPr>
         <p:spPr bwMode="auto">
           <a:xfrm>
-            <a:off x="1091850" y="428460"/>
+            <a:off x="1310993" y="465163"/>
             <a:ext cx="1395681" cy="948228"/>
           </a:xfrm>
           <a:prstGeom prst="roundRect">
@@ -7037,8 +3991,8 @@
         </p:nvSpPr>
         <p:spPr bwMode="auto">
           <a:xfrm>
-            <a:off x="172101" y="2204171"/>
-            <a:ext cx="1438256" cy="4010017"/>
+            <a:off x="377542" y="1805988"/>
+            <a:ext cx="1618767" cy="4010017"/>
           </a:xfrm>
           <a:prstGeom prst="roundRect">
             <a:avLst>
@@ -7577,7 +4531,7 @@
         </p:nvSpPr>
         <p:spPr bwMode="auto">
           <a:xfrm>
-            <a:off x="1200524" y="5253353"/>
+            <a:off x="1350393" y="5149668"/>
             <a:ext cx="1533975" cy="1044301"/>
           </a:xfrm>
           <a:prstGeom prst="roundRect">
@@ -7723,7 +4677,7 @@
         </p:nvSpPr>
         <p:spPr bwMode="auto">
           <a:xfrm>
-            <a:off x="2690218" y="216031"/>
+            <a:off x="3603736" y="193485"/>
             <a:ext cx="1395681" cy="948228"/>
           </a:xfrm>
           <a:prstGeom prst="roundRect">
@@ -7839,7 +4793,7 @@
         </p:nvSpPr>
         <p:spPr bwMode="auto">
           <a:xfrm>
-            <a:off x="3252069" y="922742"/>
+            <a:off x="3820826" y="969133"/>
             <a:ext cx="1275139" cy="1163457"/>
           </a:xfrm>
           <a:prstGeom prst="roundRect">
@@ -7970,8 +4924,8 @@
         </p:nvSpPr>
         <p:spPr bwMode="auto">
           <a:xfrm>
-            <a:off x="1385225" y="1234053"/>
-            <a:ext cx="1769091" cy="2555899"/>
+            <a:off x="1774839" y="1161160"/>
+            <a:ext cx="1769091" cy="2745395"/>
           </a:xfrm>
           <a:prstGeom prst="roundRect">
             <a:avLst>
@@ -8325,8 +5279,8 @@
         </p:nvSpPr>
         <p:spPr bwMode="auto">
           <a:xfrm>
-            <a:off x="2096029" y="3714499"/>
-            <a:ext cx="1625139" cy="1909132"/>
+            <a:off x="2378924" y="3710176"/>
+            <a:ext cx="1625139" cy="1750428"/>
           </a:xfrm>
           <a:prstGeom prst="roundRect">
             <a:avLst>
@@ -8364,21 +5318,6 @@
             <a:pPr marL="85725">
               <a:defRPr/>
             </a:pPr>
-            <a:endParaRPr lang="en-US" sz="1600" b="1">
-              <a:solidFill>
-                <a:schemeClr val="bg1"/>
-              </a:solidFill>
-              <a:highlight>
-                <a:srgbClr val="800080"/>
-              </a:highlight>
-              <a:latin typeface="Segoe UI" panose="020B0502040204020203" pitchFamily="34" charset="0"/>
-              <a:cs typeface="Segoe UI" panose="020B0502040204020203" pitchFamily="34" charset="0"/>
-            </a:endParaRPr>
-          </a:p>
-          <a:p>
-            <a:pPr marL="85725">
-              <a:defRPr/>
-            </a:pPr>
             <a:r>
               <a:rPr lang="en-US" sz="1600" b="1">
                 <a:solidFill>
@@ -8578,7 +5517,7 @@
         </p:nvSpPr>
         <p:spPr bwMode="auto">
           <a:xfrm>
-            <a:off x="3077900" y="1868250"/>
+            <a:off x="3467514" y="1795357"/>
             <a:ext cx="2172080" cy="2975213"/>
           </a:xfrm>
           <a:prstGeom prst="roundRect">
@@ -8996,8 +5935,8 @@
         </p:nvSpPr>
         <p:spPr bwMode="auto">
           <a:xfrm>
-            <a:off x="5065258" y="2738268"/>
-            <a:ext cx="1679348" cy="1909132"/>
+            <a:off x="5362376" y="2037328"/>
+            <a:ext cx="1484046" cy="1909132"/>
           </a:xfrm>
           <a:prstGeom prst="roundRect">
             <a:avLst>
@@ -9187,8 +6126,8 @@
         </p:nvSpPr>
         <p:spPr>
           <a:xfrm>
-            <a:off x="7392551" y="-624829"/>
-            <a:ext cx="4113873" cy="2215991"/>
+            <a:off x="6437846" y="-61022"/>
+            <a:ext cx="2843200" cy="1569660"/>
           </a:xfrm>
           <a:prstGeom prst="rect">
             <a:avLst/>
@@ -9203,7 +6142,7 @@
           <a:p>
             <a:pPr algn="l" rtl="0"/>
             <a:r>
-              <a:rPr lang="en-US" sz="13800" i="1">
+              <a:rPr lang="en-US" sz="9600" i="1">
                 <a:solidFill>
                   <a:schemeClr val="tx1"/>
                 </a:solidFill>
@@ -9214,7 +6153,7 @@
               <a:t>Al</a:t>
             </a:r>
             <a:r>
-              <a:rPr lang="en-US" sz="13800" i="1">
+              <a:rPr lang="en-US" sz="9600" i="1">
                 <a:latin typeface="Rastanty Cortez" panose="020F0502020204030204" pitchFamily="2" charset="0"/>
                 <a:ea typeface="Dotum" panose="020B0600000101010101" pitchFamily="34" charset="-127"/>
                 <a:cs typeface="Biome Light" panose="020B0303030204020804" pitchFamily="34" charset="0"/>
@@ -9222,7 +6161,7 @@
               <a:t>a</a:t>
             </a:r>
             <a:r>
-              <a:rPr lang="en-US" sz="13800" i="1">
+              <a:rPr lang="en-US" sz="9600" i="1">
                 <a:solidFill>
                   <a:srgbClr val="C00000"/>
                 </a:solidFill>
@@ -9233,7 +6172,7 @@
               <a:t>m</a:t>
             </a:r>
             <a:r>
-              <a:rPr lang="en-US" sz="13800" i="1">
+              <a:rPr lang="en-US" sz="9600" i="1">
                 <a:solidFill>
                   <a:schemeClr val="tx1"/>
                 </a:solidFill>
@@ -9260,8 +6199,8 @@
         </p:nvSpPr>
         <p:spPr bwMode="auto">
           <a:xfrm>
-            <a:off x="3077900" y="5135864"/>
-            <a:ext cx="2144506" cy="1213704"/>
+            <a:off x="3317397" y="5045520"/>
+            <a:ext cx="1679348" cy="1213704"/>
           </a:xfrm>
           <a:prstGeom prst="roundRect">
             <a:avLst>
@@ -9414,8 +6353,8 @@
         </p:nvSpPr>
         <p:spPr bwMode="auto">
           <a:xfrm>
-            <a:off x="5065258" y="5283555"/>
-            <a:ext cx="1679348" cy="1210093"/>
+            <a:off x="4372075" y="5303956"/>
+            <a:ext cx="1679348" cy="1111233"/>
           </a:xfrm>
           <a:prstGeom prst="roundRect">
             <a:avLst>
@@ -9579,18 +6518,6 @@
               <a:t>M01-M12</a:t>
             </a:r>
           </a:p>
-          <a:p>
-            <a:pPr>
-              <a:defRPr/>
-            </a:pPr>
-            <a:endParaRPr lang="en-US" sz="900">
-              <a:solidFill>
-                <a:schemeClr val="tx1"/>
-              </a:solidFill>
-              <a:latin typeface="Segoe UI" panose="020B0502040204020203" pitchFamily="34" charset="0"/>
-              <a:cs typeface="Segoe UI" panose="020B0502040204020203" pitchFamily="34" charset="0"/>
-            </a:endParaRPr>
-          </a:p>
         </p:txBody>
       </p:sp>
       <p:sp>
@@ -9607,8 +6534,8 @@
         </p:nvSpPr>
         <p:spPr bwMode="auto">
           <a:xfrm>
-            <a:off x="6560374" y="2204171"/>
-            <a:ext cx="1416106" cy="3419459"/>
+            <a:off x="6538306" y="2611937"/>
+            <a:ext cx="1416106" cy="2355901"/>
           </a:xfrm>
           <a:prstGeom prst="roundRect">
             <a:avLst>
@@ -9887,18 +6814,6 @@
               <a:t>IsHybid</a:t>
             </a:r>
           </a:p>
-          <a:p>
-            <a:pPr>
-              <a:defRPr/>
-            </a:pPr>
-            <a:endParaRPr lang="en-US" sz="900">
-              <a:solidFill>
-                <a:schemeClr val="tx1"/>
-              </a:solidFill>
-              <a:latin typeface="Segoe UI" panose="020B0502040204020203" pitchFamily="34" charset="0"/>
-              <a:cs typeface="Segoe UI" panose="020B0502040204020203" pitchFamily="34" charset="0"/>
-            </a:endParaRPr>
-          </a:p>
         </p:txBody>
       </p:sp>
       <p:sp>
@@ -9915,7 +6830,7 @@
         </p:nvSpPr>
         <p:spPr bwMode="auto">
           <a:xfrm>
-            <a:off x="7607111" y="2743079"/>
+            <a:off x="7617369" y="2279859"/>
             <a:ext cx="1278585" cy="1009790"/>
           </a:xfrm>
           <a:prstGeom prst="roundRect">
@@ -10061,7 +6976,7 @@
         </p:nvSpPr>
         <p:spPr bwMode="auto">
           <a:xfrm>
-            <a:off x="8498263" y="1906672"/>
+            <a:off x="8585731" y="1897387"/>
             <a:ext cx="1233203" cy="1596320"/>
           </a:xfrm>
           <a:prstGeom prst="roundRect">
@@ -10282,7 +7197,7 @@
         </p:nvSpPr>
         <p:spPr bwMode="auto">
           <a:xfrm>
-            <a:off x="9518064" y="1617811"/>
+            <a:off x="9605532" y="1608526"/>
             <a:ext cx="1377673" cy="1364705"/>
           </a:xfrm>
           <a:prstGeom prst="roundRect">
@@ -10443,7 +7358,7 @@
         </p:nvSpPr>
         <p:spPr bwMode="auto">
           <a:xfrm>
-            <a:off x="10472454" y="1271499"/>
+            <a:off x="10559922" y="1262214"/>
             <a:ext cx="1377673" cy="2943148"/>
           </a:xfrm>
           <a:prstGeom prst="roundRect">
@@ -10883,7 +7798,7 @@
         </p:nvSpPr>
         <p:spPr>
           <a:xfrm>
-            <a:off x="7965750" y="4436996"/>
+            <a:off x="7964464" y="3647976"/>
             <a:ext cx="1026285" cy="1338828"/>
           </a:xfrm>
           <a:prstGeom prst="rect">
@@ -11036,7 +7951,7 @@
         </p:nvSpPr>
         <p:spPr>
           <a:xfrm>
-            <a:off x="8837531" y="4889662"/>
+            <a:off x="8791758" y="3832642"/>
             <a:ext cx="1026285" cy="969496"/>
           </a:xfrm>
           <a:prstGeom prst="rect">
@@ -11153,7 +8068,7 @@
         </p:nvSpPr>
         <p:spPr>
           <a:xfrm>
-            <a:off x="9869594" y="5432924"/>
+            <a:off x="9605532" y="3689497"/>
             <a:ext cx="921038" cy="600164"/>
           </a:xfrm>
           <a:prstGeom prst="rect">
@@ -11216,10 +8131,83 @@
           </a:p>
         </p:txBody>
       </p:sp>
+      <p:sp>
+        <p:nvSpPr>
+          <p:cNvPr id="22" name="TextBox 21">
+            <a:extLst>
+              <a:ext uri="{FF2B5EF4-FFF2-40B4-BE49-F238E27FC236}">
+                <a16:creationId xmlns:a16="http://schemas.microsoft.com/office/drawing/2014/main" id="{051294D3-151C-1A5C-245A-703F659D8854}"/>
+              </a:ext>
+            </a:extLst>
+          </p:cNvPr>
+          <p:cNvSpPr txBox="1"/>
+          <p:nvPr/>
+        </p:nvSpPr>
+        <p:spPr>
+          <a:xfrm>
+            <a:off x="9605532" y="6415189"/>
+            <a:ext cx="2586468" cy="400110"/>
+          </a:xfrm>
+          <a:prstGeom prst="rect">
+            <a:avLst/>
+          </a:prstGeom>
+          <a:noFill/>
+        </p:spPr>
+        <p:txBody>
+          <a:bodyPr wrap="square" rtlCol="0">
+            <a:spAutoFit/>
+          </a:bodyPr>
+          <a:lstStyle/>
+          <a:p>
+            <a:pPr algn="l" rtl="0"/>
+            <a:r>
+              <a:rPr lang="en-US" sz="2000" i="1">
+                <a:solidFill>
+                  <a:schemeClr val="tx1"/>
+                </a:solidFill>
+                <a:latin typeface="Raleway Medium" pitchFamily="2" charset="0"/>
+                <a:ea typeface="Dotum" panose="020B0600000101010101" pitchFamily="34" charset="-127"/>
+                <a:cs typeface="Biome Light" panose="020B0303030204020804" pitchFamily="34" charset="0"/>
+              </a:rPr>
+              <a:t>Majid SharifiTehrani</a:t>
+            </a:r>
+          </a:p>
+        </p:txBody>
+      </p:sp>
     </p:spTree>
     <p:extLst>
       <p:ext uri="{BB962C8B-B14F-4D97-AF65-F5344CB8AC3E}">
         <p14:creationId xmlns:p14="http://schemas.microsoft.com/office/powerpoint/2010/main" val="230367927"/>
+      </p:ext>
+    </p:extLst>
+  </p:cSld>
+  <p:clrMapOvr>
+    <a:masterClrMapping/>
+  </p:clrMapOvr>
+</p:sld>
+</file>
+
+<file path=ppt/slides/slide2.xml><?xml version="1.0" encoding="utf-8"?>
+<p:sld xmlns:a="http://schemas.openxmlformats.org/drawingml/2006/main" xmlns:r="http://schemas.openxmlformats.org/officeDocument/2006/relationships" xmlns:p="http://schemas.openxmlformats.org/presentationml/2006/main">
+  <p:cSld>
+    <p:spTree>
+      <p:nvGrpSpPr>
+        <p:cNvPr id="1" name=""/>
+        <p:cNvGrpSpPr/>
+        <p:nvPr/>
+      </p:nvGrpSpPr>
+      <p:grpSpPr>
+        <a:xfrm>
+          <a:off x="0" y="0"/>
+          <a:ext cx="0" cy="0"/>
+          <a:chOff x="0" y="0"/>
+          <a:chExt cx="0" cy="0"/>
+        </a:xfrm>
+      </p:grpSpPr>
+    </p:spTree>
+    <p:extLst>
+      <p:ext uri="{BB962C8B-B14F-4D97-AF65-F5344CB8AC3E}">
+        <p14:creationId xmlns:p14="http://schemas.microsoft.com/office/powerpoint/2010/main" val="189674366"/>
       </p:ext>
     </p:extLst>
   </p:cSld>

</xml_diff>

<commit_message>
- Datasets: sort by: Name, Abbr, Year, Province
</commit_message>
<xml_diff>
--- a/AlamutB/.appCatalog/Alamut.pptx
+++ b/AlamutB/.appCatalog/Alamut.pptx
@@ -5,11 +5,10 @@
     <p:sldMasterId id="2147483648" r:id="rId1"/>
   </p:sldMasterIdLst>
   <p:notesMasterIdLst>
-    <p:notesMasterId r:id="rId4"/>
+    <p:notesMasterId r:id="rId3"/>
   </p:notesMasterIdLst>
   <p:sldIdLst>
     <p:sldId id="259" r:id="rId2"/>
-    <p:sldId id="260" r:id="rId3"/>
   </p:sldIdLst>
   <p:sldSz cx="12192000" cy="6858000"/>
   <p:notesSz cx="6858000" cy="9144000"/>
@@ -116,6 +115,12 @@
 </p:presentation>
 </file>
 
+<file path=ppt/authors.xml><?xml version="1.0" encoding="utf-8"?>
+<p188:authorLst xmlns:a="http://schemas.openxmlformats.org/drawingml/2006/main" xmlns:r="http://schemas.openxmlformats.org/officeDocument/2006/relationships" xmlns:p188="http://schemas.microsoft.com/office/powerpoint/2018/8/main">
+  <p188:author id="{D8CD309F-AF62-5F01-A3AB-FDBADD4645E6}" name="Majid SharifiTehrani" initials="MS" userId="f32ae554f42033bf" providerId="Windows Live"/>
+</p188:authorLst>
+</file>
+
 <file path=ppt/notesMasters/notesMaster1.xml><?xml version="1.0" encoding="utf-8"?>
 <p:notesMaster xmlns:a="http://schemas.openxmlformats.org/drawingml/2006/main" xmlns:r="http://schemas.openxmlformats.org/officeDocument/2006/relationships" xmlns:p="http://schemas.openxmlformats.org/presentationml/2006/main">
   <p:cSld>
@@ -198,7 +203,7 @@
           <a:p>
             <a:fld id="{76AEB20D-1E0E-486A-823D-795E0F1B1A92}" type="datetimeFigureOut">
               <a:rPr lang="en-US" smtClean="0"/>
-              <a:t>9/5/2026</a:t>
+              <a:t>9/24/2026</a:t>
             </a:fld>
             <a:endParaRPr lang="en-US"/>
           </a:p>
@@ -612,7 +617,7 @@
           <a:p>
             <a:fld id="{8A0CD729-867D-477D-ADDA-CA15108676C8}" type="datetimeFigureOut">
               <a:rPr lang="en-US" smtClean="0"/>
-              <a:t>9/5/2026</a:t>
+              <a:t>9/24/2026</a:t>
             </a:fld>
             <a:endParaRPr lang="en-US"/>
           </a:p>
@@ -810,7 +815,7 @@
           <a:p>
             <a:fld id="{8A0CD729-867D-477D-ADDA-CA15108676C8}" type="datetimeFigureOut">
               <a:rPr lang="en-US" smtClean="0"/>
-              <a:t>9/5/2026</a:t>
+              <a:t>9/24/2026</a:t>
             </a:fld>
             <a:endParaRPr lang="en-US"/>
           </a:p>
@@ -1018,7 +1023,7 @@
           <a:p>
             <a:fld id="{8A0CD729-867D-477D-ADDA-CA15108676C8}" type="datetimeFigureOut">
               <a:rPr lang="en-US" smtClean="0"/>
-              <a:t>9/5/2026</a:t>
+              <a:t>9/24/2026</a:t>
             </a:fld>
             <a:endParaRPr lang="en-US"/>
           </a:p>
@@ -1216,7 +1221,7 @@
           <a:p>
             <a:fld id="{8A0CD729-867D-477D-ADDA-CA15108676C8}" type="datetimeFigureOut">
               <a:rPr lang="en-US" smtClean="0"/>
-              <a:t>9/5/2026</a:t>
+              <a:t>9/24/2026</a:t>
             </a:fld>
             <a:endParaRPr lang="en-US"/>
           </a:p>
@@ -1491,7 +1496,7 @@
           <a:p>
             <a:fld id="{8A0CD729-867D-477D-ADDA-CA15108676C8}" type="datetimeFigureOut">
               <a:rPr lang="en-US" smtClean="0"/>
-              <a:t>9/5/2026</a:t>
+              <a:t>9/24/2026</a:t>
             </a:fld>
             <a:endParaRPr lang="en-US"/>
           </a:p>
@@ -1756,7 +1761,7 @@
           <a:p>
             <a:fld id="{8A0CD729-867D-477D-ADDA-CA15108676C8}" type="datetimeFigureOut">
               <a:rPr lang="en-US" smtClean="0"/>
-              <a:t>9/5/2026</a:t>
+              <a:t>9/24/2026</a:t>
             </a:fld>
             <a:endParaRPr lang="en-US"/>
           </a:p>
@@ -2168,7 +2173,7 @@
           <a:p>
             <a:fld id="{8A0CD729-867D-477D-ADDA-CA15108676C8}" type="datetimeFigureOut">
               <a:rPr lang="en-US" smtClean="0"/>
-              <a:t>9/5/2026</a:t>
+              <a:t>9/24/2026</a:t>
             </a:fld>
             <a:endParaRPr lang="en-US"/>
           </a:p>
@@ -2309,7 +2314,7 @@
           <a:p>
             <a:fld id="{8A0CD729-867D-477D-ADDA-CA15108676C8}" type="datetimeFigureOut">
               <a:rPr lang="en-US" smtClean="0"/>
-              <a:t>9/5/2026</a:t>
+              <a:t>9/24/2026</a:t>
             </a:fld>
             <a:endParaRPr lang="en-US"/>
           </a:p>
@@ -2422,7 +2427,7 @@
           <a:p>
             <a:fld id="{8A0CD729-867D-477D-ADDA-CA15108676C8}" type="datetimeFigureOut">
               <a:rPr lang="en-US" smtClean="0"/>
-              <a:t>9/5/2026</a:t>
+              <a:t>9/24/2026</a:t>
             </a:fld>
             <a:endParaRPr lang="en-US"/>
           </a:p>
@@ -2733,7 +2738,7 @@
           <a:p>
             <a:fld id="{8A0CD729-867D-477D-ADDA-CA15108676C8}" type="datetimeFigureOut">
               <a:rPr lang="en-US" smtClean="0"/>
-              <a:t>9/5/2026</a:t>
+              <a:t>9/24/2026</a:t>
             </a:fld>
             <a:endParaRPr lang="en-US"/>
           </a:p>
@@ -3021,7 +3026,7 @@
           <a:p>
             <a:fld id="{8A0CD729-867D-477D-ADDA-CA15108676C8}" type="datetimeFigureOut">
               <a:rPr lang="en-US" smtClean="0"/>
-              <a:t>9/5/2026</a:t>
+              <a:t>9/24/2026</a:t>
             </a:fld>
             <a:endParaRPr lang="en-US"/>
           </a:p>
@@ -3262,7 +3267,7 @@
           <a:p>
             <a:fld id="{8A0CD729-867D-477D-ADDA-CA15108676C8}" type="datetimeFigureOut">
               <a:rPr lang="en-US" smtClean="0"/>
-              <a:t>9/5/2026</a:t>
+              <a:t>9/24/2026</a:t>
             </a:fld>
             <a:endParaRPr lang="en-US"/>
           </a:p>
@@ -3687,10 +3692,10 @@
       </p:grpSpPr>
       <p:sp>
         <p:nvSpPr>
-          <p:cNvPr id="2" name="Oval 1">
+          <p:cNvPr id="10" name="Oval 9">
             <a:extLst>
               <a:ext uri="{FF2B5EF4-FFF2-40B4-BE49-F238E27FC236}">
-                <a16:creationId xmlns:a16="http://schemas.microsoft.com/office/drawing/2014/main" id="{593362CC-2ACB-B0F9-54CE-223C0497C830}"/>
+                <a16:creationId xmlns:a16="http://schemas.microsoft.com/office/drawing/2014/main" id="{60E99BB7-6ADD-2CA6-D412-260DD9E0B6F7}"/>
               </a:ext>
             </a:extLst>
           </p:cNvPr>
@@ -3698,15 +3703,15 @@
           <p:nvPr/>
         </p:nvSpPr>
         <p:spPr>
-          <a:xfrm>
-            <a:off x="6218818" y="846825"/>
-            <a:ext cx="5718777" cy="5629533"/>
+          <a:xfrm rot="20926109">
+            <a:off x="287467" y="962513"/>
+            <a:ext cx="7326724" cy="5883392"/>
           </a:xfrm>
           <a:prstGeom prst="ellipse">
             <a:avLst/>
           </a:prstGeom>
           <a:solidFill>
-            <a:srgbClr val="E4F6DE"/>
+            <a:srgbClr val="FBEFFA"/>
           </a:solidFill>
           <a:ln w="28575">
             <a:noFill/>
@@ -3748,67 +3753,6 @@
       </p:sp>
       <p:sp>
         <p:nvSpPr>
-          <p:cNvPr id="10" name="Oval 9">
-            <a:extLst>
-              <a:ext uri="{FF2B5EF4-FFF2-40B4-BE49-F238E27FC236}">
-                <a16:creationId xmlns:a16="http://schemas.microsoft.com/office/drawing/2014/main" id="{60E99BB7-6ADD-2CA6-D412-260DD9E0B6F7}"/>
-              </a:ext>
-            </a:extLst>
-          </p:cNvPr>
-          <p:cNvSpPr/>
-          <p:nvPr/>
-        </p:nvSpPr>
-        <p:spPr>
-          <a:xfrm rot="20926109">
-            <a:off x="421202" y="945579"/>
-            <a:ext cx="6369193" cy="5883392"/>
-          </a:xfrm>
-          <a:prstGeom prst="ellipse">
-            <a:avLst/>
-          </a:prstGeom>
-          <a:solidFill>
-            <a:srgbClr val="F8E4F6"/>
-          </a:solidFill>
-          <a:ln w="28575">
-            <a:noFill/>
-            <a:prstDash val="solid"/>
-          </a:ln>
-          <a:effectLst/>
-        </p:spPr>
-        <p:style>
-          <a:lnRef idx="0">
-            <a:schemeClr val="accent4"/>
-          </a:lnRef>
-          <a:fillRef idx="3">
-            <a:schemeClr val="accent4"/>
-          </a:fillRef>
-          <a:effectRef idx="3">
-            <a:schemeClr val="accent4"/>
-          </a:effectRef>
-          <a:fontRef idx="minor">
-            <a:schemeClr val="lt1"/>
-          </a:fontRef>
-        </p:style>
-        <p:txBody>
-          <a:bodyPr rtlCol="1" anchor="ctr"/>
-          <a:lstStyle/>
-          <a:p>
-            <a:pPr algn="r" rtl="1"/>
-            <a:endParaRPr lang="en-US" sz="4000" b="1">
-              <a:solidFill>
-                <a:schemeClr val="bg1"/>
-              </a:solidFill>
-              <a:highlight>
-                <a:srgbClr val="800080"/>
-              </a:highlight>
-              <a:latin typeface="Segoe UI" panose="020B0502040204020203" pitchFamily="34" charset="0"/>
-              <a:cs typeface="Segoe UI" panose="020B0502040204020203" pitchFamily="34" charset="0"/>
-            </a:endParaRPr>
-          </a:p>
-        </p:txBody>
-      </p:sp>
-      <p:sp>
-        <p:nvSpPr>
           <p:cNvPr id="13" name="Oval 12">
             <a:extLst>
               <a:ext uri="{FF2B5EF4-FFF2-40B4-BE49-F238E27FC236}">
@@ -3821,7 +3765,7 @@
         </p:nvSpPr>
         <p:spPr>
           <a:xfrm rot="20705849">
-            <a:off x="1144751" y="63945"/>
+            <a:off x="1575059" y="63945"/>
             <a:ext cx="3972129" cy="3030464"/>
           </a:xfrm>
           <a:prstGeom prst="ellipse">
@@ -3870,6 +3814,258 @@
       </p:sp>
       <p:sp>
         <p:nvSpPr>
+          <p:cNvPr id="17" name="Rectangle: Rounded Corners 45">
+            <a:extLst>
+              <a:ext uri="{FF2B5EF4-FFF2-40B4-BE49-F238E27FC236}">
+                <a16:creationId xmlns:a16="http://schemas.microsoft.com/office/drawing/2014/main" id="{2A55614E-EDBF-474D-376C-90AF0B72A1C0}"/>
+              </a:ext>
+            </a:extLst>
+          </p:cNvPr>
+          <p:cNvSpPr/>
+          <p:nvPr/>
+        </p:nvSpPr>
+        <p:spPr bwMode="auto">
+          <a:xfrm>
+            <a:off x="82867" y="4011787"/>
+            <a:ext cx="1554803" cy="1710472"/>
+          </a:xfrm>
+          <a:prstGeom prst="roundRect">
+            <a:avLst>
+              <a:gd name="adj" fmla="val 3991"/>
+            </a:avLst>
+          </a:prstGeom>
+          <a:solidFill>
+            <a:schemeClr val="bg1"/>
+          </a:solidFill>
+          <a:ln w="12700">
+            <a:solidFill>
+              <a:schemeClr val="tx1"/>
+            </a:solidFill>
+          </a:ln>
+          <a:effectLst/>
+        </p:spPr>
+        <p:style>
+          <a:lnRef idx="0">
+            <a:schemeClr val="accent4"/>
+          </a:lnRef>
+          <a:fillRef idx="3">
+            <a:schemeClr val="accent4"/>
+          </a:fillRef>
+          <a:effectRef idx="3">
+            <a:schemeClr val="accent4"/>
+          </a:effectRef>
+          <a:fontRef idx="minor">
+            <a:schemeClr val="lt1"/>
+          </a:fontRef>
+        </p:style>
+        <p:txBody>
+          <a:bodyPr rtlCol="1" anchor="t"/>
+          <a:lstStyle/>
+          <a:p>
+            <a:pPr>
+              <a:defRPr/>
+            </a:pPr>
+            <a:r>
+              <a:rPr lang="en-US" sz="1600" b="1">
+                <a:solidFill>
+                  <a:schemeClr val="bg1"/>
+                </a:solidFill>
+                <a:highlight>
+                  <a:srgbClr val="800080"/>
+                </a:highlight>
+                <a:latin typeface="Segoe UI" panose="020B0502040204020203" pitchFamily="34" charset="0"/>
+                <a:cs typeface="Segoe UI" panose="020B0502040204020203" pitchFamily="34" charset="0"/>
+              </a:rPr>
+              <a:t>Notebooks</a:t>
+            </a:r>
+            <a:endParaRPr sz="1600" b="1">
+              <a:solidFill>
+                <a:schemeClr val="bg1"/>
+              </a:solidFill>
+              <a:highlight>
+                <a:srgbClr val="800080"/>
+              </a:highlight>
+              <a:latin typeface="Segoe UI" panose="020B0502040204020203" pitchFamily="34" charset="0"/>
+              <a:cs typeface="Segoe UI" panose="020B0502040204020203" pitchFamily="34" charset="0"/>
+            </a:endParaRPr>
+          </a:p>
+          <a:p>
+            <a:pPr>
+              <a:defRPr/>
+            </a:pPr>
+            <a:r>
+              <a:rPr lang="en-US" sz="900" i="1">
+                <a:solidFill>
+                  <a:schemeClr val="accent5"/>
+                </a:solidFill>
+                <a:latin typeface="Segoe UI" panose="020B0502040204020203" pitchFamily="34" charset="0"/>
+                <a:cs typeface="Segoe UI" panose="020B0502040204020203" pitchFamily="34" charset="0"/>
+              </a:rPr>
+              <a:t>NotebookId</a:t>
+            </a:r>
+            <a:endParaRPr lang="en-US" sz="900">
+              <a:solidFill>
+                <a:schemeClr val="tx1"/>
+              </a:solidFill>
+              <a:latin typeface="Segoe UI" panose="020B0502040204020203" pitchFamily="34" charset="0"/>
+              <a:cs typeface="Segoe UI" panose="020B0502040204020203" pitchFamily="34" charset="0"/>
+            </a:endParaRPr>
+          </a:p>
+          <a:p>
+            <a:pPr>
+              <a:defRPr/>
+            </a:pPr>
+            <a:r>
+              <a:rPr lang="en-US" sz="900">
+                <a:solidFill>
+                  <a:schemeClr val="tx1"/>
+                </a:solidFill>
+                <a:latin typeface="Segoe UI" panose="020B0502040204020203" pitchFamily="34" charset="0"/>
+                <a:cs typeface="Segoe UI" panose="020B0502040204020203" pitchFamily="34" charset="0"/>
+              </a:rPr>
+              <a:t>UserId</a:t>
+            </a:r>
+          </a:p>
+          <a:p>
+            <a:pPr>
+              <a:defRPr/>
+            </a:pPr>
+            <a:r>
+              <a:rPr lang="en-US" sz="900">
+                <a:solidFill>
+                  <a:schemeClr val="tx1"/>
+                </a:solidFill>
+                <a:latin typeface="Segoe UI" panose="020B0502040204020203" pitchFamily="34" charset="0"/>
+                <a:cs typeface="Segoe UI" panose="020B0502040204020203" pitchFamily="34" charset="0"/>
+              </a:rPr>
+              <a:t>NotebookName</a:t>
+            </a:r>
+          </a:p>
+          <a:p>
+            <a:pPr>
+              <a:defRPr/>
+            </a:pPr>
+            <a:r>
+              <a:rPr lang="en-US" sz="900">
+                <a:solidFill>
+                  <a:schemeClr val="tx1"/>
+                </a:solidFill>
+                <a:latin typeface="Segoe UI" panose="020B0502040204020203" pitchFamily="34" charset="0"/>
+                <a:cs typeface="Segoe UI" panose="020B0502040204020203" pitchFamily="34" charset="0"/>
+              </a:rPr>
+              <a:t>NotebookTags</a:t>
+            </a:r>
+          </a:p>
+          <a:p>
+            <a:pPr>
+              <a:defRPr/>
+            </a:pPr>
+            <a:r>
+              <a:rPr lang="en-US" sz="900">
+                <a:solidFill>
+                  <a:schemeClr val="tx1"/>
+                </a:solidFill>
+                <a:latin typeface="Segoe UI" panose="020B0502040204020203" pitchFamily="34" charset="0"/>
+                <a:cs typeface="Segoe UI" panose="020B0502040204020203" pitchFamily="34" charset="0"/>
+              </a:rPr>
+              <a:t>IsActive</a:t>
+            </a:r>
+          </a:p>
+          <a:p>
+            <a:pPr>
+              <a:defRPr/>
+            </a:pPr>
+            <a:r>
+              <a:rPr lang="en-US" sz="900">
+                <a:solidFill>
+                  <a:srgbClr val="0070C0"/>
+                </a:solidFill>
+                <a:latin typeface="Segoe UI" panose="020B0502040204020203" pitchFamily="34" charset="0"/>
+                <a:cs typeface="Segoe UI" panose="020B0502040204020203" pitchFamily="34" charset="0"/>
+              </a:rPr>
+              <a:t>*List&lt;Section&gt; Sections</a:t>
+            </a:r>
+          </a:p>
+          <a:p>
+            <a:pPr>
+              <a:defRPr/>
+            </a:pPr>
+            <a:r>
+              <a:rPr lang="en-US" sz="900">
+                <a:solidFill>
+                  <a:srgbClr val="0070C0"/>
+                </a:solidFill>
+                <a:latin typeface="Segoe UI" panose="020B0502040204020203" pitchFamily="34" charset="0"/>
+                <a:cs typeface="Segoe UI" panose="020B0502040204020203" pitchFamily="34" charset="0"/>
+              </a:rPr>
+              <a:t>*List&lt;Note&gt; Notes</a:t>
+            </a:r>
+          </a:p>
+        </p:txBody>
+      </p:sp>
+      <p:sp>
+        <p:nvSpPr>
+          <p:cNvPr id="2" name="Oval 1">
+            <a:extLst>
+              <a:ext uri="{FF2B5EF4-FFF2-40B4-BE49-F238E27FC236}">
+                <a16:creationId xmlns:a16="http://schemas.microsoft.com/office/drawing/2014/main" id="{593362CC-2ACB-B0F9-54CE-223C0497C830}"/>
+              </a:ext>
+            </a:extLst>
+          </p:cNvPr>
+          <p:cNvSpPr/>
+          <p:nvPr/>
+        </p:nvSpPr>
+        <p:spPr>
+          <a:xfrm>
+            <a:off x="6649127" y="846825"/>
+            <a:ext cx="5444264" cy="5629533"/>
+          </a:xfrm>
+          <a:prstGeom prst="ellipse">
+            <a:avLst/>
+          </a:prstGeom>
+          <a:solidFill>
+            <a:srgbClr val="F2FBEF"/>
+          </a:solidFill>
+          <a:ln w="28575">
+            <a:noFill/>
+            <a:prstDash val="solid"/>
+          </a:ln>
+          <a:effectLst/>
+        </p:spPr>
+        <p:style>
+          <a:lnRef idx="0">
+            <a:schemeClr val="accent4"/>
+          </a:lnRef>
+          <a:fillRef idx="3">
+            <a:schemeClr val="accent4"/>
+          </a:fillRef>
+          <a:effectRef idx="3">
+            <a:schemeClr val="accent4"/>
+          </a:effectRef>
+          <a:fontRef idx="minor">
+            <a:schemeClr val="lt1"/>
+          </a:fontRef>
+        </p:style>
+        <p:txBody>
+          <a:bodyPr rtlCol="1" anchor="ctr"/>
+          <a:lstStyle/>
+          <a:p>
+            <a:pPr algn="r" rtl="1"/>
+            <a:endParaRPr lang="en-US" sz="4000" b="1">
+              <a:solidFill>
+                <a:schemeClr val="bg1"/>
+              </a:solidFill>
+              <a:highlight>
+                <a:srgbClr val="800080"/>
+              </a:highlight>
+              <a:latin typeface="Segoe UI" panose="020B0502040204020203" pitchFamily="34" charset="0"/>
+              <a:cs typeface="Segoe UI" panose="020B0502040204020203" pitchFamily="34" charset="0"/>
+            </a:endParaRPr>
+          </a:p>
+        </p:txBody>
+      </p:sp>
+      <p:sp>
+        <p:nvSpPr>
           <p:cNvPr id="6" name="Rectangle: Rounded Corners 45">
             <a:extLst>
               <a:ext uri="{FF2B5EF4-FFF2-40B4-BE49-F238E27FC236}">
@@ -3882,7 +4078,7 @@
         </p:nvSpPr>
         <p:spPr bwMode="auto">
           <a:xfrm>
-            <a:off x="1310993" y="465163"/>
+            <a:off x="2180577" y="465163"/>
             <a:ext cx="1395681" cy="948228"/>
           </a:xfrm>
           <a:prstGeom prst="roundRect">
@@ -3991,8 +4187,8 @@
         </p:nvSpPr>
         <p:spPr bwMode="auto">
           <a:xfrm>
-            <a:off x="377542" y="1805988"/>
-            <a:ext cx="1618767" cy="4010017"/>
+            <a:off x="1487078" y="1805988"/>
+            <a:ext cx="1674652" cy="4263118"/>
           </a:xfrm>
           <a:prstGeom prst="roundRect">
             <a:avLst>
@@ -4282,10 +4478,10 @@
             </a:r>
           </a:p>
           <a:p>
-            <a:pPr marL="84138">
-              <a:defRPr/>
-            </a:pPr>
-            <a:endParaRPr lang="en-US" sz="800">
+            <a:pPr>
+              <a:defRPr/>
+            </a:pPr>
+            <a:endParaRPr lang="en-US" sz="800" b="1" i="1">
               <a:solidFill>
                 <a:schemeClr val="tx1"/>
               </a:solidFill>
@@ -4531,8 +4727,8 @@
         </p:nvSpPr>
         <p:spPr bwMode="auto">
           <a:xfrm>
-            <a:off x="1350393" y="5149668"/>
-            <a:ext cx="1533975" cy="1044301"/>
+            <a:off x="2381341" y="5481366"/>
+            <a:ext cx="1533975" cy="1243169"/>
           </a:xfrm>
           <a:prstGeom prst="roundRect">
             <a:avLst>
@@ -4661,6 +4857,36 @@
               <a:t>Subsets</a:t>
             </a:r>
           </a:p>
+          <a:p>
+            <a:pPr>
+              <a:defRPr/>
+            </a:pPr>
+            <a:r>
+              <a:rPr lang="en-US" sz="900">
+                <a:solidFill>
+                  <a:srgbClr val="0070C0"/>
+                </a:solidFill>
+                <a:latin typeface="Segoe UI" panose="020B0502040204020203" pitchFamily="34" charset="0"/>
+                <a:cs typeface="Segoe UI" panose="020B0502040204020203" pitchFamily="34" charset="0"/>
+              </a:rPr>
+              <a:t>*DatasetName</a:t>
+            </a:r>
+          </a:p>
+          <a:p>
+            <a:pPr>
+              <a:defRPr/>
+            </a:pPr>
+            <a:r>
+              <a:rPr lang="en-US" sz="900">
+                <a:solidFill>
+                  <a:srgbClr val="0070C0"/>
+                </a:solidFill>
+                <a:latin typeface="Segoe UI" panose="020B0502040204020203" pitchFamily="34" charset="0"/>
+                <a:cs typeface="Segoe UI" panose="020B0502040204020203" pitchFamily="34" charset="0"/>
+              </a:rPr>
+              <a:t>*Subset1-5</a:t>
+            </a:r>
+          </a:p>
         </p:txBody>
       </p:sp>
       <p:sp>
@@ -4677,7 +4903,7 @@
         </p:nvSpPr>
         <p:spPr bwMode="auto">
           <a:xfrm>
-            <a:off x="3603736" y="193485"/>
+            <a:off x="4374705" y="193485"/>
             <a:ext cx="1395681" cy="948228"/>
           </a:xfrm>
           <a:prstGeom prst="roundRect">
@@ -4793,8 +5019,8 @@
         </p:nvSpPr>
         <p:spPr bwMode="auto">
           <a:xfrm>
-            <a:off x="3820826" y="969133"/>
-            <a:ext cx="1275139" cy="1163457"/>
+            <a:off x="4588103" y="831662"/>
+            <a:ext cx="1474660" cy="1163457"/>
           </a:xfrm>
           <a:prstGeom prst="roundRect">
             <a:avLst>
@@ -4908,6 +5134,21 @@
               <a:t>ProvinceName</a:t>
             </a:r>
           </a:p>
+          <a:p>
+            <a:pPr>
+              <a:defRPr/>
+            </a:pPr>
+            <a:r>
+              <a:rPr lang="en-US" sz="900">
+                <a:solidFill>
+                  <a:srgbClr val="0070C0"/>
+                </a:solidFill>
+                <a:latin typeface="Segoe UI" panose="020B0502040204020203" pitchFamily="34" charset="0"/>
+                <a:cs typeface="Segoe UI" panose="020B0502040204020203" pitchFamily="34" charset="0"/>
+              </a:rPr>
+              <a:t>*List&lt;Dataset&gt; Datasets</a:t>
+            </a:r>
+          </a:p>
         </p:txBody>
       </p:sp>
       <p:sp>
@@ -4924,7 +5165,7 @@
         </p:nvSpPr>
         <p:spPr bwMode="auto">
           <a:xfrm>
-            <a:off x="1774839" y="1161160"/>
+            <a:off x="2644423" y="1161160"/>
             <a:ext cx="1769091" cy="2745395"/>
           </a:xfrm>
           <a:prstGeom prst="roundRect">
@@ -5203,7 +5444,7 @@
                 <a:latin typeface="Segoe UI" panose="020B0502040204020203" pitchFamily="34" charset="0"/>
                 <a:cs typeface="Segoe UI" panose="020B0502040204020203" pitchFamily="34" charset="0"/>
               </a:rPr>
-              <a:t>  32: DueNotesDays=14  (def: 7)</a:t>
+              <a:t>  32: DueNotesDays=14 (def:7)</a:t>
             </a:r>
           </a:p>
           <a:p>
@@ -5249,6 +5490,21 @@
                 <a:cs typeface="Segoe UI" panose="020B0502040204020203" pitchFamily="34" charset="0"/>
               </a:rPr>
               <a:t>256: UseFaCalendar</a:t>
+            </a:r>
+          </a:p>
+          <a:p>
+            <a:pPr marL="84138">
+              <a:defRPr/>
+            </a:pPr>
+            <a:r>
+              <a:rPr lang="en-US" sz="900">
+                <a:solidFill>
+                  <a:srgbClr val="0070C0"/>
+                </a:solidFill>
+                <a:latin typeface="Segoe UI" panose="020B0502040204020203" pitchFamily="34" charset="0"/>
+                <a:cs typeface="Segoe UI" panose="020B0502040204020203" pitchFamily="34" charset="0"/>
+              </a:rPr>
+              <a:t>*List&lt;Note&gt; UserNotes</a:t>
             </a:r>
           </a:p>
           <a:p>
@@ -5279,8 +5535,8 @@
         </p:nvSpPr>
         <p:spPr bwMode="auto">
           <a:xfrm>
-            <a:off x="2378924" y="3710176"/>
-            <a:ext cx="1625139" cy="1750428"/>
+            <a:off x="3338158" y="3755000"/>
+            <a:ext cx="1625139" cy="2024089"/>
           </a:xfrm>
           <a:prstGeom prst="roundRect">
             <a:avLst>
@@ -5438,13 +5694,31 @@
             <a:pPr marL="85725">
               <a:defRPr/>
             </a:pPr>
-            <a:endParaRPr lang="en-US" sz="900">
-              <a:solidFill>
-                <a:srgbClr val="C00000"/>
-              </a:solidFill>
-              <a:latin typeface="Segoe UI" panose="020B0502040204020203" pitchFamily="34" charset="0"/>
-              <a:cs typeface="Segoe UI" panose="020B0502040204020203" pitchFamily="34" charset="0"/>
-            </a:endParaRPr>
+            <a:r>
+              <a:rPr lang="en-US" sz="900">
+                <a:solidFill>
+                  <a:srgbClr val="0070C0"/>
+                </a:solidFill>
+                <a:latin typeface="Segoe UI" panose="020B0502040204020203" pitchFamily="34" charset="0"/>
+                <a:cs typeface="Segoe UI" panose="020B0502040204020203" pitchFamily="34" charset="0"/>
+              </a:rPr>
+              <a:t>**IsSelected</a:t>
+            </a:r>
+          </a:p>
+          <a:p>
+            <a:pPr marL="85725">
+              <a:defRPr/>
+            </a:pPr>
+            <a:r>
+              <a:rPr lang="en-US" sz="900">
+                <a:solidFill>
+                  <a:srgbClr val="0070C0"/>
+                </a:solidFill>
+                <a:latin typeface="Segoe UI" panose="020B0502040204020203" pitchFamily="34" charset="0"/>
+                <a:cs typeface="Segoe UI" panose="020B0502040204020203" pitchFamily="34" charset="0"/>
+              </a:rPr>
+              <a:t>**SelectedSubset</a:t>
+            </a:r>
           </a:p>
           <a:p>
             <a:pPr marL="93663">
@@ -5517,7 +5791,7 @@
         </p:nvSpPr>
         <p:spPr bwMode="auto">
           <a:xfrm>
-            <a:off x="3467514" y="1795357"/>
+            <a:off x="4238483" y="1795357"/>
             <a:ext cx="2172080" cy="2975213"/>
           </a:xfrm>
           <a:prstGeom prst="roundRect">
@@ -5796,6 +6070,21 @@
             <a:r>
               <a:rPr lang="en-US" sz="900">
                 <a:solidFill>
+                  <a:srgbClr val="0070C0"/>
+                </a:solidFill>
+                <a:latin typeface="Segoe UI" panose="020B0502040204020203" pitchFamily="34" charset="0"/>
+                <a:cs typeface="Segoe UI" panose="020B0502040204020203" pitchFamily="34" charset="0"/>
+              </a:rPr>
+              <a:t>*ProvinceName</a:t>
+            </a:r>
+          </a:p>
+          <a:p>
+            <a:pPr>
+              <a:defRPr/>
+            </a:pPr>
+            <a:r>
+              <a:rPr lang="en-US" sz="900">
+                <a:solidFill>
                   <a:schemeClr val="tx1"/>
                 </a:solidFill>
                 <a:latin typeface="Segoe UI" panose="020B0502040204020203" pitchFamily="34" charset="0"/>
@@ -5871,52 +6160,32 @@
                 <a:latin typeface="Segoe UI" panose="020B0502040204020203" pitchFamily="34" charset="0"/>
                 <a:cs typeface="Segoe UI" panose="020B0502040204020203" pitchFamily="34" charset="0"/>
               </a:rPr>
-              <a:t>Tags</a:t>
-            </a:r>
-          </a:p>
-          <a:p>
-            <a:pPr>
-              <a:defRPr/>
-            </a:pPr>
-            <a:r>
-              <a:rPr lang="en-US" sz="900">
-                <a:solidFill>
-                  <a:schemeClr val="tx1"/>
-                </a:solidFill>
-                <a:latin typeface="Segoe UI" panose="020B0502040204020203" pitchFamily="34" charset="0"/>
-                <a:cs typeface="Segoe UI" panose="020B0502040204020203" pitchFamily="34" charset="0"/>
-              </a:rPr>
-              <a:t>1: </a:t>
-            </a:r>
-          </a:p>
-          <a:p>
-            <a:pPr>
-              <a:defRPr/>
-            </a:pPr>
-            <a:r>
-              <a:rPr lang="en-US" sz="900">
-                <a:solidFill>
-                  <a:schemeClr val="tx1"/>
-                </a:solidFill>
-                <a:latin typeface="Segoe UI" panose="020B0502040204020203" pitchFamily="34" charset="0"/>
-                <a:cs typeface="Segoe UI" panose="020B0502040204020203" pitchFamily="34" charset="0"/>
-              </a:rPr>
-              <a:t>2: </a:t>
-            </a:r>
-          </a:p>
-          <a:p>
-            <a:pPr>
-              <a:defRPr/>
-            </a:pPr>
-            <a:r>
-              <a:rPr lang="en-US" sz="900">
-                <a:solidFill>
-                  <a:schemeClr val="tx1"/>
-                </a:solidFill>
-                <a:latin typeface="Segoe UI" panose="020B0502040204020203" pitchFamily="34" charset="0"/>
-                <a:cs typeface="Segoe UI" panose="020B0502040204020203" pitchFamily="34" charset="0"/>
-              </a:rPr>
-              <a:t>4: </a:t>
+              <a:t>Tags   </a:t>
+            </a:r>
+            <a:r>
+              <a:rPr lang="en-US" sz="900">
+                <a:solidFill>
+                  <a:schemeClr val="tx1"/>
+                </a:solidFill>
+                <a:latin typeface="Segoe UI" panose="020B0502040204020203" pitchFamily="34" charset="0"/>
+                <a:cs typeface="Segoe UI" panose="020B0502040204020203" pitchFamily="34" charset="0"/>
+              </a:rPr>
+              <a:t>1: 2:  4: </a:t>
+            </a:r>
+          </a:p>
+          <a:p>
+            <a:pPr>
+              <a:defRPr/>
+            </a:pPr>
+            <a:r>
+              <a:rPr lang="en-US" sz="900">
+                <a:solidFill>
+                  <a:srgbClr val="0070C0"/>
+                </a:solidFill>
+                <a:latin typeface="Segoe UI" panose="020B0502040204020203" pitchFamily="34" charset="0"/>
+                <a:cs typeface="Segoe UI" panose="020B0502040204020203" pitchFamily="34" charset="0"/>
+              </a:rPr>
+              <a:t>**IsSelected</a:t>
             </a:r>
           </a:p>
         </p:txBody>
@@ -5935,7 +6204,7 @@
         </p:nvSpPr>
         <p:spPr bwMode="auto">
           <a:xfrm>
-            <a:off x="5362376" y="2037328"/>
+            <a:off x="6016804" y="2037328"/>
             <a:ext cx="1484046" cy="1909132"/>
           </a:xfrm>
           <a:prstGeom prst="roundRect">
@@ -6110,6 +6379,36 @@
               <a:t>ParsedEpithet</a:t>
             </a:r>
           </a:p>
+          <a:p>
+            <a:pPr>
+              <a:defRPr/>
+            </a:pPr>
+            <a:r>
+              <a:rPr lang="en-US" sz="900">
+                <a:solidFill>
+                  <a:srgbClr val="0070C0"/>
+                </a:solidFill>
+                <a:latin typeface="Segoe UI" panose="020B0502040204020203" pitchFamily="34" charset="0"/>
+                <a:cs typeface="Segoe UI" panose="020B0502040204020203" pitchFamily="34" charset="0"/>
+              </a:rPr>
+              <a:t>*SciName</a:t>
+            </a:r>
+          </a:p>
+          <a:p>
+            <a:pPr>
+              <a:defRPr/>
+            </a:pPr>
+            <a:r>
+              <a:rPr lang="en-US" sz="900">
+                <a:solidFill>
+                  <a:srgbClr val="0070C0"/>
+                </a:solidFill>
+                <a:latin typeface="Segoe UI" panose="020B0502040204020203" pitchFamily="34" charset="0"/>
+                <a:cs typeface="Segoe UI" panose="020B0502040204020203" pitchFamily="34" charset="0"/>
+              </a:rPr>
+              <a:t>**IsSelected</a:t>
+            </a:r>
+          </a:p>
         </p:txBody>
       </p:sp>
       <p:sp>
@@ -6126,7 +6425,7 @@
         </p:nvSpPr>
         <p:spPr>
           <a:xfrm>
-            <a:off x="6437846" y="-61022"/>
+            <a:off x="8355561" y="-239623"/>
             <a:ext cx="2843200" cy="1569660"/>
           </a:xfrm>
           <a:prstGeom prst="rect">
@@ -6199,7 +6498,7 @@
         </p:nvSpPr>
         <p:spPr bwMode="auto">
           <a:xfrm>
-            <a:off x="3317397" y="5045520"/>
+            <a:off x="4186981" y="5144135"/>
             <a:ext cx="1679348" cy="1213704"/>
           </a:xfrm>
           <a:prstGeom prst="roundRect">
@@ -6353,7 +6652,7 @@
         </p:nvSpPr>
         <p:spPr bwMode="auto">
           <a:xfrm>
-            <a:off x="4372075" y="5303956"/>
+            <a:off x="5241659" y="5402571"/>
             <a:ext cx="1679348" cy="1111233"/>
           </a:xfrm>
           <a:prstGeom prst="roundRect">
@@ -6534,8 +6833,8 @@
         </p:nvSpPr>
         <p:spPr bwMode="auto">
           <a:xfrm>
-            <a:off x="6538306" y="2611937"/>
-            <a:ext cx="1416106" cy="2355901"/>
+            <a:off x="6968614" y="2611936"/>
+            <a:ext cx="1416106" cy="3582033"/>
           </a:xfrm>
           <a:prstGeom prst="roundRect">
             <a:avLst>
@@ -6641,6 +6940,96 @@
             <a:r>
               <a:rPr lang="en-US" sz="900">
                 <a:solidFill>
+                  <a:srgbClr val="0070C0"/>
+                </a:solidFill>
+                <a:latin typeface="Segoe UI" panose="020B0502040204020203" pitchFamily="34" charset="0"/>
+                <a:cs typeface="Segoe UI" panose="020B0502040204020203" pitchFamily="34" charset="0"/>
+              </a:rPr>
+              <a:t>*ApgGroupId</a:t>
+            </a:r>
+          </a:p>
+          <a:p>
+            <a:pPr>
+              <a:defRPr/>
+            </a:pPr>
+            <a:r>
+              <a:rPr lang="en-US" sz="900">
+                <a:solidFill>
+                  <a:srgbClr val="0070C0"/>
+                </a:solidFill>
+                <a:latin typeface="Segoe UI" panose="020B0502040204020203" pitchFamily="34" charset="0"/>
+                <a:cs typeface="Segoe UI" panose="020B0502040204020203" pitchFamily="34" charset="0"/>
+              </a:rPr>
+              <a:t>*ApgGroupName</a:t>
+            </a:r>
+          </a:p>
+          <a:p>
+            <a:pPr>
+              <a:defRPr/>
+            </a:pPr>
+            <a:r>
+              <a:rPr lang="en-US" sz="900">
+                <a:solidFill>
+                  <a:srgbClr val="0070C0"/>
+                </a:solidFill>
+                <a:latin typeface="Segoe UI" panose="020B0502040204020203" pitchFamily="34" charset="0"/>
+                <a:cs typeface="Segoe UI" panose="020B0502040204020203" pitchFamily="34" charset="0"/>
+              </a:rPr>
+              <a:t>*OrderId</a:t>
+            </a:r>
+          </a:p>
+          <a:p>
+            <a:pPr>
+              <a:defRPr/>
+            </a:pPr>
+            <a:r>
+              <a:rPr lang="en-US" sz="900">
+                <a:solidFill>
+                  <a:srgbClr val="0070C0"/>
+                </a:solidFill>
+                <a:latin typeface="Segoe UI" panose="020B0502040204020203" pitchFamily="34" charset="0"/>
+                <a:cs typeface="Segoe UI" panose="020B0502040204020203" pitchFamily="34" charset="0"/>
+              </a:rPr>
+              <a:t>*OrderName</a:t>
+            </a:r>
+          </a:p>
+          <a:p>
+            <a:pPr>
+              <a:defRPr/>
+            </a:pPr>
+            <a:r>
+              <a:rPr lang="en-US" sz="900">
+                <a:solidFill>
+                  <a:srgbClr val="0070C0"/>
+                </a:solidFill>
+                <a:latin typeface="Segoe UI" panose="020B0502040204020203" pitchFamily="34" charset="0"/>
+                <a:cs typeface="Segoe UI" panose="020B0502040204020203" pitchFamily="34" charset="0"/>
+              </a:rPr>
+              <a:t>*FamilyId</a:t>
+            </a:r>
+          </a:p>
+          <a:p>
+            <a:pPr>
+              <a:defRPr/>
+            </a:pPr>
+            <a:r>
+              <a:rPr lang="en-US" sz="900">
+                <a:solidFill>
+                  <a:srgbClr val="0070C0"/>
+                </a:solidFill>
+                <a:latin typeface="Segoe UI" panose="020B0502040204020203" pitchFamily="34" charset="0"/>
+                <a:cs typeface="Segoe UI" panose="020B0502040204020203" pitchFamily="34" charset="0"/>
+              </a:rPr>
+              <a:t>*FamilyName</a:t>
+            </a:r>
+          </a:p>
+          <a:p>
+            <a:pPr>
+              <a:defRPr/>
+            </a:pPr>
+            <a:r>
+              <a:rPr lang="en-US" sz="900">
+                <a:solidFill>
                   <a:schemeClr val="tx1"/>
                 </a:solidFill>
                 <a:latin typeface="Segoe UI" panose="020B0502040204020203" pitchFamily="34" charset="0"/>
@@ -6656,6 +7045,21 @@
             <a:r>
               <a:rPr lang="en-US" sz="900">
                 <a:solidFill>
+                  <a:srgbClr val="0070C0"/>
+                </a:solidFill>
+                <a:latin typeface="Segoe UI" panose="020B0502040204020203" pitchFamily="34" charset="0"/>
+                <a:cs typeface="Segoe UI" panose="020B0502040204020203" pitchFamily="34" charset="0"/>
+              </a:rPr>
+              <a:t>*GenusName</a:t>
+            </a:r>
+          </a:p>
+          <a:p>
+            <a:pPr>
+              <a:defRPr/>
+            </a:pPr>
+            <a:r>
+              <a:rPr lang="en-US" sz="900">
+                <a:solidFill>
                   <a:schemeClr val="tx1"/>
                 </a:solidFill>
                 <a:latin typeface="Segoe UI" panose="020B0502040204020203" pitchFamily="34" charset="0"/>
@@ -6812,6 +7216,36 @@
                 <a:cs typeface="Segoe UI" panose="020B0502040204020203" pitchFamily="34" charset="0"/>
               </a:rPr>
               <a:t>IsHybid</a:t>
+            </a:r>
+          </a:p>
+          <a:p>
+            <a:pPr>
+              <a:defRPr/>
+            </a:pPr>
+            <a:r>
+              <a:rPr lang="en-US" sz="900">
+                <a:solidFill>
+                  <a:srgbClr val="0070C0"/>
+                </a:solidFill>
+                <a:latin typeface="Segoe UI" panose="020B0502040204020203" pitchFamily="34" charset="0"/>
+                <a:cs typeface="Segoe UI" panose="020B0502040204020203" pitchFamily="34" charset="0"/>
+              </a:rPr>
+              <a:t>*SciName</a:t>
+            </a:r>
+          </a:p>
+          <a:p>
+            <a:pPr>
+              <a:defRPr/>
+            </a:pPr>
+            <a:r>
+              <a:rPr lang="en-US" sz="900">
+                <a:solidFill>
+                  <a:srgbClr val="0070C0"/>
+                </a:solidFill>
+                <a:latin typeface="Segoe UI" panose="020B0502040204020203" pitchFamily="34" charset="0"/>
+                <a:cs typeface="Segoe UI" panose="020B0502040204020203" pitchFamily="34" charset="0"/>
+              </a:rPr>
+              <a:t>**IsSelected</a:t>
             </a:r>
           </a:p>
         </p:txBody>
@@ -6830,7 +7264,7 @@
         </p:nvSpPr>
         <p:spPr bwMode="auto">
           <a:xfrm>
-            <a:off x="7617369" y="2279859"/>
+            <a:off x="7984922" y="2279859"/>
             <a:ext cx="1278585" cy="1009790"/>
           </a:xfrm>
           <a:prstGeom prst="roundRect">
@@ -6976,8 +7410,8 @@
         </p:nvSpPr>
         <p:spPr bwMode="auto">
           <a:xfrm>
-            <a:off x="8585731" y="1897387"/>
-            <a:ext cx="1233203" cy="1596320"/>
+            <a:off x="8845704" y="1897387"/>
+            <a:ext cx="1416106" cy="1596320"/>
           </a:xfrm>
           <a:prstGeom prst="roundRect">
             <a:avLst>
@@ -7173,6 +7607,21 @@
             <a:pPr>
               <a:defRPr/>
             </a:pPr>
+            <a:r>
+              <a:rPr lang="en-US" sz="900">
+                <a:solidFill>
+                  <a:srgbClr val="0070C0"/>
+                </a:solidFill>
+                <a:latin typeface="Segoe UI" panose="020B0502040204020203" pitchFamily="34" charset="0"/>
+                <a:cs typeface="Segoe UI" panose="020B0502040204020203" pitchFamily="34" charset="0"/>
+              </a:rPr>
+              <a:t>*List&lt;Genus&gt; Genera</a:t>
+            </a:r>
+          </a:p>
+          <a:p>
+            <a:pPr>
+              <a:defRPr/>
+            </a:pPr>
             <a:endParaRPr lang="en-US" sz="900">
               <a:solidFill>
                 <a:schemeClr val="tx1"/>
@@ -7197,7 +7646,7 @@
         </p:nvSpPr>
         <p:spPr bwMode="auto">
           <a:xfrm>
-            <a:off x="9605532" y="1608526"/>
+            <a:off x="9793785" y="1608526"/>
             <a:ext cx="1377673" cy="1364705"/>
           </a:xfrm>
           <a:prstGeom prst="roundRect">
@@ -7358,8 +7807,8 @@
         </p:nvSpPr>
         <p:spPr bwMode="auto">
           <a:xfrm>
-            <a:off x="10559922" y="1262214"/>
-            <a:ext cx="1377673" cy="2943148"/>
+            <a:off x="10631630" y="1262213"/>
+            <a:ext cx="1377673" cy="3103659"/>
           </a:xfrm>
           <a:prstGeom prst="roundRect">
             <a:avLst>
@@ -7774,6 +8223,21 @@
             <a:pPr>
               <a:defRPr/>
             </a:pPr>
+            <a:r>
+              <a:rPr lang="en-US" sz="900">
+                <a:solidFill>
+                  <a:srgbClr val="0070C0"/>
+                </a:solidFill>
+                <a:latin typeface="Segoe UI" panose="020B0502040204020203" pitchFamily="34" charset="0"/>
+                <a:cs typeface="Segoe UI" panose="020B0502040204020203" pitchFamily="34" charset="0"/>
+              </a:rPr>
+              <a:t>*List&lt;Order&gt; Orders</a:t>
+            </a:r>
+          </a:p>
+          <a:p>
+            <a:pPr>
+              <a:defRPr/>
+            </a:pPr>
             <a:endParaRPr lang="en-US" sz="900">
               <a:solidFill>
                 <a:schemeClr val="tx1"/>
@@ -7798,7 +8262,7 @@
         </p:nvSpPr>
         <p:spPr>
           <a:xfrm>
-            <a:off x="7968274" y="3425262"/>
+            <a:off x="8425477" y="3568702"/>
             <a:ext cx="1026285" cy="1338828"/>
           </a:xfrm>
           <a:prstGeom prst="rect">
@@ -7957,7 +8421,7 @@
         </p:nvSpPr>
         <p:spPr>
           <a:xfrm>
-            <a:off x="7968273" y="4722538"/>
+            <a:off x="8425476" y="4865978"/>
             <a:ext cx="1026285" cy="969496"/>
           </a:xfrm>
           <a:prstGeom prst="rect">
@@ -8080,7 +8544,7 @@
         </p:nvSpPr>
         <p:spPr>
           <a:xfrm>
-            <a:off x="9112306" y="4244894"/>
+            <a:off x="9542614" y="4379367"/>
             <a:ext cx="1048321" cy="1815882"/>
           </a:xfrm>
           <a:prstGeom prst="rect">
@@ -8273,7 +8737,7 @@
         </p:nvSpPr>
         <p:spPr>
           <a:xfrm>
-            <a:off x="9605532" y="6415189"/>
+            <a:off x="9580652" y="6443753"/>
             <a:ext cx="2586468" cy="400110"/>
           </a:xfrm>
           <a:prstGeom prst="rect">
@@ -8316,7 +8780,7 @@
         </p:nvSpPr>
         <p:spPr>
           <a:xfrm>
-            <a:off x="7954412" y="5687007"/>
+            <a:off x="8411615" y="5830447"/>
             <a:ext cx="1040146" cy="600164"/>
           </a:xfrm>
           <a:prstGeom prst="rect">
@@ -8399,7 +8863,7 @@
         </p:nvSpPr>
         <p:spPr>
           <a:xfrm>
-            <a:off x="10028106" y="4366939"/>
+            <a:off x="10458414" y="4501412"/>
             <a:ext cx="1114701" cy="1692771"/>
           </a:xfrm>
           <a:prstGeom prst="rect">
@@ -8557,40 +9021,319 @@
           </a:p>
         </p:txBody>
       </p:sp>
+      <p:sp>
+        <p:nvSpPr>
+          <p:cNvPr id="19" name="Rectangle: Rounded Corners 45">
+            <a:extLst>
+              <a:ext uri="{FF2B5EF4-FFF2-40B4-BE49-F238E27FC236}">
+                <a16:creationId xmlns:a16="http://schemas.microsoft.com/office/drawing/2014/main" id="{3EA3B7CC-3410-6EE1-54B4-430E69FA88DC}"/>
+              </a:ext>
+            </a:extLst>
+          </p:cNvPr>
+          <p:cNvSpPr/>
+          <p:nvPr/>
+        </p:nvSpPr>
+        <p:spPr bwMode="auto">
+          <a:xfrm>
+            <a:off x="199289" y="5569653"/>
+            <a:ext cx="1180048" cy="1154882"/>
+          </a:xfrm>
+          <a:prstGeom prst="roundRect">
+            <a:avLst>
+              <a:gd name="adj" fmla="val 3991"/>
+            </a:avLst>
+          </a:prstGeom>
+          <a:solidFill>
+            <a:schemeClr val="bg1"/>
+          </a:solidFill>
+          <a:ln w="12700">
+            <a:solidFill>
+              <a:schemeClr val="tx1"/>
+            </a:solidFill>
+          </a:ln>
+          <a:effectLst/>
+        </p:spPr>
+        <p:style>
+          <a:lnRef idx="0">
+            <a:schemeClr val="accent4"/>
+          </a:lnRef>
+          <a:fillRef idx="3">
+            <a:schemeClr val="accent4"/>
+          </a:fillRef>
+          <a:effectRef idx="3">
+            <a:schemeClr val="accent4"/>
+          </a:effectRef>
+          <a:fontRef idx="minor">
+            <a:schemeClr val="lt1"/>
+          </a:fontRef>
+        </p:style>
+        <p:txBody>
+          <a:bodyPr rtlCol="1" anchor="t"/>
+          <a:lstStyle/>
+          <a:p>
+            <a:pPr>
+              <a:defRPr/>
+            </a:pPr>
+            <a:r>
+              <a:rPr lang="en-US" sz="1600" b="1">
+                <a:solidFill>
+                  <a:schemeClr val="bg1"/>
+                </a:solidFill>
+                <a:highlight>
+                  <a:srgbClr val="800080"/>
+                </a:highlight>
+                <a:latin typeface="Segoe UI" panose="020B0502040204020203" pitchFamily="34" charset="0"/>
+                <a:cs typeface="Segoe UI" panose="020B0502040204020203" pitchFamily="34" charset="0"/>
+              </a:rPr>
+              <a:t>Sections</a:t>
+            </a:r>
+            <a:endParaRPr sz="1600" b="1">
+              <a:solidFill>
+                <a:schemeClr val="bg1"/>
+              </a:solidFill>
+              <a:highlight>
+                <a:srgbClr val="800080"/>
+              </a:highlight>
+              <a:latin typeface="Segoe UI" panose="020B0502040204020203" pitchFamily="34" charset="0"/>
+              <a:cs typeface="Segoe UI" panose="020B0502040204020203" pitchFamily="34" charset="0"/>
+            </a:endParaRPr>
+          </a:p>
+          <a:p>
+            <a:pPr>
+              <a:defRPr/>
+            </a:pPr>
+            <a:r>
+              <a:rPr lang="en-US" sz="900" i="1">
+                <a:solidFill>
+                  <a:schemeClr val="accent5"/>
+                </a:solidFill>
+                <a:latin typeface="Segoe UI" panose="020B0502040204020203" pitchFamily="34" charset="0"/>
+                <a:cs typeface="Segoe UI" panose="020B0502040204020203" pitchFamily="34" charset="0"/>
+              </a:rPr>
+              <a:t>SectionId</a:t>
+            </a:r>
+            <a:endParaRPr lang="en-US" sz="900">
+              <a:solidFill>
+                <a:schemeClr val="tx1"/>
+              </a:solidFill>
+              <a:latin typeface="Segoe UI" panose="020B0502040204020203" pitchFamily="34" charset="0"/>
+              <a:cs typeface="Segoe UI" panose="020B0502040204020203" pitchFamily="34" charset="0"/>
+            </a:endParaRPr>
+          </a:p>
+          <a:p>
+            <a:pPr>
+              <a:defRPr/>
+            </a:pPr>
+            <a:r>
+              <a:rPr lang="en-US" sz="900">
+                <a:solidFill>
+                  <a:schemeClr val="tx1"/>
+                </a:solidFill>
+                <a:latin typeface="Segoe UI" panose="020B0502040204020203" pitchFamily="34" charset="0"/>
+                <a:cs typeface="Segoe UI" panose="020B0502040204020203" pitchFamily="34" charset="0"/>
+              </a:rPr>
+              <a:t>NotebookId</a:t>
+            </a:r>
+          </a:p>
+          <a:p>
+            <a:pPr>
+              <a:defRPr/>
+            </a:pPr>
+            <a:r>
+              <a:rPr lang="en-US" sz="900">
+                <a:solidFill>
+                  <a:schemeClr val="tx1"/>
+                </a:solidFill>
+                <a:latin typeface="Segoe UI" panose="020B0502040204020203" pitchFamily="34" charset="0"/>
+                <a:cs typeface="Segoe UI" panose="020B0502040204020203" pitchFamily="34" charset="0"/>
+              </a:rPr>
+              <a:t>SectionName</a:t>
+            </a:r>
+          </a:p>
+          <a:p>
+            <a:pPr>
+              <a:defRPr/>
+            </a:pPr>
+            <a:r>
+              <a:rPr lang="en-US" sz="900">
+                <a:solidFill>
+                  <a:schemeClr val="tx1"/>
+                </a:solidFill>
+                <a:latin typeface="Segoe UI" panose="020B0502040204020203" pitchFamily="34" charset="0"/>
+                <a:cs typeface="Segoe UI" panose="020B0502040204020203" pitchFamily="34" charset="0"/>
+              </a:rPr>
+              <a:t>SectionTags</a:t>
+            </a:r>
+          </a:p>
+          <a:p>
+            <a:pPr>
+              <a:defRPr/>
+            </a:pPr>
+            <a:r>
+              <a:rPr lang="en-US" sz="900">
+                <a:solidFill>
+                  <a:srgbClr val="0070C0"/>
+                </a:solidFill>
+                <a:latin typeface="Segoe UI" panose="020B0502040204020203" pitchFamily="34" charset="0"/>
+                <a:cs typeface="Segoe UI" panose="020B0502040204020203" pitchFamily="34" charset="0"/>
+              </a:rPr>
+              <a:t>*List&lt;Note&gt; Notes</a:t>
+            </a:r>
+          </a:p>
+        </p:txBody>
+      </p:sp>
+      <p:sp>
+        <p:nvSpPr>
+          <p:cNvPr id="23" name="Rectangle: Rounded Corners 45">
+            <a:extLst>
+              <a:ext uri="{FF2B5EF4-FFF2-40B4-BE49-F238E27FC236}">
+                <a16:creationId xmlns:a16="http://schemas.microsoft.com/office/drawing/2014/main" id="{2E2C498D-848C-2858-FB8D-F40785A38242}"/>
+              </a:ext>
+            </a:extLst>
+          </p:cNvPr>
+          <p:cNvSpPr/>
+          <p:nvPr/>
+        </p:nvSpPr>
+        <p:spPr bwMode="auto">
+          <a:xfrm>
+            <a:off x="6372666" y="541874"/>
+            <a:ext cx="1405790" cy="1050856"/>
+          </a:xfrm>
+          <a:prstGeom prst="roundRect">
+            <a:avLst>
+              <a:gd name="adj" fmla="val 3991"/>
+            </a:avLst>
+          </a:prstGeom>
+          <a:solidFill>
+            <a:schemeClr val="bg1"/>
+          </a:solidFill>
+          <a:ln w="12700">
+            <a:solidFill>
+              <a:schemeClr val="tx1"/>
+            </a:solidFill>
+          </a:ln>
+          <a:effectLst/>
+        </p:spPr>
+        <p:style>
+          <a:lnRef idx="0">
+            <a:schemeClr val="accent4"/>
+          </a:lnRef>
+          <a:fillRef idx="3">
+            <a:schemeClr val="accent4"/>
+          </a:fillRef>
+          <a:effectRef idx="3">
+            <a:schemeClr val="accent4"/>
+          </a:effectRef>
+          <a:fontRef idx="minor">
+            <a:schemeClr val="lt1"/>
+          </a:fontRef>
+        </p:style>
+        <p:txBody>
+          <a:bodyPr rtlCol="1" anchor="t"/>
+          <a:lstStyle/>
+          <a:p>
+            <a:pPr>
+              <a:defRPr/>
+            </a:pPr>
+            <a:r>
+              <a:rPr lang="en-US" sz="1600" b="1">
+                <a:solidFill>
+                  <a:srgbClr val="0070C0"/>
+                </a:solidFill>
+                <a:latin typeface="Segoe UI" panose="020B0502040204020203" pitchFamily="34" charset="0"/>
+                <a:cs typeface="Segoe UI" panose="020B0502040204020203" pitchFamily="34" charset="0"/>
+              </a:rPr>
+              <a:t>*Occurrence</a:t>
+            </a:r>
+            <a:endParaRPr lang="en-US" sz="900" i="1">
+              <a:solidFill>
+                <a:schemeClr val="accent5"/>
+              </a:solidFill>
+              <a:latin typeface="Segoe UI" panose="020B0502040204020203" pitchFamily="34" charset="0"/>
+              <a:cs typeface="Segoe UI" panose="020B0502040204020203" pitchFamily="34" charset="0"/>
+            </a:endParaRPr>
+          </a:p>
+          <a:p>
+            <a:pPr>
+              <a:defRPr/>
+            </a:pPr>
+            <a:r>
+              <a:rPr lang="en-US" sz="900">
+                <a:solidFill>
+                  <a:schemeClr val="tx1"/>
+                </a:solidFill>
+                <a:latin typeface="Segoe UI" panose="020B0502040204020203" pitchFamily="34" charset="0"/>
+                <a:cs typeface="Segoe UI" panose="020B0502040204020203" pitchFamily="34" charset="0"/>
+              </a:rPr>
+              <a:t>DatasetId</a:t>
+            </a:r>
+          </a:p>
+          <a:p>
+            <a:pPr>
+              <a:defRPr/>
+            </a:pPr>
+            <a:r>
+              <a:rPr lang="en-US" sz="900">
+                <a:solidFill>
+                  <a:schemeClr val="tx1"/>
+                </a:solidFill>
+                <a:latin typeface="Segoe UI" panose="020B0502040204020203" pitchFamily="34" charset="0"/>
+                <a:cs typeface="Segoe UI" panose="020B0502040204020203" pitchFamily="34" charset="0"/>
+              </a:rPr>
+              <a:t>DatasetName</a:t>
+            </a:r>
+          </a:p>
+          <a:p>
+            <a:pPr>
+              <a:defRPr/>
+            </a:pPr>
+            <a:r>
+              <a:rPr lang="en-US" sz="900">
+                <a:solidFill>
+                  <a:schemeClr val="tx1"/>
+                </a:solidFill>
+                <a:latin typeface="Segoe UI" panose="020B0502040204020203" pitchFamily="34" charset="0"/>
+                <a:cs typeface="Segoe UI" panose="020B0502040204020203" pitchFamily="34" charset="0"/>
+              </a:rPr>
+              <a:t>SpeciesId</a:t>
+            </a:r>
+          </a:p>
+          <a:p>
+            <a:pPr>
+              <a:defRPr/>
+            </a:pPr>
+            <a:r>
+              <a:rPr lang="en-US" sz="900">
+                <a:solidFill>
+                  <a:schemeClr val="tx1"/>
+                </a:solidFill>
+                <a:latin typeface="Segoe UI" panose="020B0502040204020203" pitchFamily="34" charset="0"/>
+                <a:cs typeface="Segoe UI" panose="020B0502040204020203" pitchFamily="34" charset="0"/>
+              </a:rPr>
+              <a:t>AcceptedId</a:t>
+            </a:r>
+          </a:p>
+          <a:p>
+            <a:pPr>
+              <a:defRPr/>
+            </a:pPr>
+            <a:r>
+              <a:rPr lang="en-US" sz="900">
+                <a:solidFill>
+                  <a:schemeClr val="tx1"/>
+                </a:solidFill>
+                <a:latin typeface="Segoe UI" panose="020B0502040204020203" pitchFamily="34" charset="0"/>
+                <a:cs typeface="Segoe UI" panose="020B0502040204020203" pitchFamily="34" charset="0"/>
+              </a:rPr>
+              <a:t>SciName</a:t>
+            </a:r>
+          </a:p>
+        </p:txBody>
+      </p:sp>
     </p:spTree>
     <p:extLst>
       <p:ext uri="{BB962C8B-B14F-4D97-AF65-F5344CB8AC3E}">
         <p14:creationId xmlns:p14="http://schemas.microsoft.com/office/powerpoint/2010/main" val="230367927"/>
-      </p:ext>
-    </p:extLst>
-  </p:cSld>
-  <p:clrMapOvr>
-    <a:masterClrMapping/>
-  </p:clrMapOvr>
-</p:sld>
-</file>
-
-<file path=ppt/slides/slide2.xml><?xml version="1.0" encoding="utf-8"?>
-<p:sld xmlns:a="http://schemas.openxmlformats.org/drawingml/2006/main" xmlns:r="http://schemas.openxmlformats.org/officeDocument/2006/relationships" xmlns:p="http://schemas.openxmlformats.org/presentationml/2006/main">
-  <p:cSld>
-    <p:spTree>
-      <p:nvGrpSpPr>
-        <p:cNvPr id="1" name=""/>
-        <p:cNvGrpSpPr/>
-        <p:nvPr/>
-      </p:nvGrpSpPr>
-      <p:grpSpPr>
-        <a:xfrm>
-          <a:off x="0" y="0"/>
-          <a:ext cx="0" cy="0"/>
-          <a:chOff x="0" y="0"/>
-          <a:chExt cx="0" cy="0"/>
-        </a:xfrm>
-      </p:grpSpPr>
-    </p:spTree>
-    <p:extLst>
-      <p:ext uri="{BB962C8B-B14F-4D97-AF65-F5344CB8AC3E}">
-        <p14:creationId xmlns:p14="http://schemas.microsoft.com/office/powerpoint/2010/main" val="189674366"/>
       </p:ext>
     </p:extLst>
   </p:cSld>

</xml_diff>